<commit_message>
Publish verified Colab execution and align live demo slides
</commit_message>
<xml_diff>
--- a/output/Bringing-the-Heat.pptx
+++ b/output/Bringing-the-Heat.pptx
@@ -2,34 +2,34 @@
 <file path=ppt/presentation.xml><?xml version="1.0" encoding="utf-8"?>
 <p:presentation xmlns:p="http://schemas.openxmlformats.org/presentationml/2006/main">
   <p:sldMasterIdLst>
-    <p:sldMasterId xmlns:r="http://schemas.openxmlformats.org/officeDocument/2006/relationships" id="2147483648" r:id="R84e629a240634f86"/>
+    <p:sldMasterId xmlns:r="http://schemas.openxmlformats.org/officeDocument/2006/relationships" id="2147483648" r:id="Rccdb42fd401e42ed"/>
   </p:sldMasterIdLst>
   <p:notesMasterIdLst>
-    <p:notesMasterId xmlns:r="http://schemas.openxmlformats.org/officeDocument/2006/relationships" r:id="R82b2de5d6b3648ea"/>
+    <p:notesMasterId xmlns:r="http://schemas.openxmlformats.org/officeDocument/2006/relationships" r:id="R5625f2e1a2ff4dcc"/>
   </p:notesMasterIdLst>
   <p:sldIdLst>
-    <p:sldId xmlns:r="http://schemas.openxmlformats.org/officeDocument/2006/relationships" id="256" r:id="R52fa044628b74ed3"/>
-    <p:sldId xmlns:r="http://schemas.openxmlformats.org/officeDocument/2006/relationships" id="257" r:id="Re8c4c2df4c924f52"/>
-    <p:sldId xmlns:r="http://schemas.openxmlformats.org/officeDocument/2006/relationships" id="258" r:id="R12f2d7ffb9904572"/>
-    <p:sldId xmlns:r="http://schemas.openxmlformats.org/officeDocument/2006/relationships" id="259" r:id="R27d18639a1ca4b5e"/>
-    <p:sldId xmlns:r="http://schemas.openxmlformats.org/officeDocument/2006/relationships" id="260" r:id="Ra8fe01758e954a08"/>
-    <p:sldId xmlns:r="http://schemas.openxmlformats.org/officeDocument/2006/relationships" id="261" r:id="Rbe0ad0f820554972"/>
-    <p:sldId xmlns:r="http://schemas.openxmlformats.org/officeDocument/2006/relationships" id="262" r:id="R75f9da03f2d24aa4"/>
-    <p:sldId xmlns:r="http://schemas.openxmlformats.org/officeDocument/2006/relationships" id="263" r:id="R20b45583ac6f4b94"/>
-    <p:sldId xmlns:r="http://schemas.openxmlformats.org/officeDocument/2006/relationships" id="264" r:id="Ra99f9cd1dde44e0f"/>
-    <p:sldId xmlns:r="http://schemas.openxmlformats.org/officeDocument/2006/relationships" id="265" r:id="R094aa2a653114aea"/>
-    <p:sldId xmlns:r="http://schemas.openxmlformats.org/officeDocument/2006/relationships" id="266" r:id="R2f22bfa527224af9"/>
-    <p:sldId xmlns:r="http://schemas.openxmlformats.org/officeDocument/2006/relationships" id="267" r:id="Rb3335910b314483c"/>
-    <p:sldId xmlns:r="http://schemas.openxmlformats.org/officeDocument/2006/relationships" id="268" r:id="R5e3137a823fe44d8"/>
-    <p:sldId xmlns:r="http://schemas.openxmlformats.org/officeDocument/2006/relationships" id="269" r:id="Rb99a3dbf22fa4084"/>
-    <p:sldId xmlns:r="http://schemas.openxmlformats.org/officeDocument/2006/relationships" id="270" r:id="R04bc3880507a4554"/>
-    <p:sldId xmlns:r="http://schemas.openxmlformats.org/officeDocument/2006/relationships" id="271" r:id="Raa8d1d750ac542c7"/>
-    <p:sldId xmlns:r="http://schemas.openxmlformats.org/officeDocument/2006/relationships" id="272" r:id="R0966ed5b3480424d"/>
-    <p:sldId xmlns:r="http://schemas.openxmlformats.org/officeDocument/2006/relationships" id="273" r:id="R571b7d6877b74b4a"/>
-    <p:sldId xmlns:r="http://schemas.openxmlformats.org/officeDocument/2006/relationships" id="274" r:id="R2ece7f7aba4240fd"/>
-    <p:sldId xmlns:r="http://schemas.openxmlformats.org/officeDocument/2006/relationships" id="275" r:id="R84615b8ca24e4d4b"/>
-    <p:sldId xmlns:r="http://schemas.openxmlformats.org/officeDocument/2006/relationships" id="276" r:id="R85c0a0e26ac94b07"/>
-    <p:sldId xmlns:r="http://schemas.openxmlformats.org/officeDocument/2006/relationships" id="277" r:id="Rdf48af35cdf24f2f"/>
+    <p:sldId xmlns:r="http://schemas.openxmlformats.org/officeDocument/2006/relationships" id="256" r:id="R3ff89bd34d774df1"/>
+    <p:sldId xmlns:r="http://schemas.openxmlformats.org/officeDocument/2006/relationships" id="257" r:id="R5575d1da1fe543be"/>
+    <p:sldId xmlns:r="http://schemas.openxmlformats.org/officeDocument/2006/relationships" id="258" r:id="R21dc38d28dd64f59"/>
+    <p:sldId xmlns:r="http://schemas.openxmlformats.org/officeDocument/2006/relationships" id="259" r:id="R75aa47c2c6e24ba9"/>
+    <p:sldId xmlns:r="http://schemas.openxmlformats.org/officeDocument/2006/relationships" id="260" r:id="R6759e2e7af1b442b"/>
+    <p:sldId xmlns:r="http://schemas.openxmlformats.org/officeDocument/2006/relationships" id="261" r:id="Rc4a0b87cf598473d"/>
+    <p:sldId xmlns:r="http://schemas.openxmlformats.org/officeDocument/2006/relationships" id="262" r:id="R4541251e8ea447d3"/>
+    <p:sldId xmlns:r="http://schemas.openxmlformats.org/officeDocument/2006/relationships" id="263" r:id="R066673d6aae74964"/>
+    <p:sldId xmlns:r="http://schemas.openxmlformats.org/officeDocument/2006/relationships" id="264" r:id="R18edce62a87c4ee5"/>
+    <p:sldId xmlns:r="http://schemas.openxmlformats.org/officeDocument/2006/relationships" id="265" r:id="R963d9388b5804dcf"/>
+    <p:sldId xmlns:r="http://schemas.openxmlformats.org/officeDocument/2006/relationships" id="266" r:id="R6f11c56c8eab4a98"/>
+    <p:sldId xmlns:r="http://schemas.openxmlformats.org/officeDocument/2006/relationships" id="267" r:id="R1fe7eddb2f1b4425"/>
+    <p:sldId xmlns:r="http://schemas.openxmlformats.org/officeDocument/2006/relationships" id="268" r:id="Reff40a34fcbb42b4"/>
+    <p:sldId xmlns:r="http://schemas.openxmlformats.org/officeDocument/2006/relationships" id="269" r:id="R4479b49f5caf4d44"/>
+    <p:sldId xmlns:r="http://schemas.openxmlformats.org/officeDocument/2006/relationships" id="270" r:id="R7ef9dbda204f465a"/>
+    <p:sldId xmlns:r="http://schemas.openxmlformats.org/officeDocument/2006/relationships" id="271" r:id="R46c1a16e3cf14fe7"/>
+    <p:sldId xmlns:r="http://schemas.openxmlformats.org/officeDocument/2006/relationships" id="272" r:id="Rd889bc064b1046a1"/>
+    <p:sldId xmlns:r="http://schemas.openxmlformats.org/officeDocument/2006/relationships" id="273" r:id="R53f1225f68934553"/>
+    <p:sldId xmlns:r="http://schemas.openxmlformats.org/officeDocument/2006/relationships" id="274" r:id="R0f28f21c101745e0"/>
+    <p:sldId xmlns:r="http://schemas.openxmlformats.org/officeDocument/2006/relationships" id="275" r:id="Rf577f3be87e849d3"/>
+    <p:sldId xmlns:r="http://schemas.openxmlformats.org/officeDocument/2006/relationships" id="276" r:id="Rf28220b834ce4568"/>
+    <p:sldId xmlns:r="http://schemas.openxmlformats.org/officeDocument/2006/relationships" id="277" r:id="R2f1dc4d2ae904ab9"/>
   </p:sldIdLst>
   <p:sldSz cx="12192000" cy="6858000"/>
   <p:notesSz cx="6858000" cy="9144000"/>
@@ -1153,7 +1153,7 @@
           </a:p>
           <a:p xmlns:a="http://schemas.openxmlformats.org/drawingml/2006/main">
             <a:r>
-              <a:t>2 minutes including local app switch. Start the prepared Gradio app or use the already running localhost tab. Submit a short example and show the model/runtime identity. This proves an exported model can back an interface; it is a local demo, not a production deployment. Explain the remaining service work: auth for sensitive access, input limits, health/readiness checks, concurrency/load testing, structured logs, monitored quality, and rollback to an immutable artifact. A Space is useful for sharing a demo; a dedicated Endpoint or owned service can meet different operational requirements. No paid resources or public writes are required in this talk package.</a:t>
+              <a:t>2 minutes including the Colab demo. Open notebook section 8, change HEADLINES, and rerun the inference cell. Point to the exported INT8 artifact that the cell loads and show the resulting predictions. The local Gradio app is an optional fallback if Colab is unavailable. This demonstrates the exported model artifact in an interactive demo. Explain the remaining service work: auth for sensitive access, input limits, health/readiness checks, concurrency/load testing, structured logs, monitored quality, and rollback to an immutable artifact. A Space is useful for sharing a demo; a dedicated Endpoint or owned service can meet different operational requirements. No paid resources or public writes are required in this talk package.</a:t>
             </a:r>
           </a:p>
           <a:p xmlns:a="http://schemas.openxmlformats.org/drawingml/2006/main">
@@ -2841,7 +2841,7 @@
   </p:cSld>
   <p:clrMap bg1="lt1" tx1="dk1" bg2="lt2" tx2="dk2" accent1="accent1" accent2="accent2" accent3="accent3" accent4="accent4" accent5="accent5" accent6="accent6" hlink="hlink" folHlink="folHlink"/>
   <p:sldLayoutIdLst>
-    <p:sldLayoutId xmlns:r="http://schemas.openxmlformats.org/officeDocument/2006/relationships" id="2147483649" r:id="R3c533099d0b64c2b"/>
+    <p:sldLayoutId xmlns:r="http://schemas.openxmlformats.org/officeDocument/2006/relationships" id="2147483649" r:id="Rdf83381653f34128"/>
   </p:sldLayoutIdLst>
   <p:txStyles>
     <p:titleStyle>
@@ -3392,7 +3392,7 @@
           <p:cNvPr id="4" name="">
             <a:extLst xmlns:a="http://schemas.openxmlformats.org/drawingml/2006/main">
               <a:ext uri="{FF2B5EF4-FFF2-40B4-BE49-F238E27FC236}">
-                <a16:creationId xmlns:a16="http://schemas.microsoft.com/office/drawing/2014/main" id="{F1EFAF2E-B791-4655-8363-A4AF7FAEF500}"/>
+                <a16:creationId xmlns:a16="http://schemas.microsoft.com/office/drawing/2014/main" id="{2C52B07D-C2ED-409C-981C-79C0FC649413}"/>
               </a:ext>
             </a:extLst>
           </p:cNvPr>
@@ -3449,7 +3449,7 @@
           <p:cNvPr id="2" name="">
             <a:extLst xmlns:a="http://schemas.openxmlformats.org/drawingml/2006/main">
               <a:ext uri="{FF2B5EF4-FFF2-40B4-BE49-F238E27FC236}">
-                <a16:creationId xmlns:a16="http://schemas.microsoft.com/office/drawing/2014/main" id="{03C895B6-C7FD-4C8F-BE61-94F40C2C49D0}"/>
+                <a16:creationId xmlns:a16="http://schemas.microsoft.com/office/drawing/2014/main" id="{8D091419-0DC0-41D4-B2E2-05445938BF15}"/>
               </a:ext>
             </a:extLst>
           </p:cNvPr>
@@ -3495,7 +3495,7 @@
                 <a:latin typeface="Arial"/>
                 <a:ea typeface="Arial"/>
                 <a:cs typeface="Arial"/>
-                <a:hlinkClick xmlns:r="http://schemas.openxmlformats.org/officeDocument/2006/relationships" r:id="Rfeb99059a6d141e5"/>
+                <a:hlinkClick xmlns:r="http://schemas.openxmlformats.org/officeDocument/2006/relationships" r:id="R70138a18e5374bd6"/>
               </a:rPr>
               <a:t>muntasersyed.com</a:t>
             </a:r>
@@ -3511,7 +3511,7 @@
           <p:nvPr/>
         </p:nvPicPr>
         <p:blipFill>
-          <a:blip xmlns:r="http://schemas.openxmlformats.org/officeDocument/2006/relationships" xmlns:a="http://schemas.openxmlformats.org/drawingml/2006/main" r:embed="Rafe1dbe8d9224055"/>
+          <a:blip xmlns:r="http://schemas.openxmlformats.org/officeDocument/2006/relationships" xmlns:a="http://schemas.openxmlformats.org/drawingml/2006/main" r:embed="R3309248293264bec"/>
           <a:stretch xmlns:a="http://schemas.openxmlformats.org/drawingml/2006/main"/>
         </p:blipFill>
         <p:spPr>
@@ -3527,7 +3527,7 @@
     </p:spTree>
     <p:extLst>
       <p:ext uri="{BB962C8B-B14F-4D97-AF65-F5344CB8AC3E}">
-        <p14:creationId xmlns:p14="http://schemas.microsoft.com/office/powerpoint/2010/main" val="2040391775"/>
+        <p14:creationId xmlns:p14="http://schemas.microsoft.com/office/powerpoint/2010/main" val="1853575997"/>
       </p:ext>
     </p:extLst>
   </p:cSld>
@@ -3558,7 +3558,7 @@
           <p:cNvPr id="13" name="">
             <a:extLst xmlns:a="http://schemas.openxmlformats.org/drawingml/2006/main">
               <a:ext uri="{FF2B5EF4-FFF2-40B4-BE49-F238E27FC236}">
-                <a16:creationId xmlns:a16="http://schemas.microsoft.com/office/drawing/2014/main" id="{B53E0493-60B1-4168-B327-9D3B19399DD9}"/>
+                <a16:creationId xmlns:a16="http://schemas.microsoft.com/office/drawing/2014/main" id="{FFDDA945-9D7A-4DE8-BAD4-E7D245B51F45}"/>
               </a:ext>
             </a:extLst>
           </p:cNvPr>
@@ -3615,7 +3615,7 @@
           <p:cNvPr id="2" name="">
             <a:extLst xmlns:a="http://schemas.openxmlformats.org/drawingml/2006/main">
               <a:ext uri="{FF2B5EF4-FFF2-40B4-BE49-F238E27FC236}">
-                <a16:creationId xmlns:a16="http://schemas.microsoft.com/office/drawing/2014/main" id="{9DD6B5F1-2782-4677-8274-542E0CD9F25D}"/>
+                <a16:creationId xmlns:a16="http://schemas.microsoft.com/office/drawing/2014/main" id="{C29408EF-54C0-4952-9F53-7FDA9B952918}"/>
               </a:ext>
             </a:extLst>
           </p:cNvPr>
@@ -3672,7 +3672,7 @@
           <p:cNvPr id="3" name="">
             <a:extLst xmlns:a="http://schemas.openxmlformats.org/drawingml/2006/main">
               <a:ext uri="{FF2B5EF4-FFF2-40B4-BE49-F238E27FC236}">
-                <a16:creationId xmlns:a16="http://schemas.microsoft.com/office/drawing/2014/main" id="{C5205D2C-7EDD-4BA3-9E8A-76C5368AB4CC}"/>
+                <a16:creationId xmlns:a16="http://schemas.microsoft.com/office/drawing/2014/main" id="{21F5D5BC-9184-45DA-B799-02212AA0D5D8}"/>
               </a:ext>
             </a:extLst>
           </p:cNvPr>
@@ -3729,7 +3729,7 @@
           <p:cNvPr id="4" name="">
             <a:extLst xmlns:a="http://schemas.openxmlformats.org/drawingml/2006/main">
               <a:ext uri="{FF2B5EF4-FFF2-40B4-BE49-F238E27FC236}">
-                <a16:creationId xmlns:a16="http://schemas.microsoft.com/office/drawing/2014/main" id="{B99F1734-4B4F-4D35-970F-0D1EBB08ECC1}"/>
+                <a16:creationId xmlns:a16="http://schemas.microsoft.com/office/drawing/2014/main" id="{757D4FDB-25D0-41D7-90F2-9B7CF77F4690}"/>
               </a:ext>
             </a:extLst>
           </p:cNvPr>
@@ -3786,7 +3786,7 @@
           <p:cNvPr id="5" name="">
             <a:extLst xmlns:a="http://schemas.openxmlformats.org/drawingml/2006/main">
               <a:ext uri="{FF2B5EF4-FFF2-40B4-BE49-F238E27FC236}">
-                <a16:creationId xmlns:a16="http://schemas.microsoft.com/office/drawing/2014/main" id="{C1469208-FEE3-477D-9B95-A71C1358BF5C}"/>
+                <a16:creationId xmlns:a16="http://schemas.microsoft.com/office/drawing/2014/main" id="{8EBB3D68-A10E-44F0-9956-28FA82DDF7B6}"/>
               </a:ext>
             </a:extLst>
           </p:cNvPr>
@@ -3843,7 +3843,7 @@
           <p:cNvPr id="6" name="">
             <a:extLst xmlns:a="http://schemas.openxmlformats.org/drawingml/2006/main">
               <a:ext uri="{FF2B5EF4-FFF2-40B4-BE49-F238E27FC236}">
-                <a16:creationId xmlns:a16="http://schemas.microsoft.com/office/drawing/2014/main" id="{70002C1F-8354-4E8C-B0F5-6BB14F11086A}"/>
+                <a16:creationId xmlns:a16="http://schemas.microsoft.com/office/drawing/2014/main" id="{A83C87E5-A447-410E-A86E-4D41C17FD0E2}"/>
               </a:ext>
             </a:extLst>
           </p:cNvPr>
@@ -3900,7 +3900,7 @@
           <p:cNvPr id="7" name="">
             <a:extLst xmlns:a="http://schemas.openxmlformats.org/drawingml/2006/main">
               <a:ext uri="{FF2B5EF4-FFF2-40B4-BE49-F238E27FC236}">
-                <a16:creationId xmlns:a16="http://schemas.microsoft.com/office/drawing/2014/main" id="{771D0B6E-7217-4FBE-BAAC-F7CE17D47C55}"/>
+                <a16:creationId xmlns:a16="http://schemas.microsoft.com/office/drawing/2014/main" id="{6A7130DA-DF12-4B0C-BDBD-AF40D74B3F11}"/>
               </a:ext>
             </a:extLst>
           </p:cNvPr>
@@ -3957,7 +3957,7 @@
           <p:cNvPr id="8" name="">
             <a:extLst xmlns:a="http://schemas.openxmlformats.org/drawingml/2006/main">
               <a:ext uri="{FF2B5EF4-FFF2-40B4-BE49-F238E27FC236}">
-                <a16:creationId xmlns:a16="http://schemas.microsoft.com/office/drawing/2014/main" id="{C4E87F39-71AA-46C3-B875-B79238FE3E50}"/>
+                <a16:creationId xmlns:a16="http://schemas.microsoft.com/office/drawing/2014/main" id="{A7289238-EA97-46BF-AD45-21B751213624}"/>
               </a:ext>
             </a:extLst>
           </p:cNvPr>
@@ -4014,7 +4014,7 @@
           <p:cNvPr id="9" name="">
             <a:extLst xmlns:a="http://schemas.openxmlformats.org/drawingml/2006/main">
               <a:ext uri="{FF2B5EF4-FFF2-40B4-BE49-F238E27FC236}">
-                <a16:creationId xmlns:a16="http://schemas.microsoft.com/office/drawing/2014/main" id="{6A6EB938-32CC-422B-A827-064CC4E35840}"/>
+                <a16:creationId xmlns:a16="http://schemas.microsoft.com/office/drawing/2014/main" id="{C27A3B50-B0C2-4482-800C-9C1A1A085229}"/>
               </a:ext>
             </a:extLst>
           </p:cNvPr>
@@ -4071,7 +4071,7 @@
           <p:cNvPr id="10" name="">
             <a:extLst xmlns:a="http://schemas.openxmlformats.org/drawingml/2006/main">
               <a:ext uri="{FF2B5EF4-FFF2-40B4-BE49-F238E27FC236}">
-                <a16:creationId xmlns:a16="http://schemas.microsoft.com/office/drawing/2014/main" id="{E04D767D-39B4-4406-BB0C-FBDEF6EC4372}"/>
+                <a16:creationId xmlns:a16="http://schemas.microsoft.com/office/drawing/2014/main" id="{1E39D37B-BBC5-409D-BDBB-79E0B34AEA27}"/>
               </a:ext>
             </a:extLst>
           </p:cNvPr>
@@ -4128,7 +4128,7 @@
           <p:cNvPr id="11" name="">
             <a:extLst xmlns:a="http://schemas.openxmlformats.org/drawingml/2006/main">
               <a:ext uri="{FF2B5EF4-FFF2-40B4-BE49-F238E27FC236}">
-                <a16:creationId xmlns:a16="http://schemas.microsoft.com/office/drawing/2014/main" id="{7E6D9E0E-CD00-462E-9A09-D90B630E7811}"/>
+                <a16:creationId xmlns:a16="http://schemas.microsoft.com/office/drawing/2014/main" id="{AD6CBE60-02C4-4A77-A811-6EC8358BADC2}"/>
               </a:ext>
             </a:extLst>
           </p:cNvPr>
@@ -4185,7 +4185,7 @@
           <p:cNvPr id="12" name="">
             <a:extLst xmlns:a="http://schemas.openxmlformats.org/drawingml/2006/main">
               <a:ext uri="{FF2B5EF4-FFF2-40B4-BE49-F238E27FC236}">
-                <a16:creationId xmlns:a16="http://schemas.microsoft.com/office/drawing/2014/main" id="{2E9C970A-992E-4FB2-9C54-2DD2669C0D27}"/>
+                <a16:creationId xmlns:a16="http://schemas.microsoft.com/office/drawing/2014/main" id="{AC808A4E-8986-4FE3-AC37-8C3AB86D5E2E}"/>
               </a:ext>
             </a:extLst>
           </p:cNvPr>
@@ -4240,7 +4240,7 @@
     </p:spTree>
     <p:extLst>
       <p:ext uri="{BB962C8B-B14F-4D97-AF65-F5344CB8AC3E}">
-        <p14:creationId xmlns:p14="http://schemas.microsoft.com/office/powerpoint/2010/main" val="386957193"/>
+        <p14:creationId xmlns:p14="http://schemas.microsoft.com/office/powerpoint/2010/main" val="1881904069"/>
       </p:ext>
     </p:extLst>
   </p:cSld>
@@ -4271,7 +4271,7 @@
           <p:cNvPr id="5" name="">
             <a:extLst xmlns:a="http://schemas.openxmlformats.org/drawingml/2006/main">
               <a:ext uri="{FF2B5EF4-FFF2-40B4-BE49-F238E27FC236}">
-                <a16:creationId xmlns:a16="http://schemas.microsoft.com/office/drawing/2014/main" id="{933BD607-E8FB-4A5A-B190-48DBC0CBA860}"/>
+                <a16:creationId xmlns:a16="http://schemas.microsoft.com/office/drawing/2014/main" id="{8C32BBB2-41A1-4B4E-840E-142418F3A0C3}"/>
               </a:ext>
             </a:extLst>
           </p:cNvPr>
@@ -4721,7 +4721,7 @@
           <p:cNvPr id="3" name="">
             <a:extLst xmlns:a="http://schemas.openxmlformats.org/drawingml/2006/main">
               <a:ext uri="{FF2B5EF4-FFF2-40B4-BE49-F238E27FC236}">
-                <a16:creationId xmlns:a16="http://schemas.microsoft.com/office/drawing/2014/main" id="{C4D84B96-A06E-45FD-96E6-9B6F6E46F0FC}"/>
+                <a16:creationId xmlns:a16="http://schemas.microsoft.com/office/drawing/2014/main" id="{20105103-B369-41E3-B5B9-EB4B37194F43}"/>
               </a:ext>
             </a:extLst>
           </p:cNvPr>
@@ -4778,7 +4778,7 @@
           <p:cNvPr id="4" name="">
             <a:extLst xmlns:a="http://schemas.openxmlformats.org/drawingml/2006/main">
               <a:ext uri="{FF2B5EF4-FFF2-40B4-BE49-F238E27FC236}">
-                <a16:creationId xmlns:a16="http://schemas.microsoft.com/office/drawing/2014/main" id="{867E61F7-93C3-418B-B96D-39C76211E018}"/>
+                <a16:creationId xmlns:a16="http://schemas.microsoft.com/office/drawing/2014/main" id="{F6E7116B-D5B6-40F7-AF70-B17ECE15B506}"/>
               </a:ext>
             </a:extLst>
           </p:cNvPr>
@@ -4833,7 +4833,7 @@
     </p:spTree>
     <p:extLst>
       <p:ext uri="{BB962C8B-B14F-4D97-AF65-F5344CB8AC3E}">
-        <p14:creationId xmlns:p14="http://schemas.microsoft.com/office/powerpoint/2010/main" val="1697298013"/>
+        <p14:creationId xmlns:p14="http://schemas.microsoft.com/office/powerpoint/2010/main" val="1686618111"/>
       </p:ext>
     </p:extLst>
   </p:cSld>
@@ -4864,7 +4864,7 @@
           <p:cNvPr id="7" name="">
             <a:extLst xmlns:a="http://schemas.openxmlformats.org/drawingml/2006/main">
               <a:ext uri="{FF2B5EF4-FFF2-40B4-BE49-F238E27FC236}">
-                <a16:creationId xmlns:a16="http://schemas.microsoft.com/office/drawing/2014/main" id="{8533C687-4483-4009-8B7D-2B60B9F0EF84}"/>
+                <a16:creationId xmlns:a16="http://schemas.microsoft.com/office/drawing/2014/main" id="{AE8E52C6-A8DF-4F22-B390-6816C17C85FC}"/>
               </a:ext>
             </a:extLst>
           </p:cNvPr>
@@ -4921,7 +4921,7 @@
           <p:cNvPr id="2" name="">
             <a:extLst xmlns:a="http://schemas.openxmlformats.org/drawingml/2006/main">
               <a:ext uri="{FF2B5EF4-FFF2-40B4-BE49-F238E27FC236}">
-                <a16:creationId xmlns:a16="http://schemas.microsoft.com/office/drawing/2014/main" id="{5A9FA971-5886-476B-B4D8-1354651E0A58}"/>
+                <a16:creationId xmlns:a16="http://schemas.microsoft.com/office/drawing/2014/main" id="{EF89FBA2-051A-4618-8C40-3ADCB1D74BAA}"/>
               </a:ext>
             </a:extLst>
           </p:cNvPr>
@@ -5172,7 +5172,7 @@
           <p:cNvPr id="3" name="">
             <a:extLst xmlns:a="http://schemas.openxmlformats.org/drawingml/2006/main">
               <a:ext uri="{FF2B5EF4-FFF2-40B4-BE49-F238E27FC236}">
-                <a16:creationId xmlns:a16="http://schemas.microsoft.com/office/drawing/2014/main" id="{B7AC7C08-E213-4E5D-8428-AA0880BC6653}"/>
+                <a16:creationId xmlns:a16="http://schemas.microsoft.com/office/drawing/2014/main" id="{CEA51736-8CE0-43BF-BCE2-A23FF84B0069}"/>
               </a:ext>
             </a:extLst>
           </p:cNvPr>
@@ -5229,7 +5229,7 @@
           <p:cNvPr id="4" name="">
             <a:extLst xmlns:a="http://schemas.openxmlformats.org/drawingml/2006/main">
               <a:ext uri="{FF2B5EF4-FFF2-40B4-BE49-F238E27FC236}">
-                <a16:creationId xmlns:a16="http://schemas.microsoft.com/office/drawing/2014/main" id="{B5BFC307-A43F-4EFD-98B9-6A4F648F13E6}"/>
+                <a16:creationId xmlns:a16="http://schemas.microsoft.com/office/drawing/2014/main" id="{B2BC122D-5FAD-473A-898E-F7B8C9E30A70}"/>
               </a:ext>
             </a:extLst>
           </p:cNvPr>
@@ -5370,7 +5370,7 @@
           <p:cNvPr id="5" name="">
             <a:extLst xmlns:a="http://schemas.openxmlformats.org/drawingml/2006/main">
               <a:ext uri="{FF2B5EF4-FFF2-40B4-BE49-F238E27FC236}">
-                <a16:creationId xmlns:a16="http://schemas.microsoft.com/office/drawing/2014/main" id="{3CD022C2-9753-4E77-AE39-CE464ED1A2FE}"/>
+                <a16:creationId xmlns:a16="http://schemas.microsoft.com/office/drawing/2014/main" id="{CA0D7476-7711-4C24-8656-041ACF2A881E}"/>
               </a:ext>
             </a:extLst>
           </p:cNvPr>
@@ -5427,7 +5427,7 @@
           <p:cNvPr id="6" name="">
             <a:extLst xmlns:a="http://schemas.openxmlformats.org/drawingml/2006/main">
               <a:ext uri="{FF2B5EF4-FFF2-40B4-BE49-F238E27FC236}">
-                <a16:creationId xmlns:a16="http://schemas.microsoft.com/office/drawing/2014/main" id="{FC77F97D-76B6-417C-8DCC-E53363896343}"/>
+                <a16:creationId xmlns:a16="http://schemas.microsoft.com/office/drawing/2014/main" id="{65F51116-46A3-4F84-A65E-3D356220E20F}"/>
               </a:ext>
             </a:extLst>
           </p:cNvPr>
@@ -5482,7 +5482,7 @@
     </p:spTree>
     <p:extLst>
       <p:ext uri="{BB962C8B-B14F-4D97-AF65-F5344CB8AC3E}">
-        <p14:creationId xmlns:p14="http://schemas.microsoft.com/office/powerpoint/2010/main" val="70475244"/>
+        <p14:creationId xmlns:p14="http://schemas.microsoft.com/office/powerpoint/2010/main" val="2052660444"/>
       </p:ext>
     </p:extLst>
   </p:cSld>
@@ -5513,7 +5513,7 @@
           <p:cNvPr id="6" name="">
             <a:extLst xmlns:a="http://schemas.openxmlformats.org/drawingml/2006/main">
               <a:ext uri="{FF2B5EF4-FFF2-40B4-BE49-F238E27FC236}">
-                <a16:creationId xmlns:a16="http://schemas.microsoft.com/office/drawing/2014/main" id="{A61AA6F1-3916-4715-A4BF-A59B899CA302}"/>
+                <a16:creationId xmlns:a16="http://schemas.microsoft.com/office/drawing/2014/main" id="{79E9541E-9BE2-4655-9E51-A26181D9E0A6}"/>
               </a:ext>
             </a:extLst>
           </p:cNvPr>
@@ -5986,7 +5986,7 @@
           <p:cNvPr id="3" name="">
             <a:extLst xmlns:a="http://schemas.openxmlformats.org/drawingml/2006/main">
               <a:ext uri="{FF2B5EF4-FFF2-40B4-BE49-F238E27FC236}">
-                <a16:creationId xmlns:a16="http://schemas.microsoft.com/office/drawing/2014/main" id="{CF50F0F7-5690-4FD5-88D3-7F2733A8D888}"/>
+                <a16:creationId xmlns:a16="http://schemas.microsoft.com/office/drawing/2014/main" id="{356DF9EF-4642-4D73-9CED-E20374E2D83F}"/>
               </a:ext>
             </a:extLst>
           </p:cNvPr>
@@ -6089,7 +6089,7 @@
           <p:cNvPr id="4" name="">
             <a:extLst xmlns:a="http://schemas.openxmlformats.org/drawingml/2006/main">
               <a:ext uri="{FF2B5EF4-FFF2-40B4-BE49-F238E27FC236}">
-                <a16:creationId xmlns:a16="http://schemas.microsoft.com/office/drawing/2014/main" id="{1143A8C4-4ECF-4812-BBAE-6C3EB4CCC97C}"/>
+                <a16:creationId xmlns:a16="http://schemas.microsoft.com/office/drawing/2014/main" id="{E80B32BE-3493-4E62-A6FE-E587DC68B6B3}"/>
               </a:ext>
             </a:extLst>
           </p:cNvPr>
@@ -6146,7 +6146,7 @@
           <p:cNvPr id="5" name="">
             <a:extLst xmlns:a="http://schemas.openxmlformats.org/drawingml/2006/main">
               <a:ext uri="{FF2B5EF4-FFF2-40B4-BE49-F238E27FC236}">
-                <a16:creationId xmlns:a16="http://schemas.microsoft.com/office/drawing/2014/main" id="{60872DA1-D746-444E-856E-EC15A00FFB78}"/>
+                <a16:creationId xmlns:a16="http://schemas.microsoft.com/office/drawing/2014/main" id="{D8C7A04B-459A-4991-90D3-94C1595DBCD5}"/>
               </a:ext>
             </a:extLst>
           </p:cNvPr>
@@ -6201,7 +6201,7 @@
     </p:spTree>
     <p:extLst>
       <p:ext uri="{BB962C8B-B14F-4D97-AF65-F5344CB8AC3E}">
-        <p14:creationId xmlns:p14="http://schemas.microsoft.com/office/powerpoint/2010/main" val="1847045405"/>
+        <p14:creationId xmlns:p14="http://schemas.microsoft.com/office/powerpoint/2010/main" val="115698480"/>
       </p:ext>
     </p:extLst>
   </p:cSld>
@@ -6232,7 +6232,7 @@
           <p:cNvPr id="5" name="">
             <a:extLst xmlns:a="http://schemas.openxmlformats.org/drawingml/2006/main">
               <a:ext uri="{FF2B5EF4-FFF2-40B4-BE49-F238E27FC236}">
-                <a16:creationId xmlns:a16="http://schemas.microsoft.com/office/drawing/2014/main" id="{B2FBF6F0-D671-449A-8C50-171E16586F97}"/>
+                <a16:creationId xmlns:a16="http://schemas.microsoft.com/office/drawing/2014/main" id="{43725856-7D84-48E6-8B39-21EE86D88B8A}"/>
               </a:ext>
             </a:extLst>
           </p:cNvPr>
@@ -6682,7 +6682,7 @@
           <p:cNvPr id="3" name="">
             <a:extLst xmlns:a="http://schemas.openxmlformats.org/drawingml/2006/main">
               <a:ext uri="{FF2B5EF4-FFF2-40B4-BE49-F238E27FC236}">
-                <a16:creationId xmlns:a16="http://schemas.microsoft.com/office/drawing/2014/main" id="{5EDA7004-3F73-4EF9-9B52-DBE2B8AC720E}"/>
+                <a16:creationId xmlns:a16="http://schemas.microsoft.com/office/drawing/2014/main" id="{0578110E-1D26-4133-953B-95D835A3F288}"/>
               </a:ext>
             </a:extLst>
           </p:cNvPr>
@@ -6729,7 +6729,7 @@
                 <a:ea typeface="Arial"/>
                 <a:cs typeface="Arial"/>
               </a:rPr>
-              <a:t>The classifier runs locally. Browser and GPU serving are separate extensions.</a:t>
+              <a:t>Classifier inference runs on CPU. Browser and GPU serving are separate extensions.</a:t>
             </a:r>
           </a:p>
         </p:txBody>
@@ -6739,7 +6739,7 @@
           <p:cNvPr id="4" name="">
             <a:extLst xmlns:a="http://schemas.openxmlformats.org/drawingml/2006/main">
               <a:ext uri="{FF2B5EF4-FFF2-40B4-BE49-F238E27FC236}">
-                <a16:creationId xmlns:a16="http://schemas.microsoft.com/office/drawing/2014/main" id="{9330C6FD-5434-4EF1-AE04-081D49EDAD12}"/>
+                <a16:creationId xmlns:a16="http://schemas.microsoft.com/office/drawing/2014/main" id="{7C461DFC-C393-4280-83EE-8C59C6DCF3C1}"/>
               </a:ext>
             </a:extLst>
           </p:cNvPr>
@@ -6794,7 +6794,7 @@
     </p:spTree>
     <p:extLst>
       <p:ext uri="{BB962C8B-B14F-4D97-AF65-F5344CB8AC3E}">
-        <p14:creationId xmlns:p14="http://schemas.microsoft.com/office/powerpoint/2010/main" val="874223036"/>
+        <p14:creationId xmlns:p14="http://schemas.microsoft.com/office/powerpoint/2010/main" val="849614235"/>
       </p:ext>
     </p:extLst>
   </p:cSld>
@@ -6825,7 +6825,7 @@
           <p:cNvPr id="13" name="">
             <a:extLst xmlns:a="http://schemas.openxmlformats.org/drawingml/2006/main">
               <a:ext uri="{FF2B5EF4-FFF2-40B4-BE49-F238E27FC236}">
-                <a16:creationId xmlns:a16="http://schemas.microsoft.com/office/drawing/2014/main" id="{20A7E996-1C43-4D09-B90E-0D6C09BFF360}"/>
+                <a16:creationId xmlns:a16="http://schemas.microsoft.com/office/drawing/2014/main" id="{8C709DDD-2984-4051-9F3E-FE3D88FCEDBD}"/>
               </a:ext>
             </a:extLst>
           </p:cNvPr>
@@ -6882,7 +6882,7 @@
           <p:cNvPr id="2" name="">
             <a:extLst xmlns:a="http://schemas.openxmlformats.org/drawingml/2006/main">
               <a:ext uri="{FF2B5EF4-FFF2-40B4-BE49-F238E27FC236}">
-                <a16:creationId xmlns:a16="http://schemas.microsoft.com/office/drawing/2014/main" id="{7791F6DC-4447-400A-A802-B5A116D55A49}"/>
+                <a16:creationId xmlns:a16="http://schemas.microsoft.com/office/drawing/2014/main" id="{CD1F340B-09FE-430C-A227-78F5E3F3AD2D}"/>
               </a:ext>
             </a:extLst>
           </p:cNvPr>
@@ -6939,7 +6939,7 @@
           <p:cNvPr id="3" name="">
             <a:extLst xmlns:a="http://schemas.openxmlformats.org/drawingml/2006/main">
               <a:ext uri="{FF2B5EF4-FFF2-40B4-BE49-F238E27FC236}">
-                <a16:creationId xmlns:a16="http://schemas.microsoft.com/office/drawing/2014/main" id="{71927681-02CA-49FB-AB02-5887F6777373}"/>
+                <a16:creationId xmlns:a16="http://schemas.microsoft.com/office/drawing/2014/main" id="{FE5B5AAF-3E1F-4959-B438-30EAE28CE5B1}"/>
               </a:ext>
             </a:extLst>
           </p:cNvPr>
@@ -6996,7 +6996,7 @@
           <p:cNvPr id="4" name="">
             <a:extLst xmlns:a="http://schemas.openxmlformats.org/drawingml/2006/main">
               <a:ext uri="{FF2B5EF4-FFF2-40B4-BE49-F238E27FC236}">
-                <a16:creationId xmlns:a16="http://schemas.microsoft.com/office/drawing/2014/main" id="{743A4E89-63E1-4A38-9C6C-7CFE10284B03}"/>
+                <a16:creationId xmlns:a16="http://schemas.microsoft.com/office/drawing/2014/main" id="{41AC31F3-F8C2-4835-B246-C420621AB01C}"/>
               </a:ext>
             </a:extLst>
           </p:cNvPr>
@@ -7053,7 +7053,7 @@
           <p:cNvPr id="5" name="">
             <a:extLst xmlns:a="http://schemas.openxmlformats.org/drawingml/2006/main">
               <a:ext uri="{FF2B5EF4-FFF2-40B4-BE49-F238E27FC236}">
-                <a16:creationId xmlns:a16="http://schemas.microsoft.com/office/drawing/2014/main" id="{B3B7C0A5-0D42-4D18-A626-606A519B1B8C}"/>
+                <a16:creationId xmlns:a16="http://schemas.microsoft.com/office/drawing/2014/main" id="{E0E00876-4B43-4C7E-98EF-D1CC8A8392AD}"/>
               </a:ext>
             </a:extLst>
           </p:cNvPr>
@@ -7110,7 +7110,7 @@
           <p:cNvPr id="6" name="">
             <a:extLst xmlns:a="http://schemas.openxmlformats.org/drawingml/2006/main">
               <a:ext uri="{FF2B5EF4-FFF2-40B4-BE49-F238E27FC236}">
-                <a16:creationId xmlns:a16="http://schemas.microsoft.com/office/drawing/2014/main" id="{5FE1F93A-7FE0-41D3-81BC-10434F8739A8}"/>
+                <a16:creationId xmlns:a16="http://schemas.microsoft.com/office/drawing/2014/main" id="{4FD6FB9C-F8B3-4FF9-96FA-2C2BB4390052}"/>
               </a:ext>
             </a:extLst>
           </p:cNvPr>
@@ -7167,7 +7167,7 @@
           <p:cNvPr id="7" name="">
             <a:extLst xmlns:a="http://schemas.openxmlformats.org/drawingml/2006/main">
               <a:ext uri="{FF2B5EF4-FFF2-40B4-BE49-F238E27FC236}">
-                <a16:creationId xmlns:a16="http://schemas.microsoft.com/office/drawing/2014/main" id="{689997CC-D01E-40A3-BE6D-BB3F7C86370A}"/>
+                <a16:creationId xmlns:a16="http://schemas.microsoft.com/office/drawing/2014/main" id="{EDD7A91E-403D-4A05-BA41-AD54BD9605D2}"/>
               </a:ext>
             </a:extLst>
           </p:cNvPr>
@@ -7224,7 +7224,7 @@
           <p:cNvPr id="8" name="">
             <a:extLst xmlns:a="http://schemas.openxmlformats.org/drawingml/2006/main">
               <a:ext uri="{FF2B5EF4-FFF2-40B4-BE49-F238E27FC236}">
-                <a16:creationId xmlns:a16="http://schemas.microsoft.com/office/drawing/2014/main" id="{EBC05D7C-94E8-4235-821C-7CB0E8E91640}"/>
+                <a16:creationId xmlns:a16="http://schemas.microsoft.com/office/drawing/2014/main" id="{BB3E68DC-046C-4C5D-8C2A-FAACE6A1C97F}"/>
               </a:ext>
             </a:extLst>
           </p:cNvPr>
@@ -7281,7 +7281,7 @@
           <p:cNvPr id="9" name="">
             <a:extLst xmlns:a="http://schemas.openxmlformats.org/drawingml/2006/main">
               <a:ext uri="{FF2B5EF4-FFF2-40B4-BE49-F238E27FC236}">
-                <a16:creationId xmlns:a16="http://schemas.microsoft.com/office/drawing/2014/main" id="{F45A3D20-4208-4206-B3DD-8460D3F436B2}"/>
+                <a16:creationId xmlns:a16="http://schemas.microsoft.com/office/drawing/2014/main" id="{CDAD74EC-C774-4944-A72D-AAEE4FC0249B}"/>
               </a:ext>
             </a:extLst>
           </p:cNvPr>
@@ -7338,7 +7338,7 @@
           <p:cNvPr id="10" name="">
             <a:extLst xmlns:a="http://schemas.openxmlformats.org/drawingml/2006/main">
               <a:ext uri="{FF2B5EF4-FFF2-40B4-BE49-F238E27FC236}">
-                <a16:creationId xmlns:a16="http://schemas.microsoft.com/office/drawing/2014/main" id="{727C0E31-B7FA-4758-9BE0-BBA225CD2D8E}"/>
+                <a16:creationId xmlns:a16="http://schemas.microsoft.com/office/drawing/2014/main" id="{582E560B-386D-422C-8D59-2AB608CFCD52}"/>
               </a:ext>
             </a:extLst>
           </p:cNvPr>
@@ -7395,7 +7395,7 @@
           <p:cNvPr id="11" name="">
             <a:extLst xmlns:a="http://schemas.openxmlformats.org/drawingml/2006/main">
               <a:ext uri="{FF2B5EF4-FFF2-40B4-BE49-F238E27FC236}">
-                <a16:creationId xmlns:a16="http://schemas.microsoft.com/office/drawing/2014/main" id="{F5814273-0B3E-4731-B151-5A38D062B070}"/>
+                <a16:creationId xmlns:a16="http://schemas.microsoft.com/office/drawing/2014/main" id="{40AFC660-75E5-48C7-A779-3E3F40372C7D}"/>
               </a:ext>
             </a:extLst>
           </p:cNvPr>
@@ -7442,7 +7442,7 @@
                 <a:ea typeface="Arial"/>
                 <a:cs typeface="Arial"/>
               </a:rPr>
-              <a:t>Live: the local Gradio app loads the exported artifact.</a:t>
+              <a:t>Live: Colab inference uses the exported INT8 artifact.</a:t>
             </a:r>
           </a:p>
         </p:txBody>
@@ -7452,7 +7452,7 @@
           <p:cNvPr id="12" name="">
             <a:extLst xmlns:a="http://schemas.openxmlformats.org/drawingml/2006/main">
               <a:ext uri="{FF2B5EF4-FFF2-40B4-BE49-F238E27FC236}">
-                <a16:creationId xmlns:a16="http://schemas.microsoft.com/office/drawing/2014/main" id="{8CFBE7D8-864C-4407-8936-8B5EA8FE962D}"/>
+                <a16:creationId xmlns:a16="http://schemas.microsoft.com/office/drawing/2014/main" id="{391847B4-6F03-4822-BA3B-2688BC2E3DA5}"/>
               </a:ext>
             </a:extLst>
           </p:cNvPr>
@@ -7507,7 +7507,7 @@
     </p:spTree>
     <p:extLst>
       <p:ext uri="{BB962C8B-B14F-4D97-AF65-F5344CB8AC3E}">
-        <p14:creationId xmlns:p14="http://schemas.microsoft.com/office/powerpoint/2010/main" val="1268091682"/>
+        <p14:creationId xmlns:p14="http://schemas.microsoft.com/office/powerpoint/2010/main" val="2136777365"/>
       </p:ext>
     </p:extLst>
   </p:cSld>
@@ -7538,7 +7538,7 @@
           <p:cNvPr id="14" name="">
             <a:extLst xmlns:a="http://schemas.openxmlformats.org/drawingml/2006/main">
               <a:ext uri="{FF2B5EF4-FFF2-40B4-BE49-F238E27FC236}">
-                <a16:creationId xmlns:a16="http://schemas.microsoft.com/office/drawing/2014/main" id="{2D0CA967-67C6-4855-8079-ACDA7BBE7074}"/>
+                <a16:creationId xmlns:a16="http://schemas.microsoft.com/office/drawing/2014/main" id="{0EA624FC-5A3A-43AD-973D-5E137F448A77}"/>
               </a:ext>
             </a:extLst>
           </p:cNvPr>
@@ -7595,7 +7595,7 @@
           <p:cNvPr id="2" name="">
             <a:extLst xmlns:a="http://schemas.openxmlformats.org/drawingml/2006/main">
               <a:ext uri="{FF2B5EF4-FFF2-40B4-BE49-F238E27FC236}">
-                <a16:creationId xmlns:a16="http://schemas.microsoft.com/office/drawing/2014/main" id="{D7E84DA5-41D2-4784-B662-7D248DBF82C4}"/>
+                <a16:creationId xmlns:a16="http://schemas.microsoft.com/office/drawing/2014/main" id="{B0A6C2D2-0021-4193-8FF3-27480A213DDE}"/>
               </a:ext>
             </a:extLst>
           </p:cNvPr>
@@ -7652,7 +7652,7 @@
           <p:cNvPr id="3" name="">
             <a:extLst xmlns:a="http://schemas.openxmlformats.org/drawingml/2006/main">
               <a:ext uri="{FF2B5EF4-FFF2-40B4-BE49-F238E27FC236}">
-                <a16:creationId xmlns:a16="http://schemas.microsoft.com/office/drawing/2014/main" id="{56DA1290-168B-43E2-BFB0-0990C256B696}"/>
+                <a16:creationId xmlns:a16="http://schemas.microsoft.com/office/drawing/2014/main" id="{DEBCCA90-D068-49A8-B8A8-21D9A1EEAC7E}"/>
               </a:ext>
             </a:extLst>
           </p:cNvPr>
@@ -7709,7 +7709,7 @@
           <p:cNvPr id="4" name="">
             <a:extLst xmlns:a="http://schemas.openxmlformats.org/drawingml/2006/main">
               <a:ext uri="{FF2B5EF4-FFF2-40B4-BE49-F238E27FC236}">
-                <a16:creationId xmlns:a16="http://schemas.microsoft.com/office/drawing/2014/main" id="{05221792-1BE6-41FF-B093-88D3592B0215}"/>
+                <a16:creationId xmlns:a16="http://schemas.microsoft.com/office/drawing/2014/main" id="{A3524B7D-CE24-43C1-BEF0-4CC0DB806DC1}"/>
               </a:ext>
             </a:extLst>
           </p:cNvPr>
@@ -7766,7 +7766,7 @@
           <p:cNvPr id="5" name="">
             <a:extLst xmlns:a="http://schemas.openxmlformats.org/drawingml/2006/main">
               <a:ext uri="{FF2B5EF4-FFF2-40B4-BE49-F238E27FC236}">
-                <a16:creationId xmlns:a16="http://schemas.microsoft.com/office/drawing/2014/main" id="{D25DCD2A-843B-499D-9705-A24FB9036DFE}"/>
+                <a16:creationId xmlns:a16="http://schemas.microsoft.com/office/drawing/2014/main" id="{2CD1A1D6-FA8B-476A-BC25-4EA78352A0CA}"/>
               </a:ext>
             </a:extLst>
           </p:cNvPr>
@@ -7823,7 +7823,7 @@
           <p:cNvPr id="6" name="">
             <a:extLst xmlns:a="http://schemas.openxmlformats.org/drawingml/2006/main">
               <a:ext uri="{FF2B5EF4-FFF2-40B4-BE49-F238E27FC236}">
-                <a16:creationId xmlns:a16="http://schemas.microsoft.com/office/drawing/2014/main" id="{8CA3C76E-3BB1-4698-8CBD-BA9E86F374DD}"/>
+                <a16:creationId xmlns:a16="http://schemas.microsoft.com/office/drawing/2014/main" id="{DEF35B2B-E0D1-4C83-8A39-B9216353A5E9}"/>
               </a:ext>
             </a:extLst>
           </p:cNvPr>
@@ -7880,7 +7880,7 @@
           <p:cNvPr id="7" name="">
             <a:extLst xmlns:a="http://schemas.openxmlformats.org/drawingml/2006/main">
               <a:ext uri="{FF2B5EF4-FFF2-40B4-BE49-F238E27FC236}">
-                <a16:creationId xmlns:a16="http://schemas.microsoft.com/office/drawing/2014/main" id="{7C9605C0-7292-442C-8415-F241E3E6D606}"/>
+                <a16:creationId xmlns:a16="http://schemas.microsoft.com/office/drawing/2014/main" id="{DC677392-0033-4CA1-89AA-5E301F0AFAF7}"/>
               </a:ext>
             </a:extLst>
           </p:cNvPr>
@@ -7937,7 +7937,7 @@
           <p:cNvPr id="8" name="">
             <a:extLst xmlns:a="http://schemas.openxmlformats.org/drawingml/2006/main">
               <a:ext uri="{FF2B5EF4-FFF2-40B4-BE49-F238E27FC236}">
-                <a16:creationId xmlns:a16="http://schemas.microsoft.com/office/drawing/2014/main" id="{E95BADF8-43A5-4913-B957-AD3A050569D7}"/>
+                <a16:creationId xmlns:a16="http://schemas.microsoft.com/office/drawing/2014/main" id="{F3876D11-52D5-46AB-8D45-E2E6DDADE2E6}"/>
               </a:ext>
             </a:extLst>
           </p:cNvPr>
@@ -7994,7 +7994,7 @@
           <p:cNvPr id="9" name="">
             <a:extLst xmlns:a="http://schemas.openxmlformats.org/drawingml/2006/main">
               <a:ext uri="{FF2B5EF4-FFF2-40B4-BE49-F238E27FC236}">
-                <a16:creationId xmlns:a16="http://schemas.microsoft.com/office/drawing/2014/main" id="{14DA0C9C-A668-441A-9649-AB7003393917}"/>
+                <a16:creationId xmlns:a16="http://schemas.microsoft.com/office/drawing/2014/main" id="{B97290D4-FDA5-477E-AEE4-F2C334C7F067}"/>
               </a:ext>
             </a:extLst>
           </p:cNvPr>
@@ -8051,7 +8051,7 @@
           <p:cNvPr id="10" name="">
             <a:extLst xmlns:a="http://schemas.openxmlformats.org/drawingml/2006/main">
               <a:ext uri="{FF2B5EF4-FFF2-40B4-BE49-F238E27FC236}">
-                <a16:creationId xmlns:a16="http://schemas.microsoft.com/office/drawing/2014/main" id="{B242BB41-1E66-4F80-A23D-0CF87C0C0E88}"/>
+                <a16:creationId xmlns:a16="http://schemas.microsoft.com/office/drawing/2014/main" id="{DE192DEF-7BC4-4DDF-A3D4-764A21DE7882}"/>
               </a:ext>
             </a:extLst>
           </p:cNvPr>
@@ -8108,7 +8108,7 @@
           <p:cNvPr id="11" name="">
             <a:extLst xmlns:a="http://schemas.openxmlformats.org/drawingml/2006/main">
               <a:ext uri="{FF2B5EF4-FFF2-40B4-BE49-F238E27FC236}">
-                <a16:creationId xmlns:a16="http://schemas.microsoft.com/office/drawing/2014/main" id="{E167CBEA-6B0D-4919-B8B6-DCBB8CFE542D}"/>
+                <a16:creationId xmlns:a16="http://schemas.microsoft.com/office/drawing/2014/main" id="{491EC6F5-6DEA-413F-B22B-F64A1687F9CA}"/>
               </a:ext>
             </a:extLst>
           </p:cNvPr>
@@ -8165,7 +8165,7 @@
           <p:cNvPr id="12" name="">
             <a:extLst xmlns:a="http://schemas.openxmlformats.org/drawingml/2006/main">
               <a:ext uri="{FF2B5EF4-FFF2-40B4-BE49-F238E27FC236}">
-                <a16:creationId xmlns:a16="http://schemas.microsoft.com/office/drawing/2014/main" id="{8FFD264A-FB55-4907-B3E6-D35AE04E8F6C}"/>
+                <a16:creationId xmlns:a16="http://schemas.microsoft.com/office/drawing/2014/main" id="{78F843C3-8888-4CD8-B997-437010478B67}"/>
               </a:ext>
             </a:extLst>
           </p:cNvPr>
@@ -8222,7 +8222,7 @@
           <p:cNvPr id="13" name="">
             <a:extLst xmlns:a="http://schemas.openxmlformats.org/drawingml/2006/main">
               <a:ext uri="{FF2B5EF4-FFF2-40B4-BE49-F238E27FC236}">
-                <a16:creationId xmlns:a16="http://schemas.microsoft.com/office/drawing/2014/main" id="{70C0780F-12D1-4C8B-94B0-C0AC12EFC2E1}"/>
+                <a16:creationId xmlns:a16="http://schemas.microsoft.com/office/drawing/2014/main" id="{8BE74866-9F7E-4F0D-8D5D-AD0A3413E55C}"/>
               </a:ext>
             </a:extLst>
           </p:cNvPr>
@@ -8277,7 +8277,7 @@
     </p:spTree>
     <p:extLst>
       <p:ext uri="{BB962C8B-B14F-4D97-AF65-F5344CB8AC3E}">
-        <p14:creationId xmlns:p14="http://schemas.microsoft.com/office/powerpoint/2010/main" val="1620675841"/>
+        <p14:creationId xmlns:p14="http://schemas.microsoft.com/office/powerpoint/2010/main" val="1794930296"/>
       </p:ext>
     </p:extLst>
   </p:cSld>
@@ -8308,7 +8308,7 @@
           <p:cNvPr id="8" name="">
             <a:extLst xmlns:a="http://schemas.openxmlformats.org/drawingml/2006/main">
               <a:ext uri="{FF2B5EF4-FFF2-40B4-BE49-F238E27FC236}">
-                <a16:creationId xmlns:a16="http://schemas.microsoft.com/office/drawing/2014/main" id="{D786BFF3-E6E3-40A6-A5B6-159A7F200892}"/>
+                <a16:creationId xmlns:a16="http://schemas.microsoft.com/office/drawing/2014/main" id="{5D87E656-CC30-4A65-9A18-97FE7E92E7C4}"/>
               </a:ext>
             </a:extLst>
           </p:cNvPr>
@@ -8365,7 +8365,7 @@
           <p:cNvPr id="2" name="">
             <a:extLst xmlns:a="http://schemas.openxmlformats.org/drawingml/2006/main">
               <a:ext uri="{FF2B5EF4-FFF2-40B4-BE49-F238E27FC236}">
-                <a16:creationId xmlns:a16="http://schemas.microsoft.com/office/drawing/2014/main" id="{781C71BA-A360-410A-BCED-AE07DBC13457}"/>
+                <a16:creationId xmlns:a16="http://schemas.microsoft.com/office/drawing/2014/main" id="{410190D6-3748-41D5-B901-27FD58B7E525}"/>
               </a:ext>
             </a:extLst>
           </p:cNvPr>
@@ -8422,7 +8422,7 @@
           <p:cNvPr id="3" name="">
             <a:extLst xmlns:a="http://schemas.openxmlformats.org/drawingml/2006/main">
               <a:ext uri="{FF2B5EF4-FFF2-40B4-BE49-F238E27FC236}">
-                <a16:creationId xmlns:a16="http://schemas.microsoft.com/office/drawing/2014/main" id="{B1097EAF-12AF-4DDA-8716-FB09B364FAED}"/>
+                <a16:creationId xmlns:a16="http://schemas.microsoft.com/office/drawing/2014/main" id="{54F719D2-7D46-409F-8461-2FB9CF025683}"/>
               </a:ext>
             </a:extLst>
           </p:cNvPr>
@@ -8535,7 +8535,7 @@
           <p:cNvPr id="4" name="">
             <a:extLst xmlns:a="http://schemas.openxmlformats.org/drawingml/2006/main">
               <a:ext uri="{FF2B5EF4-FFF2-40B4-BE49-F238E27FC236}">
-                <a16:creationId xmlns:a16="http://schemas.microsoft.com/office/drawing/2014/main" id="{51DD5A3C-5D3C-492A-A3E9-5A9C6C9C092D}"/>
+                <a16:creationId xmlns:a16="http://schemas.microsoft.com/office/drawing/2014/main" id="{83674FC4-DDE4-48A5-A635-E283B1C3DCEF}"/>
               </a:ext>
             </a:extLst>
           </p:cNvPr>
@@ -8592,7 +8592,7 @@
           <p:cNvPr id="5" name="">
             <a:extLst xmlns:a="http://schemas.openxmlformats.org/drawingml/2006/main">
               <a:ext uri="{FF2B5EF4-FFF2-40B4-BE49-F238E27FC236}">
-                <a16:creationId xmlns:a16="http://schemas.microsoft.com/office/drawing/2014/main" id="{E1A84C0E-2AD7-4222-BA0A-1B15A129DC3A}"/>
+                <a16:creationId xmlns:a16="http://schemas.microsoft.com/office/drawing/2014/main" id="{1E997BA8-E1AE-4C9D-A952-1BC8394B31B6}"/>
               </a:ext>
             </a:extLst>
           </p:cNvPr>
@@ -8705,7 +8705,7 @@
           <p:cNvPr id="6" name="">
             <a:extLst xmlns:a="http://schemas.openxmlformats.org/drawingml/2006/main">
               <a:ext uri="{FF2B5EF4-FFF2-40B4-BE49-F238E27FC236}">
-                <a16:creationId xmlns:a16="http://schemas.microsoft.com/office/drawing/2014/main" id="{FF7C8986-4D6A-4629-BEC4-40D7D00D45CD}"/>
+                <a16:creationId xmlns:a16="http://schemas.microsoft.com/office/drawing/2014/main" id="{CA284EFF-610A-4AB2-81F1-0E6DE0FDAD67}"/>
               </a:ext>
             </a:extLst>
           </p:cNvPr>
@@ -8762,7 +8762,7 @@
           <p:cNvPr id="7" name="">
             <a:extLst xmlns:a="http://schemas.openxmlformats.org/drawingml/2006/main">
               <a:ext uri="{FF2B5EF4-FFF2-40B4-BE49-F238E27FC236}">
-                <a16:creationId xmlns:a16="http://schemas.microsoft.com/office/drawing/2014/main" id="{0DCE8E6C-7C86-449A-AA4A-CEEEE3EF2E48}"/>
+                <a16:creationId xmlns:a16="http://schemas.microsoft.com/office/drawing/2014/main" id="{9312E6DA-ECC1-41DE-8A4A-4C97289BE08D}"/>
               </a:ext>
             </a:extLst>
           </p:cNvPr>
@@ -8817,7 +8817,7 @@
     </p:spTree>
     <p:extLst>
       <p:ext uri="{BB962C8B-B14F-4D97-AF65-F5344CB8AC3E}">
-        <p14:creationId xmlns:p14="http://schemas.microsoft.com/office/powerpoint/2010/main" val="134469945"/>
+        <p14:creationId xmlns:p14="http://schemas.microsoft.com/office/powerpoint/2010/main" val="1383983570"/>
       </p:ext>
     </p:extLst>
   </p:cSld>
@@ -8848,7 +8848,7 @@
           <p:cNvPr id="5" name="">
             <a:extLst xmlns:a="http://schemas.openxmlformats.org/drawingml/2006/main">
               <a:ext uri="{FF2B5EF4-FFF2-40B4-BE49-F238E27FC236}">
-                <a16:creationId xmlns:a16="http://schemas.microsoft.com/office/drawing/2014/main" id="{A6DCF558-95B5-4927-A326-941F756BE4F1}"/>
+                <a16:creationId xmlns:a16="http://schemas.microsoft.com/office/drawing/2014/main" id="{F87A9539-A34E-4167-BE38-295AF0643098}"/>
               </a:ext>
             </a:extLst>
           </p:cNvPr>
@@ -8905,7 +8905,7 @@
           <p:cNvPr id="2" name="">
             <a:extLst xmlns:a="http://schemas.openxmlformats.org/drawingml/2006/main">
               <a:ext uri="{FF2B5EF4-FFF2-40B4-BE49-F238E27FC236}">
-                <a16:creationId xmlns:a16="http://schemas.microsoft.com/office/drawing/2014/main" id="{EC6F522B-4D4F-4D9A-A99D-8FAA6F79F105}"/>
+                <a16:creationId xmlns:a16="http://schemas.microsoft.com/office/drawing/2014/main" id="{12018163-5C73-4D0B-8BCD-F199226F6867}"/>
               </a:ext>
             </a:extLst>
           </p:cNvPr>
@@ -8985,7 +8985,7 @@
           <p:cNvPr id="3" name="">
             <a:extLst xmlns:a="http://schemas.openxmlformats.org/drawingml/2006/main">
               <a:ext uri="{FF2B5EF4-FFF2-40B4-BE49-F238E27FC236}">
-                <a16:creationId xmlns:a16="http://schemas.microsoft.com/office/drawing/2014/main" id="{1EBD76CF-7BDB-41A5-93ED-0CFAD1C7FF3B}"/>
+                <a16:creationId xmlns:a16="http://schemas.microsoft.com/office/drawing/2014/main" id="{A9B82C6A-61C5-4FA9-822F-2C5833C180E7}"/>
               </a:ext>
             </a:extLst>
           </p:cNvPr>
@@ -9042,7 +9042,7 @@
           <p:cNvPr id="4" name="">
             <a:extLst xmlns:a="http://schemas.openxmlformats.org/drawingml/2006/main">
               <a:ext uri="{FF2B5EF4-FFF2-40B4-BE49-F238E27FC236}">
-                <a16:creationId xmlns:a16="http://schemas.microsoft.com/office/drawing/2014/main" id="{DA0D7C7E-B60A-49C3-B36E-A2F38687000F}"/>
+                <a16:creationId xmlns:a16="http://schemas.microsoft.com/office/drawing/2014/main" id="{E1C4A67F-7FE6-4E4A-BEFD-80272FF3CA69}"/>
               </a:ext>
             </a:extLst>
           </p:cNvPr>
@@ -9097,7 +9097,7 @@
     </p:spTree>
     <p:extLst>
       <p:ext uri="{BB962C8B-B14F-4D97-AF65-F5344CB8AC3E}">
-        <p14:creationId xmlns:p14="http://schemas.microsoft.com/office/powerpoint/2010/main" val="2119209004"/>
+        <p14:creationId xmlns:p14="http://schemas.microsoft.com/office/powerpoint/2010/main" val="2139175565"/>
       </p:ext>
     </p:extLst>
   </p:cSld>
@@ -9128,7 +9128,7 @@
           <p:cNvPr id="8" name="">
             <a:extLst xmlns:a="http://schemas.openxmlformats.org/drawingml/2006/main">
               <a:ext uri="{FF2B5EF4-FFF2-40B4-BE49-F238E27FC236}">
-                <a16:creationId xmlns:a16="http://schemas.microsoft.com/office/drawing/2014/main" id="{285D05CA-3243-44ED-B0B5-D6153521A561}"/>
+                <a16:creationId xmlns:a16="http://schemas.microsoft.com/office/drawing/2014/main" id="{F191F2F3-717E-4896-A323-5EC51DC39221}"/>
               </a:ext>
             </a:extLst>
           </p:cNvPr>
@@ -9185,7 +9185,7 @@
           <p:cNvPr id="2" name="">
             <a:extLst xmlns:a="http://schemas.openxmlformats.org/drawingml/2006/main">
               <a:ext uri="{FF2B5EF4-FFF2-40B4-BE49-F238E27FC236}">
-                <a16:creationId xmlns:a16="http://schemas.microsoft.com/office/drawing/2014/main" id="{607EC756-3759-441B-9AF6-69F48D68669E}"/>
+                <a16:creationId xmlns:a16="http://schemas.microsoft.com/office/drawing/2014/main" id="{D9BBF7BF-E090-4585-A904-7A02C8E1F039}"/>
               </a:ext>
             </a:extLst>
           </p:cNvPr>
@@ -9242,7 +9242,7 @@
           <p:cNvPr id="3" name="">
             <a:extLst xmlns:a="http://schemas.openxmlformats.org/drawingml/2006/main">
               <a:ext uri="{FF2B5EF4-FFF2-40B4-BE49-F238E27FC236}">
-                <a16:creationId xmlns:a16="http://schemas.microsoft.com/office/drawing/2014/main" id="{C472E86B-A807-4E9C-885C-DB488146FD1D}"/>
+                <a16:creationId xmlns:a16="http://schemas.microsoft.com/office/drawing/2014/main" id="{E907A231-79D0-4C71-B7C7-9E1DCAC51251}"/>
               </a:ext>
             </a:extLst>
           </p:cNvPr>
@@ -9368,7 +9368,7 @@
           <p:cNvPr id="4" name="">
             <a:extLst xmlns:a="http://schemas.openxmlformats.org/drawingml/2006/main">
               <a:ext uri="{FF2B5EF4-FFF2-40B4-BE49-F238E27FC236}">
-                <a16:creationId xmlns:a16="http://schemas.microsoft.com/office/drawing/2014/main" id="{A5CC6CF5-2923-4D7C-8D56-87A30966195A}"/>
+                <a16:creationId xmlns:a16="http://schemas.microsoft.com/office/drawing/2014/main" id="{95ECBE67-4154-4EE4-91DF-819B955D94E6}"/>
               </a:ext>
             </a:extLst>
           </p:cNvPr>
@@ -9425,7 +9425,7 @@
           <p:cNvPr id="5" name="">
             <a:extLst xmlns:a="http://schemas.openxmlformats.org/drawingml/2006/main">
               <a:ext uri="{FF2B5EF4-FFF2-40B4-BE49-F238E27FC236}">
-                <a16:creationId xmlns:a16="http://schemas.microsoft.com/office/drawing/2014/main" id="{421CAA6A-DD57-4D22-9ADA-0806C97F7608}"/>
+                <a16:creationId xmlns:a16="http://schemas.microsoft.com/office/drawing/2014/main" id="{73AA988C-083A-4BFC-8DB0-4B1A9F5F87A4}"/>
               </a:ext>
             </a:extLst>
           </p:cNvPr>
@@ -9574,7 +9574,7 @@
           <p:cNvPr id="6" name="">
             <a:extLst xmlns:a="http://schemas.openxmlformats.org/drawingml/2006/main">
               <a:ext uri="{FF2B5EF4-FFF2-40B4-BE49-F238E27FC236}">
-                <a16:creationId xmlns:a16="http://schemas.microsoft.com/office/drawing/2014/main" id="{A9FC0728-5EE7-4C65-A4D9-336383915E2F}"/>
+                <a16:creationId xmlns:a16="http://schemas.microsoft.com/office/drawing/2014/main" id="{5FD75B0F-C968-42C7-9A17-BA4417940204}"/>
               </a:ext>
             </a:extLst>
           </p:cNvPr>
@@ -9631,7 +9631,7 @@
           <p:cNvPr id="7" name="">
             <a:extLst xmlns:a="http://schemas.openxmlformats.org/drawingml/2006/main">
               <a:ext uri="{FF2B5EF4-FFF2-40B4-BE49-F238E27FC236}">
-                <a16:creationId xmlns:a16="http://schemas.microsoft.com/office/drawing/2014/main" id="{45328038-D218-4486-84CF-1D65B3452C9A}"/>
+                <a16:creationId xmlns:a16="http://schemas.microsoft.com/office/drawing/2014/main" id="{E2F3D303-D61F-456F-BF68-27613A6130F4}"/>
               </a:ext>
             </a:extLst>
           </p:cNvPr>
@@ -9686,7 +9686,7 @@
     </p:spTree>
     <p:extLst>
       <p:ext uri="{BB962C8B-B14F-4D97-AF65-F5344CB8AC3E}">
-        <p14:creationId xmlns:p14="http://schemas.microsoft.com/office/powerpoint/2010/main" val="2043566622"/>
+        <p14:creationId xmlns:p14="http://schemas.microsoft.com/office/powerpoint/2010/main" val="95443792"/>
       </p:ext>
     </p:extLst>
   </p:cSld>
@@ -9717,7 +9717,7 @@
           <p:cNvPr id="8" name="">
             <a:extLst xmlns:a="http://schemas.openxmlformats.org/drawingml/2006/main">
               <a:ext uri="{FF2B5EF4-FFF2-40B4-BE49-F238E27FC236}">
-                <a16:creationId xmlns:a16="http://schemas.microsoft.com/office/drawing/2014/main" id="{EA99EC8F-32A9-495B-8726-F856A64D5EF4}"/>
+                <a16:creationId xmlns:a16="http://schemas.microsoft.com/office/drawing/2014/main" id="{A307B69D-D1C3-4BD4-9B0C-F9092DB8706F}"/>
               </a:ext>
             </a:extLst>
           </p:cNvPr>
@@ -9774,7 +9774,7 @@
           <p:cNvPr id="2" name="">
             <a:extLst xmlns:a="http://schemas.openxmlformats.org/drawingml/2006/main">
               <a:ext uri="{FF2B5EF4-FFF2-40B4-BE49-F238E27FC236}">
-                <a16:creationId xmlns:a16="http://schemas.microsoft.com/office/drawing/2014/main" id="{3B4D2B30-4CFE-4D86-969E-D4C29356DFB5}"/>
+                <a16:creationId xmlns:a16="http://schemas.microsoft.com/office/drawing/2014/main" id="{32BAB402-C966-4547-974B-C19952236BAD}"/>
               </a:ext>
             </a:extLst>
           </p:cNvPr>
@@ -9831,7 +9831,7 @@
           <p:cNvPr id="3" name="">
             <a:extLst xmlns:a="http://schemas.openxmlformats.org/drawingml/2006/main">
               <a:ext uri="{FF2B5EF4-FFF2-40B4-BE49-F238E27FC236}">
-                <a16:creationId xmlns:a16="http://schemas.microsoft.com/office/drawing/2014/main" id="{29117B24-D472-465E-B974-2FA4DD9FF485}"/>
+                <a16:creationId xmlns:a16="http://schemas.microsoft.com/office/drawing/2014/main" id="{1D0B1951-801E-435C-BDAC-6368701CEFE1}"/>
               </a:ext>
             </a:extLst>
           </p:cNvPr>
@@ -9916,7 +9916,7 @@
           <p:cNvPr id="4" name="">
             <a:extLst xmlns:a="http://schemas.openxmlformats.org/drawingml/2006/main">
               <a:ext uri="{FF2B5EF4-FFF2-40B4-BE49-F238E27FC236}">
-                <a16:creationId xmlns:a16="http://schemas.microsoft.com/office/drawing/2014/main" id="{2B438E9B-083C-4326-BF04-266B6B4EFA25}"/>
+                <a16:creationId xmlns:a16="http://schemas.microsoft.com/office/drawing/2014/main" id="{4BBAB1BF-1C22-4041-8782-D8B01CC50294}"/>
               </a:ext>
             </a:extLst>
           </p:cNvPr>
@@ -9973,7 +9973,7 @@
           <p:cNvPr id="5" name="">
             <a:extLst xmlns:a="http://schemas.openxmlformats.org/drawingml/2006/main">
               <a:ext uri="{FF2B5EF4-FFF2-40B4-BE49-F238E27FC236}">
-                <a16:creationId xmlns:a16="http://schemas.microsoft.com/office/drawing/2014/main" id="{BDA7E04B-11ED-43C4-B8FF-59890E3BFBFB}"/>
+                <a16:creationId xmlns:a16="http://schemas.microsoft.com/office/drawing/2014/main" id="{A27A9CA3-C25E-4D4D-845B-D9C28F8FC50D}"/>
               </a:ext>
             </a:extLst>
           </p:cNvPr>
@@ -10109,7 +10109,7 @@
           <p:cNvPr id="6" name="">
             <a:extLst xmlns:a="http://schemas.openxmlformats.org/drawingml/2006/main">
               <a:ext uri="{FF2B5EF4-FFF2-40B4-BE49-F238E27FC236}">
-                <a16:creationId xmlns:a16="http://schemas.microsoft.com/office/drawing/2014/main" id="{707802D9-30CD-4812-AEFD-6BF7809B3B36}"/>
+                <a16:creationId xmlns:a16="http://schemas.microsoft.com/office/drawing/2014/main" id="{978E0665-963D-4881-A2A6-5E75572D0FC1}"/>
               </a:ext>
             </a:extLst>
           </p:cNvPr>
@@ -10166,7 +10166,7 @@
           <p:cNvPr id="7" name="">
             <a:extLst xmlns:a="http://schemas.openxmlformats.org/drawingml/2006/main">
               <a:ext uri="{FF2B5EF4-FFF2-40B4-BE49-F238E27FC236}">
-                <a16:creationId xmlns:a16="http://schemas.microsoft.com/office/drawing/2014/main" id="{828F38FA-8020-485B-BCBE-0259FA2FBDF2}"/>
+                <a16:creationId xmlns:a16="http://schemas.microsoft.com/office/drawing/2014/main" id="{6B4B76CB-81F5-415F-AA2A-217BB37E817B}"/>
               </a:ext>
             </a:extLst>
           </p:cNvPr>
@@ -10221,7 +10221,7 @@
     </p:spTree>
     <p:extLst>
       <p:ext uri="{BB962C8B-B14F-4D97-AF65-F5344CB8AC3E}">
-        <p14:creationId xmlns:p14="http://schemas.microsoft.com/office/powerpoint/2010/main" val="2105323083"/>
+        <p14:creationId xmlns:p14="http://schemas.microsoft.com/office/powerpoint/2010/main" val="1236311986"/>
       </p:ext>
     </p:extLst>
   </p:cSld>
@@ -10252,7 +10252,7 @@
           <p:cNvPr id="5" name="">
             <a:extLst xmlns:a="http://schemas.openxmlformats.org/drawingml/2006/main">
               <a:ext uri="{FF2B5EF4-FFF2-40B4-BE49-F238E27FC236}">
-                <a16:creationId xmlns:a16="http://schemas.microsoft.com/office/drawing/2014/main" id="{03F848E2-34F5-4AC9-B05F-6A8CBBF7EC5D}"/>
+                <a16:creationId xmlns:a16="http://schemas.microsoft.com/office/drawing/2014/main" id="{813CA7E2-CD63-435F-BEE3-94FFBC10274B}"/>
               </a:ext>
             </a:extLst>
           </p:cNvPr>
@@ -10702,7 +10702,7 @@
           <p:cNvPr id="3" name="">
             <a:extLst xmlns:a="http://schemas.openxmlformats.org/drawingml/2006/main">
               <a:ext uri="{FF2B5EF4-FFF2-40B4-BE49-F238E27FC236}">
-                <a16:creationId xmlns:a16="http://schemas.microsoft.com/office/drawing/2014/main" id="{9F5FFF7F-B880-4BE5-A4B6-9E6F0059644E}"/>
+                <a16:creationId xmlns:a16="http://schemas.microsoft.com/office/drawing/2014/main" id="{B47DA987-23E8-4D9D-9077-31D79D6928A3}"/>
               </a:ext>
             </a:extLst>
           </p:cNvPr>
@@ -10759,7 +10759,7 @@
           <p:cNvPr id="4" name="">
             <a:extLst xmlns:a="http://schemas.openxmlformats.org/drawingml/2006/main">
               <a:ext uri="{FF2B5EF4-FFF2-40B4-BE49-F238E27FC236}">
-                <a16:creationId xmlns:a16="http://schemas.microsoft.com/office/drawing/2014/main" id="{4C9F095E-D140-46BC-99E2-9A85C58EFF97}"/>
+                <a16:creationId xmlns:a16="http://schemas.microsoft.com/office/drawing/2014/main" id="{0B3243F3-817D-48F0-9BFE-B81BD882ADA8}"/>
               </a:ext>
             </a:extLst>
           </p:cNvPr>
@@ -10814,7 +10814,7 @@
     </p:spTree>
     <p:extLst>
       <p:ext uri="{BB962C8B-B14F-4D97-AF65-F5344CB8AC3E}">
-        <p14:creationId xmlns:p14="http://schemas.microsoft.com/office/powerpoint/2010/main" val="313172522"/>
+        <p14:creationId xmlns:p14="http://schemas.microsoft.com/office/powerpoint/2010/main" val="161874407"/>
       </p:ext>
     </p:extLst>
   </p:cSld>
@@ -10845,7 +10845,7 @@
           <p:cNvPr id="5" name="">
             <a:extLst xmlns:a="http://schemas.openxmlformats.org/drawingml/2006/main">
               <a:ext uri="{FF2B5EF4-FFF2-40B4-BE49-F238E27FC236}">
-                <a16:creationId xmlns:a16="http://schemas.microsoft.com/office/drawing/2014/main" id="{96810084-2746-4A68-A445-81E7A4092AC0}"/>
+                <a16:creationId xmlns:a16="http://schemas.microsoft.com/office/drawing/2014/main" id="{A0B78A30-FA1F-4C3D-98EB-1A5E9E279279}"/>
               </a:ext>
             </a:extLst>
           </p:cNvPr>
@@ -11295,7 +11295,7 @@
           <p:cNvPr id="3" name="">
             <a:extLst xmlns:a="http://schemas.openxmlformats.org/drawingml/2006/main">
               <a:ext uri="{FF2B5EF4-FFF2-40B4-BE49-F238E27FC236}">
-                <a16:creationId xmlns:a16="http://schemas.microsoft.com/office/drawing/2014/main" id="{CFA7EFB4-D1BD-4BDB-A503-BC3929A0FF67}"/>
+                <a16:creationId xmlns:a16="http://schemas.microsoft.com/office/drawing/2014/main" id="{11591E09-FDB0-401A-90F7-F8D23C56A1F4}"/>
               </a:ext>
             </a:extLst>
           </p:cNvPr>
@@ -11352,7 +11352,7 @@
           <p:cNvPr id="4" name="">
             <a:extLst xmlns:a="http://schemas.openxmlformats.org/drawingml/2006/main">
               <a:ext uri="{FF2B5EF4-FFF2-40B4-BE49-F238E27FC236}">
-                <a16:creationId xmlns:a16="http://schemas.microsoft.com/office/drawing/2014/main" id="{EEA91A9F-8F6C-419C-9031-F17402F9219F}"/>
+                <a16:creationId xmlns:a16="http://schemas.microsoft.com/office/drawing/2014/main" id="{F4761142-F795-45F3-A0D3-AB9B89C4F78A}"/>
               </a:ext>
             </a:extLst>
           </p:cNvPr>
@@ -11407,7 +11407,7 @@
     </p:spTree>
     <p:extLst>
       <p:ext uri="{BB962C8B-B14F-4D97-AF65-F5344CB8AC3E}">
-        <p14:creationId xmlns:p14="http://schemas.microsoft.com/office/powerpoint/2010/main" val="28416725"/>
+        <p14:creationId xmlns:p14="http://schemas.microsoft.com/office/powerpoint/2010/main" val="1965191409"/>
       </p:ext>
     </p:extLst>
   </p:cSld>
@@ -11438,7 +11438,7 @@
           <p:cNvPr id="14" name="">
             <a:extLst xmlns:a="http://schemas.openxmlformats.org/drawingml/2006/main">
               <a:ext uri="{FF2B5EF4-FFF2-40B4-BE49-F238E27FC236}">
-                <a16:creationId xmlns:a16="http://schemas.microsoft.com/office/drawing/2014/main" id="{752E7E04-B00D-4E2E-A57E-E9708F995AEF}"/>
+                <a16:creationId xmlns:a16="http://schemas.microsoft.com/office/drawing/2014/main" id="{3AA91E39-E146-4203-A1C8-4BB2C2148F19}"/>
               </a:ext>
             </a:extLst>
           </p:cNvPr>
@@ -11495,7 +11495,7 @@
           <p:cNvPr id="2" name="">
             <a:extLst xmlns:a="http://schemas.openxmlformats.org/drawingml/2006/main">
               <a:ext uri="{FF2B5EF4-FFF2-40B4-BE49-F238E27FC236}">
-                <a16:creationId xmlns:a16="http://schemas.microsoft.com/office/drawing/2014/main" id="{42BB45CC-6C08-473E-BF1D-C9D70DBD3DE8}"/>
+                <a16:creationId xmlns:a16="http://schemas.microsoft.com/office/drawing/2014/main" id="{8A419485-1F05-41BF-920F-08C343ABAB75}"/>
               </a:ext>
             </a:extLst>
           </p:cNvPr>
@@ -11552,7 +11552,7 @@
           <p:cNvPr id="3" name="">
             <a:extLst xmlns:a="http://schemas.openxmlformats.org/drawingml/2006/main">
               <a:ext uri="{FF2B5EF4-FFF2-40B4-BE49-F238E27FC236}">
-                <a16:creationId xmlns:a16="http://schemas.microsoft.com/office/drawing/2014/main" id="{B8763ED7-D7DA-4B98-8C3F-B70C25C0A704}"/>
+                <a16:creationId xmlns:a16="http://schemas.microsoft.com/office/drawing/2014/main" id="{30DE32C8-17F1-4146-9C96-B3D792B18BC4}"/>
               </a:ext>
             </a:extLst>
           </p:cNvPr>
@@ -11609,7 +11609,7 @@
           <p:cNvPr id="4" name="">
             <a:extLst xmlns:a="http://schemas.openxmlformats.org/drawingml/2006/main">
               <a:ext uri="{FF2B5EF4-FFF2-40B4-BE49-F238E27FC236}">
-                <a16:creationId xmlns:a16="http://schemas.microsoft.com/office/drawing/2014/main" id="{FC9CB5BE-3842-4FC5-97FC-1F91BDF496D7}"/>
+                <a16:creationId xmlns:a16="http://schemas.microsoft.com/office/drawing/2014/main" id="{A1D3FAB0-6626-4739-A3A4-A2B0174D7022}"/>
               </a:ext>
             </a:extLst>
           </p:cNvPr>
@@ -11666,7 +11666,7 @@
           <p:cNvPr id="5" name="">
             <a:extLst xmlns:a="http://schemas.openxmlformats.org/drawingml/2006/main">
               <a:ext uri="{FF2B5EF4-FFF2-40B4-BE49-F238E27FC236}">
-                <a16:creationId xmlns:a16="http://schemas.microsoft.com/office/drawing/2014/main" id="{AB4EC611-6ED8-49A6-9FA5-5E353B21CE9A}"/>
+                <a16:creationId xmlns:a16="http://schemas.microsoft.com/office/drawing/2014/main" id="{F4218F92-3273-43D2-9D64-5D4D4EF368D2}"/>
               </a:ext>
             </a:extLst>
           </p:cNvPr>
@@ -11723,7 +11723,7 @@
           <p:cNvPr id="6" name="">
             <a:extLst xmlns:a="http://schemas.openxmlformats.org/drawingml/2006/main">
               <a:ext uri="{FF2B5EF4-FFF2-40B4-BE49-F238E27FC236}">
-                <a16:creationId xmlns:a16="http://schemas.microsoft.com/office/drawing/2014/main" id="{9DB64473-AD49-4FE8-B42D-30F5BBF52979}"/>
+                <a16:creationId xmlns:a16="http://schemas.microsoft.com/office/drawing/2014/main" id="{DCBD4F86-694A-458B-9ECE-C50224C44816}"/>
               </a:ext>
             </a:extLst>
           </p:cNvPr>
@@ -11780,7 +11780,7 @@
           <p:cNvPr id="7" name="">
             <a:extLst xmlns:a="http://schemas.openxmlformats.org/drawingml/2006/main">
               <a:ext uri="{FF2B5EF4-FFF2-40B4-BE49-F238E27FC236}">
-                <a16:creationId xmlns:a16="http://schemas.microsoft.com/office/drawing/2014/main" id="{7C927855-FF6A-404B-8374-A5B7F1E5C853}"/>
+                <a16:creationId xmlns:a16="http://schemas.microsoft.com/office/drawing/2014/main" id="{363395CF-1540-4C9C-99DB-1153C035B8BA}"/>
               </a:ext>
             </a:extLst>
           </p:cNvPr>
@@ -11837,7 +11837,7 @@
           <p:cNvPr id="8" name="">
             <a:extLst xmlns:a="http://schemas.openxmlformats.org/drawingml/2006/main">
               <a:ext uri="{FF2B5EF4-FFF2-40B4-BE49-F238E27FC236}">
-                <a16:creationId xmlns:a16="http://schemas.microsoft.com/office/drawing/2014/main" id="{0D8B0CFE-359F-4E18-9B7B-D065BE14C6CB}"/>
+                <a16:creationId xmlns:a16="http://schemas.microsoft.com/office/drawing/2014/main" id="{7EAD082C-4515-4737-B930-8675BFA0DC89}"/>
               </a:ext>
             </a:extLst>
           </p:cNvPr>
@@ -11894,7 +11894,7 @@
           <p:cNvPr id="9" name="">
             <a:extLst xmlns:a="http://schemas.openxmlformats.org/drawingml/2006/main">
               <a:ext uri="{FF2B5EF4-FFF2-40B4-BE49-F238E27FC236}">
-                <a16:creationId xmlns:a16="http://schemas.microsoft.com/office/drawing/2014/main" id="{52C1DB5D-2808-4BD0-A7DA-335E18600F42}"/>
+                <a16:creationId xmlns:a16="http://schemas.microsoft.com/office/drawing/2014/main" id="{83CAC0DC-9472-4895-8427-1E6B35849CAB}"/>
               </a:ext>
             </a:extLst>
           </p:cNvPr>
@@ -11951,7 +11951,7 @@
           <p:cNvPr id="10" name="">
             <a:extLst xmlns:a="http://schemas.openxmlformats.org/drawingml/2006/main">
               <a:ext uri="{FF2B5EF4-FFF2-40B4-BE49-F238E27FC236}">
-                <a16:creationId xmlns:a16="http://schemas.microsoft.com/office/drawing/2014/main" id="{20113F6B-96D6-443E-B861-77276C1C5DDF}"/>
+                <a16:creationId xmlns:a16="http://schemas.microsoft.com/office/drawing/2014/main" id="{D61068A9-AFE8-4656-88EB-F6A03E9A0AFD}"/>
               </a:ext>
             </a:extLst>
           </p:cNvPr>
@@ -12008,7 +12008,7 @@
           <p:cNvPr id="11" name="">
             <a:extLst xmlns:a="http://schemas.openxmlformats.org/drawingml/2006/main">
               <a:ext uri="{FF2B5EF4-FFF2-40B4-BE49-F238E27FC236}">
-                <a16:creationId xmlns:a16="http://schemas.microsoft.com/office/drawing/2014/main" id="{4940D2E6-A5E4-45FB-AB0D-692A48534394}"/>
+                <a16:creationId xmlns:a16="http://schemas.microsoft.com/office/drawing/2014/main" id="{7649F27F-77FA-45CA-8C98-EDFD7C198DC0}"/>
               </a:ext>
             </a:extLst>
           </p:cNvPr>
@@ -12065,7 +12065,7 @@
           <p:cNvPr id="12" name="">
             <a:extLst xmlns:a="http://schemas.openxmlformats.org/drawingml/2006/main">
               <a:ext uri="{FF2B5EF4-FFF2-40B4-BE49-F238E27FC236}">
-                <a16:creationId xmlns:a16="http://schemas.microsoft.com/office/drawing/2014/main" id="{A8C15DA1-A1C1-49A7-8528-8A178F201AE5}"/>
+                <a16:creationId xmlns:a16="http://schemas.microsoft.com/office/drawing/2014/main" id="{E1EAE5AC-322E-4C61-8DAF-2C959A4A5F08}"/>
               </a:ext>
             </a:extLst>
           </p:cNvPr>
@@ -12122,7 +12122,7 @@
           <p:cNvPr id="13" name="">
             <a:extLst xmlns:a="http://schemas.openxmlformats.org/drawingml/2006/main">
               <a:ext uri="{FF2B5EF4-FFF2-40B4-BE49-F238E27FC236}">
-                <a16:creationId xmlns:a16="http://schemas.microsoft.com/office/drawing/2014/main" id="{E0850D6A-148B-491B-999B-01A0A29F40E0}"/>
+                <a16:creationId xmlns:a16="http://schemas.microsoft.com/office/drawing/2014/main" id="{80B7D54D-99D7-4825-A2F8-F6EDD7E314F4}"/>
               </a:ext>
             </a:extLst>
           </p:cNvPr>
@@ -12177,7 +12177,7 @@
     </p:spTree>
     <p:extLst>
       <p:ext uri="{BB962C8B-B14F-4D97-AF65-F5344CB8AC3E}">
-        <p14:creationId xmlns:p14="http://schemas.microsoft.com/office/powerpoint/2010/main" val="243016250"/>
+        <p14:creationId xmlns:p14="http://schemas.microsoft.com/office/powerpoint/2010/main" val="637207218"/>
       </p:ext>
     </p:extLst>
   </p:cSld>
@@ -12208,7 +12208,7 @@
           <p:cNvPr id="8" name="">
             <a:extLst xmlns:a="http://schemas.openxmlformats.org/drawingml/2006/main">
               <a:ext uri="{FF2B5EF4-FFF2-40B4-BE49-F238E27FC236}">
-                <a16:creationId xmlns:a16="http://schemas.microsoft.com/office/drawing/2014/main" id="{F914E2C0-15D6-4073-9E0C-1A7A35703832}"/>
+                <a16:creationId xmlns:a16="http://schemas.microsoft.com/office/drawing/2014/main" id="{B7C47366-B41D-4665-9017-829FC532F8CB}"/>
               </a:ext>
             </a:extLst>
           </p:cNvPr>
@@ -12265,7 +12265,7 @@
           <p:cNvPr id="2" name="">
             <a:extLst xmlns:a="http://schemas.openxmlformats.org/drawingml/2006/main">
               <a:ext uri="{FF2B5EF4-FFF2-40B4-BE49-F238E27FC236}">
-                <a16:creationId xmlns:a16="http://schemas.microsoft.com/office/drawing/2014/main" id="{B30C96B2-7A33-4BA0-8832-B7E87DAE24F6}"/>
+                <a16:creationId xmlns:a16="http://schemas.microsoft.com/office/drawing/2014/main" id="{E3F4DD6C-3B46-406B-B340-0D046923F995}"/>
               </a:ext>
             </a:extLst>
           </p:cNvPr>
@@ -12322,7 +12322,7 @@
           <p:cNvPr id="3" name="">
             <a:extLst xmlns:a="http://schemas.openxmlformats.org/drawingml/2006/main">
               <a:ext uri="{FF2B5EF4-FFF2-40B4-BE49-F238E27FC236}">
-                <a16:creationId xmlns:a16="http://schemas.microsoft.com/office/drawing/2014/main" id="{3F13E723-6740-4444-BF23-0BED48F7BE31}"/>
+                <a16:creationId xmlns:a16="http://schemas.microsoft.com/office/drawing/2014/main" id="{B6030882-E1D0-4EA1-B52A-6655C896FA3B}"/>
               </a:ext>
             </a:extLst>
           </p:cNvPr>
@@ -12485,7 +12485,7 @@
           <p:nvPr/>
         </p:nvPicPr>
         <p:blipFill>
-          <a:blip xmlns:r="http://schemas.openxmlformats.org/officeDocument/2006/relationships" xmlns:a="http://schemas.openxmlformats.org/drawingml/2006/main" r:embed="Rc0d40c3ed1054d1e"/>
+          <a:blip xmlns:r="http://schemas.openxmlformats.org/officeDocument/2006/relationships" xmlns:a="http://schemas.openxmlformats.org/drawingml/2006/main" r:embed="Rcecff0809d7e4a6b"/>
           <a:stretch xmlns:a="http://schemas.openxmlformats.org/drawingml/2006/main"/>
         </p:blipFill>
         <p:spPr>
@@ -12503,7 +12503,7 @@
           <p:cNvPr id="5" name="">
             <a:extLst xmlns:a="http://schemas.openxmlformats.org/drawingml/2006/main">
               <a:ext uri="{FF2B5EF4-FFF2-40B4-BE49-F238E27FC236}">
-                <a16:creationId xmlns:a16="http://schemas.microsoft.com/office/drawing/2014/main" id="{7CA50747-8A4B-4B60-A94C-0496E68A938B}"/>
+                <a16:creationId xmlns:a16="http://schemas.microsoft.com/office/drawing/2014/main" id="{BFF2690C-9662-496A-938D-7A34B511584A}"/>
               </a:ext>
             </a:extLst>
           </p:cNvPr>
@@ -12583,7 +12583,7 @@
           <p:cNvPr id="6" name="">
             <a:extLst xmlns:a="http://schemas.openxmlformats.org/drawingml/2006/main">
               <a:ext uri="{FF2B5EF4-FFF2-40B4-BE49-F238E27FC236}">
-                <a16:creationId xmlns:a16="http://schemas.microsoft.com/office/drawing/2014/main" id="{B2F3CD61-D54B-47D8-8080-8CD322ADE241}"/>
+                <a16:creationId xmlns:a16="http://schemas.microsoft.com/office/drawing/2014/main" id="{CA32A5C3-3F49-49C2-8625-F1808E70C48F}"/>
               </a:ext>
             </a:extLst>
           </p:cNvPr>
@@ -12640,7 +12640,7 @@
           <p:cNvPr id="7" name="">
             <a:extLst xmlns:a="http://schemas.openxmlformats.org/drawingml/2006/main">
               <a:ext uri="{FF2B5EF4-FFF2-40B4-BE49-F238E27FC236}">
-                <a16:creationId xmlns:a16="http://schemas.microsoft.com/office/drawing/2014/main" id="{1D31555B-E7B2-489C-B7DB-0C783A092A95}"/>
+                <a16:creationId xmlns:a16="http://schemas.microsoft.com/office/drawing/2014/main" id="{C2B58F41-E4D7-4F40-9860-0FC0E4088D9C}"/>
               </a:ext>
             </a:extLst>
           </p:cNvPr>
@@ -12695,7 +12695,7 @@
     </p:spTree>
     <p:extLst>
       <p:ext uri="{BB962C8B-B14F-4D97-AF65-F5344CB8AC3E}">
-        <p14:creationId xmlns:p14="http://schemas.microsoft.com/office/powerpoint/2010/main" val="1165120898"/>
+        <p14:creationId xmlns:p14="http://schemas.microsoft.com/office/powerpoint/2010/main" val="913679395"/>
       </p:ext>
     </p:extLst>
   </p:cSld>
@@ -12726,7 +12726,7 @@
           <p:cNvPr id="5" name="">
             <a:extLst xmlns:a="http://schemas.openxmlformats.org/drawingml/2006/main">
               <a:ext uri="{FF2B5EF4-FFF2-40B4-BE49-F238E27FC236}">
-                <a16:creationId xmlns:a16="http://schemas.microsoft.com/office/drawing/2014/main" id="{191458F3-C7E3-440A-93BC-543BC2F72B3C}"/>
+                <a16:creationId xmlns:a16="http://schemas.microsoft.com/office/drawing/2014/main" id="{9C2B9321-BDC0-424A-9CF1-774C823BE97E}"/>
               </a:ext>
             </a:extLst>
           </p:cNvPr>
@@ -13176,7 +13176,7 @@
           <p:cNvPr id="3" name="">
             <a:extLst xmlns:a="http://schemas.openxmlformats.org/drawingml/2006/main">
               <a:ext uri="{FF2B5EF4-FFF2-40B4-BE49-F238E27FC236}">
-                <a16:creationId xmlns:a16="http://schemas.microsoft.com/office/drawing/2014/main" id="{EE688CB4-BE2F-4D56-803E-C221721F9877}"/>
+                <a16:creationId xmlns:a16="http://schemas.microsoft.com/office/drawing/2014/main" id="{DC28E9C9-D944-4E73-9C47-B7B9DAD092DF}"/>
               </a:ext>
             </a:extLst>
           </p:cNvPr>
@@ -13233,7 +13233,7 @@
           <p:cNvPr id="4" name="">
             <a:extLst xmlns:a="http://schemas.openxmlformats.org/drawingml/2006/main">
               <a:ext uri="{FF2B5EF4-FFF2-40B4-BE49-F238E27FC236}">
-                <a16:creationId xmlns:a16="http://schemas.microsoft.com/office/drawing/2014/main" id="{53968372-5D64-4618-8F4F-61B8955FA66C}"/>
+                <a16:creationId xmlns:a16="http://schemas.microsoft.com/office/drawing/2014/main" id="{A8507B05-61CA-4B7C-B137-EA0461664F0E}"/>
               </a:ext>
             </a:extLst>
           </p:cNvPr>
@@ -13288,7 +13288,7 @@
     </p:spTree>
     <p:extLst>
       <p:ext uri="{BB962C8B-B14F-4D97-AF65-F5344CB8AC3E}">
-        <p14:creationId xmlns:p14="http://schemas.microsoft.com/office/powerpoint/2010/main" val="1868790957"/>
+        <p14:creationId xmlns:p14="http://schemas.microsoft.com/office/powerpoint/2010/main" val="618546357"/>
       </p:ext>
     </p:extLst>
   </p:cSld>
@@ -13319,7 +13319,7 @@
           <p:cNvPr id="8" name="">
             <a:extLst xmlns:a="http://schemas.openxmlformats.org/drawingml/2006/main">
               <a:ext uri="{FF2B5EF4-FFF2-40B4-BE49-F238E27FC236}">
-                <a16:creationId xmlns:a16="http://schemas.microsoft.com/office/drawing/2014/main" id="{E5A22AFE-385D-409E-8D28-DE3B25A4BFF3}"/>
+                <a16:creationId xmlns:a16="http://schemas.microsoft.com/office/drawing/2014/main" id="{7C98969B-1839-469F-B9D5-2FFEECA83C4D}"/>
               </a:ext>
             </a:extLst>
           </p:cNvPr>
@@ -13376,7 +13376,7 @@
           <p:cNvPr id="2" name="">
             <a:extLst xmlns:a="http://schemas.openxmlformats.org/drawingml/2006/main">
               <a:ext uri="{FF2B5EF4-FFF2-40B4-BE49-F238E27FC236}">
-                <a16:creationId xmlns:a16="http://schemas.microsoft.com/office/drawing/2014/main" id="{865AAD11-5EFF-475A-B68D-A23A506E72FD}"/>
+                <a16:creationId xmlns:a16="http://schemas.microsoft.com/office/drawing/2014/main" id="{18814C2C-1B6C-4CCD-8010-37C849B95DA9}"/>
               </a:ext>
             </a:extLst>
           </p:cNvPr>
@@ -13433,7 +13433,7 @@
           <p:cNvPr id="3" name="">
             <a:extLst xmlns:a="http://schemas.openxmlformats.org/drawingml/2006/main">
               <a:ext uri="{FF2B5EF4-FFF2-40B4-BE49-F238E27FC236}">
-                <a16:creationId xmlns:a16="http://schemas.microsoft.com/office/drawing/2014/main" id="{2AB2F192-DE8C-4DB7-8A5E-7F803EBC52D4}"/>
+                <a16:creationId xmlns:a16="http://schemas.microsoft.com/office/drawing/2014/main" id="{421C9BFE-0AC7-455C-A0CC-2363C9F8C2F2}"/>
               </a:ext>
             </a:extLst>
           </p:cNvPr>
@@ -13541,7 +13541,7 @@
           <p:cNvPr id="4" name="">
             <a:extLst xmlns:a="http://schemas.openxmlformats.org/drawingml/2006/main">
               <a:ext uri="{FF2B5EF4-FFF2-40B4-BE49-F238E27FC236}">
-                <a16:creationId xmlns:a16="http://schemas.microsoft.com/office/drawing/2014/main" id="{F11120C7-42CC-4214-A69C-EF3ADF9360BF}"/>
+                <a16:creationId xmlns:a16="http://schemas.microsoft.com/office/drawing/2014/main" id="{A67BEF96-9603-4841-BC3B-3F33A8922142}"/>
               </a:ext>
             </a:extLst>
           </p:cNvPr>
@@ -13598,7 +13598,7 @@
           <p:cNvPr id="5" name="">
             <a:extLst xmlns:a="http://schemas.openxmlformats.org/drawingml/2006/main">
               <a:ext uri="{FF2B5EF4-FFF2-40B4-BE49-F238E27FC236}">
-                <a16:creationId xmlns:a16="http://schemas.microsoft.com/office/drawing/2014/main" id="{A13D3496-6048-4948-8152-742F8F48D83E}"/>
+                <a16:creationId xmlns:a16="http://schemas.microsoft.com/office/drawing/2014/main" id="{EB8A9FE6-F103-43D9-86AD-EC51D03D3EB5}"/>
               </a:ext>
             </a:extLst>
           </p:cNvPr>
@@ -13724,7 +13724,7 @@
           <p:cNvPr id="6" name="">
             <a:extLst xmlns:a="http://schemas.openxmlformats.org/drawingml/2006/main">
               <a:ext uri="{FF2B5EF4-FFF2-40B4-BE49-F238E27FC236}">
-                <a16:creationId xmlns:a16="http://schemas.microsoft.com/office/drawing/2014/main" id="{181A83B5-6B94-40B7-BEA0-22FFAB2E9F3A}"/>
+                <a16:creationId xmlns:a16="http://schemas.microsoft.com/office/drawing/2014/main" id="{DD9AA2A3-D04E-4B86-A3A9-469837CE2C3F}"/>
               </a:ext>
             </a:extLst>
           </p:cNvPr>
@@ -13781,7 +13781,7 @@
           <p:cNvPr id="7" name="">
             <a:extLst xmlns:a="http://schemas.openxmlformats.org/drawingml/2006/main">
               <a:ext uri="{FF2B5EF4-FFF2-40B4-BE49-F238E27FC236}">
-                <a16:creationId xmlns:a16="http://schemas.microsoft.com/office/drawing/2014/main" id="{D83CEA18-4A56-46AA-BF5F-D047CEDC79BA}"/>
+                <a16:creationId xmlns:a16="http://schemas.microsoft.com/office/drawing/2014/main" id="{445AC841-ED3C-471F-A0E5-C5CCD5376A5D}"/>
               </a:ext>
             </a:extLst>
           </p:cNvPr>
@@ -13836,7 +13836,7 @@
     </p:spTree>
     <p:extLst>
       <p:ext uri="{BB962C8B-B14F-4D97-AF65-F5344CB8AC3E}">
-        <p14:creationId xmlns:p14="http://schemas.microsoft.com/office/powerpoint/2010/main" val="1935562417"/>
+        <p14:creationId xmlns:p14="http://schemas.microsoft.com/office/powerpoint/2010/main" val="1146325165"/>
       </p:ext>
     </p:extLst>
   </p:cSld>
@@ -13867,7 +13867,7 @@
           <p:cNvPr id="7" name="">
             <a:extLst xmlns:a="http://schemas.openxmlformats.org/drawingml/2006/main">
               <a:ext uri="{FF2B5EF4-FFF2-40B4-BE49-F238E27FC236}">
-                <a16:creationId xmlns:a16="http://schemas.microsoft.com/office/drawing/2014/main" id="{4BC6E943-7732-445C-A9EB-2247D9B7EAAA}"/>
+                <a16:creationId xmlns:a16="http://schemas.microsoft.com/office/drawing/2014/main" id="{17F1DD03-BB67-4FC3-8FD1-46A93A1971D1}"/>
               </a:ext>
             </a:extLst>
           </p:cNvPr>
@@ -13924,7 +13924,7 @@
           <p:cNvPr id="2" name="">
             <a:extLst xmlns:a="http://schemas.openxmlformats.org/drawingml/2006/main">
               <a:ext uri="{FF2B5EF4-FFF2-40B4-BE49-F238E27FC236}">
-                <a16:creationId xmlns:a16="http://schemas.microsoft.com/office/drawing/2014/main" id="{C16FF630-ACFB-41F9-8F07-4655BCE099B3}"/>
+                <a16:creationId xmlns:a16="http://schemas.microsoft.com/office/drawing/2014/main" id="{19C806FF-40BB-4104-8BA6-CDAE2B7AEB68}"/>
               </a:ext>
             </a:extLst>
           </p:cNvPr>
@@ -14147,7 +14147,7 @@
           <p:cNvPr id="3" name="">
             <a:extLst xmlns:a="http://schemas.openxmlformats.org/drawingml/2006/main">
               <a:ext uri="{FF2B5EF4-FFF2-40B4-BE49-F238E27FC236}">
-                <a16:creationId xmlns:a16="http://schemas.microsoft.com/office/drawing/2014/main" id="{5A9BF016-70E6-4B93-A106-B954F5FF388B}"/>
+                <a16:creationId xmlns:a16="http://schemas.microsoft.com/office/drawing/2014/main" id="{67BC765B-73F0-4A6E-B471-7B73AD5BCC5C}"/>
               </a:ext>
             </a:extLst>
           </p:cNvPr>
@@ -14204,7 +14204,7 @@
           <p:cNvPr id="4" name="">
             <a:extLst xmlns:a="http://schemas.openxmlformats.org/drawingml/2006/main">
               <a:ext uri="{FF2B5EF4-FFF2-40B4-BE49-F238E27FC236}">
-                <a16:creationId xmlns:a16="http://schemas.microsoft.com/office/drawing/2014/main" id="{979882A4-1B81-4A3C-AD42-8A92944BAECB}"/>
+                <a16:creationId xmlns:a16="http://schemas.microsoft.com/office/drawing/2014/main" id="{0E0DA199-C5BD-4A93-AFB0-CD5A71B0C7A1}"/>
               </a:ext>
             </a:extLst>
           </p:cNvPr>
@@ -14353,7 +14353,7 @@
           <p:cNvPr id="5" name="">
             <a:extLst xmlns:a="http://schemas.openxmlformats.org/drawingml/2006/main">
               <a:ext uri="{FF2B5EF4-FFF2-40B4-BE49-F238E27FC236}">
-                <a16:creationId xmlns:a16="http://schemas.microsoft.com/office/drawing/2014/main" id="{BD22DAD4-33F5-45BC-8E2E-5CBD5B630BA0}"/>
+                <a16:creationId xmlns:a16="http://schemas.microsoft.com/office/drawing/2014/main" id="{1B57AB79-6221-4DCE-9911-B43EAD143AF3}"/>
               </a:ext>
             </a:extLst>
           </p:cNvPr>
@@ -14410,7 +14410,7 @@
           <p:cNvPr id="6" name="">
             <a:extLst xmlns:a="http://schemas.openxmlformats.org/drawingml/2006/main">
               <a:ext uri="{FF2B5EF4-FFF2-40B4-BE49-F238E27FC236}">
-                <a16:creationId xmlns:a16="http://schemas.microsoft.com/office/drawing/2014/main" id="{9FCEE2D4-AB91-4E88-88C8-DC3174B5983A}"/>
+                <a16:creationId xmlns:a16="http://schemas.microsoft.com/office/drawing/2014/main" id="{686829ED-9A0D-405B-A772-A020AF3F9E20}"/>
               </a:ext>
             </a:extLst>
           </p:cNvPr>
@@ -14465,7 +14465,7 @@
     </p:spTree>
     <p:extLst>
       <p:ext uri="{BB962C8B-B14F-4D97-AF65-F5344CB8AC3E}">
-        <p14:creationId xmlns:p14="http://schemas.microsoft.com/office/powerpoint/2010/main" val="1167562930"/>
+        <p14:creationId xmlns:p14="http://schemas.microsoft.com/office/powerpoint/2010/main" val="526753791"/>
       </p:ext>
     </p:extLst>
   </p:cSld>
@@ -14496,7 +14496,7 @@
           <p:cNvPr id="9" name="">
             <a:extLst xmlns:a="http://schemas.openxmlformats.org/drawingml/2006/main">
               <a:ext uri="{FF2B5EF4-FFF2-40B4-BE49-F238E27FC236}">
-                <a16:creationId xmlns:a16="http://schemas.microsoft.com/office/drawing/2014/main" id="{67167228-AE4D-468C-B959-FC0EDB473E7E}"/>
+                <a16:creationId xmlns:a16="http://schemas.microsoft.com/office/drawing/2014/main" id="{11DC3A5F-2487-4357-9D0B-D915B1300C26}"/>
               </a:ext>
             </a:extLst>
           </p:cNvPr>
@@ -14553,7 +14553,7 @@
           <p:cNvPr id="2" name="">
             <a:extLst xmlns:a="http://schemas.openxmlformats.org/drawingml/2006/main">
               <a:ext uri="{FF2B5EF4-FFF2-40B4-BE49-F238E27FC236}">
-                <a16:creationId xmlns:a16="http://schemas.microsoft.com/office/drawing/2014/main" id="{C6EA3145-BF1D-4623-8971-60D8EC697325}"/>
+                <a16:creationId xmlns:a16="http://schemas.microsoft.com/office/drawing/2014/main" id="{596F7020-7423-4486-A781-5EAADD0829C7}"/>
               </a:ext>
             </a:extLst>
           </p:cNvPr>
@@ -14610,7 +14610,7 @@
           <p:cNvPr id="3" name="">
             <a:extLst xmlns:a="http://schemas.openxmlformats.org/drawingml/2006/main">
               <a:ext uri="{FF2B5EF4-FFF2-40B4-BE49-F238E27FC236}">
-                <a16:creationId xmlns:a16="http://schemas.microsoft.com/office/drawing/2014/main" id="{C23D3143-8983-47B3-BFA0-09C72CFA9D48}"/>
+                <a16:creationId xmlns:a16="http://schemas.microsoft.com/office/drawing/2014/main" id="{B761B888-A0E5-4E9D-8044-1D2FC994FF26}"/>
               </a:ext>
             </a:extLst>
           </p:cNvPr>
@@ -14667,7 +14667,7 @@
           <p:cNvPr id="4" name="">
             <a:extLst xmlns:a="http://schemas.openxmlformats.org/drawingml/2006/main">
               <a:ext uri="{FF2B5EF4-FFF2-40B4-BE49-F238E27FC236}">
-                <a16:creationId xmlns:a16="http://schemas.microsoft.com/office/drawing/2014/main" id="{1779CAEC-ECDF-49C3-AA4D-2DDBB1AAD4C6}"/>
+                <a16:creationId xmlns:a16="http://schemas.microsoft.com/office/drawing/2014/main" id="{89A53D33-BCE2-4F33-AF90-7D09CA4604BD}"/>
               </a:ext>
             </a:extLst>
           </p:cNvPr>
@@ -14747,7 +14747,7 @@
           <p:cNvPr id="5" name="">
             <a:extLst xmlns:a="http://schemas.openxmlformats.org/drawingml/2006/main">
               <a:ext uri="{FF2B5EF4-FFF2-40B4-BE49-F238E27FC236}">
-                <a16:creationId xmlns:a16="http://schemas.microsoft.com/office/drawing/2014/main" id="{E0148E9F-B8DC-4B4B-9FCD-B16BF1A7651E}"/>
+                <a16:creationId xmlns:a16="http://schemas.microsoft.com/office/drawing/2014/main" id="{6D75D188-154C-46F7-9738-6AAEF6902095}"/>
               </a:ext>
             </a:extLst>
           </p:cNvPr>
@@ -14804,7 +14804,7 @@
           <p:cNvPr id="6" name="">
             <a:extLst xmlns:a="http://schemas.openxmlformats.org/drawingml/2006/main">
               <a:ext uri="{FF2B5EF4-FFF2-40B4-BE49-F238E27FC236}">
-                <a16:creationId xmlns:a16="http://schemas.microsoft.com/office/drawing/2014/main" id="{D6641BB3-2576-4FAA-9665-E46ECC6CBCA1}"/>
+                <a16:creationId xmlns:a16="http://schemas.microsoft.com/office/drawing/2014/main" id="{5B3C2554-B2CB-4BB9-8CB0-E4DE5166B501}"/>
               </a:ext>
             </a:extLst>
           </p:cNvPr>
@@ -14884,7 +14884,7 @@
           <p:cNvPr id="7" name="">
             <a:extLst xmlns:a="http://schemas.openxmlformats.org/drawingml/2006/main">
               <a:ext uri="{FF2B5EF4-FFF2-40B4-BE49-F238E27FC236}">
-                <a16:creationId xmlns:a16="http://schemas.microsoft.com/office/drawing/2014/main" id="{E703702E-41B6-4F10-BBCE-A7327E5EAD86}"/>
+                <a16:creationId xmlns:a16="http://schemas.microsoft.com/office/drawing/2014/main" id="{43BBB2C3-A0C4-4576-B468-B0379F71C568}"/>
               </a:ext>
             </a:extLst>
           </p:cNvPr>
@@ -14941,7 +14941,7 @@
           <p:cNvPr id="8" name="">
             <a:extLst xmlns:a="http://schemas.openxmlformats.org/drawingml/2006/main">
               <a:ext uri="{FF2B5EF4-FFF2-40B4-BE49-F238E27FC236}">
-                <a16:creationId xmlns:a16="http://schemas.microsoft.com/office/drawing/2014/main" id="{2F70B305-9D00-4F2D-8E7C-F2A545525FDA}"/>
+                <a16:creationId xmlns:a16="http://schemas.microsoft.com/office/drawing/2014/main" id="{79C4AD54-2C2E-40C5-B9B5-B25F1FCE087F}"/>
               </a:ext>
             </a:extLst>
           </p:cNvPr>
@@ -14996,7 +14996,7 @@
     </p:spTree>
     <p:extLst>
       <p:ext uri="{BB962C8B-B14F-4D97-AF65-F5344CB8AC3E}">
-        <p14:creationId xmlns:p14="http://schemas.microsoft.com/office/powerpoint/2010/main" val="536407378"/>
+        <p14:creationId xmlns:p14="http://schemas.microsoft.com/office/powerpoint/2010/main" val="1962629214"/>
       </p:ext>
     </p:extLst>
   </p:cSld>
@@ -15027,7 +15027,7 @@
           <p:cNvPr id="7" name="">
             <a:extLst xmlns:a="http://schemas.openxmlformats.org/drawingml/2006/main">
               <a:ext uri="{FF2B5EF4-FFF2-40B4-BE49-F238E27FC236}">
-                <a16:creationId xmlns:a16="http://schemas.microsoft.com/office/drawing/2014/main" id="{6DB86E1A-9430-41BA-9B9D-D57D555B0D03}"/>
+                <a16:creationId xmlns:a16="http://schemas.microsoft.com/office/drawing/2014/main" id="{536AB909-4241-4086-9281-A67F1F03F97B}"/>
               </a:ext>
             </a:extLst>
           </p:cNvPr>
@@ -15084,7 +15084,7 @@
           <p:cNvPr id="2" name="">
             <a:extLst xmlns:a="http://schemas.openxmlformats.org/drawingml/2006/main">
               <a:ext uri="{FF2B5EF4-FFF2-40B4-BE49-F238E27FC236}">
-                <a16:creationId xmlns:a16="http://schemas.microsoft.com/office/drawing/2014/main" id="{BA310FB9-46C1-4CD0-BF62-3135DAF17F3E}"/>
+                <a16:creationId xmlns:a16="http://schemas.microsoft.com/office/drawing/2014/main" id="{16A79850-C34F-48A9-B977-18091C5309B9}"/>
               </a:ext>
             </a:extLst>
           </p:cNvPr>
@@ -15348,7 +15348,7 @@
           <p:cNvPr id="3" name="">
             <a:extLst xmlns:a="http://schemas.openxmlformats.org/drawingml/2006/main">
               <a:ext uri="{FF2B5EF4-FFF2-40B4-BE49-F238E27FC236}">
-                <a16:creationId xmlns:a16="http://schemas.microsoft.com/office/drawing/2014/main" id="{AC95A00E-672D-45B0-B4B4-FA7CE99414AA}"/>
+                <a16:creationId xmlns:a16="http://schemas.microsoft.com/office/drawing/2014/main" id="{309B6108-17FC-4CFD-AB7B-A5DF68F79A9B}"/>
               </a:ext>
             </a:extLst>
           </p:cNvPr>
@@ -15405,7 +15405,7 @@
           <p:cNvPr id="4" name="">
             <a:extLst xmlns:a="http://schemas.openxmlformats.org/drawingml/2006/main">
               <a:ext uri="{FF2B5EF4-FFF2-40B4-BE49-F238E27FC236}">
-                <a16:creationId xmlns:a16="http://schemas.microsoft.com/office/drawing/2014/main" id="{4C8748FE-6C63-478A-81D7-9E2AFD3ABCC9}"/>
+                <a16:creationId xmlns:a16="http://schemas.microsoft.com/office/drawing/2014/main" id="{3EF0A95C-8060-4529-938C-06B09A5F67F2}"/>
               </a:ext>
             </a:extLst>
           </p:cNvPr>
@@ -15564,7 +15564,7 @@
           <p:cNvPr id="5" name="">
             <a:extLst xmlns:a="http://schemas.openxmlformats.org/drawingml/2006/main">
               <a:ext uri="{FF2B5EF4-FFF2-40B4-BE49-F238E27FC236}">
-                <a16:creationId xmlns:a16="http://schemas.microsoft.com/office/drawing/2014/main" id="{1E01C9C4-DB67-4169-970B-5E1E0654E9A7}"/>
+                <a16:creationId xmlns:a16="http://schemas.microsoft.com/office/drawing/2014/main" id="{F2034E4D-F00A-411D-ABB9-09969E937936}"/>
               </a:ext>
             </a:extLst>
           </p:cNvPr>
@@ -15621,7 +15621,7 @@
           <p:cNvPr id="6" name="">
             <a:extLst xmlns:a="http://schemas.openxmlformats.org/drawingml/2006/main">
               <a:ext uri="{FF2B5EF4-FFF2-40B4-BE49-F238E27FC236}">
-                <a16:creationId xmlns:a16="http://schemas.microsoft.com/office/drawing/2014/main" id="{1A95BDFB-2C5A-4831-B02E-6481E68AB205}"/>
+                <a16:creationId xmlns:a16="http://schemas.microsoft.com/office/drawing/2014/main" id="{8DAC650A-4DBF-4D0B-855F-EB9B82A1F3E7}"/>
               </a:ext>
             </a:extLst>
           </p:cNvPr>
@@ -15676,7 +15676,7 @@
     </p:spTree>
     <p:extLst>
       <p:ext uri="{BB962C8B-B14F-4D97-AF65-F5344CB8AC3E}">
-        <p14:creationId xmlns:p14="http://schemas.microsoft.com/office/powerpoint/2010/main" val="250172840"/>
+        <p14:creationId xmlns:p14="http://schemas.microsoft.com/office/powerpoint/2010/main" val="127747287"/>
       </p:ext>
     </p:extLst>
   </p:cSld>
@@ -15707,7 +15707,7 @@
           <p:cNvPr id="7" name="">
             <a:extLst xmlns:a="http://schemas.openxmlformats.org/drawingml/2006/main">
               <a:ext uri="{FF2B5EF4-FFF2-40B4-BE49-F238E27FC236}">
-                <a16:creationId xmlns:a16="http://schemas.microsoft.com/office/drawing/2014/main" id="{CA58AC6E-CBE6-4AB6-973B-E144797E847F}"/>
+                <a16:creationId xmlns:a16="http://schemas.microsoft.com/office/drawing/2014/main" id="{3D976621-E48B-4AA0-9BEF-2484B9FE9CC3}"/>
               </a:ext>
             </a:extLst>
           </p:cNvPr>
@@ -15764,7 +15764,7 @@
           <p:cNvPr id="2" name="">
             <a:extLst xmlns:a="http://schemas.openxmlformats.org/drawingml/2006/main">
               <a:ext uri="{FF2B5EF4-FFF2-40B4-BE49-F238E27FC236}">
-                <a16:creationId xmlns:a16="http://schemas.microsoft.com/office/drawing/2014/main" id="{1FE19AF0-51C6-4DE3-8DF6-C243D1C9F36F}"/>
+                <a16:creationId xmlns:a16="http://schemas.microsoft.com/office/drawing/2014/main" id="{B2B68F24-1EBD-49AC-9D46-A9E7FE1B426E}"/>
               </a:ext>
             </a:extLst>
           </p:cNvPr>
@@ -16010,7 +16010,7 @@
           <p:cNvPr id="3" name="">
             <a:extLst xmlns:a="http://schemas.openxmlformats.org/drawingml/2006/main">
               <a:ext uri="{FF2B5EF4-FFF2-40B4-BE49-F238E27FC236}">
-                <a16:creationId xmlns:a16="http://schemas.microsoft.com/office/drawing/2014/main" id="{C8C8B1EA-3405-42C7-866A-555A65CE9FB0}"/>
+                <a16:creationId xmlns:a16="http://schemas.microsoft.com/office/drawing/2014/main" id="{72693D79-FC00-4BC6-9095-67E420188E96}"/>
               </a:ext>
             </a:extLst>
           </p:cNvPr>
@@ -16067,7 +16067,7 @@
           <p:cNvPr id="4" name="">
             <a:extLst xmlns:a="http://schemas.openxmlformats.org/drawingml/2006/main">
               <a:ext uri="{FF2B5EF4-FFF2-40B4-BE49-F238E27FC236}">
-                <a16:creationId xmlns:a16="http://schemas.microsoft.com/office/drawing/2014/main" id="{44EED0B9-3899-42D2-B442-33D8AE996211}"/>
+                <a16:creationId xmlns:a16="http://schemas.microsoft.com/office/drawing/2014/main" id="{06949B74-3924-47A8-BDB0-D6304890BE2E}"/>
               </a:ext>
             </a:extLst>
           </p:cNvPr>
@@ -16226,7 +16226,7 @@
           <p:cNvPr id="5" name="">
             <a:extLst xmlns:a="http://schemas.openxmlformats.org/drawingml/2006/main">
               <a:ext uri="{FF2B5EF4-FFF2-40B4-BE49-F238E27FC236}">
-                <a16:creationId xmlns:a16="http://schemas.microsoft.com/office/drawing/2014/main" id="{C75FD9D4-0C5F-48E9-AFA3-231B8FE10EF1}"/>
+                <a16:creationId xmlns:a16="http://schemas.microsoft.com/office/drawing/2014/main" id="{2729ED9A-C4C8-4BAB-9FB5-049393812F29}"/>
               </a:ext>
             </a:extLst>
           </p:cNvPr>
@@ -16283,7 +16283,7 @@
           <p:cNvPr id="6" name="">
             <a:extLst xmlns:a="http://schemas.openxmlformats.org/drawingml/2006/main">
               <a:ext uri="{FF2B5EF4-FFF2-40B4-BE49-F238E27FC236}">
-                <a16:creationId xmlns:a16="http://schemas.microsoft.com/office/drawing/2014/main" id="{E45DF04F-2211-4C7F-A682-9D74428471EF}"/>
+                <a16:creationId xmlns:a16="http://schemas.microsoft.com/office/drawing/2014/main" id="{3C250F04-77A4-428B-AFD4-04524C1D28BD}"/>
               </a:ext>
             </a:extLst>
           </p:cNvPr>
@@ -16338,7 +16338,7 @@
     </p:spTree>
     <p:extLst>
       <p:ext uri="{BB962C8B-B14F-4D97-AF65-F5344CB8AC3E}">
-        <p14:creationId xmlns:p14="http://schemas.microsoft.com/office/powerpoint/2010/main" val="1562407831"/>
+        <p14:creationId xmlns:p14="http://schemas.microsoft.com/office/powerpoint/2010/main" val="350500046"/>
       </p:ext>
     </p:extLst>
   </p:cSld>

</xml_diff>

<commit_message>
Add the talk title to the opening slide
</commit_message>
<xml_diff>
--- a/output/Bringing-the-Heat.pptx
+++ b/output/Bringing-the-Heat.pptx
@@ -2,34 +2,34 @@
 <file path=ppt/presentation.xml><?xml version="1.0" encoding="utf-8"?>
 <p:presentation xmlns:p="http://schemas.openxmlformats.org/presentationml/2006/main">
   <p:sldMasterIdLst>
-    <p:sldMasterId xmlns:r="http://schemas.openxmlformats.org/officeDocument/2006/relationships" id="2147483648" r:id="Rccdb42fd401e42ed"/>
+    <p:sldMasterId xmlns:r="http://schemas.openxmlformats.org/officeDocument/2006/relationships" id="2147483648" r:id="Rcaabcf9d3b2345b1"/>
   </p:sldMasterIdLst>
   <p:notesMasterIdLst>
-    <p:notesMasterId xmlns:r="http://schemas.openxmlformats.org/officeDocument/2006/relationships" r:id="R5625f2e1a2ff4dcc"/>
+    <p:notesMasterId xmlns:r="http://schemas.openxmlformats.org/officeDocument/2006/relationships" r:id="Rbf9942fc934b4694"/>
   </p:notesMasterIdLst>
   <p:sldIdLst>
-    <p:sldId xmlns:r="http://schemas.openxmlformats.org/officeDocument/2006/relationships" id="256" r:id="R3ff89bd34d774df1"/>
-    <p:sldId xmlns:r="http://schemas.openxmlformats.org/officeDocument/2006/relationships" id="257" r:id="R5575d1da1fe543be"/>
-    <p:sldId xmlns:r="http://schemas.openxmlformats.org/officeDocument/2006/relationships" id="258" r:id="R21dc38d28dd64f59"/>
-    <p:sldId xmlns:r="http://schemas.openxmlformats.org/officeDocument/2006/relationships" id="259" r:id="R75aa47c2c6e24ba9"/>
-    <p:sldId xmlns:r="http://schemas.openxmlformats.org/officeDocument/2006/relationships" id="260" r:id="R6759e2e7af1b442b"/>
-    <p:sldId xmlns:r="http://schemas.openxmlformats.org/officeDocument/2006/relationships" id="261" r:id="Rc4a0b87cf598473d"/>
-    <p:sldId xmlns:r="http://schemas.openxmlformats.org/officeDocument/2006/relationships" id="262" r:id="R4541251e8ea447d3"/>
-    <p:sldId xmlns:r="http://schemas.openxmlformats.org/officeDocument/2006/relationships" id="263" r:id="R066673d6aae74964"/>
-    <p:sldId xmlns:r="http://schemas.openxmlformats.org/officeDocument/2006/relationships" id="264" r:id="R18edce62a87c4ee5"/>
-    <p:sldId xmlns:r="http://schemas.openxmlformats.org/officeDocument/2006/relationships" id="265" r:id="R963d9388b5804dcf"/>
-    <p:sldId xmlns:r="http://schemas.openxmlformats.org/officeDocument/2006/relationships" id="266" r:id="R6f11c56c8eab4a98"/>
-    <p:sldId xmlns:r="http://schemas.openxmlformats.org/officeDocument/2006/relationships" id="267" r:id="R1fe7eddb2f1b4425"/>
-    <p:sldId xmlns:r="http://schemas.openxmlformats.org/officeDocument/2006/relationships" id="268" r:id="Reff40a34fcbb42b4"/>
-    <p:sldId xmlns:r="http://schemas.openxmlformats.org/officeDocument/2006/relationships" id="269" r:id="R4479b49f5caf4d44"/>
-    <p:sldId xmlns:r="http://schemas.openxmlformats.org/officeDocument/2006/relationships" id="270" r:id="R7ef9dbda204f465a"/>
-    <p:sldId xmlns:r="http://schemas.openxmlformats.org/officeDocument/2006/relationships" id="271" r:id="R46c1a16e3cf14fe7"/>
-    <p:sldId xmlns:r="http://schemas.openxmlformats.org/officeDocument/2006/relationships" id="272" r:id="Rd889bc064b1046a1"/>
-    <p:sldId xmlns:r="http://schemas.openxmlformats.org/officeDocument/2006/relationships" id="273" r:id="R53f1225f68934553"/>
-    <p:sldId xmlns:r="http://schemas.openxmlformats.org/officeDocument/2006/relationships" id="274" r:id="R0f28f21c101745e0"/>
-    <p:sldId xmlns:r="http://schemas.openxmlformats.org/officeDocument/2006/relationships" id="275" r:id="Rf577f3be87e849d3"/>
-    <p:sldId xmlns:r="http://schemas.openxmlformats.org/officeDocument/2006/relationships" id="276" r:id="Rf28220b834ce4568"/>
-    <p:sldId xmlns:r="http://schemas.openxmlformats.org/officeDocument/2006/relationships" id="277" r:id="R2f1dc4d2ae904ab9"/>
+    <p:sldId xmlns:r="http://schemas.openxmlformats.org/officeDocument/2006/relationships" id="256" r:id="Rcb8538808c174704"/>
+    <p:sldId xmlns:r="http://schemas.openxmlformats.org/officeDocument/2006/relationships" id="257" r:id="R51e5ecb37b994b32"/>
+    <p:sldId xmlns:r="http://schemas.openxmlformats.org/officeDocument/2006/relationships" id="258" r:id="R4ddf81cca1ca4584"/>
+    <p:sldId xmlns:r="http://schemas.openxmlformats.org/officeDocument/2006/relationships" id="259" r:id="R39ec322abec34798"/>
+    <p:sldId xmlns:r="http://schemas.openxmlformats.org/officeDocument/2006/relationships" id="260" r:id="R88f56f9e96af4eb8"/>
+    <p:sldId xmlns:r="http://schemas.openxmlformats.org/officeDocument/2006/relationships" id="261" r:id="R8482dfdb0ea241d9"/>
+    <p:sldId xmlns:r="http://schemas.openxmlformats.org/officeDocument/2006/relationships" id="262" r:id="R0c6c0754dc6647d2"/>
+    <p:sldId xmlns:r="http://schemas.openxmlformats.org/officeDocument/2006/relationships" id="263" r:id="Ra53047a5860a4fa4"/>
+    <p:sldId xmlns:r="http://schemas.openxmlformats.org/officeDocument/2006/relationships" id="264" r:id="Ra340dcd1ce9b4d90"/>
+    <p:sldId xmlns:r="http://schemas.openxmlformats.org/officeDocument/2006/relationships" id="265" r:id="Rf7b301372ec34f92"/>
+    <p:sldId xmlns:r="http://schemas.openxmlformats.org/officeDocument/2006/relationships" id="266" r:id="R9dd8e69dc1574395"/>
+    <p:sldId xmlns:r="http://schemas.openxmlformats.org/officeDocument/2006/relationships" id="267" r:id="Rccfae6bd91294ef4"/>
+    <p:sldId xmlns:r="http://schemas.openxmlformats.org/officeDocument/2006/relationships" id="268" r:id="R8205f3fb43764c9b"/>
+    <p:sldId xmlns:r="http://schemas.openxmlformats.org/officeDocument/2006/relationships" id="269" r:id="R1e1e71d96f874bd0"/>
+    <p:sldId xmlns:r="http://schemas.openxmlformats.org/officeDocument/2006/relationships" id="270" r:id="Rfe067a66e6ba482e"/>
+    <p:sldId xmlns:r="http://schemas.openxmlformats.org/officeDocument/2006/relationships" id="271" r:id="R3935505433b246e7"/>
+    <p:sldId xmlns:r="http://schemas.openxmlformats.org/officeDocument/2006/relationships" id="272" r:id="Rd5433a4ff6c84657"/>
+    <p:sldId xmlns:r="http://schemas.openxmlformats.org/officeDocument/2006/relationships" id="273" r:id="Ra211d43423a84f9e"/>
+    <p:sldId xmlns:r="http://schemas.openxmlformats.org/officeDocument/2006/relationships" id="274" r:id="R1c4e06f8796e4d2f"/>
+    <p:sldId xmlns:r="http://schemas.openxmlformats.org/officeDocument/2006/relationships" id="275" r:id="R07c32fcffc044ff5"/>
+    <p:sldId xmlns:r="http://schemas.openxmlformats.org/officeDocument/2006/relationships" id="276" r:id="Rac483a7c55a94fcd"/>
+    <p:sldId xmlns:r="http://schemas.openxmlformats.org/officeDocument/2006/relationships" id="277" r:id="Ra812f46735094add"/>
   </p:sldIdLst>
   <p:sldSz cx="12192000" cy="6858000"/>
   <p:notesSz cx="6858000" cy="9144000"/>
@@ -2841,7 +2841,7 @@
   </p:cSld>
   <p:clrMap bg1="lt1" tx1="dk1" bg2="lt2" tx2="dk2" accent1="accent1" accent2="accent2" accent3="accent3" accent4="accent4" accent5="accent5" accent6="accent6" hlink="hlink" folHlink="folHlink"/>
   <p:sldLayoutIdLst>
-    <p:sldLayoutId xmlns:r="http://schemas.openxmlformats.org/officeDocument/2006/relationships" id="2147483649" r:id="Rdf83381653f34128"/>
+    <p:sldLayoutId xmlns:r="http://schemas.openxmlformats.org/officeDocument/2006/relationships" id="2147483649" r:id="R556630a817074c2d"/>
   </p:sldLayoutIdLst>
   <p:txStyles>
     <p:titleStyle>
@@ -3389,10 +3389,10 @@
       </p:grpSpPr>
       <p:sp>
         <p:nvSpPr>
-          <p:cNvPr id="4" name="">
+          <p:cNvPr id="6" name="">
             <a:extLst xmlns:a="http://schemas.openxmlformats.org/drawingml/2006/main">
               <a:ext uri="{FF2B5EF4-FFF2-40B4-BE49-F238E27FC236}">
-                <a16:creationId xmlns:a16="http://schemas.microsoft.com/office/drawing/2014/main" id="{2C52B07D-C2ED-409C-981C-79C0FC649413}"/>
+                <a16:creationId xmlns:a16="http://schemas.microsoft.com/office/drawing/2014/main" id="{3DE4553E-80C1-4D58-872C-CC42C69682C9}"/>
               </a:ext>
             </a:extLst>
           </p:cNvPr>
@@ -3403,8 +3403,8 @@
         </p:nvSpPr>
         <p:spPr>
           <a:xfrm xmlns:a="http://schemas.openxmlformats.org/drawingml/2006/main">
-            <a:off x="723900" y="2333625"/>
-            <a:ext cx="6686550" cy="1066800"/>
+            <a:off x="723900" y="857250"/>
+            <a:ext cx="10744200" cy="1104900"/>
           </a:xfrm>
           <a:prstGeom xmlns:a="http://schemas.openxmlformats.org/drawingml/2006/main" prst="rect">
             <a:avLst/>
@@ -3421,7 +3421,7 @@
           <a:lstStyle xmlns:a="http://schemas.openxmlformats.org/drawingml/2006/main"/>
           <a:p xmlns:a="http://schemas.openxmlformats.org/drawingml/2006/main">
             <a:pPr>
-              <a:defRPr sz="5850" b="1">
+              <a:defRPr sz="6000" b="1">
                 <a:solidFill>
                   <a:srgbClr val="FFD21E"/>
                 </a:solidFill>
@@ -3431,7 +3431,7 @@
               </a:defRPr>
             </a:pPr>
             <a:r>
-              <a:rPr sz="5850" b="1">
+              <a:rPr sz="6000" b="1">
                 <a:solidFill>
                   <a:srgbClr val="FFD21E"/>
                 </a:solidFill>
@@ -3439,7 +3439,7 @@
                 <a:ea typeface="Arial"/>
                 <a:cs typeface="Arial"/>
               </a:rPr>
-              <a:t>Muntaser Syed</a:t>
+              <a:t>Bringing the Heat</a:t>
             </a:r>
           </a:p>
         </p:txBody>
@@ -3449,7 +3449,7 @@
           <p:cNvPr id="2" name="">
             <a:extLst xmlns:a="http://schemas.openxmlformats.org/drawingml/2006/main">
               <a:ext uri="{FF2B5EF4-FFF2-40B4-BE49-F238E27FC236}">
-                <a16:creationId xmlns:a16="http://schemas.microsoft.com/office/drawing/2014/main" id="{8D091419-0DC0-41D4-B2E2-05445938BF15}"/>
+                <a16:creationId xmlns:a16="http://schemas.microsoft.com/office/drawing/2014/main" id="{8139EEAE-24B5-40D2-95DF-B881E23E7D05}"/>
               </a:ext>
             </a:extLst>
           </p:cNvPr>
@@ -3460,8 +3460,8 @@
         </p:nvSpPr>
         <p:spPr>
           <a:xfrm xmlns:a="http://schemas.openxmlformats.org/drawingml/2006/main">
-            <a:off x="762000" y="3619500"/>
-            <a:ext cx="6286500" cy="666750"/>
+            <a:off x="762000" y="2190750"/>
+            <a:ext cx="6724650" cy="1485900"/>
           </a:xfrm>
           <a:prstGeom xmlns:a="http://schemas.openxmlformats.org/drawingml/2006/main" prst="rect">
             <a:avLst/>
@@ -3478,24 +3478,161 @@
           <a:lstStyle xmlns:a="http://schemas.openxmlformats.org/drawingml/2006/main"/>
           <a:p xmlns:a="http://schemas.openxmlformats.org/drawingml/2006/main">
             <a:pPr>
-              <a:defRPr sz="2700" b="0">
-                <a:solidFill>
-                  <a:srgbClr val="FFF9ED"/>
-                </a:solidFill>
-                <a:latin typeface="Arial"/>
-                <a:ea typeface="Arial"/>
-                <a:cs typeface="Arial"/>
-              </a:defRPr>
-            </a:pPr>
-            <a:r>
-              <a:rPr sz="2700" b="0">
-                <a:solidFill>
-                  <a:srgbClr val="FFF9ED"/>
-                </a:solidFill>
-                <a:latin typeface="Arial"/>
-                <a:ea typeface="Arial"/>
-                <a:cs typeface="Arial"/>
-                <a:hlinkClick xmlns:r="http://schemas.openxmlformats.org/officeDocument/2006/relationships" r:id="R70138a18e5374bd6"/>
+              <a:defRPr sz="3300" b="0">
+                <a:solidFill>
+                  <a:srgbClr val="FFF9ED"/>
+                </a:solidFill>
+                <a:latin typeface="Arial"/>
+                <a:ea typeface="Arial"/>
+                <a:cs typeface="Arial"/>
+              </a:defRPr>
+            </a:pPr>
+            <a:r>
+              <a:rPr sz="3300" b="0">
+                <a:solidFill>
+                  <a:srgbClr val="FFF9ED"/>
+                </a:solidFill>
+                <a:latin typeface="Arial"/>
+                <a:ea typeface="Arial"/>
+                <a:cs typeface="Arial"/>
+              </a:rPr>
+              <a:t>Supercharging Your ML</a:t>
+            </a:r>
+          </a:p>
+          <a:p xmlns:a="http://schemas.openxmlformats.org/drawingml/2006/main">
+            <a:pPr>
+              <a:defRPr sz="3300" b="0">
+                <a:solidFill>
+                  <a:srgbClr val="FFF9ED"/>
+                </a:solidFill>
+                <a:latin typeface="Arial"/>
+                <a:ea typeface="Arial"/>
+                <a:cs typeface="Arial"/>
+              </a:defRPr>
+            </a:pPr>
+            <a:r>
+              <a:rPr sz="3300" b="0">
+                <a:solidFill>
+                  <a:srgbClr val="FFF9ED"/>
+                </a:solidFill>
+                <a:latin typeface="Arial"/>
+                <a:ea typeface="Arial"/>
+                <a:cs typeface="Arial"/>
+              </a:rPr>
+              <a:t>Pipelines with HuggingFace</a:t>
+            </a:r>
+          </a:p>
+        </p:txBody>
+      </p:sp>
+      <p:sp>
+        <p:nvSpPr>
+          <p:cNvPr id="3" name="">
+            <a:extLst xmlns:a="http://schemas.openxmlformats.org/drawingml/2006/main">
+              <a:ext uri="{FF2B5EF4-FFF2-40B4-BE49-F238E27FC236}">
+                <a16:creationId xmlns:a16="http://schemas.microsoft.com/office/drawing/2014/main" id="{04181503-7A16-4050-9071-F7A99E132E2C}"/>
+              </a:ext>
+            </a:extLst>
+          </p:cNvPr>
+          <p:cNvSpPr>
+            <a:spLocks xmlns:a="http://schemas.openxmlformats.org/drawingml/2006/main" noGrp="1"/>
+          </p:cNvSpPr>
+          <p:nvPr/>
+        </p:nvSpPr>
+        <p:spPr>
+          <a:xfrm xmlns:a="http://schemas.openxmlformats.org/drawingml/2006/main">
+            <a:off x="762000" y="4391025"/>
+            <a:ext cx="6724650" cy="619125"/>
+          </a:xfrm>
+          <a:prstGeom xmlns:a="http://schemas.openxmlformats.org/drawingml/2006/main" prst="rect">
+            <a:avLst/>
+          </a:prstGeom>
+          <a:noFill xmlns:a="http://schemas.openxmlformats.org/drawingml/2006/main"/>
+          <a:ln xmlns:a="http://schemas.openxmlformats.org/drawingml/2006/main" w="0">
+            <a:noFill/>
+          </a:ln>
+        </p:spPr>
+        <p:txBody>
+          <a:bodyPr xmlns:a="http://schemas.openxmlformats.org/drawingml/2006/main" anchor="t">
+            <a:noAutofit/>
+          </a:bodyPr>
+          <a:lstStyle xmlns:a="http://schemas.openxmlformats.org/drawingml/2006/main"/>
+          <a:p xmlns:a="http://schemas.openxmlformats.org/drawingml/2006/main">
+            <a:pPr>
+              <a:defRPr sz="3300" b="1">
+                <a:solidFill>
+                  <a:srgbClr val="FFF9ED"/>
+                </a:solidFill>
+                <a:latin typeface="Arial"/>
+                <a:ea typeface="Arial"/>
+                <a:cs typeface="Arial"/>
+              </a:defRPr>
+            </a:pPr>
+            <a:r>
+              <a:rPr sz="3300" b="1">
+                <a:solidFill>
+                  <a:srgbClr val="FFF9ED"/>
+                </a:solidFill>
+                <a:latin typeface="Arial"/>
+                <a:ea typeface="Arial"/>
+                <a:cs typeface="Arial"/>
+              </a:rPr>
+              <a:t>Muntaser Syed</a:t>
+            </a:r>
+          </a:p>
+        </p:txBody>
+      </p:sp>
+      <p:sp>
+        <p:nvSpPr>
+          <p:cNvPr id="4" name="">
+            <a:extLst xmlns:a="http://schemas.openxmlformats.org/drawingml/2006/main">
+              <a:ext uri="{FF2B5EF4-FFF2-40B4-BE49-F238E27FC236}">
+                <a16:creationId xmlns:a16="http://schemas.microsoft.com/office/drawing/2014/main" id="{5E048EA0-1CCE-4F57-897A-F400DDEF6FA9}"/>
+              </a:ext>
+            </a:extLst>
+          </p:cNvPr>
+          <p:cNvSpPr>
+            <a:spLocks xmlns:a="http://schemas.openxmlformats.org/drawingml/2006/main" noGrp="1"/>
+          </p:cNvSpPr>
+          <p:nvPr/>
+        </p:nvSpPr>
+        <p:spPr>
+          <a:xfrm xmlns:a="http://schemas.openxmlformats.org/drawingml/2006/main">
+            <a:off x="762000" y="5095875"/>
+            <a:ext cx="6572250" cy="552450"/>
+          </a:xfrm>
+          <a:prstGeom xmlns:a="http://schemas.openxmlformats.org/drawingml/2006/main" prst="rect">
+            <a:avLst/>
+          </a:prstGeom>
+          <a:noFill xmlns:a="http://schemas.openxmlformats.org/drawingml/2006/main"/>
+          <a:ln xmlns:a="http://schemas.openxmlformats.org/drawingml/2006/main" w="0">
+            <a:noFill/>
+          </a:ln>
+        </p:spPr>
+        <p:txBody>
+          <a:bodyPr xmlns:a="http://schemas.openxmlformats.org/drawingml/2006/main" anchor="t">
+            <a:noAutofit/>
+          </a:bodyPr>
+          <a:lstStyle xmlns:a="http://schemas.openxmlformats.org/drawingml/2006/main"/>
+          <a:p xmlns:a="http://schemas.openxmlformats.org/drawingml/2006/main">
+            <a:pPr>
+              <a:defRPr sz="2400" b="0">
+                <a:solidFill>
+                  <a:srgbClr val="FFF9ED"/>
+                </a:solidFill>
+                <a:latin typeface="Arial"/>
+                <a:ea typeface="Arial"/>
+                <a:cs typeface="Arial"/>
+              </a:defRPr>
+            </a:pPr>
+            <a:r>
+              <a:rPr sz="2400" b="0">
+                <a:solidFill>
+                  <a:srgbClr val="FFF9ED"/>
+                </a:solidFill>
+                <a:latin typeface="Arial"/>
+                <a:ea typeface="Arial"/>
+                <a:cs typeface="Arial"/>
+                <a:hlinkClick xmlns:r="http://schemas.openxmlformats.org/officeDocument/2006/relationships" r:id="R6dbfa0f7c2374e45"/>
               </a:rPr>
               <a:t>muntasersyed.com</a:t>
             </a:r>
@@ -3504,19 +3641,19 @@
       </p:sp>
       <p:pic>
         <p:nvPicPr>
-          <p:cNvPr id="6" name=""/>
+          <p:cNvPr id="10" name=""/>
           <p:cNvPicPr>
             <a:picLocks xmlns:a="http://schemas.openxmlformats.org/drawingml/2006/main" noChangeAspect="1"/>
           </p:cNvPicPr>
           <p:nvPr/>
         </p:nvPicPr>
         <p:blipFill>
-          <a:blip xmlns:r="http://schemas.openxmlformats.org/officeDocument/2006/relationships" xmlns:a="http://schemas.openxmlformats.org/drawingml/2006/main" r:embed="R3309248293264bec"/>
+          <a:blip xmlns:r="http://schemas.openxmlformats.org/officeDocument/2006/relationships" xmlns:a="http://schemas.openxmlformats.org/drawingml/2006/main" r:embed="R16aeaec100aa471a"/>
           <a:stretch xmlns:a="http://schemas.openxmlformats.org/drawingml/2006/main"/>
         </p:blipFill>
         <p:spPr>
           <a:xfrm xmlns:a="http://schemas.openxmlformats.org/drawingml/2006/main">
-            <a:off x="7810500" y="1562100"/>
+            <a:off x="7810500" y="2143125"/>
             <a:ext cx="3733800" cy="3733800"/>
           </a:xfrm>
           <a:prstGeom xmlns:a="http://schemas.openxmlformats.org/drawingml/2006/main" prst="rect">
@@ -3527,7 +3664,7 @@
     </p:spTree>
     <p:extLst>
       <p:ext uri="{BB962C8B-B14F-4D97-AF65-F5344CB8AC3E}">
-        <p14:creationId xmlns:p14="http://schemas.microsoft.com/office/powerpoint/2010/main" val="1853575997"/>
+        <p14:creationId xmlns:p14="http://schemas.microsoft.com/office/powerpoint/2010/main" val="1444336801"/>
       </p:ext>
     </p:extLst>
   </p:cSld>
@@ -3558,7 +3695,7 @@
           <p:cNvPr id="13" name="">
             <a:extLst xmlns:a="http://schemas.openxmlformats.org/drawingml/2006/main">
               <a:ext uri="{FF2B5EF4-FFF2-40B4-BE49-F238E27FC236}">
-                <a16:creationId xmlns:a16="http://schemas.microsoft.com/office/drawing/2014/main" id="{FFDDA945-9D7A-4DE8-BAD4-E7D245B51F45}"/>
+                <a16:creationId xmlns:a16="http://schemas.microsoft.com/office/drawing/2014/main" id="{6C70B1EC-3F57-49C2-B16D-D78667E8BCB8}"/>
               </a:ext>
             </a:extLst>
           </p:cNvPr>
@@ -3615,7 +3752,7 @@
           <p:cNvPr id="2" name="">
             <a:extLst xmlns:a="http://schemas.openxmlformats.org/drawingml/2006/main">
               <a:ext uri="{FF2B5EF4-FFF2-40B4-BE49-F238E27FC236}">
-                <a16:creationId xmlns:a16="http://schemas.microsoft.com/office/drawing/2014/main" id="{C29408EF-54C0-4952-9F53-7FDA9B952918}"/>
+                <a16:creationId xmlns:a16="http://schemas.microsoft.com/office/drawing/2014/main" id="{C5E89937-68C6-42E0-A3E3-AB78CF7FBBC6}"/>
               </a:ext>
             </a:extLst>
           </p:cNvPr>
@@ -3672,7 +3809,7 @@
           <p:cNvPr id="3" name="">
             <a:extLst xmlns:a="http://schemas.openxmlformats.org/drawingml/2006/main">
               <a:ext uri="{FF2B5EF4-FFF2-40B4-BE49-F238E27FC236}">
-                <a16:creationId xmlns:a16="http://schemas.microsoft.com/office/drawing/2014/main" id="{21F5D5BC-9184-45DA-B799-02212AA0D5D8}"/>
+                <a16:creationId xmlns:a16="http://schemas.microsoft.com/office/drawing/2014/main" id="{7A9B138C-54E1-409A-BEA5-54F6810B8E01}"/>
               </a:ext>
             </a:extLst>
           </p:cNvPr>
@@ -3729,7 +3866,7 @@
           <p:cNvPr id="4" name="">
             <a:extLst xmlns:a="http://schemas.openxmlformats.org/drawingml/2006/main">
               <a:ext uri="{FF2B5EF4-FFF2-40B4-BE49-F238E27FC236}">
-                <a16:creationId xmlns:a16="http://schemas.microsoft.com/office/drawing/2014/main" id="{757D4FDB-25D0-41D7-90F2-9B7CF77F4690}"/>
+                <a16:creationId xmlns:a16="http://schemas.microsoft.com/office/drawing/2014/main" id="{F0B23969-F28C-4E31-ABD9-B7CC94EEF379}"/>
               </a:ext>
             </a:extLst>
           </p:cNvPr>
@@ -3786,7 +3923,7 @@
           <p:cNvPr id="5" name="">
             <a:extLst xmlns:a="http://schemas.openxmlformats.org/drawingml/2006/main">
               <a:ext uri="{FF2B5EF4-FFF2-40B4-BE49-F238E27FC236}">
-                <a16:creationId xmlns:a16="http://schemas.microsoft.com/office/drawing/2014/main" id="{8EBB3D68-A10E-44F0-9956-28FA82DDF7B6}"/>
+                <a16:creationId xmlns:a16="http://schemas.microsoft.com/office/drawing/2014/main" id="{4A9B69B7-4603-426D-8333-84DE1AE3E489}"/>
               </a:ext>
             </a:extLst>
           </p:cNvPr>
@@ -3843,7 +3980,7 @@
           <p:cNvPr id="6" name="">
             <a:extLst xmlns:a="http://schemas.openxmlformats.org/drawingml/2006/main">
               <a:ext uri="{FF2B5EF4-FFF2-40B4-BE49-F238E27FC236}">
-                <a16:creationId xmlns:a16="http://schemas.microsoft.com/office/drawing/2014/main" id="{A83C87E5-A447-410E-A86E-4D41C17FD0E2}"/>
+                <a16:creationId xmlns:a16="http://schemas.microsoft.com/office/drawing/2014/main" id="{A6ABCC4D-9B07-4848-ADFA-21BF9569971B}"/>
               </a:ext>
             </a:extLst>
           </p:cNvPr>
@@ -3900,7 +4037,7 @@
           <p:cNvPr id="7" name="">
             <a:extLst xmlns:a="http://schemas.openxmlformats.org/drawingml/2006/main">
               <a:ext uri="{FF2B5EF4-FFF2-40B4-BE49-F238E27FC236}">
-                <a16:creationId xmlns:a16="http://schemas.microsoft.com/office/drawing/2014/main" id="{6A7130DA-DF12-4B0C-BDBD-AF40D74B3F11}"/>
+                <a16:creationId xmlns:a16="http://schemas.microsoft.com/office/drawing/2014/main" id="{56FCEF07-EC5A-4AFE-AB6E-875BF74B0F57}"/>
               </a:ext>
             </a:extLst>
           </p:cNvPr>
@@ -3957,7 +4094,7 @@
           <p:cNvPr id="8" name="">
             <a:extLst xmlns:a="http://schemas.openxmlformats.org/drawingml/2006/main">
               <a:ext uri="{FF2B5EF4-FFF2-40B4-BE49-F238E27FC236}">
-                <a16:creationId xmlns:a16="http://schemas.microsoft.com/office/drawing/2014/main" id="{A7289238-EA97-46BF-AD45-21B751213624}"/>
+                <a16:creationId xmlns:a16="http://schemas.microsoft.com/office/drawing/2014/main" id="{838DA086-AA2D-4D74-862D-AECFAEEA0680}"/>
               </a:ext>
             </a:extLst>
           </p:cNvPr>
@@ -4014,7 +4151,7 @@
           <p:cNvPr id="9" name="">
             <a:extLst xmlns:a="http://schemas.openxmlformats.org/drawingml/2006/main">
               <a:ext uri="{FF2B5EF4-FFF2-40B4-BE49-F238E27FC236}">
-                <a16:creationId xmlns:a16="http://schemas.microsoft.com/office/drawing/2014/main" id="{C27A3B50-B0C2-4482-800C-9C1A1A085229}"/>
+                <a16:creationId xmlns:a16="http://schemas.microsoft.com/office/drawing/2014/main" id="{70C8CCCE-2265-40F2-8779-45BF2D42DB02}"/>
               </a:ext>
             </a:extLst>
           </p:cNvPr>
@@ -4071,7 +4208,7 @@
           <p:cNvPr id="10" name="">
             <a:extLst xmlns:a="http://schemas.openxmlformats.org/drawingml/2006/main">
               <a:ext uri="{FF2B5EF4-FFF2-40B4-BE49-F238E27FC236}">
-                <a16:creationId xmlns:a16="http://schemas.microsoft.com/office/drawing/2014/main" id="{1E39D37B-BBC5-409D-BDBB-79E0B34AEA27}"/>
+                <a16:creationId xmlns:a16="http://schemas.microsoft.com/office/drawing/2014/main" id="{4D3B8CD0-F22B-4565-BF30-D705D08BD36A}"/>
               </a:ext>
             </a:extLst>
           </p:cNvPr>
@@ -4128,7 +4265,7 @@
           <p:cNvPr id="11" name="">
             <a:extLst xmlns:a="http://schemas.openxmlformats.org/drawingml/2006/main">
               <a:ext uri="{FF2B5EF4-FFF2-40B4-BE49-F238E27FC236}">
-                <a16:creationId xmlns:a16="http://schemas.microsoft.com/office/drawing/2014/main" id="{AD6CBE60-02C4-4A77-A811-6EC8358BADC2}"/>
+                <a16:creationId xmlns:a16="http://schemas.microsoft.com/office/drawing/2014/main" id="{ADE9799E-0B99-40D1-9043-45C815075DA4}"/>
               </a:ext>
             </a:extLst>
           </p:cNvPr>
@@ -4185,7 +4322,7 @@
           <p:cNvPr id="12" name="">
             <a:extLst xmlns:a="http://schemas.openxmlformats.org/drawingml/2006/main">
               <a:ext uri="{FF2B5EF4-FFF2-40B4-BE49-F238E27FC236}">
-                <a16:creationId xmlns:a16="http://schemas.microsoft.com/office/drawing/2014/main" id="{AC808A4E-8986-4FE3-AC37-8C3AB86D5E2E}"/>
+                <a16:creationId xmlns:a16="http://schemas.microsoft.com/office/drawing/2014/main" id="{0019E209-99CC-4547-9258-0B39B55FAD5E}"/>
               </a:ext>
             </a:extLst>
           </p:cNvPr>
@@ -4240,7 +4377,7 @@
     </p:spTree>
     <p:extLst>
       <p:ext uri="{BB962C8B-B14F-4D97-AF65-F5344CB8AC3E}">
-        <p14:creationId xmlns:p14="http://schemas.microsoft.com/office/powerpoint/2010/main" val="1881904069"/>
+        <p14:creationId xmlns:p14="http://schemas.microsoft.com/office/powerpoint/2010/main" val="1201975822"/>
       </p:ext>
     </p:extLst>
   </p:cSld>
@@ -4271,7 +4408,7 @@
           <p:cNvPr id="5" name="">
             <a:extLst xmlns:a="http://schemas.openxmlformats.org/drawingml/2006/main">
               <a:ext uri="{FF2B5EF4-FFF2-40B4-BE49-F238E27FC236}">
-                <a16:creationId xmlns:a16="http://schemas.microsoft.com/office/drawing/2014/main" id="{8C32BBB2-41A1-4B4E-840E-142418F3A0C3}"/>
+                <a16:creationId xmlns:a16="http://schemas.microsoft.com/office/drawing/2014/main" id="{AE686E60-E0EA-4016-8099-4C783524BD22}"/>
               </a:ext>
             </a:extLst>
           </p:cNvPr>
@@ -4721,7 +4858,7 @@
           <p:cNvPr id="3" name="">
             <a:extLst xmlns:a="http://schemas.openxmlformats.org/drawingml/2006/main">
               <a:ext uri="{FF2B5EF4-FFF2-40B4-BE49-F238E27FC236}">
-                <a16:creationId xmlns:a16="http://schemas.microsoft.com/office/drawing/2014/main" id="{20105103-B369-41E3-B5B9-EB4B37194F43}"/>
+                <a16:creationId xmlns:a16="http://schemas.microsoft.com/office/drawing/2014/main" id="{2E77C6B8-DC9A-44D8-AFB8-E470A4595937}"/>
               </a:ext>
             </a:extLst>
           </p:cNvPr>
@@ -4778,7 +4915,7 @@
           <p:cNvPr id="4" name="">
             <a:extLst xmlns:a="http://schemas.openxmlformats.org/drawingml/2006/main">
               <a:ext uri="{FF2B5EF4-FFF2-40B4-BE49-F238E27FC236}">
-                <a16:creationId xmlns:a16="http://schemas.microsoft.com/office/drawing/2014/main" id="{F6E7116B-D5B6-40F7-AF70-B17ECE15B506}"/>
+                <a16:creationId xmlns:a16="http://schemas.microsoft.com/office/drawing/2014/main" id="{5B4A06D2-30C4-4FD6-BD3E-FB7B617E8681}"/>
               </a:ext>
             </a:extLst>
           </p:cNvPr>
@@ -4833,7 +4970,7 @@
     </p:spTree>
     <p:extLst>
       <p:ext uri="{BB962C8B-B14F-4D97-AF65-F5344CB8AC3E}">
-        <p14:creationId xmlns:p14="http://schemas.microsoft.com/office/powerpoint/2010/main" val="1686618111"/>
+        <p14:creationId xmlns:p14="http://schemas.microsoft.com/office/powerpoint/2010/main" val="653008237"/>
       </p:ext>
     </p:extLst>
   </p:cSld>
@@ -4864,7 +5001,7 @@
           <p:cNvPr id="7" name="">
             <a:extLst xmlns:a="http://schemas.openxmlformats.org/drawingml/2006/main">
               <a:ext uri="{FF2B5EF4-FFF2-40B4-BE49-F238E27FC236}">
-                <a16:creationId xmlns:a16="http://schemas.microsoft.com/office/drawing/2014/main" id="{AE8E52C6-A8DF-4F22-B390-6816C17C85FC}"/>
+                <a16:creationId xmlns:a16="http://schemas.microsoft.com/office/drawing/2014/main" id="{7A977ADC-8254-4611-906E-2CB29D8A3416}"/>
               </a:ext>
             </a:extLst>
           </p:cNvPr>
@@ -4921,7 +5058,7 @@
           <p:cNvPr id="2" name="">
             <a:extLst xmlns:a="http://schemas.openxmlformats.org/drawingml/2006/main">
               <a:ext uri="{FF2B5EF4-FFF2-40B4-BE49-F238E27FC236}">
-                <a16:creationId xmlns:a16="http://schemas.microsoft.com/office/drawing/2014/main" id="{EF89FBA2-051A-4618-8C40-3ADCB1D74BAA}"/>
+                <a16:creationId xmlns:a16="http://schemas.microsoft.com/office/drawing/2014/main" id="{B4117869-3653-42D7-ADCE-258DA9A4D288}"/>
               </a:ext>
             </a:extLst>
           </p:cNvPr>
@@ -5172,7 +5309,7 @@
           <p:cNvPr id="3" name="">
             <a:extLst xmlns:a="http://schemas.openxmlformats.org/drawingml/2006/main">
               <a:ext uri="{FF2B5EF4-FFF2-40B4-BE49-F238E27FC236}">
-                <a16:creationId xmlns:a16="http://schemas.microsoft.com/office/drawing/2014/main" id="{CEA51736-8CE0-43BF-BCE2-A23FF84B0069}"/>
+                <a16:creationId xmlns:a16="http://schemas.microsoft.com/office/drawing/2014/main" id="{A53BC629-EB65-461A-99B4-5F12B0C6C920}"/>
               </a:ext>
             </a:extLst>
           </p:cNvPr>
@@ -5229,7 +5366,7 @@
           <p:cNvPr id="4" name="">
             <a:extLst xmlns:a="http://schemas.openxmlformats.org/drawingml/2006/main">
               <a:ext uri="{FF2B5EF4-FFF2-40B4-BE49-F238E27FC236}">
-                <a16:creationId xmlns:a16="http://schemas.microsoft.com/office/drawing/2014/main" id="{B2BC122D-5FAD-473A-898E-F7B8C9E30A70}"/>
+                <a16:creationId xmlns:a16="http://schemas.microsoft.com/office/drawing/2014/main" id="{596D99D9-7FC7-45A1-A8EB-F57D35608597}"/>
               </a:ext>
             </a:extLst>
           </p:cNvPr>
@@ -5370,7 +5507,7 @@
           <p:cNvPr id="5" name="">
             <a:extLst xmlns:a="http://schemas.openxmlformats.org/drawingml/2006/main">
               <a:ext uri="{FF2B5EF4-FFF2-40B4-BE49-F238E27FC236}">
-                <a16:creationId xmlns:a16="http://schemas.microsoft.com/office/drawing/2014/main" id="{CA0D7476-7711-4C24-8656-041ACF2A881E}"/>
+                <a16:creationId xmlns:a16="http://schemas.microsoft.com/office/drawing/2014/main" id="{7F5FA234-318C-4CAA-9FFE-71587FD0CD4B}"/>
               </a:ext>
             </a:extLst>
           </p:cNvPr>
@@ -5427,7 +5564,7 @@
           <p:cNvPr id="6" name="">
             <a:extLst xmlns:a="http://schemas.openxmlformats.org/drawingml/2006/main">
               <a:ext uri="{FF2B5EF4-FFF2-40B4-BE49-F238E27FC236}">
-                <a16:creationId xmlns:a16="http://schemas.microsoft.com/office/drawing/2014/main" id="{65F51116-46A3-4F84-A65E-3D356220E20F}"/>
+                <a16:creationId xmlns:a16="http://schemas.microsoft.com/office/drawing/2014/main" id="{8D35364B-8A76-4C13-9C1E-CDCB9E217EF5}"/>
               </a:ext>
             </a:extLst>
           </p:cNvPr>
@@ -5482,7 +5619,7 @@
     </p:spTree>
     <p:extLst>
       <p:ext uri="{BB962C8B-B14F-4D97-AF65-F5344CB8AC3E}">
-        <p14:creationId xmlns:p14="http://schemas.microsoft.com/office/powerpoint/2010/main" val="2052660444"/>
+        <p14:creationId xmlns:p14="http://schemas.microsoft.com/office/powerpoint/2010/main" val="737254805"/>
       </p:ext>
     </p:extLst>
   </p:cSld>
@@ -5513,7 +5650,7 @@
           <p:cNvPr id="6" name="">
             <a:extLst xmlns:a="http://schemas.openxmlformats.org/drawingml/2006/main">
               <a:ext uri="{FF2B5EF4-FFF2-40B4-BE49-F238E27FC236}">
-                <a16:creationId xmlns:a16="http://schemas.microsoft.com/office/drawing/2014/main" id="{79E9541E-9BE2-4655-9E51-A26181D9E0A6}"/>
+                <a16:creationId xmlns:a16="http://schemas.microsoft.com/office/drawing/2014/main" id="{B5FA7B15-C944-4524-91EC-9DF536279569}"/>
               </a:ext>
             </a:extLst>
           </p:cNvPr>
@@ -5986,7 +6123,7 @@
           <p:cNvPr id="3" name="">
             <a:extLst xmlns:a="http://schemas.openxmlformats.org/drawingml/2006/main">
               <a:ext uri="{FF2B5EF4-FFF2-40B4-BE49-F238E27FC236}">
-                <a16:creationId xmlns:a16="http://schemas.microsoft.com/office/drawing/2014/main" id="{356DF9EF-4642-4D73-9CED-E20374E2D83F}"/>
+                <a16:creationId xmlns:a16="http://schemas.microsoft.com/office/drawing/2014/main" id="{A2D8CBB7-18D0-4B6F-BC1D-A567EB205AC7}"/>
               </a:ext>
             </a:extLst>
           </p:cNvPr>
@@ -6089,7 +6226,7 @@
           <p:cNvPr id="4" name="">
             <a:extLst xmlns:a="http://schemas.openxmlformats.org/drawingml/2006/main">
               <a:ext uri="{FF2B5EF4-FFF2-40B4-BE49-F238E27FC236}">
-                <a16:creationId xmlns:a16="http://schemas.microsoft.com/office/drawing/2014/main" id="{E80B32BE-3493-4E62-A6FE-E587DC68B6B3}"/>
+                <a16:creationId xmlns:a16="http://schemas.microsoft.com/office/drawing/2014/main" id="{AA3451C5-36DE-4A9A-88CB-17791681818C}"/>
               </a:ext>
             </a:extLst>
           </p:cNvPr>
@@ -6146,7 +6283,7 @@
           <p:cNvPr id="5" name="">
             <a:extLst xmlns:a="http://schemas.openxmlformats.org/drawingml/2006/main">
               <a:ext uri="{FF2B5EF4-FFF2-40B4-BE49-F238E27FC236}">
-                <a16:creationId xmlns:a16="http://schemas.microsoft.com/office/drawing/2014/main" id="{D8C7A04B-459A-4991-90D3-94C1595DBCD5}"/>
+                <a16:creationId xmlns:a16="http://schemas.microsoft.com/office/drawing/2014/main" id="{7691DD94-3309-4E33-8A73-74B7DCB776FD}"/>
               </a:ext>
             </a:extLst>
           </p:cNvPr>
@@ -6201,7 +6338,7 @@
     </p:spTree>
     <p:extLst>
       <p:ext uri="{BB962C8B-B14F-4D97-AF65-F5344CB8AC3E}">
-        <p14:creationId xmlns:p14="http://schemas.microsoft.com/office/powerpoint/2010/main" val="115698480"/>
+        <p14:creationId xmlns:p14="http://schemas.microsoft.com/office/powerpoint/2010/main" val="2044048616"/>
       </p:ext>
     </p:extLst>
   </p:cSld>
@@ -6232,7 +6369,7 @@
           <p:cNvPr id="5" name="">
             <a:extLst xmlns:a="http://schemas.openxmlformats.org/drawingml/2006/main">
               <a:ext uri="{FF2B5EF4-FFF2-40B4-BE49-F238E27FC236}">
-                <a16:creationId xmlns:a16="http://schemas.microsoft.com/office/drawing/2014/main" id="{43725856-7D84-48E6-8B39-21EE86D88B8A}"/>
+                <a16:creationId xmlns:a16="http://schemas.microsoft.com/office/drawing/2014/main" id="{BEF5352D-7BC2-47D7-B52A-7190F2D6B660}"/>
               </a:ext>
             </a:extLst>
           </p:cNvPr>
@@ -6682,7 +6819,7 @@
           <p:cNvPr id="3" name="">
             <a:extLst xmlns:a="http://schemas.openxmlformats.org/drawingml/2006/main">
               <a:ext uri="{FF2B5EF4-FFF2-40B4-BE49-F238E27FC236}">
-                <a16:creationId xmlns:a16="http://schemas.microsoft.com/office/drawing/2014/main" id="{0578110E-1D26-4133-953B-95D835A3F288}"/>
+                <a16:creationId xmlns:a16="http://schemas.microsoft.com/office/drawing/2014/main" id="{7A5B1322-EED7-4812-8BCC-D7D0747C8F17}"/>
               </a:ext>
             </a:extLst>
           </p:cNvPr>
@@ -6739,7 +6876,7 @@
           <p:cNvPr id="4" name="">
             <a:extLst xmlns:a="http://schemas.openxmlformats.org/drawingml/2006/main">
               <a:ext uri="{FF2B5EF4-FFF2-40B4-BE49-F238E27FC236}">
-                <a16:creationId xmlns:a16="http://schemas.microsoft.com/office/drawing/2014/main" id="{7C461DFC-C393-4280-83EE-8C59C6DCF3C1}"/>
+                <a16:creationId xmlns:a16="http://schemas.microsoft.com/office/drawing/2014/main" id="{05994885-E739-47A6-BAD9-3BF5486BE5EE}"/>
               </a:ext>
             </a:extLst>
           </p:cNvPr>
@@ -6794,7 +6931,7 @@
     </p:spTree>
     <p:extLst>
       <p:ext uri="{BB962C8B-B14F-4D97-AF65-F5344CB8AC3E}">
-        <p14:creationId xmlns:p14="http://schemas.microsoft.com/office/powerpoint/2010/main" val="849614235"/>
+        <p14:creationId xmlns:p14="http://schemas.microsoft.com/office/powerpoint/2010/main" val="1370585606"/>
       </p:ext>
     </p:extLst>
   </p:cSld>
@@ -6825,7 +6962,7 @@
           <p:cNvPr id="13" name="">
             <a:extLst xmlns:a="http://schemas.openxmlformats.org/drawingml/2006/main">
               <a:ext uri="{FF2B5EF4-FFF2-40B4-BE49-F238E27FC236}">
-                <a16:creationId xmlns:a16="http://schemas.microsoft.com/office/drawing/2014/main" id="{8C709DDD-2984-4051-9F3E-FE3D88FCEDBD}"/>
+                <a16:creationId xmlns:a16="http://schemas.microsoft.com/office/drawing/2014/main" id="{F1ABBB92-6F14-4F34-B67F-E15DE3DD3EEB}"/>
               </a:ext>
             </a:extLst>
           </p:cNvPr>
@@ -6882,7 +7019,7 @@
           <p:cNvPr id="2" name="">
             <a:extLst xmlns:a="http://schemas.openxmlformats.org/drawingml/2006/main">
               <a:ext uri="{FF2B5EF4-FFF2-40B4-BE49-F238E27FC236}">
-                <a16:creationId xmlns:a16="http://schemas.microsoft.com/office/drawing/2014/main" id="{CD1F340B-09FE-430C-A227-78F5E3F3AD2D}"/>
+                <a16:creationId xmlns:a16="http://schemas.microsoft.com/office/drawing/2014/main" id="{BFA28507-F2CD-4603-B05B-C669FD14F332}"/>
               </a:ext>
             </a:extLst>
           </p:cNvPr>
@@ -6939,7 +7076,7 @@
           <p:cNvPr id="3" name="">
             <a:extLst xmlns:a="http://schemas.openxmlformats.org/drawingml/2006/main">
               <a:ext uri="{FF2B5EF4-FFF2-40B4-BE49-F238E27FC236}">
-                <a16:creationId xmlns:a16="http://schemas.microsoft.com/office/drawing/2014/main" id="{FE5B5AAF-3E1F-4959-B438-30EAE28CE5B1}"/>
+                <a16:creationId xmlns:a16="http://schemas.microsoft.com/office/drawing/2014/main" id="{3311C0F6-2315-4B65-8104-642814FC3E41}"/>
               </a:ext>
             </a:extLst>
           </p:cNvPr>
@@ -6996,7 +7133,7 @@
           <p:cNvPr id="4" name="">
             <a:extLst xmlns:a="http://schemas.openxmlformats.org/drawingml/2006/main">
               <a:ext uri="{FF2B5EF4-FFF2-40B4-BE49-F238E27FC236}">
-                <a16:creationId xmlns:a16="http://schemas.microsoft.com/office/drawing/2014/main" id="{41AC31F3-F8C2-4835-B246-C420621AB01C}"/>
+                <a16:creationId xmlns:a16="http://schemas.microsoft.com/office/drawing/2014/main" id="{6AF7427C-96E6-42BD-A454-342593120709}"/>
               </a:ext>
             </a:extLst>
           </p:cNvPr>
@@ -7053,7 +7190,7 @@
           <p:cNvPr id="5" name="">
             <a:extLst xmlns:a="http://schemas.openxmlformats.org/drawingml/2006/main">
               <a:ext uri="{FF2B5EF4-FFF2-40B4-BE49-F238E27FC236}">
-                <a16:creationId xmlns:a16="http://schemas.microsoft.com/office/drawing/2014/main" id="{E0E00876-4B43-4C7E-98EF-D1CC8A8392AD}"/>
+                <a16:creationId xmlns:a16="http://schemas.microsoft.com/office/drawing/2014/main" id="{2C3BDEC9-126A-4049-A4D6-AC1919965C3F}"/>
               </a:ext>
             </a:extLst>
           </p:cNvPr>
@@ -7110,7 +7247,7 @@
           <p:cNvPr id="6" name="">
             <a:extLst xmlns:a="http://schemas.openxmlformats.org/drawingml/2006/main">
               <a:ext uri="{FF2B5EF4-FFF2-40B4-BE49-F238E27FC236}">
-                <a16:creationId xmlns:a16="http://schemas.microsoft.com/office/drawing/2014/main" id="{4FD6FB9C-F8B3-4FF9-96FA-2C2BB4390052}"/>
+                <a16:creationId xmlns:a16="http://schemas.microsoft.com/office/drawing/2014/main" id="{B13751B3-644B-4B3F-A808-23E7B25928AE}"/>
               </a:ext>
             </a:extLst>
           </p:cNvPr>
@@ -7167,7 +7304,7 @@
           <p:cNvPr id="7" name="">
             <a:extLst xmlns:a="http://schemas.openxmlformats.org/drawingml/2006/main">
               <a:ext uri="{FF2B5EF4-FFF2-40B4-BE49-F238E27FC236}">
-                <a16:creationId xmlns:a16="http://schemas.microsoft.com/office/drawing/2014/main" id="{EDD7A91E-403D-4A05-BA41-AD54BD9605D2}"/>
+                <a16:creationId xmlns:a16="http://schemas.microsoft.com/office/drawing/2014/main" id="{EDDD3E07-4803-49EE-8F23-CA3BBCF813C7}"/>
               </a:ext>
             </a:extLst>
           </p:cNvPr>
@@ -7224,7 +7361,7 @@
           <p:cNvPr id="8" name="">
             <a:extLst xmlns:a="http://schemas.openxmlformats.org/drawingml/2006/main">
               <a:ext uri="{FF2B5EF4-FFF2-40B4-BE49-F238E27FC236}">
-                <a16:creationId xmlns:a16="http://schemas.microsoft.com/office/drawing/2014/main" id="{BB3E68DC-046C-4C5D-8C2A-FAACE6A1C97F}"/>
+                <a16:creationId xmlns:a16="http://schemas.microsoft.com/office/drawing/2014/main" id="{C9768FE6-972B-43A1-853B-BFCB456E3DF6}"/>
               </a:ext>
             </a:extLst>
           </p:cNvPr>
@@ -7281,7 +7418,7 @@
           <p:cNvPr id="9" name="">
             <a:extLst xmlns:a="http://schemas.openxmlformats.org/drawingml/2006/main">
               <a:ext uri="{FF2B5EF4-FFF2-40B4-BE49-F238E27FC236}">
-                <a16:creationId xmlns:a16="http://schemas.microsoft.com/office/drawing/2014/main" id="{CDAD74EC-C774-4944-A72D-AAEE4FC0249B}"/>
+                <a16:creationId xmlns:a16="http://schemas.microsoft.com/office/drawing/2014/main" id="{572B29D0-8020-4DE1-9CB9-DC2A40BB1BE5}"/>
               </a:ext>
             </a:extLst>
           </p:cNvPr>
@@ -7338,7 +7475,7 @@
           <p:cNvPr id="10" name="">
             <a:extLst xmlns:a="http://schemas.openxmlformats.org/drawingml/2006/main">
               <a:ext uri="{FF2B5EF4-FFF2-40B4-BE49-F238E27FC236}">
-                <a16:creationId xmlns:a16="http://schemas.microsoft.com/office/drawing/2014/main" id="{582E560B-386D-422C-8D59-2AB608CFCD52}"/>
+                <a16:creationId xmlns:a16="http://schemas.microsoft.com/office/drawing/2014/main" id="{3707D953-0308-475D-8A94-3A9F78C5D33E}"/>
               </a:ext>
             </a:extLst>
           </p:cNvPr>
@@ -7395,7 +7532,7 @@
           <p:cNvPr id="11" name="">
             <a:extLst xmlns:a="http://schemas.openxmlformats.org/drawingml/2006/main">
               <a:ext uri="{FF2B5EF4-FFF2-40B4-BE49-F238E27FC236}">
-                <a16:creationId xmlns:a16="http://schemas.microsoft.com/office/drawing/2014/main" id="{40AFC660-75E5-48C7-A779-3E3F40372C7D}"/>
+                <a16:creationId xmlns:a16="http://schemas.microsoft.com/office/drawing/2014/main" id="{EC1E8A4D-322E-491D-8580-95BF09677A36}"/>
               </a:ext>
             </a:extLst>
           </p:cNvPr>
@@ -7452,7 +7589,7 @@
           <p:cNvPr id="12" name="">
             <a:extLst xmlns:a="http://schemas.openxmlformats.org/drawingml/2006/main">
               <a:ext uri="{FF2B5EF4-FFF2-40B4-BE49-F238E27FC236}">
-                <a16:creationId xmlns:a16="http://schemas.microsoft.com/office/drawing/2014/main" id="{391847B4-6F03-4822-BA3B-2688BC2E3DA5}"/>
+                <a16:creationId xmlns:a16="http://schemas.microsoft.com/office/drawing/2014/main" id="{3CF4F008-FA76-4C60-A252-21B409ECA1C0}"/>
               </a:ext>
             </a:extLst>
           </p:cNvPr>
@@ -7507,7 +7644,7 @@
     </p:spTree>
     <p:extLst>
       <p:ext uri="{BB962C8B-B14F-4D97-AF65-F5344CB8AC3E}">
-        <p14:creationId xmlns:p14="http://schemas.microsoft.com/office/powerpoint/2010/main" val="2136777365"/>
+        <p14:creationId xmlns:p14="http://schemas.microsoft.com/office/powerpoint/2010/main" val="170078020"/>
       </p:ext>
     </p:extLst>
   </p:cSld>
@@ -7538,7 +7675,7 @@
           <p:cNvPr id="14" name="">
             <a:extLst xmlns:a="http://schemas.openxmlformats.org/drawingml/2006/main">
               <a:ext uri="{FF2B5EF4-FFF2-40B4-BE49-F238E27FC236}">
-                <a16:creationId xmlns:a16="http://schemas.microsoft.com/office/drawing/2014/main" id="{0EA624FC-5A3A-43AD-973D-5E137F448A77}"/>
+                <a16:creationId xmlns:a16="http://schemas.microsoft.com/office/drawing/2014/main" id="{B3BE240C-951A-476C-99C3-F40BF27F764D}"/>
               </a:ext>
             </a:extLst>
           </p:cNvPr>
@@ -7595,7 +7732,7 @@
           <p:cNvPr id="2" name="">
             <a:extLst xmlns:a="http://schemas.openxmlformats.org/drawingml/2006/main">
               <a:ext uri="{FF2B5EF4-FFF2-40B4-BE49-F238E27FC236}">
-                <a16:creationId xmlns:a16="http://schemas.microsoft.com/office/drawing/2014/main" id="{B0A6C2D2-0021-4193-8FF3-27480A213DDE}"/>
+                <a16:creationId xmlns:a16="http://schemas.microsoft.com/office/drawing/2014/main" id="{91DB3DC1-35DA-4F67-8FA6-113CD240164D}"/>
               </a:ext>
             </a:extLst>
           </p:cNvPr>
@@ -7652,7 +7789,7 @@
           <p:cNvPr id="3" name="">
             <a:extLst xmlns:a="http://schemas.openxmlformats.org/drawingml/2006/main">
               <a:ext uri="{FF2B5EF4-FFF2-40B4-BE49-F238E27FC236}">
-                <a16:creationId xmlns:a16="http://schemas.microsoft.com/office/drawing/2014/main" id="{DEBCCA90-D068-49A8-B8A8-21D9A1EEAC7E}"/>
+                <a16:creationId xmlns:a16="http://schemas.microsoft.com/office/drawing/2014/main" id="{B830685C-8486-47F6-814B-75A59AC144C4}"/>
               </a:ext>
             </a:extLst>
           </p:cNvPr>
@@ -7709,7 +7846,7 @@
           <p:cNvPr id="4" name="">
             <a:extLst xmlns:a="http://schemas.openxmlformats.org/drawingml/2006/main">
               <a:ext uri="{FF2B5EF4-FFF2-40B4-BE49-F238E27FC236}">
-                <a16:creationId xmlns:a16="http://schemas.microsoft.com/office/drawing/2014/main" id="{A3524B7D-CE24-43C1-BEF0-4CC0DB806DC1}"/>
+                <a16:creationId xmlns:a16="http://schemas.microsoft.com/office/drawing/2014/main" id="{630377CB-1BA4-4369-A8A9-C99D3114AEDB}"/>
               </a:ext>
             </a:extLst>
           </p:cNvPr>
@@ -7766,7 +7903,7 @@
           <p:cNvPr id="5" name="">
             <a:extLst xmlns:a="http://schemas.openxmlformats.org/drawingml/2006/main">
               <a:ext uri="{FF2B5EF4-FFF2-40B4-BE49-F238E27FC236}">
-                <a16:creationId xmlns:a16="http://schemas.microsoft.com/office/drawing/2014/main" id="{2CD1A1D6-FA8B-476A-BC25-4EA78352A0CA}"/>
+                <a16:creationId xmlns:a16="http://schemas.microsoft.com/office/drawing/2014/main" id="{9BF71CEF-A5CA-4BE4-8EB3-2A5CB5FC122B}"/>
               </a:ext>
             </a:extLst>
           </p:cNvPr>
@@ -7823,7 +7960,7 @@
           <p:cNvPr id="6" name="">
             <a:extLst xmlns:a="http://schemas.openxmlformats.org/drawingml/2006/main">
               <a:ext uri="{FF2B5EF4-FFF2-40B4-BE49-F238E27FC236}">
-                <a16:creationId xmlns:a16="http://schemas.microsoft.com/office/drawing/2014/main" id="{DEF35B2B-E0D1-4C83-8A39-B9216353A5E9}"/>
+                <a16:creationId xmlns:a16="http://schemas.microsoft.com/office/drawing/2014/main" id="{326EFBF8-C0A7-4C1B-9871-89A4CBA73D57}"/>
               </a:ext>
             </a:extLst>
           </p:cNvPr>
@@ -7880,7 +8017,7 @@
           <p:cNvPr id="7" name="">
             <a:extLst xmlns:a="http://schemas.openxmlformats.org/drawingml/2006/main">
               <a:ext uri="{FF2B5EF4-FFF2-40B4-BE49-F238E27FC236}">
-                <a16:creationId xmlns:a16="http://schemas.microsoft.com/office/drawing/2014/main" id="{DC677392-0033-4CA1-89AA-5E301F0AFAF7}"/>
+                <a16:creationId xmlns:a16="http://schemas.microsoft.com/office/drawing/2014/main" id="{3C86EA36-CBBD-44DF-8FF9-704CC8C40E09}"/>
               </a:ext>
             </a:extLst>
           </p:cNvPr>
@@ -7937,7 +8074,7 @@
           <p:cNvPr id="8" name="">
             <a:extLst xmlns:a="http://schemas.openxmlformats.org/drawingml/2006/main">
               <a:ext uri="{FF2B5EF4-FFF2-40B4-BE49-F238E27FC236}">
-                <a16:creationId xmlns:a16="http://schemas.microsoft.com/office/drawing/2014/main" id="{F3876D11-52D5-46AB-8D45-E2E6DDADE2E6}"/>
+                <a16:creationId xmlns:a16="http://schemas.microsoft.com/office/drawing/2014/main" id="{DAE96E15-170F-49CA-A030-B78C3F218330}"/>
               </a:ext>
             </a:extLst>
           </p:cNvPr>
@@ -7994,7 +8131,7 @@
           <p:cNvPr id="9" name="">
             <a:extLst xmlns:a="http://schemas.openxmlformats.org/drawingml/2006/main">
               <a:ext uri="{FF2B5EF4-FFF2-40B4-BE49-F238E27FC236}">
-                <a16:creationId xmlns:a16="http://schemas.microsoft.com/office/drawing/2014/main" id="{B97290D4-FDA5-477E-AEE4-F2C334C7F067}"/>
+                <a16:creationId xmlns:a16="http://schemas.microsoft.com/office/drawing/2014/main" id="{51D20C19-2425-4D3B-8FC2-094517AAC6E4}"/>
               </a:ext>
             </a:extLst>
           </p:cNvPr>
@@ -8051,7 +8188,7 @@
           <p:cNvPr id="10" name="">
             <a:extLst xmlns:a="http://schemas.openxmlformats.org/drawingml/2006/main">
               <a:ext uri="{FF2B5EF4-FFF2-40B4-BE49-F238E27FC236}">
-                <a16:creationId xmlns:a16="http://schemas.microsoft.com/office/drawing/2014/main" id="{DE192DEF-7BC4-4DDF-A3D4-764A21DE7882}"/>
+                <a16:creationId xmlns:a16="http://schemas.microsoft.com/office/drawing/2014/main" id="{38E617D7-01A1-4409-86D6-4C6752AA0954}"/>
               </a:ext>
             </a:extLst>
           </p:cNvPr>
@@ -8108,7 +8245,7 @@
           <p:cNvPr id="11" name="">
             <a:extLst xmlns:a="http://schemas.openxmlformats.org/drawingml/2006/main">
               <a:ext uri="{FF2B5EF4-FFF2-40B4-BE49-F238E27FC236}">
-                <a16:creationId xmlns:a16="http://schemas.microsoft.com/office/drawing/2014/main" id="{491EC6F5-6DEA-413F-B22B-F64A1687F9CA}"/>
+                <a16:creationId xmlns:a16="http://schemas.microsoft.com/office/drawing/2014/main" id="{81C90AA7-77C1-46BB-96F0-E258C9E02C33}"/>
               </a:ext>
             </a:extLst>
           </p:cNvPr>
@@ -8165,7 +8302,7 @@
           <p:cNvPr id="12" name="">
             <a:extLst xmlns:a="http://schemas.openxmlformats.org/drawingml/2006/main">
               <a:ext uri="{FF2B5EF4-FFF2-40B4-BE49-F238E27FC236}">
-                <a16:creationId xmlns:a16="http://schemas.microsoft.com/office/drawing/2014/main" id="{78F843C3-8888-4CD8-B997-437010478B67}"/>
+                <a16:creationId xmlns:a16="http://schemas.microsoft.com/office/drawing/2014/main" id="{D7FEF235-BBF0-4171-8FE2-71D737097ADF}"/>
               </a:ext>
             </a:extLst>
           </p:cNvPr>
@@ -8222,7 +8359,7 @@
           <p:cNvPr id="13" name="">
             <a:extLst xmlns:a="http://schemas.openxmlformats.org/drawingml/2006/main">
               <a:ext uri="{FF2B5EF4-FFF2-40B4-BE49-F238E27FC236}">
-                <a16:creationId xmlns:a16="http://schemas.microsoft.com/office/drawing/2014/main" id="{8BE74866-9F7E-4F0D-8D5D-AD0A3413E55C}"/>
+                <a16:creationId xmlns:a16="http://schemas.microsoft.com/office/drawing/2014/main" id="{220A047A-D94A-4C55-88AB-F54EA811B8BE}"/>
               </a:ext>
             </a:extLst>
           </p:cNvPr>
@@ -8277,7 +8414,7 @@
     </p:spTree>
     <p:extLst>
       <p:ext uri="{BB962C8B-B14F-4D97-AF65-F5344CB8AC3E}">
-        <p14:creationId xmlns:p14="http://schemas.microsoft.com/office/powerpoint/2010/main" val="1794930296"/>
+        <p14:creationId xmlns:p14="http://schemas.microsoft.com/office/powerpoint/2010/main" val="479440299"/>
       </p:ext>
     </p:extLst>
   </p:cSld>
@@ -8308,7 +8445,7 @@
           <p:cNvPr id="8" name="">
             <a:extLst xmlns:a="http://schemas.openxmlformats.org/drawingml/2006/main">
               <a:ext uri="{FF2B5EF4-FFF2-40B4-BE49-F238E27FC236}">
-                <a16:creationId xmlns:a16="http://schemas.microsoft.com/office/drawing/2014/main" id="{5D87E656-CC30-4A65-9A18-97FE7E92E7C4}"/>
+                <a16:creationId xmlns:a16="http://schemas.microsoft.com/office/drawing/2014/main" id="{AFAEEF6A-2A73-41B8-ABC8-6A41F3FCCA4B}"/>
               </a:ext>
             </a:extLst>
           </p:cNvPr>
@@ -8365,7 +8502,7 @@
           <p:cNvPr id="2" name="">
             <a:extLst xmlns:a="http://schemas.openxmlformats.org/drawingml/2006/main">
               <a:ext uri="{FF2B5EF4-FFF2-40B4-BE49-F238E27FC236}">
-                <a16:creationId xmlns:a16="http://schemas.microsoft.com/office/drawing/2014/main" id="{410190D6-3748-41D5-B901-27FD58B7E525}"/>
+                <a16:creationId xmlns:a16="http://schemas.microsoft.com/office/drawing/2014/main" id="{7C28F2C3-911D-420C-806A-8734904B39E7}"/>
               </a:ext>
             </a:extLst>
           </p:cNvPr>
@@ -8422,7 +8559,7 @@
           <p:cNvPr id="3" name="">
             <a:extLst xmlns:a="http://schemas.openxmlformats.org/drawingml/2006/main">
               <a:ext uri="{FF2B5EF4-FFF2-40B4-BE49-F238E27FC236}">
-                <a16:creationId xmlns:a16="http://schemas.microsoft.com/office/drawing/2014/main" id="{54F719D2-7D46-409F-8461-2FB9CF025683}"/>
+                <a16:creationId xmlns:a16="http://schemas.microsoft.com/office/drawing/2014/main" id="{CC04412F-56A3-4E7E-87D4-E4ABB61F8DF6}"/>
               </a:ext>
             </a:extLst>
           </p:cNvPr>
@@ -8535,7 +8672,7 @@
           <p:cNvPr id="4" name="">
             <a:extLst xmlns:a="http://schemas.openxmlformats.org/drawingml/2006/main">
               <a:ext uri="{FF2B5EF4-FFF2-40B4-BE49-F238E27FC236}">
-                <a16:creationId xmlns:a16="http://schemas.microsoft.com/office/drawing/2014/main" id="{83674FC4-DDE4-48A5-A635-E283B1C3DCEF}"/>
+                <a16:creationId xmlns:a16="http://schemas.microsoft.com/office/drawing/2014/main" id="{F2DD80DD-4ED9-4F94-93F1-2F6079A3F70A}"/>
               </a:ext>
             </a:extLst>
           </p:cNvPr>
@@ -8592,7 +8729,7 @@
           <p:cNvPr id="5" name="">
             <a:extLst xmlns:a="http://schemas.openxmlformats.org/drawingml/2006/main">
               <a:ext uri="{FF2B5EF4-FFF2-40B4-BE49-F238E27FC236}">
-                <a16:creationId xmlns:a16="http://schemas.microsoft.com/office/drawing/2014/main" id="{1E997BA8-E1AE-4C9D-A952-1BC8394B31B6}"/>
+                <a16:creationId xmlns:a16="http://schemas.microsoft.com/office/drawing/2014/main" id="{A68E98F0-E143-46D0-B9FF-0451061FD0F7}"/>
               </a:ext>
             </a:extLst>
           </p:cNvPr>
@@ -8705,7 +8842,7 @@
           <p:cNvPr id="6" name="">
             <a:extLst xmlns:a="http://schemas.openxmlformats.org/drawingml/2006/main">
               <a:ext uri="{FF2B5EF4-FFF2-40B4-BE49-F238E27FC236}">
-                <a16:creationId xmlns:a16="http://schemas.microsoft.com/office/drawing/2014/main" id="{CA284EFF-610A-4AB2-81F1-0E6DE0FDAD67}"/>
+                <a16:creationId xmlns:a16="http://schemas.microsoft.com/office/drawing/2014/main" id="{A762CE98-FA2F-4A5A-A0D6-9253100E429B}"/>
               </a:ext>
             </a:extLst>
           </p:cNvPr>
@@ -8762,7 +8899,7 @@
           <p:cNvPr id="7" name="">
             <a:extLst xmlns:a="http://schemas.openxmlformats.org/drawingml/2006/main">
               <a:ext uri="{FF2B5EF4-FFF2-40B4-BE49-F238E27FC236}">
-                <a16:creationId xmlns:a16="http://schemas.microsoft.com/office/drawing/2014/main" id="{9312E6DA-ECC1-41DE-8A4A-4C97289BE08D}"/>
+                <a16:creationId xmlns:a16="http://schemas.microsoft.com/office/drawing/2014/main" id="{318BB09E-360A-477F-971D-D3327A8214EE}"/>
               </a:ext>
             </a:extLst>
           </p:cNvPr>
@@ -8817,7 +8954,7 @@
     </p:spTree>
     <p:extLst>
       <p:ext uri="{BB962C8B-B14F-4D97-AF65-F5344CB8AC3E}">
-        <p14:creationId xmlns:p14="http://schemas.microsoft.com/office/powerpoint/2010/main" val="1383983570"/>
+        <p14:creationId xmlns:p14="http://schemas.microsoft.com/office/powerpoint/2010/main" val="1290052136"/>
       </p:ext>
     </p:extLst>
   </p:cSld>
@@ -8848,7 +8985,7 @@
           <p:cNvPr id="5" name="">
             <a:extLst xmlns:a="http://schemas.openxmlformats.org/drawingml/2006/main">
               <a:ext uri="{FF2B5EF4-FFF2-40B4-BE49-F238E27FC236}">
-                <a16:creationId xmlns:a16="http://schemas.microsoft.com/office/drawing/2014/main" id="{F87A9539-A34E-4167-BE38-295AF0643098}"/>
+                <a16:creationId xmlns:a16="http://schemas.microsoft.com/office/drawing/2014/main" id="{7A4B6D1A-6655-4953-9806-9AFF9090D3FC}"/>
               </a:ext>
             </a:extLst>
           </p:cNvPr>
@@ -8905,7 +9042,7 @@
           <p:cNvPr id="2" name="">
             <a:extLst xmlns:a="http://schemas.openxmlformats.org/drawingml/2006/main">
               <a:ext uri="{FF2B5EF4-FFF2-40B4-BE49-F238E27FC236}">
-                <a16:creationId xmlns:a16="http://schemas.microsoft.com/office/drawing/2014/main" id="{12018163-5C73-4D0B-8BCD-F199226F6867}"/>
+                <a16:creationId xmlns:a16="http://schemas.microsoft.com/office/drawing/2014/main" id="{4E7A8CBF-FA00-4A0D-8ECA-09472D31F25A}"/>
               </a:ext>
             </a:extLst>
           </p:cNvPr>
@@ -8985,7 +9122,7 @@
           <p:cNvPr id="3" name="">
             <a:extLst xmlns:a="http://schemas.openxmlformats.org/drawingml/2006/main">
               <a:ext uri="{FF2B5EF4-FFF2-40B4-BE49-F238E27FC236}">
-                <a16:creationId xmlns:a16="http://schemas.microsoft.com/office/drawing/2014/main" id="{A9B82C6A-61C5-4FA9-822F-2C5833C180E7}"/>
+                <a16:creationId xmlns:a16="http://schemas.microsoft.com/office/drawing/2014/main" id="{F9B5D1F8-F423-4A46-A051-1BD061E5C6CC}"/>
               </a:ext>
             </a:extLst>
           </p:cNvPr>
@@ -9042,7 +9179,7 @@
           <p:cNvPr id="4" name="">
             <a:extLst xmlns:a="http://schemas.openxmlformats.org/drawingml/2006/main">
               <a:ext uri="{FF2B5EF4-FFF2-40B4-BE49-F238E27FC236}">
-                <a16:creationId xmlns:a16="http://schemas.microsoft.com/office/drawing/2014/main" id="{E1C4A67F-7FE6-4E4A-BEFD-80272FF3CA69}"/>
+                <a16:creationId xmlns:a16="http://schemas.microsoft.com/office/drawing/2014/main" id="{E0C62FB3-2DD7-48C6-AEAB-0FF8CD7FCFDD}"/>
               </a:ext>
             </a:extLst>
           </p:cNvPr>
@@ -9097,7 +9234,7 @@
     </p:spTree>
     <p:extLst>
       <p:ext uri="{BB962C8B-B14F-4D97-AF65-F5344CB8AC3E}">
-        <p14:creationId xmlns:p14="http://schemas.microsoft.com/office/powerpoint/2010/main" val="2139175565"/>
+        <p14:creationId xmlns:p14="http://schemas.microsoft.com/office/powerpoint/2010/main" val="2059242068"/>
       </p:ext>
     </p:extLst>
   </p:cSld>
@@ -9128,7 +9265,7 @@
           <p:cNvPr id="8" name="">
             <a:extLst xmlns:a="http://schemas.openxmlformats.org/drawingml/2006/main">
               <a:ext uri="{FF2B5EF4-FFF2-40B4-BE49-F238E27FC236}">
-                <a16:creationId xmlns:a16="http://schemas.microsoft.com/office/drawing/2014/main" id="{F191F2F3-717E-4896-A323-5EC51DC39221}"/>
+                <a16:creationId xmlns:a16="http://schemas.microsoft.com/office/drawing/2014/main" id="{02FD45AC-C894-4642-90ED-F42C62F35F44}"/>
               </a:ext>
             </a:extLst>
           </p:cNvPr>
@@ -9185,7 +9322,7 @@
           <p:cNvPr id="2" name="">
             <a:extLst xmlns:a="http://schemas.openxmlformats.org/drawingml/2006/main">
               <a:ext uri="{FF2B5EF4-FFF2-40B4-BE49-F238E27FC236}">
-                <a16:creationId xmlns:a16="http://schemas.microsoft.com/office/drawing/2014/main" id="{D9BBF7BF-E090-4585-A904-7A02C8E1F039}"/>
+                <a16:creationId xmlns:a16="http://schemas.microsoft.com/office/drawing/2014/main" id="{53E69388-C25B-4A5A-B6F5-C6C5BA3F6A71}"/>
               </a:ext>
             </a:extLst>
           </p:cNvPr>
@@ -9242,7 +9379,7 @@
           <p:cNvPr id="3" name="">
             <a:extLst xmlns:a="http://schemas.openxmlformats.org/drawingml/2006/main">
               <a:ext uri="{FF2B5EF4-FFF2-40B4-BE49-F238E27FC236}">
-                <a16:creationId xmlns:a16="http://schemas.microsoft.com/office/drawing/2014/main" id="{E907A231-79D0-4C71-B7C7-9E1DCAC51251}"/>
+                <a16:creationId xmlns:a16="http://schemas.microsoft.com/office/drawing/2014/main" id="{3587D7C1-3D55-411F-8E0E-AA54CA48F6C5}"/>
               </a:ext>
             </a:extLst>
           </p:cNvPr>
@@ -9368,7 +9505,7 @@
           <p:cNvPr id="4" name="">
             <a:extLst xmlns:a="http://schemas.openxmlformats.org/drawingml/2006/main">
               <a:ext uri="{FF2B5EF4-FFF2-40B4-BE49-F238E27FC236}">
-                <a16:creationId xmlns:a16="http://schemas.microsoft.com/office/drawing/2014/main" id="{95ECBE67-4154-4EE4-91DF-819B955D94E6}"/>
+                <a16:creationId xmlns:a16="http://schemas.microsoft.com/office/drawing/2014/main" id="{EDB0B99C-D79E-47C3-B231-1A6BB963111F}"/>
               </a:ext>
             </a:extLst>
           </p:cNvPr>
@@ -9425,7 +9562,7 @@
           <p:cNvPr id="5" name="">
             <a:extLst xmlns:a="http://schemas.openxmlformats.org/drawingml/2006/main">
               <a:ext uri="{FF2B5EF4-FFF2-40B4-BE49-F238E27FC236}">
-                <a16:creationId xmlns:a16="http://schemas.microsoft.com/office/drawing/2014/main" id="{73AA988C-083A-4BFC-8DB0-4B1A9F5F87A4}"/>
+                <a16:creationId xmlns:a16="http://schemas.microsoft.com/office/drawing/2014/main" id="{85034A45-9719-4E08-8EFD-EA4442AAC7A3}"/>
               </a:ext>
             </a:extLst>
           </p:cNvPr>
@@ -9574,7 +9711,7 @@
           <p:cNvPr id="6" name="">
             <a:extLst xmlns:a="http://schemas.openxmlformats.org/drawingml/2006/main">
               <a:ext uri="{FF2B5EF4-FFF2-40B4-BE49-F238E27FC236}">
-                <a16:creationId xmlns:a16="http://schemas.microsoft.com/office/drawing/2014/main" id="{5FD75B0F-C968-42C7-9A17-BA4417940204}"/>
+                <a16:creationId xmlns:a16="http://schemas.microsoft.com/office/drawing/2014/main" id="{BB1FDF1A-C350-4D23-B678-E171360E6E72}"/>
               </a:ext>
             </a:extLst>
           </p:cNvPr>
@@ -9631,7 +9768,7 @@
           <p:cNvPr id="7" name="">
             <a:extLst xmlns:a="http://schemas.openxmlformats.org/drawingml/2006/main">
               <a:ext uri="{FF2B5EF4-FFF2-40B4-BE49-F238E27FC236}">
-                <a16:creationId xmlns:a16="http://schemas.microsoft.com/office/drawing/2014/main" id="{E2F3D303-D61F-456F-BF68-27613A6130F4}"/>
+                <a16:creationId xmlns:a16="http://schemas.microsoft.com/office/drawing/2014/main" id="{2B7FEDF2-2B87-4E63-8176-49D51EF01B18}"/>
               </a:ext>
             </a:extLst>
           </p:cNvPr>
@@ -9686,7 +9823,7 @@
     </p:spTree>
     <p:extLst>
       <p:ext uri="{BB962C8B-B14F-4D97-AF65-F5344CB8AC3E}">
-        <p14:creationId xmlns:p14="http://schemas.microsoft.com/office/powerpoint/2010/main" val="95443792"/>
+        <p14:creationId xmlns:p14="http://schemas.microsoft.com/office/powerpoint/2010/main" val="1894052492"/>
       </p:ext>
     </p:extLst>
   </p:cSld>
@@ -9717,7 +9854,7 @@
           <p:cNvPr id="8" name="">
             <a:extLst xmlns:a="http://schemas.openxmlformats.org/drawingml/2006/main">
               <a:ext uri="{FF2B5EF4-FFF2-40B4-BE49-F238E27FC236}">
-                <a16:creationId xmlns:a16="http://schemas.microsoft.com/office/drawing/2014/main" id="{A307B69D-D1C3-4BD4-9B0C-F9092DB8706F}"/>
+                <a16:creationId xmlns:a16="http://schemas.microsoft.com/office/drawing/2014/main" id="{49AA7963-6485-44F8-BBE3-BC024814C539}"/>
               </a:ext>
             </a:extLst>
           </p:cNvPr>
@@ -9774,7 +9911,7 @@
           <p:cNvPr id="2" name="">
             <a:extLst xmlns:a="http://schemas.openxmlformats.org/drawingml/2006/main">
               <a:ext uri="{FF2B5EF4-FFF2-40B4-BE49-F238E27FC236}">
-                <a16:creationId xmlns:a16="http://schemas.microsoft.com/office/drawing/2014/main" id="{32BAB402-C966-4547-974B-C19952236BAD}"/>
+                <a16:creationId xmlns:a16="http://schemas.microsoft.com/office/drawing/2014/main" id="{5CE57702-5772-4EE1-84DA-6E2B71A74E64}"/>
               </a:ext>
             </a:extLst>
           </p:cNvPr>
@@ -9831,7 +9968,7 @@
           <p:cNvPr id="3" name="">
             <a:extLst xmlns:a="http://schemas.openxmlformats.org/drawingml/2006/main">
               <a:ext uri="{FF2B5EF4-FFF2-40B4-BE49-F238E27FC236}">
-                <a16:creationId xmlns:a16="http://schemas.microsoft.com/office/drawing/2014/main" id="{1D0B1951-801E-435C-BDAC-6368701CEFE1}"/>
+                <a16:creationId xmlns:a16="http://schemas.microsoft.com/office/drawing/2014/main" id="{FFED4D3F-A254-4DCD-86AE-3230776273E0}"/>
               </a:ext>
             </a:extLst>
           </p:cNvPr>
@@ -9916,7 +10053,7 @@
           <p:cNvPr id="4" name="">
             <a:extLst xmlns:a="http://schemas.openxmlformats.org/drawingml/2006/main">
               <a:ext uri="{FF2B5EF4-FFF2-40B4-BE49-F238E27FC236}">
-                <a16:creationId xmlns:a16="http://schemas.microsoft.com/office/drawing/2014/main" id="{4BBAB1BF-1C22-4041-8782-D8B01CC50294}"/>
+                <a16:creationId xmlns:a16="http://schemas.microsoft.com/office/drawing/2014/main" id="{290401CC-F970-48CC-AF6C-7A970E6B0FF1}"/>
               </a:ext>
             </a:extLst>
           </p:cNvPr>
@@ -9973,7 +10110,7 @@
           <p:cNvPr id="5" name="">
             <a:extLst xmlns:a="http://schemas.openxmlformats.org/drawingml/2006/main">
               <a:ext uri="{FF2B5EF4-FFF2-40B4-BE49-F238E27FC236}">
-                <a16:creationId xmlns:a16="http://schemas.microsoft.com/office/drawing/2014/main" id="{A27A9CA3-C25E-4D4D-845B-D9C28F8FC50D}"/>
+                <a16:creationId xmlns:a16="http://schemas.microsoft.com/office/drawing/2014/main" id="{8349F0F5-3EDA-4AE0-A058-F25BCA019FB2}"/>
               </a:ext>
             </a:extLst>
           </p:cNvPr>
@@ -10109,7 +10246,7 @@
           <p:cNvPr id="6" name="">
             <a:extLst xmlns:a="http://schemas.openxmlformats.org/drawingml/2006/main">
               <a:ext uri="{FF2B5EF4-FFF2-40B4-BE49-F238E27FC236}">
-                <a16:creationId xmlns:a16="http://schemas.microsoft.com/office/drawing/2014/main" id="{978E0665-963D-4881-A2A6-5E75572D0FC1}"/>
+                <a16:creationId xmlns:a16="http://schemas.microsoft.com/office/drawing/2014/main" id="{A8087032-A0B9-4293-AD2D-D49F83A3C20B}"/>
               </a:ext>
             </a:extLst>
           </p:cNvPr>
@@ -10166,7 +10303,7 @@
           <p:cNvPr id="7" name="">
             <a:extLst xmlns:a="http://schemas.openxmlformats.org/drawingml/2006/main">
               <a:ext uri="{FF2B5EF4-FFF2-40B4-BE49-F238E27FC236}">
-                <a16:creationId xmlns:a16="http://schemas.microsoft.com/office/drawing/2014/main" id="{6B4B76CB-81F5-415F-AA2A-217BB37E817B}"/>
+                <a16:creationId xmlns:a16="http://schemas.microsoft.com/office/drawing/2014/main" id="{B772F941-B96F-4DDE-B740-4992B43DC5E7}"/>
               </a:ext>
             </a:extLst>
           </p:cNvPr>
@@ -10221,7 +10358,7 @@
     </p:spTree>
     <p:extLst>
       <p:ext uri="{BB962C8B-B14F-4D97-AF65-F5344CB8AC3E}">
-        <p14:creationId xmlns:p14="http://schemas.microsoft.com/office/powerpoint/2010/main" val="1236311986"/>
+        <p14:creationId xmlns:p14="http://schemas.microsoft.com/office/powerpoint/2010/main" val="557012094"/>
       </p:ext>
     </p:extLst>
   </p:cSld>
@@ -10252,7 +10389,7 @@
           <p:cNvPr id="5" name="">
             <a:extLst xmlns:a="http://schemas.openxmlformats.org/drawingml/2006/main">
               <a:ext uri="{FF2B5EF4-FFF2-40B4-BE49-F238E27FC236}">
-                <a16:creationId xmlns:a16="http://schemas.microsoft.com/office/drawing/2014/main" id="{813CA7E2-CD63-435F-BEE3-94FFBC10274B}"/>
+                <a16:creationId xmlns:a16="http://schemas.microsoft.com/office/drawing/2014/main" id="{94CD3C4B-813C-44D1-B484-8CD9E0461520}"/>
               </a:ext>
             </a:extLst>
           </p:cNvPr>
@@ -10702,7 +10839,7 @@
           <p:cNvPr id="3" name="">
             <a:extLst xmlns:a="http://schemas.openxmlformats.org/drawingml/2006/main">
               <a:ext uri="{FF2B5EF4-FFF2-40B4-BE49-F238E27FC236}">
-                <a16:creationId xmlns:a16="http://schemas.microsoft.com/office/drawing/2014/main" id="{B47DA987-23E8-4D9D-9077-31D79D6928A3}"/>
+                <a16:creationId xmlns:a16="http://schemas.microsoft.com/office/drawing/2014/main" id="{2A5E0108-8D5D-4869-BE48-FAECD7001182}"/>
               </a:ext>
             </a:extLst>
           </p:cNvPr>
@@ -10759,7 +10896,7 @@
           <p:cNvPr id="4" name="">
             <a:extLst xmlns:a="http://schemas.openxmlformats.org/drawingml/2006/main">
               <a:ext uri="{FF2B5EF4-FFF2-40B4-BE49-F238E27FC236}">
-                <a16:creationId xmlns:a16="http://schemas.microsoft.com/office/drawing/2014/main" id="{0B3243F3-817D-48F0-9BFE-B81BD882ADA8}"/>
+                <a16:creationId xmlns:a16="http://schemas.microsoft.com/office/drawing/2014/main" id="{2A46CA6F-AAB8-412B-897A-8AF21A063F5B}"/>
               </a:ext>
             </a:extLst>
           </p:cNvPr>
@@ -10814,7 +10951,7 @@
     </p:spTree>
     <p:extLst>
       <p:ext uri="{BB962C8B-B14F-4D97-AF65-F5344CB8AC3E}">
-        <p14:creationId xmlns:p14="http://schemas.microsoft.com/office/powerpoint/2010/main" val="161874407"/>
+        <p14:creationId xmlns:p14="http://schemas.microsoft.com/office/powerpoint/2010/main" val="1169798559"/>
       </p:ext>
     </p:extLst>
   </p:cSld>
@@ -10845,7 +10982,7 @@
           <p:cNvPr id="5" name="">
             <a:extLst xmlns:a="http://schemas.openxmlformats.org/drawingml/2006/main">
               <a:ext uri="{FF2B5EF4-FFF2-40B4-BE49-F238E27FC236}">
-                <a16:creationId xmlns:a16="http://schemas.microsoft.com/office/drawing/2014/main" id="{A0B78A30-FA1F-4C3D-98EB-1A5E9E279279}"/>
+                <a16:creationId xmlns:a16="http://schemas.microsoft.com/office/drawing/2014/main" id="{2077A799-B34F-4264-90C3-D15A8CEA0B74}"/>
               </a:ext>
             </a:extLst>
           </p:cNvPr>
@@ -11295,7 +11432,7 @@
           <p:cNvPr id="3" name="">
             <a:extLst xmlns:a="http://schemas.openxmlformats.org/drawingml/2006/main">
               <a:ext uri="{FF2B5EF4-FFF2-40B4-BE49-F238E27FC236}">
-                <a16:creationId xmlns:a16="http://schemas.microsoft.com/office/drawing/2014/main" id="{11591E09-FDB0-401A-90F7-F8D23C56A1F4}"/>
+                <a16:creationId xmlns:a16="http://schemas.microsoft.com/office/drawing/2014/main" id="{728DB0B1-7BDF-424C-9A81-FDFD610FB3E6}"/>
               </a:ext>
             </a:extLst>
           </p:cNvPr>
@@ -11352,7 +11489,7 @@
           <p:cNvPr id="4" name="">
             <a:extLst xmlns:a="http://schemas.openxmlformats.org/drawingml/2006/main">
               <a:ext uri="{FF2B5EF4-FFF2-40B4-BE49-F238E27FC236}">
-                <a16:creationId xmlns:a16="http://schemas.microsoft.com/office/drawing/2014/main" id="{F4761142-F795-45F3-A0D3-AB9B89C4F78A}"/>
+                <a16:creationId xmlns:a16="http://schemas.microsoft.com/office/drawing/2014/main" id="{C3E8B830-9F01-42D9-AE20-13AAD8189CBA}"/>
               </a:ext>
             </a:extLst>
           </p:cNvPr>
@@ -11407,7 +11544,7 @@
     </p:spTree>
     <p:extLst>
       <p:ext uri="{BB962C8B-B14F-4D97-AF65-F5344CB8AC3E}">
-        <p14:creationId xmlns:p14="http://schemas.microsoft.com/office/powerpoint/2010/main" val="1965191409"/>
+        <p14:creationId xmlns:p14="http://schemas.microsoft.com/office/powerpoint/2010/main" val="1328966132"/>
       </p:ext>
     </p:extLst>
   </p:cSld>
@@ -11438,7 +11575,7 @@
           <p:cNvPr id="14" name="">
             <a:extLst xmlns:a="http://schemas.openxmlformats.org/drawingml/2006/main">
               <a:ext uri="{FF2B5EF4-FFF2-40B4-BE49-F238E27FC236}">
-                <a16:creationId xmlns:a16="http://schemas.microsoft.com/office/drawing/2014/main" id="{3AA91E39-E146-4203-A1C8-4BB2C2148F19}"/>
+                <a16:creationId xmlns:a16="http://schemas.microsoft.com/office/drawing/2014/main" id="{4E2BC6ED-B5C1-47DF-9D23-D0F61D940F80}"/>
               </a:ext>
             </a:extLst>
           </p:cNvPr>
@@ -11495,7 +11632,7 @@
           <p:cNvPr id="2" name="">
             <a:extLst xmlns:a="http://schemas.openxmlformats.org/drawingml/2006/main">
               <a:ext uri="{FF2B5EF4-FFF2-40B4-BE49-F238E27FC236}">
-                <a16:creationId xmlns:a16="http://schemas.microsoft.com/office/drawing/2014/main" id="{8A419485-1F05-41BF-920F-08C343ABAB75}"/>
+                <a16:creationId xmlns:a16="http://schemas.microsoft.com/office/drawing/2014/main" id="{ED3FBC4A-0641-45F8-8F1F-880074E76414}"/>
               </a:ext>
             </a:extLst>
           </p:cNvPr>
@@ -11552,7 +11689,7 @@
           <p:cNvPr id="3" name="">
             <a:extLst xmlns:a="http://schemas.openxmlformats.org/drawingml/2006/main">
               <a:ext uri="{FF2B5EF4-FFF2-40B4-BE49-F238E27FC236}">
-                <a16:creationId xmlns:a16="http://schemas.microsoft.com/office/drawing/2014/main" id="{30DE32C8-17F1-4146-9C96-B3D792B18BC4}"/>
+                <a16:creationId xmlns:a16="http://schemas.microsoft.com/office/drawing/2014/main" id="{4540DF54-5EA4-402A-823D-4917DA6CCBFC}"/>
               </a:ext>
             </a:extLst>
           </p:cNvPr>
@@ -11609,7 +11746,7 @@
           <p:cNvPr id="4" name="">
             <a:extLst xmlns:a="http://schemas.openxmlformats.org/drawingml/2006/main">
               <a:ext uri="{FF2B5EF4-FFF2-40B4-BE49-F238E27FC236}">
-                <a16:creationId xmlns:a16="http://schemas.microsoft.com/office/drawing/2014/main" id="{A1D3FAB0-6626-4739-A3A4-A2B0174D7022}"/>
+                <a16:creationId xmlns:a16="http://schemas.microsoft.com/office/drawing/2014/main" id="{AF87EE93-2C8F-4A58-A8BF-0913320A0238}"/>
               </a:ext>
             </a:extLst>
           </p:cNvPr>
@@ -11666,7 +11803,7 @@
           <p:cNvPr id="5" name="">
             <a:extLst xmlns:a="http://schemas.openxmlformats.org/drawingml/2006/main">
               <a:ext uri="{FF2B5EF4-FFF2-40B4-BE49-F238E27FC236}">
-                <a16:creationId xmlns:a16="http://schemas.microsoft.com/office/drawing/2014/main" id="{F4218F92-3273-43D2-9D64-5D4D4EF368D2}"/>
+                <a16:creationId xmlns:a16="http://schemas.microsoft.com/office/drawing/2014/main" id="{F954B928-0A21-4DD9-8FF7-0DB5F94FFC5E}"/>
               </a:ext>
             </a:extLst>
           </p:cNvPr>
@@ -11723,7 +11860,7 @@
           <p:cNvPr id="6" name="">
             <a:extLst xmlns:a="http://schemas.openxmlformats.org/drawingml/2006/main">
               <a:ext uri="{FF2B5EF4-FFF2-40B4-BE49-F238E27FC236}">
-                <a16:creationId xmlns:a16="http://schemas.microsoft.com/office/drawing/2014/main" id="{DCBD4F86-694A-458B-9ECE-C50224C44816}"/>
+                <a16:creationId xmlns:a16="http://schemas.microsoft.com/office/drawing/2014/main" id="{64F00471-FF89-4F33-9F56-B36B0C952A83}"/>
               </a:ext>
             </a:extLst>
           </p:cNvPr>
@@ -11780,7 +11917,7 @@
           <p:cNvPr id="7" name="">
             <a:extLst xmlns:a="http://schemas.openxmlformats.org/drawingml/2006/main">
               <a:ext uri="{FF2B5EF4-FFF2-40B4-BE49-F238E27FC236}">
-                <a16:creationId xmlns:a16="http://schemas.microsoft.com/office/drawing/2014/main" id="{363395CF-1540-4C9C-99DB-1153C035B8BA}"/>
+                <a16:creationId xmlns:a16="http://schemas.microsoft.com/office/drawing/2014/main" id="{2F92D06D-58DB-4852-81DF-D4EB6D04ED4E}"/>
               </a:ext>
             </a:extLst>
           </p:cNvPr>
@@ -11837,7 +11974,7 @@
           <p:cNvPr id="8" name="">
             <a:extLst xmlns:a="http://schemas.openxmlformats.org/drawingml/2006/main">
               <a:ext uri="{FF2B5EF4-FFF2-40B4-BE49-F238E27FC236}">
-                <a16:creationId xmlns:a16="http://schemas.microsoft.com/office/drawing/2014/main" id="{7EAD082C-4515-4737-B930-8675BFA0DC89}"/>
+                <a16:creationId xmlns:a16="http://schemas.microsoft.com/office/drawing/2014/main" id="{B9425641-6AAF-4B92-8361-FE7268DF9AF2}"/>
               </a:ext>
             </a:extLst>
           </p:cNvPr>
@@ -11894,7 +12031,7 @@
           <p:cNvPr id="9" name="">
             <a:extLst xmlns:a="http://schemas.openxmlformats.org/drawingml/2006/main">
               <a:ext uri="{FF2B5EF4-FFF2-40B4-BE49-F238E27FC236}">
-                <a16:creationId xmlns:a16="http://schemas.microsoft.com/office/drawing/2014/main" id="{83CAC0DC-9472-4895-8427-1E6B35849CAB}"/>
+                <a16:creationId xmlns:a16="http://schemas.microsoft.com/office/drawing/2014/main" id="{EDF20C90-07CC-47A8-A3CE-FF8525CE1B7E}"/>
               </a:ext>
             </a:extLst>
           </p:cNvPr>
@@ -11951,7 +12088,7 @@
           <p:cNvPr id="10" name="">
             <a:extLst xmlns:a="http://schemas.openxmlformats.org/drawingml/2006/main">
               <a:ext uri="{FF2B5EF4-FFF2-40B4-BE49-F238E27FC236}">
-                <a16:creationId xmlns:a16="http://schemas.microsoft.com/office/drawing/2014/main" id="{D61068A9-AFE8-4656-88EB-F6A03E9A0AFD}"/>
+                <a16:creationId xmlns:a16="http://schemas.microsoft.com/office/drawing/2014/main" id="{CD0BE3A4-E731-4836-ACF2-DEB9E5A52C12}"/>
               </a:ext>
             </a:extLst>
           </p:cNvPr>
@@ -12008,7 +12145,7 @@
           <p:cNvPr id="11" name="">
             <a:extLst xmlns:a="http://schemas.openxmlformats.org/drawingml/2006/main">
               <a:ext uri="{FF2B5EF4-FFF2-40B4-BE49-F238E27FC236}">
-                <a16:creationId xmlns:a16="http://schemas.microsoft.com/office/drawing/2014/main" id="{7649F27F-77FA-45CA-8C98-EDFD7C198DC0}"/>
+                <a16:creationId xmlns:a16="http://schemas.microsoft.com/office/drawing/2014/main" id="{DA93EF89-C8F5-494A-806F-031D8CF1ECBA}"/>
               </a:ext>
             </a:extLst>
           </p:cNvPr>
@@ -12065,7 +12202,7 @@
           <p:cNvPr id="12" name="">
             <a:extLst xmlns:a="http://schemas.openxmlformats.org/drawingml/2006/main">
               <a:ext uri="{FF2B5EF4-FFF2-40B4-BE49-F238E27FC236}">
-                <a16:creationId xmlns:a16="http://schemas.microsoft.com/office/drawing/2014/main" id="{E1EAE5AC-322E-4C61-8DAF-2C959A4A5F08}"/>
+                <a16:creationId xmlns:a16="http://schemas.microsoft.com/office/drawing/2014/main" id="{27A09AFF-D454-4505-91BB-030CA2486976}"/>
               </a:ext>
             </a:extLst>
           </p:cNvPr>
@@ -12122,7 +12259,7 @@
           <p:cNvPr id="13" name="">
             <a:extLst xmlns:a="http://schemas.openxmlformats.org/drawingml/2006/main">
               <a:ext uri="{FF2B5EF4-FFF2-40B4-BE49-F238E27FC236}">
-                <a16:creationId xmlns:a16="http://schemas.microsoft.com/office/drawing/2014/main" id="{80B7D54D-99D7-4825-A2F8-F6EDD7E314F4}"/>
+                <a16:creationId xmlns:a16="http://schemas.microsoft.com/office/drawing/2014/main" id="{6A720029-FC50-4828-A845-A54FE2EAF0F5}"/>
               </a:ext>
             </a:extLst>
           </p:cNvPr>
@@ -12177,7 +12314,7 @@
     </p:spTree>
     <p:extLst>
       <p:ext uri="{BB962C8B-B14F-4D97-AF65-F5344CB8AC3E}">
-        <p14:creationId xmlns:p14="http://schemas.microsoft.com/office/powerpoint/2010/main" val="637207218"/>
+        <p14:creationId xmlns:p14="http://schemas.microsoft.com/office/powerpoint/2010/main" val="2072266721"/>
       </p:ext>
     </p:extLst>
   </p:cSld>
@@ -12208,7 +12345,7 @@
           <p:cNvPr id="8" name="">
             <a:extLst xmlns:a="http://schemas.openxmlformats.org/drawingml/2006/main">
               <a:ext uri="{FF2B5EF4-FFF2-40B4-BE49-F238E27FC236}">
-                <a16:creationId xmlns:a16="http://schemas.microsoft.com/office/drawing/2014/main" id="{B7C47366-B41D-4665-9017-829FC532F8CB}"/>
+                <a16:creationId xmlns:a16="http://schemas.microsoft.com/office/drawing/2014/main" id="{3F6A5009-6522-4922-9DD1-91F467CC5FFF}"/>
               </a:ext>
             </a:extLst>
           </p:cNvPr>
@@ -12265,7 +12402,7 @@
           <p:cNvPr id="2" name="">
             <a:extLst xmlns:a="http://schemas.openxmlformats.org/drawingml/2006/main">
               <a:ext uri="{FF2B5EF4-FFF2-40B4-BE49-F238E27FC236}">
-                <a16:creationId xmlns:a16="http://schemas.microsoft.com/office/drawing/2014/main" id="{E3F4DD6C-3B46-406B-B340-0D046923F995}"/>
+                <a16:creationId xmlns:a16="http://schemas.microsoft.com/office/drawing/2014/main" id="{5A0FE10F-AFFE-415A-B942-61157AE1D65A}"/>
               </a:ext>
             </a:extLst>
           </p:cNvPr>
@@ -12322,7 +12459,7 @@
           <p:cNvPr id="3" name="">
             <a:extLst xmlns:a="http://schemas.openxmlformats.org/drawingml/2006/main">
               <a:ext uri="{FF2B5EF4-FFF2-40B4-BE49-F238E27FC236}">
-                <a16:creationId xmlns:a16="http://schemas.microsoft.com/office/drawing/2014/main" id="{B6030882-E1D0-4EA1-B52A-6655C896FA3B}"/>
+                <a16:creationId xmlns:a16="http://schemas.microsoft.com/office/drawing/2014/main" id="{4E7914F2-42AF-42B4-9501-2ABD695FE8B8}"/>
               </a:ext>
             </a:extLst>
           </p:cNvPr>
@@ -12485,7 +12622,7 @@
           <p:nvPr/>
         </p:nvPicPr>
         <p:blipFill>
-          <a:blip xmlns:r="http://schemas.openxmlformats.org/officeDocument/2006/relationships" xmlns:a="http://schemas.openxmlformats.org/drawingml/2006/main" r:embed="Rcecff0809d7e4a6b"/>
+          <a:blip xmlns:r="http://schemas.openxmlformats.org/officeDocument/2006/relationships" xmlns:a="http://schemas.openxmlformats.org/drawingml/2006/main" r:embed="R7375e9fd16c7428f"/>
           <a:stretch xmlns:a="http://schemas.openxmlformats.org/drawingml/2006/main"/>
         </p:blipFill>
         <p:spPr>
@@ -12503,7 +12640,7 @@
           <p:cNvPr id="5" name="">
             <a:extLst xmlns:a="http://schemas.openxmlformats.org/drawingml/2006/main">
               <a:ext uri="{FF2B5EF4-FFF2-40B4-BE49-F238E27FC236}">
-                <a16:creationId xmlns:a16="http://schemas.microsoft.com/office/drawing/2014/main" id="{BFF2690C-9662-496A-938D-7A34B511584A}"/>
+                <a16:creationId xmlns:a16="http://schemas.microsoft.com/office/drawing/2014/main" id="{372CA88F-3706-4807-8C8E-1972084BE018}"/>
               </a:ext>
             </a:extLst>
           </p:cNvPr>
@@ -12583,7 +12720,7 @@
           <p:cNvPr id="6" name="">
             <a:extLst xmlns:a="http://schemas.openxmlformats.org/drawingml/2006/main">
               <a:ext uri="{FF2B5EF4-FFF2-40B4-BE49-F238E27FC236}">
-                <a16:creationId xmlns:a16="http://schemas.microsoft.com/office/drawing/2014/main" id="{CA32A5C3-3F49-49C2-8625-F1808E70C48F}"/>
+                <a16:creationId xmlns:a16="http://schemas.microsoft.com/office/drawing/2014/main" id="{3D6B616A-99D6-462F-99A1-43A487C95CCC}"/>
               </a:ext>
             </a:extLst>
           </p:cNvPr>
@@ -12640,7 +12777,7 @@
           <p:cNvPr id="7" name="">
             <a:extLst xmlns:a="http://schemas.openxmlformats.org/drawingml/2006/main">
               <a:ext uri="{FF2B5EF4-FFF2-40B4-BE49-F238E27FC236}">
-                <a16:creationId xmlns:a16="http://schemas.microsoft.com/office/drawing/2014/main" id="{C2B58F41-E4D7-4F40-9860-0FC0E4088D9C}"/>
+                <a16:creationId xmlns:a16="http://schemas.microsoft.com/office/drawing/2014/main" id="{A2713E4B-8A3B-4EEB-8027-551191BF66A0}"/>
               </a:ext>
             </a:extLst>
           </p:cNvPr>
@@ -12695,7 +12832,7 @@
     </p:spTree>
     <p:extLst>
       <p:ext uri="{BB962C8B-B14F-4D97-AF65-F5344CB8AC3E}">
-        <p14:creationId xmlns:p14="http://schemas.microsoft.com/office/powerpoint/2010/main" val="913679395"/>
+        <p14:creationId xmlns:p14="http://schemas.microsoft.com/office/powerpoint/2010/main" val="358101444"/>
       </p:ext>
     </p:extLst>
   </p:cSld>
@@ -12726,7 +12863,7 @@
           <p:cNvPr id="5" name="">
             <a:extLst xmlns:a="http://schemas.openxmlformats.org/drawingml/2006/main">
               <a:ext uri="{FF2B5EF4-FFF2-40B4-BE49-F238E27FC236}">
-                <a16:creationId xmlns:a16="http://schemas.microsoft.com/office/drawing/2014/main" id="{9C2B9321-BDC0-424A-9CF1-774C823BE97E}"/>
+                <a16:creationId xmlns:a16="http://schemas.microsoft.com/office/drawing/2014/main" id="{0E58C380-3205-499C-9DF2-9165A1E1B1D0}"/>
               </a:ext>
             </a:extLst>
           </p:cNvPr>
@@ -13176,7 +13313,7 @@
           <p:cNvPr id="3" name="">
             <a:extLst xmlns:a="http://schemas.openxmlformats.org/drawingml/2006/main">
               <a:ext uri="{FF2B5EF4-FFF2-40B4-BE49-F238E27FC236}">
-                <a16:creationId xmlns:a16="http://schemas.microsoft.com/office/drawing/2014/main" id="{DC28E9C9-D944-4E73-9C47-B7B9DAD092DF}"/>
+                <a16:creationId xmlns:a16="http://schemas.microsoft.com/office/drawing/2014/main" id="{059A7D5C-EC95-41E0-8BF7-92B9F65FA9EE}"/>
               </a:ext>
             </a:extLst>
           </p:cNvPr>
@@ -13233,7 +13370,7 @@
           <p:cNvPr id="4" name="">
             <a:extLst xmlns:a="http://schemas.openxmlformats.org/drawingml/2006/main">
               <a:ext uri="{FF2B5EF4-FFF2-40B4-BE49-F238E27FC236}">
-                <a16:creationId xmlns:a16="http://schemas.microsoft.com/office/drawing/2014/main" id="{A8507B05-61CA-4B7C-B137-EA0461664F0E}"/>
+                <a16:creationId xmlns:a16="http://schemas.microsoft.com/office/drawing/2014/main" id="{309C4385-E7BB-4AA4-A9D3-A45994A57289}"/>
               </a:ext>
             </a:extLst>
           </p:cNvPr>
@@ -13288,7 +13425,7 @@
     </p:spTree>
     <p:extLst>
       <p:ext uri="{BB962C8B-B14F-4D97-AF65-F5344CB8AC3E}">
-        <p14:creationId xmlns:p14="http://schemas.microsoft.com/office/powerpoint/2010/main" val="618546357"/>
+        <p14:creationId xmlns:p14="http://schemas.microsoft.com/office/powerpoint/2010/main" val="1534942941"/>
       </p:ext>
     </p:extLst>
   </p:cSld>
@@ -13319,7 +13456,7 @@
           <p:cNvPr id="8" name="">
             <a:extLst xmlns:a="http://schemas.openxmlformats.org/drawingml/2006/main">
               <a:ext uri="{FF2B5EF4-FFF2-40B4-BE49-F238E27FC236}">
-                <a16:creationId xmlns:a16="http://schemas.microsoft.com/office/drawing/2014/main" id="{7C98969B-1839-469F-B9D5-2FFEECA83C4D}"/>
+                <a16:creationId xmlns:a16="http://schemas.microsoft.com/office/drawing/2014/main" id="{7EFED915-76A6-4062-8213-EA1C368C92F9}"/>
               </a:ext>
             </a:extLst>
           </p:cNvPr>
@@ -13376,7 +13513,7 @@
           <p:cNvPr id="2" name="">
             <a:extLst xmlns:a="http://schemas.openxmlformats.org/drawingml/2006/main">
               <a:ext uri="{FF2B5EF4-FFF2-40B4-BE49-F238E27FC236}">
-                <a16:creationId xmlns:a16="http://schemas.microsoft.com/office/drawing/2014/main" id="{18814C2C-1B6C-4CCD-8010-37C849B95DA9}"/>
+                <a16:creationId xmlns:a16="http://schemas.microsoft.com/office/drawing/2014/main" id="{5DE24D21-A896-4BA4-B968-6E28DE58C339}"/>
               </a:ext>
             </a:extLst>
           </p:cNvPr>
@@ -13433,7 +13570,7 @@
           <p:cNvPr id="3" name="">
             <a:extLst xmlns:a="http://schemas.openxmlformats.org/drawingml/2006/main">
               <a:ext uri="{FF2B5EF4-FFF2-40B4-BE49-F238E27FC236}">
-                <a16:creationId xmlns:a16="http://schemas.microsoft.com/office/drawing/2014/main" id="{421C9BFE-0AC7-455C-A0CC-2363C9F8C2F2}"/>
+                <a16:creationId xmlns:a16="http://schemas.microsoft.com/office/drawing/2014/main" id="{0A72BD13-B186-4CFB-B0AF-1DC28762B87F}"/>
               </a:ext>
             </a:extLst>
           </p:cNvPr>
@@ -13541,7 +13678,7 @@
           <p:cNvPr id="4" name="">
             <a:extLst xmlns:a="http://schemas.openxmlformats.org/drawingml/2006/main">
               <a:ext uri="{FF2B5EF4-FFF2-40B4-BE49-F238E27FC236}">
-                <a16:creationId xmlns:a16="http://schemas.microsoft.com/office/drawing/2014/main" id="{A67BEF96-9603-4841-BC3B-3F33A8922142}"/>
+                <a16:creationId xmlns:a16="http://schemas.microsoft.com/office/drawing/2014/main" id="{2AEB82ED-F5BE-433B-BA92-1B38640FF21D}"/>
               </a:ext>
             </a:extLst>
           </p:cNvPr>
@@ -13598,7 +13735,7 @@
           <p:cNvPr id="5" name="">
             <a:extLst xmlns:a="http://schemas.openxmlformats.org/drawingml/2006/main">
               <a:ext uri="{FF2B5EF4-FFF2-40B4-BE49-F238E27FC236}">
-                <a16:creationId xmlns:a16="http://schemas.microsoft.com/office/drawing/2014/main" id="{EB8A9FE6-F103-43D9-86AD-EC51D03D3EB5}"/>
+                <a16:creationId xmlns:a16="http://schemas.microsoft.com/office/drawing/2014/main" id="{B043D3DA-4203-4B07-A331-8579AF8084EF}"/>
               </a:ext>
             </a:extLst>
           </p:cNvPr>
@@ -13724,7 +13861,7 @@
           <p:cNvPr id="6" name="">
             <a:extLst xmlns:a="http://schemas.openxmlformats.org/drawingml/2006/main">
               <a:ext uri="{FF2B5EF4-FFF2-40B4-BE49-F238E27FC236}">
-                <a16:creationId xmlns:a16="http://schemas.microsoft.com/office/drawing/2014/main" id="{DD9AA2A3-D04E-4B86-A3A9-469837CE2C3F}"/>
+                <a16:creationId xmlns:a16="http://schemas.microsoft.com/office/drawing/2014/main" id="{77C0395F-B3EA-4936-BC13-0AA102DD9AF4}"/>
               </a:ext>
             </a:extLst>
           </p:cNvPr>
@@ -13781,7 +13918,7 @@
           <p:cNvPr id="7" name="">
             <a:extLst xmlns:a="http://schemas.openxmlformats.org/drawingml/2006/main">
               <a:ext uri="{FF2B5EF4-FFF2-40B4-BE49-F238E27FC236}">
-                <a16:creationId xmlns:a16="http://schemas.microsoft.com/office/drawing/2014/main" id="{445AC841-ED3C-471F-A0E5-C5CCD5376A5D}"/>
+                <a16:creationId xmlns:a16="http://schemas.microsoft.com/office/drawing/2014/main" id="{6688806A-68EC-4F4C-A90A-172B13B91B5F}"/>
               </a:ext>
             </a:extLst>
           </p:cNvPr>
@@ -13836,7 +13973,7 @@
     </p:spTree>
     <p:extLst>
       <p:ext uri="{BB962C8B-B14F-4D97-AF65-F5344CB8AC3E}">
-        <p14:creationId xmlns:p14="http://schemas.microsoft.com/office/powerpoint/2010/main" val="1146325165"/>
+        <p14:creationId xmlns:p14="http://schemas.microsoft.com/office/powerpoint/2010/main" val="310169528"/>
       </p:ext>
     </p:extLst>
   </p:cSld>
@@ -13867,7 +14004,7 @@
           <p:cNvPr id="7" name="">
             <a:extLst xmlns:a="http://schemas.openxmlformats.org/drawingml/2006/main">
               <a:ext uri="{FF2B5EF4-FFF2-40B4-BE49-F238E27FC236}">
-                <a16:creationId xmlns:a16="http://schemas.microsoft.com/office/drawing/2014/main" id="{17F1DD03-BB67-4FC3-8FD1-46A93A1971D1}"/>
+                <a16:creationId xmlns:a16="http://schemas.microsoft.com/office/drawing/2014/main" id="{7C74A20A-36A8-448E-9380-62135367E130}"/>
               </a:ext>
             </a:extLst>
           </p:cNvPr>
@@ -13924,7 +14061,7 @@
           <p:cNvPr id="2" name="">
             <a:extLst xmlns:a="http://schemas.openxmlformats.org/drawingml/2006/main">
               <a:ext uri="{FF2B5EF4-FFF2-40B4-BE49-F238E27FC236}">
-                <a16:creationId xmlns:a16="http://schemas.microsoft.com/office/drawing/2014/main" id="{19C806FF-40BB-4104-8BA6-CDAE2B7AEB68}"/>
+                <a16:creationId xmlns:a16="http://schemas.microsoft.com/office/drawing/2014/main" id="{D4FAEAA0-0900-4A16-B11A-5AE1188A315D}"/>
               </a:ext>
             </a:extLst>
           </p:cNvPr>
@@ -14147,7 +14284,7 @@
           <p:cNvPr id="3" name="">
             <a:extLst xmlns:a="http://schemas.openxmlformats.org/drawingml/2006/main">
               <a:ext uri="{FF2B5EF4-FFF2-40B4-BE49-F238E27FC236}">
-                <a16:creationId xmlns:a16="http://schemas.microsoft.com/office/drawing/2014/main" id="{67BC765B-73F0-4A6E-B471-7B73AD5BCC5C}"/>
+                <a16:creationId xmlns:a16="http://schemas.microsoft.com/office/drawing/2014/main" id="{CA712BA2-1A61-445C-B2B4-C12D5645DFF7}"/>
               </a:ext>
             </a:extLst>
           </p:cNvPr>
@@ -14204,7 +14341,7 @@
           <p:cNvPr id="4" name="">
             <a:extLst xmlns:a="http://schemas.openxmlformats.org/drawingml/2006/main">
               <a:ext uri="{FF2B5EF4-FFF2-40B4-BE49-F238E27FC236}">
-                <a16:creationId xmlns:a16="http://schemas.microsoft.com/office/drawing/2014/main" id="{0E0DA199-C5BD-4A93-AFB0-CD5A71B0C7A1}"/>
+                <a16:creationId xmlns:a16="http://schemas.microsoft.com/office/drawing/2014/main" id="{5AA46B24-48BB-4799-8422-2F0F8C87A1F7}"/>
               </a:ext>
             </a:extLst>
           </p:cNvPr>
@@ -14353,7 +14490,7 @@
           <p:cNvPr id="5" name="">
             <a:extLst xmlns:a="http://schemas.openxmlformats.org/drawingml/2006/main">
               <a:ext uri="{FF2B5EF4-FFF2-40B4-BE49-F238E27FC236}">
-                <a16:creationId xmlns:a16="http://schemas.microsoft.com/office/drawing/2014/main" id="{1B57AB79-6221-4DCE-9911-B43EAD143AF3}"/>
+                <a16:creationId xmlns:a16="http://schemas.microsoft.com/office/drawing/2014/main" id="{1A202B39-5F33-4F76-B9DC-4528D4050180}"/>
               </a:ext>
             </a:extLst>
           </p:cNvPr>
@@ -14410,7 +14547,7 @@
           <p:cNvPr id="6" name="">
             <a:extLst xmlns:a="http://schemas.openxmlformats.org/drawingml/2006/main">
               <a:ext uri="{FF2B5EF4-FFF2-40B4-BE49-F238E27FC236}">
-                <a16:creationId xmlns:a16="http://schemas.microsoft.com/office/drawing/2014/main" id="{686829ED-9A0D-405B-A772-A020AF3F9E20}"/>
+                <a16:creationId xmlns:a16="http://schemas.microsoft.com/office/drawing/2014/main" id="{DD37AE62-8A69-419C-9AEB-B70E83452924}"/>
               </a:ext>
             </a:extLst>
           </p:cNvPr>
@@ -14465,7 +14602,7 @@
     </p:spTree>
     <p:extLst>
       <p:ext uri="{BB962C8B-B14F-4D97-AF65-F5344CB8AC3E}">
-        <p14:creationId xmlns:p14="http://schemas.microsoft.com/office/powerpoint/2010/main" val="526753791"/>
+        <p14:creationId xmlns:p14="http://schemas.microsoft.com/office/powerpoint/2010/main" val="1640993360"/>
       </p:ext>
     </p:extLst>
   </p:cSld>
@@ -14496,7 +14633,7 @@
           <p:cNvPr id="9" name="">
             <a:extLst xmlns:a="http://schemas.openxmlformats.org/drawingml/2006/main">
               <a:ext uri="{FF2B5EF4-FFF2-40B4-BE49-F238E27FC236}">
-                <a16:creationId xmlns:a16="http://schemas.microsoft.com/office/drawing/2014/main" id="{11DC3A5F-2487-4357-9D0B-D915B1300C26}"/>
+                <a16:creationId xmlns:a16="http://schemas.microsoft.com/office/drawing/2014/main" id="{9B7AFB59-4314-45D9-BE53-24041F57BE7D}"/>
               </a:ext>
             </a:extLst>
           </p:cNvPr>
@@ -14553,7 +14690,7 @@
           <p:cNvPr id="2" name="">
             <a:extLst xmlns:a="http://schemas.openxmlformats.org/drawingml/2006/main">
               <a:ext uri="{FF2B5EF4-FFF2-40B4-BE49-F238E27FC236}">
-                <a16:creationId xmlns:a16="http://schemas.microsoft.com/office/drawing/2014/main" id="{596F7020-7423-4486-A781-5EAADD0829C7}"/>
+                <a16:creationId xmlns:a16="http://schemas.microsoft.com/office/drawing/2014/main" id="{571014D8-BA25-4F36-B178-2CB7C38426D7}"/>
               </a:ext>
             </a:extLst>
           </p:cNvPr>
@@ -14610,7 +14747,7 @@
           <p:cNvPr id="3" name="">
             <a:extLst xmlns:a="http://schemas.openxmlformats.org/drawingml/2006/main">
               <a:ext uri="{FF2B5EF4-FFF2-40B4-BE49-F238E27FC236}">
-                <a16:creationId xmlns:a16="http://schemas.microsoft.com/office/drawing/2014/main" id="{B761B888-A0E5-4E9D-8044-1D2FC994FF26}"/>
+                <a16:creationId xmlns:a16="http://schemas.microsoft.com/office/drawing/2014/main" id="{166F5CDC-BA58-44E8-8CEE-A0A4218181D2}"/>
               </a:ext>
             </a:extLst>
           </p:cNvPr>
@@ -14667,7 +14804,7 @@
           <p:cNvPr id="4" name="">
             <a:extLst xmlns:a="http://schemas.openxmlformats.org/drawingml/2006/main">
               <a:ext uri="{FF2B5EF4-FFF2-40B4-BE49-F238E27FC236}">
-                <a16:creationId xmlns:a16="http://schemas.microsoft.com/office/drawing/2014/main" id="{89A53D33-BCE2-4F33-AF90-7D09CA4604BD}"/>
+                <a16:creationId xmlns:a16="http://schemas.microsoft.com/office/drawing/2014/main" id="{ACBDDB66-5EA4-49FF-ACD9-8A02770C24ED}"/>
               </a:ext>
             </a:extLst>
           </p:cNvPr>
@@ -14747,7 +14884,7 @@
           <p:cNvPr id="5" name="">
             <a:extLst xmlns:a="http://schemas.openxmlformats.org/drawingml/2006/main">
               <a:ext uri="{FF2B5EF4-FFF2-40B4-BE49-F238E27FC236}">
-                <a16:creationId xmlns:a16="http://schemas.microsoft.com/office/drawing/2014/main" id="{6D75D188-154C-46F7-9738-6AAEF6902095}"/>
+                <a16:creationId xmlns:a16="http://schemas.microsoft.com/office/drawing/2014/main" id="{55647B18-47F1-48F9-ADC2-A135734899A0}"/>
               </a:ext>
             </a:extLst>
           </p:cNvPr>
@@ -14804,7 +14941,7 @@
           <p:cNvPr id="6" name="">
             <a:extLst xmlns:a="http://schemas.openxmlformats.org/drawingml/2006/main">
               <a:ext uri="{FF2B5EF4-FFF2-40B4-BE49-F238E27FC236}">
-                <a16:creationId xmlns:a16="http://schemas.microsoft.com/office/drawing/2014/main" id="{5B3C2554-B2CB-4BB9-8CB0-E4DE5166B501}"/>
+                <a16:creationId xmlns:a16="http://schemas.microsoft.com/office/drawing/2014/main" id="{752795F9-A866-4C5B-A067-BFEBEE0438CD}"/>
               </a:ext>
             </a:extLst>
           </p:cNvPr>
@@ -14884,7 +15021,7 @@
           <p:cNvPr id="7" name="">
             <a:extLst xmlns:a="http://schemas.openxmlformats.org/drawingml/2006/main">
               <a:ext uri="{FF2B5EF4-FFF2-40B4-BE49-F238E27FC236}">
-                <a16:creationId xmlns:a16="http://schemas.microsoft.com/office/drawing/2014/main" id="{43BBB2C3-A0C4-4576-B468-B0379F71C568}"/>
+                <a16:creationId xmlns:a16="http://schemas.microsoft.com/office/drawing/2014/main" id="{EC63A544-0B66-42C9-B0D2-D77D3F80F807}"/>
               </a:ext>
             </a:extLst>
           </p:cNvPr>
@@ -14941,7 +15078,7 @@
           <p:cNvPr id="8" name="">
             <a:extLst xmlns:a="http://schemas.openxmlformats.org/drawingml/2006/main">
               <a:ext uri="{FF2B5EF4-FFF2-40B4-BE49-F238E27FC236}">
-                <a16:creationId xmlns:a16="http://schemas.microsoft.com/office/drawing/2014/main" id="{79C4AD54-2C2E-40C5-B9B5-B25F1FCE087F}"/>
+                <a16:creationId xmlns:a16="http://schemas.microsoft.com/office/drawing/2014/main" id="{2BB029B0-932C-4C76-8847-D35B46A6ECC5}"/>
               </a:ext>
             </a:extLst>
           </p:cNvPr>
@@ -14996,7 +15133,7 @@
     </p:spTree>
     <p:extLst>
       <p:ext uri="{BB962C8B-B14F-4D97-AF65-F5344CB8AC3E}">
-        <p14:creationId xmlns:p14="http://schemas.microsoft.com/office/powerpoint/2010/main" val="1962629214"/>
+        <p14:creationId xmlns:p14="http://schemas.microsoft.com/office/powerpoint/2010/main" val="1437015115"/>
       </p:ext>
     </p:extLst>
   </p:cSld>
@@ -15027,7 +15164,7 @@
           <p:cNvPr id="7" name="">
             <a:extLst xmlns:a="http://schemas.openxmlformats.org/drawingml/2006/main">
               <a:ext uri="{FF2B5EF4-FFF2-40B4-BE49-F238E27FC236}">
-                <a16:creationId xmlns:a16="http://schemas.microsoft.com/office/drawing/2014/main" id="{536AB909-4241-4086-9281-A67F1F03F97B}"/>
+                <a16:creationId xmlns:a16="http://schemas.microsoft.com/office/drawing/2014/main" id="{7D8BD7FA-C711-4FF4-BA10-252B8881CEF7}"/>
               </a:ext>
             </a:extLst>
           </p:cNvPr>
@@ -15084,7 +15221,7 @@
           <p:cNvPr id="2" name="">
             <a:extLst xmlns:a="http://schemas.openxmlformats.org/drawingml/2006/main">
               <a:ext uri="{FF2B5EF4-FFF2-40B4-BE49-F238E27FC236}">
-                <a16:creationId xmlns:a16="http://schemas.microsoft.com/office/drawing/2014/main" id="{16A79850-C34F-48A9-B977-18091C5309B9}"/>
+                <a16:creationId xmlns:a16="http://schemas.microsoft.com/office/drawing/2014/main" id="{79E3BD45-29DC-475B-B9B5-47CC958E99BD}"/>
               </a:ext>
             </a:extLst>
           </p:cNvPr>
@@ -15348,7 +15485,7 @@
           <p:cNvPr id="3" name="">
             <a:extLst xmlns:a="http://schemas.openxmlformats.org/drawingml/2006/main">
               <a:ext uri="{FF2B5EF4-FFF2-40B4-BE49-F238E27FC236}">
-                <a16:creationId xmlns:a16="http://schemas.microsoft.com/office/drawing/2014/main" id="{309B6108-17FC-4CFD-AB7B-A5DF68F79A9B}"/>
+                <a16:creationId xmlns:a16="http://schemas.microsoft.com/office/drawing/2014/main" id="{F44A3FB3-5CF8-4C7A-8525-0DCC42E1538E}"/>
               </a:ext>
             </a:extLst>
           </p:cNvPr>
@@ -15405,7 +15542,7 @@
           <p:cNvPr id="4" name="">
             <a:extLst xmlns:a="http://schemas.openxmlformats.org/drawingml/2006/main">
               <a:ext uri="{FF2B5EF4-FFF2-40B4-BE49-F238E27FC236}">
-                <a16:creationId xmlns:a16="http://schemas.microsoft.com/office/drawing/2014/main" id="{3EF0A95C-8060-4529-938C-06B09A5F67F2}"/>
+                <a16:creationId xmlns:a16="http://schemas.microsoft.com/office/drawing/2014/main" id="{823454E1-AC6E-4A12-96A4-838C7473FEFD}"/>
               </a:ext>
             </a:extLst>
           </p:cNvPr>
@@ -15564,7 +15701,7 @@
           <p:cNvPr id="5" name="">
             <a:extLst xmlns:a="http://schemas.openxmlformats.org/drawingml/2006/main">
               <a:ext uri="{FF2B5EF4-FFF2-40B4-BE49-F238E27FC236}">
-                <a16:creationId xmlns:a16="http://schemas.microsoft.com/office/drawing/2014/main" id="{F2034E4D-F00A-411D-ABB9-09969E937936}"/>
+                <a16:creationId xmlns:a16="http://schemas.microsoft.com/office/drawing/2014/main" id="{F1C96BAD-B729-4F18-9D4E-A43C6E3C091F}"/>
               </a:ext>
             </a:extLst>
           </p:cNvPr>
@@ -15621,7 +15758,7 @@
           <p:cNvPr id="6" name="">
             <a:extLst xmlns:a="http://schemas.openxmlformats.org/drawingml/2006/main">
               <a:ext uri="{FF2B5EF4-FFF2-40B4-BE49-F238E27FC236}">
-                <a16:creationId xmlns:a16="http://schemas.microsoft.com/office/drawing/2014/main" id="{8DAC650A-4DBF-4D0B-855F-EB9B82A1F3E7}"/>
+                <a16:creationId xmlns:a16="http://schemas.microsoft.com/office/drawing/2014/main" id="{763F522E-3037-4724-9734-74F75BE74D91}"/>
               </a:ext>
             </a:extLst>
           </p:cNvPr>
@@ -15676,7 +15813,7 @@
     </p:spTree>
     <p:extLst>
       <p:ext uri="{BB962C8B-B14F-4D97-AF65-F5344CB8AC3E}">
-        <p14:creationId xmlns:p14="http://schemas.microsoft.com/office/powerpoint/2010/main" val="127747287"/>
+        <p14:creationId xmlns:p14="http://schemas.microsoft.com/office/powerpoint/2010/main" val="399320903"/>
       </p:ext>
     </p:extLst>
   </p:cSld>
@@ -15707,7 +15844,7 @@
           <p:cNvPr id="7" name="">
             <a:extLst xmlns:a="http://schemas.openxmlformats.org/drawingml/2006/main">
               <a:ext uri="{FF2B5EF4-FFF2-40B4-BE49-F238E27FC236}">
-                <a16:creationId xmlns:a16="http://schemas.microsoft.com/office/drawing/2014/main" id="{3D976621-E48B-4AA0-9BEF-2484B9FE9CC3}"/>
+                <a16:creationId xmlns:a16="http://schemas.microsoft.com/office/drawing/2014/main" id="{B43B9227-1F39-493F-8095-EF061CF26154}"/>
               </a:ext>
             </a:extLst>
           </p:cNvPr>
@@ -15764,7 +15901,7 @@
           <p:cNvPr id="2" name="">
             <a:extLst xmlns:a="http://schemas.openxmlformats.org/drawingml/2006/main">
               <a:ext uri="{FF2B5EF4-FFF2-40B4-BE49-F238E27FC236}">
-                <a16:creationId xmlns:a16="http://schemas.microsoft.com/office/drawing/2014/main" id="{B2B68F24-1EBD-49AC-9D46-A9E7FE1B426E}"/>
+                <a16:creationId xmlns:a16="http://schemas.microsoft.com/office/drawing/2014/main" id="{3DD80831-CC20-4AC4-9BF0-2331D3ACC68E}"/>
               </a:ext>
             </a:extLst>
           </p:cNvPr>
@@ -16010,7 +16147,7 @@
           <p:cNvPr id="3" name="">
             <a:extLst xmlns:a="http://schemas.openxmlformats.org/drawingml/2006/main">
               <a:ext uri="{FF2B5EF4-FFF2-40B4-BE49-F238E27FC236}">
-                <a16:creationId xmlns:a16="http://schemas.microsoft.com/office/drawing/2014/main" id="{72693D79-FC00-4BC6-9095-67E420188E96}"/>
+                <a16:creationId xmlns:a16="http://schemas.microsoft.com/office/drawing/2014/main" id="{63C78E03-5625-46FB-8A8E-7F2268040CDA}"/>
               </a:ext>
             </a:extLst>
           </p:cNvPr>
@@ -16067,7 +16204,7 @@
           <p:cNvPr id="4" name="">
             <a:extLst xmlns:a="http://schemas.openxmlformats.org/drawingml/2006/main">
               <a:ext uri="{FF2B5EF4-FFF2-40B4-BE49-F238E27FC236}">
-                <a16:creationId xmlns:a16="http://schemas.microsoft.com/office/drawing/2014/main" id="{06949B74-3924-47A8-BDB0-D6304890BE2E}"/>
+                <a16:creationId xmlns:a16="http://schemas.microsoft.com/office/drawing/2014/main" id="{12B5202B-DA23-4E1C-BDCE-F59816188108}"/>
               </a:ext>
             </a:extLst>
           </p:cNvPr>
@@ -16226,7 +16363,7 @@
           <p:cNvPr id="5" name="">
             <a:extLst xmlns:a="http://schemas.openxmlformats.org/drawingml/2006/main">
               <a:ext uri="{FF2B5EF4-FFF2-40B4-BE49-F238E27FC236}">
-                <a16:creationId xmlns:a16="http://schemas.microsoft.com/office/drawing/2014/main" id="{2729ED9A-C4C8-4BAB-9FB5-049393812F29}"/>
+                <a16:creationId xmlns:a16="http://schemas.microsoft.com/office/drawing/2014/main" id="{964CF8F5-A9DF-4C0D-929F-83672627199D}"/>
               </a:ext>
             </a:extLst>
           </p:cNvPr>
@@ -16283,7 +16420,7 @@
           <p:cNvPr id="6" name="">
             <a:extLst xmlns:a="http://schemas.openxmlformats.org/drawingml/2006/main">
               <a:ext uri="{FF2B5EF4-FFF2-40B4-BE49-F238E27FC236}">
-                <a16:creationId xmlns:a16="http://schemas.microsoft.com/office/drawing/2014/main" id="{3C250F04-77A4-428B-AFD4-04524C1D28BD}"/>
+                <a16:creationId xmlns:a16="http://schemas.microsoft.com/office/drawing/2014/main" id="{89C6C2C1-4BDD-4D41-8B7E-FE7A483D348B}"/>
               </a:ext>
             </a:extLst>
           </p:cNvPr>
@@ -16338,7 +16475,7 @@
     </p:spTree>
     <p:extLst>
       <p:ext uri="{BB962C8B-B14F-4D97-AF65-F5344CB8AC3E}">
-        <p14:creationId xmlns:p14="http://schemas.microsoft.com/office/powerpoint/2010/main" val="350500046"/>
+        <p14:creationId xmlns:p14="http://schemas.microsoft.com/office/powerpoint/2010/main" val="1474640682"/>
       </p:ext>
     </p:extLst>
   </p:cSld>

</xml_diff>

<commit_message>
Add the public repository QR code to slide two
</commit_message>
<xml_diff>
--- a/output/Bringing-the-Heat.pptx
+++ b/output/Bringing-the-Heat.pptx
@@ -2,34 +2,34 @@
 <file path=ppt/presentation.xml><?xml version="1.0" encoding="utf-8"?>
 <p:presentation xmlns:p="http://schemas.openxmlformats.org/presentationml/2006/main">
   <p:sldMasterIdLst>
-    <p:sldMasterId xmlns:r="http://schemas.openxmlformats.org/officeDocument/2006/relationships" id="2147483648" r:id="Rcaabcf9d3b2345b1"/>
+    <p:sldMasterId xmlns:r="http://schemas.openxmlformats.org/officeDocument/2006/relationships" id="2147483648" r:id="R992b6ff2aa6b40d3"/>
   </p:sldMasterIdLst>
   <p:notesMasterIdLst>
-    <p:notesMasterId xmlns:r="http://schemas.openxmlformats.org/officeDocument/2006/relationships" r:id="Rbf9942fc934b4694"/>
+    <p:notesMasterId xmlns:r="http://schemas.openxmlformats.org/officeDocument/2006/relationships" r:id="R6f6600196749494c"/>
   </p:notesMasterIdLst>
   <p:sldIdLst>
-    <p:sldId xmlns:r="http://schemas.openxmlformats.org/officeDocument/2006/relationships" id="256" r:id="Rcb8538808c174704"/>
-    <p:sldId xmlns:r="http://schemas.openxmlformats.org/officeDocument/2006/relationships" id="257" r:id="R51e5ecb37b994b32"/>
-    <p:sldId xmlns:r="http://schemas.openxmlformats.org/officeDocument/2006/relationships" id="258" r:id="R4ddf81cca1ca4584"/>
-    <p:sldId xmlns:r="http://schemas.openxmlformats.org/officeDocument/2006/relationships" id="259" r:id="R39ec322abec34798"/>
-    <p:sldId xmlns:r="http://schemas.openxmlformats.org/officeDocument/2006/relationships" id="260" r:id="R88f56f9e96af4eb8"/>
-    <p:sldId xmlns:r="http://schemas.openxmlformats.org/officeDocument/2006/relationships" id="261" r:id="R8482dfdb0ea241d9"/>
-    <p:sldId xmlns:r="http://schemas.openxmlformats.org/officeDocument/2006/relationships" id="262" r:id="R0c6c0754dc6647d2"/>
-    <p:sldId xmlns:r="http://schemas.openxmlformats.org/officeDocument/2006/relationships" id="263" r:id="Ra53047a5860a4fa4"/>
-    <p:sldId xmlns:r="http://schemas.openxmlformats.org/officeDocument/2006/relationships" id="264" r:id="Ra340dcd1ce9b4d90"/>
-    <p:sldId xmlns:r="http://schemas.openxmlformats.org/officeDocument/2006/relationships" id="265" r:id="Rf7b301372ec34f92"/>
-    <p:sldId xmlns:r="http://schemas.openxmlformats.org/officeDocument/2006/relationships" id="266" r:id="R9dd8e69dc1574395"/>
-    <p:sldId xmlns:r="http://schemas.openxmlformats.org/officeDocument/2006/relationships" id="267" r:id="Rccfae6bd91294ef4"/>
-    <p:sldId xmlns:r="http://schemas.openxmlformats.org/officeDocument/2006/relationships" id="268" r:id="R8205f3fb43764c9b"/>
-    <p:sldId xmlns:r="http://schemas.openxmlformats.org/officeDocument/2006/relationships" id="269" r:id="R1e1e71d96f874bd0"/>
-    <p:sldId xmlns:r="http://schemas.openxmlformats.org/officeDocument/2006/relationships" id="270" r:id="Rfe067a66e6ba482e"/>
-    <p:sldId xmlns:r="http://schemas.openxmlformats.org/officeDocument/2006/relationships" id="271" r:id="R3935505433b246e7"/>
-    <p:sldId xmlns:r="http://schemas.openxmlformats.org/officeDocument/2006/relationships" id="272" r:id="Rd5433a4ff6c84657"/>
-    <p:sldId xmlns:r="http://schemas.openxmlformats.org/officeDocument/2006/relationships" id="273" r:id="Ra211d43423a84f9e"/>
-    <p:sldId xmlns:r="http://schemas.openxmlformats.org/officeDocument/2006/relationships" id="274" r:id="R1c4e06f8796e4d2f"/>
-    <p:sldId xmlns:r="http://schemas.openxmlformats.org/officeDocument/2006/relationships" id="275" r:id="R07c32fcffc044ff5"/>
-    <p:sldId xmlns:r="http://schemas.openxmlformats.org/officeDocument/2006/relationships" id="276" r:id="Rac483a7c55a94fcd"/>
-    <p:sldId xmlns:r="http://schemas.openxmlformats.org/officeDocument/2006/relationships" id="277" r:id="Ra812f46735094add"/>
+    <p:sldId xmlns:r="http://schemas.openxmlformats.org/officeDocument/2006/relationships" id="256" r:id="R53ed5d15b9b44c72"/>
+    <p:sldId xmlns:r="http://schemas.openxmlformats.org/officeDocument/2006/relationships" id="257" r:id="Ra8e2782a0add454d"/>
+    <p:sldId xmlns:r="http://schemas.openxmlformats.org/officeDocument/2006/relationships" id="258" r:id="R5a793dc595554150"/>
+    <p:sldId xmlns:r="http://schemas.openxmlformats.org/officeDocument/2006/relationships" id="259" r:id="Rd2efe8e0555549a6"/>
+    <p:sldId xmlns:r="http://schemas.openxmlformats.org/officeDocument/2006/relationships" id="260" r:id="R957a0ed63c3c41b8"/>
+    <p:sldId xmlns:r="http://schemas.openxmlformats.org/officeDocument/2006/relationships" id="261" r:id="R0b7878af14fe49f8"/>
+    <p:sldId xmlns:r="http://schemas.openxmlformats.org/officeDocument/2006/relationships" id="262" r:id="R277afa83f6a34a3c"/>
+    <p:sldId xmlns:r="http://schemas.openxmlformats.org/officeDocument/2006/relationships" id="263" r:id="Rb04af078384b437e"/>
+    <p:sldId xmlns:r="http://schemas.openxmlformats.org/officeDocument/2006/relationships" id="264" r:id="R858af1b1d069473d"/>
+    <p:sldId xmlns:r="http://schemas.openxmlformats.org/officeDocument/2006/relationships" id="265" r:id="R951aceb1c6594a73"/>
+    <p:sldId xmlns:r="http://schemas.openxmlformats.org/officeDocument/2006/relationships" id="266" r:id="R959392096a3c4ec4"/>
+    <p:sldId xmlns:r="http://schemas.openxmlformats.org/officeDocument/2006/relationships" id="267" r:id="R4d56cbf726a74987"/>
+    <p:sldId xmlns:r="http://schemas.openxmlformats.org/officeDocument/2006/relationships" id="268" r:id="R2b1c65b2c8fd412f"/>
+    <p:sldId xmlns:r="http://schemas.openxmlformats.org/officeDocument/2006/relationships" id="269" r:id="R67732fcbb1894598"/>
+    <p:sldId xmlns:r="http://schemas.openxmlformats.org/officeDocument/2006/relationships" id="270" r:id="Ra3a3a247b222492d"/>
+    <p:sldId xmlns:r="http://schemas.openxmlformats.org/officeDocument/2006/relationships" id="271" r:id="Rfed3b719261c4f9b"/>
+    <p:sldId xmlns:r="http://schemas.openxmlformats.org/officeDocument/2006/relationships" id="272" r:id="Rfabd2cca0aa84c85"/>
+    <p:sldId xmlns:r="http://schemas.openxmlformats.org/officeDocument/2006/relationships" id="273" r:id="Rb8a8f8ef2a0d4280"/>
+    <p:sldId xmlns:r="http://schemas.openxmlformats.org/officeDocument/2006/relationships" id="274" r:id="Rf7cf53c0180745e5"/>
+    <p:sldId xmlns:r="http://schemas.openxmlformats.org/officeDocument/2006/relationships" id="275" r:id="Rec116c5a541f4ee7"/>
+    <p:sldId xmlns:r="http://schemas.openxmlformats.org/officeDocument/2006/relationships" id="276" r:id="R856ed25b031c464a"/>
+    <p:sldId xmlns:r="http://schemas.openxmlformats.org/officeDocument/2006/relationships" id="277" r:id="R747b51a571614a42"/>
   </p:sldIdLst>
   <p:sldSz cx="12192000" cy="6858000"/>
   <p:notesSz cx="6858000" cy="9144000"/>
@@ -1668,7 +1668,7 @@
           </a:p>
           <a:p xmlns:a="http://schemas.openxmlformats.org/drawingml/2006/main">
             <a:r>
-              <a:t>75 seconds. Give a concrete failure: the notebook looks good, but a new package version changes preprocessing, or one minority class collapses behind a high average accuracy. The engineering question is what evidence travels with the weights. Introduce the contract: source revisions, preprocessing, test results, runtime configuration, and rollback. This is our proposed engineering framework, not a promise provided by a library. Students should listen for the role of each tool. Engineers should listen for the boundary between training code and an operational service.</a:t>
+              <a:t>75 seconds. Point out the repo QR: it opens the code, Colab notebook, slides, and recorded results. Give a concrete failure: the notebook looks good, but a new package version changes preprocessing, or one minority class collapses behind a high average accuracy. The engineering question is what evidence travels with the weights. Introduce the contract: source revisions, preprocessing, test results, runtime configuration, and rollback. This is our proposed engineering framework, not a promise provided by a library. Students should listen for the role of each tool. Engineers should listen for the boundary between training code and an operational service.</a:t>
             </a:r>
           </a:p>
           <a:p xmlns:a="http://schemas.openxmlformats.org/drawingml/2006/main">
@@ -1694,6 +1694,11 @@
           <a:p xmlns:a="http://schemas.openxmlformats.org/drawingml/2006/main">
             <a:r>
               <a:t>https://huggingface.co/docs/huggingface_hub/guides/download</a:t>
+            </a:r>
+          </a:p>
+          <a:p xmlns:a="http://schemas.openxmlformats.org/drawingml/2006/main">
+            <a:r>
+              <a:t>https://github.com/jemsbhai/bringing-the-heat</a:t>
             </a:r>
           </a:p>
         </p:txBody>
@@ -2841,7 +2846,7 @@
   </p:cSld>
   <p:clrMap bg1="lt1" tx1="dk1" bg2="lt2" tx2="dk2" accent1="accent1" accent2="accent2" accent3="accent3" accent4="accent4" accent5="accent5" accent6="accent6" hlink="hlink" folHlink="folHlink"/>
   <p:sldLayoutIdLst>
-    <p:sldLayoutId xmlns:r="http://schemas.openxmlformats.org/officeDocument/2006/relationships" id="2147483649" r:id="R556630a817074c2d"/>
+    <p:sldLayoutId xmlns:r="http://schemas.openxmlformats.org/officeDocument/2006/relationships" id="2147483649" r:id="Re7f29b0e7d154830"/>
   </p:sldLayoutIdLst>
   <p:txStyles>
     <p:titleStyle>
@@ -3392,7 +3397,7 @@
           <p:cNvPr id="6" name="">
             <a:extLst xmlns:a="http://schemas.openxmlformats.org/drawingml/2006/main">
               <a:ext uri="{FF2B5EF4-FFF2-40B4-BE49-F238E27FC236}">
-                <a16:creationId xmlns:a16="http://schemas.microsoft.com/office/drawing/2014/main" id="{3DE4553E-80C1-4D58-872C-CC42C69682C9}"/>
+                <a16:creationId xmlns:a16="http://schemas.microsoft.com/office/drawing/2014/main" id="{16951031-94B8-4612-BAE3-305D6B0D1E42}"/>
               </a:ext>
             </a:extLst>
           </p:cNvPr>
@@ -3449,7 +3454,7 @@
           <p:cNvPr id="2" name="">
             <a:extLst xmlns:a="http://schemas.openxmlformats.org/drawingml/2006/main">
               <a:ext uri="{FF2B5EF4-FFF2-40B4-BE49-F238E27FC236}">
-                <a16:creationId xmlns:a16="http://schemas.microsoft.com/office/drawing/2014/main" id="{8139EEAE-24B5-40D2-95DF-B881E23E7D05}"/>
+                <a16:creationId xmlns:a16="http://schemas.microsoft.com/office/drawing/2014/main" id="{FFCDF9FE-92B2-411E-9D02-1968BC143768}"/>
               </a:ext>
             </a:extLst>
           </p:cNvPr>
@@ -3529,7 +3534,7 @@
           <p:cNvPr id="3" name="">
             <a:extLst xmlns:a="http://schemas.openxmlformats.org/drawingml/2006/main">
               <a:ext uri="{FF2B5EF4-FFF2-40B4-BE49-F238E27FC236}">
-                <a16:creationId xmlns:a16="http://schemas.microsoft.com/office/drawing/2014/main" id="{04181503-7A16-4050-9071-F7A99E132E2C}"/>
+                <a16:creationId xmlns:a16="http://schemas.microsoft.com/office/drawing/2014/main" id="{9393DADA-9406-44A5-81A6-BBCDF96151AA}"/>
               </a:ext>
             </a:extLst>
           </p:cNvPr>
@@ -3586,7 +3591,7 @@
           <p:cNvPr id="4" name="">
             <a:extLst xmlns:a="http://schemas.openxmlformats.org/drawingml/2006/main">
               <a:ext uri="{FF2B5EF4-FFF2-40B4-BE49-F238E27FC236}">
-                <a16:creationId xmlns:a16="http://schemas.microsoft.com/office/drawing/2014/main" id="{5E048EA0-1CCE-4F57-897A-F400DDEF6FA9}"/>
+                <a16:creationId xmlns:a16="http://schemas.microsoft.com/office/drawing/2014/main" id="{883A43FA-6667-4D23-8D5E-610BE470441E}"/>
               </a:ext>
             </a:extLst>
           </p:cNvPr>
@@ -3632,7 +3637,7 @@
                 <a:latin typeface="Arial"/>
                 <a:ea typeface="Arial"/>
                 <a:cs typeface="Arial"/>
-                <a:hlinkClick xmlns:r="http://schemas.openxmlformats.org/officeDocument/2006/relationships" r:id="R6dbfa0f7c2374e45"/>
+                <a:hlinkClick xmlns:r="http://schemas.openxmlformats.org/officeDocument/2006/relationships" r:id="R63cb786942f94594"/>
               </a:rPr>
               <a:t>muntasersyed.com</a:t>
             </a:r>
@@ -3648,7 +3653,7 @@
           <p:nvPr/>
         </p:nvPicPr>
         <p:blipFill>
-          <a:blip xmlns:r="http://schemas.openxmlformats.org/officeDocument/2006/relationships" xmlns:a="http://schemas.openxmlformats.org/drawingml/2006/main" r:embed="R16aeaec100aa471a"/>
+          <a:blip xmlns:r="http://schemas.openxmlformats.org/officeDocument/2006/relationships" xmlns:a="http://schemas.openxmlformats.org/drawingml/2006/main" r:embed="R2659f28d010c4688"/>
           <a:stretch xmlns:a="http://schemas.openxmlformats.org/drawingml/2006/main"/>
         </p:blipFill>
         <p:spPr>
@@ -3664,7 +3669,7 @@
     </p:spTree>
     <p:extLst>
       <p:ext uri="{BB962C8B-B14F-4D97-AF65-F5344CB8AC3E}">
-        <p14:creationId xmlns:p14="http://schemas.microsoft.com/office/powerpoint/2010/main" val="1444336801"/>
+        <p14:creationId xmlns:p14="http://schemas.microsoft.com/office/powerpoint/2010/main" val="148576986"/>
       </p:ext>
     </p:extLst>
   </p:cSld>
@@ -3695,7 +3700,7 @@
           <p:cNvPr id="13" name="">
             <a:extLst xmlns:a="http://schemas.openxmlformats.org/drawingml/2006/main">
               <a:ext uri="{FF2B5EF4-FFF2-40B4-BE49-F238E27FC236}">
-                <a16:creationId xmlns:a16="http://schemas.microsoft.com/office/drawing/2014/main" id="{6C70B1EC-3F57-49C2-B16D-D78667E8BCB8}"/>
+                <a16:creationId xmlns:a16="http://schemas.microsoft.com/office/drawing/2014/main" id="{009AF8D0-D16D-4FA3-AC5B-BFEC27F6BA03}"/>
               </a:ext>
             </a:extLst>
           </p:cNvPr>
@@ -3752,7 +3757,7 @@
           <p:cNvPr id="2" name="">
             <a:extLst xmlns:a="http://schemas.openxmlformats.org/drawingml/2006/main">
               <a:ext uri="{FF2B5EF4-FFF2-40B4-BE49-F238E27FC236}">
-                <a16:creationId xmlns:a16="http://schemas.microsoft.com/office/drawing/2014/main" id="{C5E89937-68C6-42E0-A3E3-AB78CF7FBBC6}"/>
+                <a16:creationId xmlns:a16="http://schemas.microsoft.com/office/drawing/2014/main" id="{6E1DE461-104F-4172-BFF0-C1884CEBABC4}"/>
               </a:ext>
             </a:extLst>
           </p:cNvPr>
@@ -3809,7 +3814,7 @@
           <p:cNvPr id="3" name="">
             <a:extLst xmlns:a="http://schemas.openxmlformats.org/drawingml/2006/main">
               <a:ext uri="{FF2B5EF4-FFF2-40B4-BE49-F238E27FC236}">
-                <a16:creationId xmlns:a16="http://schemas.microsoft.com/office/drawing/2014/main" id="{7A9B138C-54E1-409A-BEA5-54F6810B8E01}"/>
+                <a16:creationId xmlns:a16="http://schemas.microsoft.com/office/drawing/2014/main" id="{4CCCFAAE-5980-42FB-BE51-2D32F001B517}"/>
               </a:ext>
             </a:extLst>
           </p:cNvPr>
@@ -3866,7 +3871,7 @@
           <p:cNvPr id="4" name="">
             <a:extLst xmlns:a="http://schemas.openxmlformats.org/drawingml/2006/main">
               <a:ext uri="{FF2B5EF4-FFF2-40B4-BE49-F238E27FC236}">
-                <a16:creationId xmlns:a16="http://schemas.microsoft.com/office/drawing/2014/main" id="{F0B23969-F28C-4E31-ABD9-B7CC94EEF379}"/>
+                <a16:creationId xmlns:a16="http://schemas.microsoft.com/office/drawing/2014/main" id="{E1754073-5943-445B-8B7C-490AF735EFDC}"/>
               </a:ext>
             </a:extLst>
           </p:cNvPr>
@@ -3923,7 +3928,7 @@
           <p:cNvPr id="5" name="">
             <a:extLst xmlns:a="http://schemas.openxmlformats.org/drawingml/2006/main">
               <a:ext uri="{FF2B5EF4-FFF2-40B4-BE49-F238E27FC236}">
-                <a16:creationId xmlns:a16="http://schemas.microsoft.com/office/drawing/2014/main" id="{4A9B69B7-4603-426D-8333-84DE1AE3E489}"/>
+                <a16:creationId xmlns:a16="http://schemas.microsoft.com/office/drawing/2014/main" id="{4C088BB0-856C-429B-9F70-01CACB0A56F5}"/>
               </a:ext>
             </a:extLst>
           </p:cNvPr>
@@ -3980,7 +3985,7 @@
           <p:cNvPr id="6" name="">
             <a:extLst xmlns:a="http://schemas.openxmlformats.org/drawingml/2006/main">
               <a:ext uri="{FF2B5EF4-FFF2-40B4-BE49-F238E27FC236}">
-                <a16:creationId xmlns:a16="http://schemas.microsoft.com/office/drawing/2014/main" id="{A6ABCC4D-9B07-4848-ADFA-21BF9569971B}"/>
+                <a16:creationId xmlns:a16="http://schemas.microsoft.com/office/drawing/2014/main" id="{5973550A-37E6-49BC-8A21-C465B9822DAA}"/>
               </a:ext>
             </a:extLst>
           </p:cNvPr>
@@ -4037,7 +4042,7 @@
           <p:cNvPr id="7" name="">
             <a:extLst xmlns:a="http://schemas.openxmlformats.org/drawingml/2006/main">
               <a:ext uri="{FF2B5EF4-FFF2-40B4-BE49-F238E27FC236}">
-                <a16:creationId xmlns:a16="http://schemas.microsoft.com/office/drawing/2014/main" id="{56FCEF07-EC5A-4AFE-AB6E-875BF74B0F57}"/>
+                <a16:creationId xmlns:a16="http://schemas.microsoft.com/office/drawing/2014/main" id="{02256A28-79CD-4C67-82D8-E44B753884FB}"/>
               </a:ext>
             </a:extLst>
           </p:cNvPr>
@@ -4094,7 +4099,7 @@
           <p:cNvPr id="8" name="">
             <a:extLst xmlns:a="http://schemas.openxmlformats.org/drawingml/2006/main">
               <a:ext uri="{FF2B5EF4-FFF2-40B4-BE49-F238E27FC236}">
-                <a16:creationId xmlns:a16="http://schemas.microsoft.com/office/drawing/2014/main" id="{838DA086-AA2D-4D74-862D-AECFAEEA0680}"/>
+                <a16:creationId xmlns:a16="http://schemas.microsoft.com/office/drawing/2014/main" id="{498A2AB9-F846-46A3-8B2A-3D2CF5ABD345}"/>
               </a:ext>
             </a:extLst>
           </p:cNvPr>
@@ -4151,7 +4156,7 @@
           <p:cNvPr id="9" name="">
             <a:extLst xmlns:a="http://schemas.openxmlformats.org/drawingml/2006/main">
               <a:ext uri="{FF2B5EF4-FFF2-40B4-BE49-F238E27FC236}">
-                <a16:creationId xmlns:a16="http://schemas.microsoft.com/office/drawing/2014/main" id="{70C8CCCE-2265-40F2-8779-45BF2D42DB02}"/>
+                <a16:creationId xmlns:a16="http://schemas.microsoft.com/office/drawing/2014/main" id="{91202958-1084-44DC-B451-2025D5CC24CA}"/>
               </a:ext>
             </a:extLst>
           </p:cNvPr>
@@ -4208,7 +4213,7 @@
           <p:cNvPr id="10" name="">
             <a:extLst xmlns:a="http://schemas.openxmlformats.org/drawingml/2006/main">
               <a:ext uri="{FF2B5EF4-FFF2-40B4-BE49-F238E27FC236}">
-                <a16:creationId xmlns:a16="http://schemas.microsoft.com/office/drawing/2014/main" id="{4D3B8CD0-F22B-4565-BF30-D705D08BD36A}"/>
+                <a16:creationId xmlns:a16="http://schemas.microsoft.com/office/drawing/2014/main" id="{46B11358-071C-4FCC-BF0A-AB3FB8FCD925}"/>
               </a:ext>
             </a:extLst>
           </p:cNvPr>
@@ -4265,7 +4270,7 @@
           <p:cNvPr id="11" name="">
             <a:extLst xmlns:a="http://schemas.openxmlformats.org/drawingml/2006/main">
               <a:ext uri="{FF2B5EF4-FFF2-40B4-BE49-F238E27FC236}">
-                <a16:creationId xmlns:a16="http://schemas.microsoft.com/office/drawing/2014/main" id="{ADE9799E-0B99-40D1-9043-45C815075DA4}"/>
+                <a16:creationId xmlns:a16="http://schemas.microsoft.com/office/drawing/2014/main" id="{EAC51A1F-3C9C-4679-A624-94760D979FAB}"/>
               </a:ext>
             </a:extLst>
           </p:cNvPr>
@@ -4322,7 +4327,7 @@
           <p:cNvPr id="12" name="">
             <a:extLst xmlns:a="http://schemas.openxmlformats.org/drawingml/2006/main">
               <a:ext uri="{FF2B5EF4-FFF2-40B4-BE49-F238E27FC236}">
-                <a16:creationId xmlns:a16="http://schemas.microsoft.com/office/drawing/2014/main" id="{0019E209-99CC-4547-9258-0B39B55FAD5E}"/>
+                <a16:creationId xmlns:a16="http://schemas.microsoft.com/office/drawing/2014/main" id="{7DFA1CFC-B26C-4D0C-9214-8851151B0D5C}"/>
               </a:ext>
             </a:extLst>
           </p:cNvPr>
@@ -4377,7 +4382,7 @@
     </p:spTree>
     <p:extLst>
       <p:ext uri="{BB962C8B-B14F-4D97-AF65-F5344CB8AC3E}">
-        <p14:creationId xmlns:p14="http://schemas.microsoft.com/office/powerpoint/2010/main" val="1201975822"/>
+        <p14:creationId xmlns:p14="http://schemas.microsoft.com/office/powerpoint/2010/main" val="1382776502"/>
       </p:ext>
     </p:extLst>
   </p:cSld>
@@ -4408,7 +4413,7 @@
           <p:cNvPr id="5" name="">
             <a:extLst xmlns:a="http://schemas.openxmlformats.org/drawingml/2006/main">
               <a:ext uri="{FF2B5EF4-FFF2-40B4-BE49-F238E27FC236}">
-                <a16:creationId xmlns:a16="http://schemas.microsoft.com/office/drawing/2014/main" id="{AE686E60-E0EA-4016-8099-4C783524BD22}"/>
+                <a16:creationId xmlns:a16="http://schemas.microsoft.com/office/drawing/2014/main" id="{029E9D74-25EC-4B63-BE78-B7ED949B41C6}"/>
               </a:ext>
             </a:extLst>
           </p:cNvPr>
@@ -4858,7 +4863,7 @@
           <p:cNvPr id="3" name="">
             <a:extLst xmlns:a="http://schemas.openxmlformats.org/drawingml/2006/main">
               <a:ext uri="{FF2B5EF4-FFF2-40B4-BE49-F238E27FC236}">
-                <a16:creationId xmlns:a16="http://schemas.microsoft.com/office/drawing/2014/main" id="{2E77C6B8-DC9A-44D8-AFB8-E470A4595937}"/>
+                <a16:creationId xmlns:a16="http://schemas.microsoft.com/office/drawing/2014/main" id="{D8F640AB-60B3-4DFD-A10D-957B9EEF1A48}"/>
               </a:ext>
             </a:extLst>
           </p:cNvPr>
@@ -4915,7 +4920,7 @@
           <p:cNvPr id="4" name="">
             <a:extLst xmlns:a="http://schemas.openxmlformats.org/drawingml/2006/main">
               <a:ext uri="{FF2B5EF4-FFF2-40B4-BE49-F238E27FC236}">
-                <a16:creationId xmlns:a16="http://schemas.microsoft.com/office/drawing/2014/main" id="{5B4A06D2-30C4-4FD6-BD3E-FB7B617E8681}"/>
+                <a16:creationId xmlns:a16="http://schemas.microsoft.com/office/drawing/2014/main" id="{57BCF1CE-8C3B-43A2-9765-DC8677533874}"/>
               </a:ext>
             </a:extLst>
           </p:cNvPr>
@@ -4970,7 +4975,7 @@
     </p:spTree>
     <p:extLst>
       <p:ext uri="{BB962C8B-B14F-4D97-AF65-F5344CB8AC3E}">
-        <p14:creationId xmlns:p14="http://schemas.microsoft.com/office/powerpoint/2010/main" val="653008237"/>
+        <p14:creationId xmlns:p14="http://schemas.microsoft.com/office/powerpoint/2010/main" val="205418376"/>
       </p:ext>
     </p:extLst>
   </p:cSld>
@@ -5001,7 +5006,7 @@
           <p:cNvPr id="7" name="">
             <a:extLst xmlns:a="http://schemas.openxmlformats.org/drawingml/2006/main">
               <a:ext uri="{FF2B5EF4-FFF2-40B4-BE49-F238E27FC236}">
-                <a16:creationId xmlns:a16="http://schemas.microsoft.com/office/drawing/2014/main" id="{7A977ADC-8254-4611-906E-2CB29D8A3416}"/>
+                <a16:creationId xmlns:a16="http://schemas.microsoft.com/office/drawing/2014/main" id="{0B15205C-7E64-455D-BCA6-818A8C24BD62}"/>
               </a:ext>
             </a:extLst>
           </p:cNvPr>
@@ -5058,7 +5063,7 @@
           <p:cNvPr id="2" name="">
             <a:extLst xmlns:a="http://schemas.openxmlformats.org/drawingml/2006/main">
               <a:ext uri="{FF2B5EF4-FFF2-40B4-BE49-F238E27FC236}">
-                <a16:creationId xmlns:a16="http://schemas.microsoft.com/office/drawing/2014/main" id="{B4117869-3653-42D7-ADCE-258DA9A4D288}"/>
+                <a16:creationId xmlns:a16="http://schemas.microsoft.com/office/drawing/2014/main" id="{5024006D-C94D-485D-BC47-4CFCED56F14F}"/>
               </a:ext>
             </a:extLst>
           </p:cNvPr>
@@ -5309,7 +5314,7 @@
           <p:cNvPr id="3" name="">
             <a:extLst xmlns:a="http://schemas.openxmlformats.org/drawingml/2006/main">
               <a:ext uri="{FF2B5EF4-FFF2-40B4-BE49-F238E27FC236}">
-                <a16:creationId xmlns:a16="http://schemas.microsoft.com/office/drawing/2014/main" id="{A53BC629-EB65-461A-99B4-5F12B0C6C920}"/>
+                <a16:creationId xmlns:a16="http://schemas.microsoft.com/office/drawing/2014/main" id="{2C0B9D2D-977C-48D4-AC26-F231A37469B8}"/>
               </a:ext>
             </a:extLst>
           </p:cNvPr>
@@ -5366,7 +5371,7 @@
           <p:cNvPr id="4" name="">
             <a:extLst xmlns:a="http://schemas.openxmlformats.org/drawingml/2006/main">
               <a:ext uri="{FF2B5EF4-FFF2-40B4-BE49-F238E27FC236}">
-                <a16:creationId xmlns:a16="http://schemas.microsoft.com/office/drawing/2014/main" id="{596D99D9-7FC7-45A1-A8EB-F57D35608597}"/>
+                <a16:creationId xmlns:a16="http://schemas.microsoft.com/office/drawing/2014/main" id="{7409E313-4B52-4B5A-881D-17C9F12D9316}"/>
               </a:ext>
             </a:extLst>
           </p:cNvPr>
@@ -5507,7 +5512,7 @@
           <p:cNvPr id="5" name="">
             <a:extLst xmlns:a="http://schemas.openxmlformats.org/drawingml/2006/main">
               <a:ext uri="{FF2B5EF4-FFF2-40B4-BE49-F238E27FC236}">
-                <a16:creationId xmlns:a16="http://schemas.microsoft.com/office/drawing/2014/main" id="{7F5FA234-318C-4CAA-9FFE-71587FD0CD4B}"/>
+                <a16:creationId xmlns:a16="http://schemas.microsoft.com/office/drawing/2014/main" id="{4BFD744D-740D-4A68-B126-368A213E80E1}"/>
               </a:ext>
             </a:extLst>
           </p:cNvPr>
@@ -5564,7 +5569,7 @@
           <p:cNvPr id="6" name="">
             <a:extLst xmlns:a="http://schemas.openxmlformats.org/drawingml/2006/main">
               <a:ext uri="{FF2B5EF4-FFF2-40B4-BE49-F238E27FC236}">
-                <a16:creationId xmlns:a16="http://schemas.microsoft.com/office/drawing/2014/main" id="{8D35364B-8A76-4C13-9C1E-CDCB9E217EF5}"/>
+                <a16:creationId xmlns:a16="http://schemas.microsoft.com/office/drawing/2014/main" id="{1EB3C42D-A352-43EF-91AA-AEE606E9CC9A}"/>
               </a:ext>
             </a:extLst>
           </p:cNvPr>
@@ -5619,7 +5624,7 @@
     </p:spTree>
     <p:extLst>
       <p:ext uri="{BB962C8B-B14F-4D97-AF65-F5344CB8AC3E}">
-        <p14:creationId xmlns:p14="http://schemas.microsoft.com/office/powerpoint/2010/main" val="737254805"/>
+        <p14:creationId xmlns:p14="http://schemas.microsoft.com/office/powerpoint/2010/main" val="188631722"/>
       </p:ext>
     </p:extLst>
   </p:cSld>
@@ -5650,7 +5655,7 @@
           <p:cNvPr id="6" name="">
             <a:extLst xmlns:a="http://schemas.openxmlformats.org/drawingml/2006/main">
               <a:ext uri="{FF2B5EF4-FFF2-40B4-BE49-F238E27FC236}">
-                <a16:creationId xmlns:a16="http://schemas.microsoft.com/office/drawing/2014/main" id="{B5FA7B15-C944-4524-91EC-9DF536279569}"/>
+                <a16:creationId xmlns:a16="http://schemas.microsoft.com/office/drawing/2014/main" id="{A4066216-37BA-4FD5-8E70-AB6C8DFCF646}"/>
               </a:ext>
             </a:extLst>
           </p:cNvPr>
@@ -6123,7 +6128,7 @@
           <p:cNvPr id="3" name="">
             <a:extLst xmlns:a="http://schemas.openxmlformats.org/drawingml/2006/main">
               <a:ext uri="{FF2B5EF4-FFF2-40B4-BE49-F238E27FC236}">
-                <a16:creationId xmlns:a16="http://schemas.microsoft.com/office/drawing/2014/main" id="{A2D8CBB7-18D0-4B6F-BC1D-A567EB205AC7}"/>
+                <a16:creationId xmlns:a16="http://schemas.microsoft.com/office/drawing/2014/main" id="{7041CCD8-F7BC-44C2-8BBD-6D427DE84308}"/>
               </a:ext>
             </a:extLst>
           </p:cNvPr>
@@ -6226,7 +6231,7 @@
           <p:cNvPr id="4" name="">
             <a:extLst xmlns:a="http://schemas.openxmlformats.org/drawingml/2006/main">
               <a:ext uri="{FF2B5EF4-FFF2-40B4-BE49-F238E27FC236}">
-                <a16:creationId xmlns:a16="http://schemas.microsoft.com/office/drawing/2014/main" id="{AA3451C5-36DE-4A9A-88CB-17791681818C}"/>
+                <a16:creationId xmlns:a16="http://schemas.microsoft.com/office/drawing/2014/main" id="{F9131D9B-3B74-45F0-8AD9-BD4366C28142}"/>
               </a:ext>
             </a:extLst>
           </p:cNvPr>
@@ -6283,7 +6288,7 @@
           <p:cNvPr id="5" name="">
             <a:extLst xmlns:a="http://schemas.openxmlformats.org/drawingml/2006/main">
               <a:ext uri="{FF2B5EF4-FFF2-40B4-BE49-F238E27FC236}">
-                <a16:creationId xmlns:a16="http://schemas.microsoft.com/office/drawing/2014/main" id="{7691DD94-3309-4E33-8A73-74B7DCB776FD}"/>
+                <a16:creationId xmlns:a16="http://schemas.microsoft.com/office/drawing/2014/main" id="{8341F950-39CC-464B-B83E-9CA28CF05933}"/>
               </a:ext>
             </a:extLst>
           </p:cNvPr>
@@ -6338,7 +6343,7 @@
     </p:spTree>
     <p:extLst>
       <p:ext uri="{BB962C8B-B14F-4D97-AF65-F5344CB8AC3E}">
-        <p14:creationId xmlns:p14="http://schemas.microsoft.com/office/powerpoint/2010/main" val="2044048616"/>
+        <p14:creationId xmlns:p14="http://schemas.microsoft.com/office/powerpoint/2010/main" val="1296179603"/>
       </p:ext>
     </p:extLst>
   </p:cSld>
@@ -6369,7 +6374,7 @@
           <p:cNvPr id="5" name="">
             <a:extLst xmlns:a="http://schemas.openxmlformats.org/drawingml/2006/main">
               <a:ext uri="{FF2B5EF4-FFF2-40B4-BE49-F238E27FC236}">
-                <a16:creationId xmlns:a16="http://schemas.microsoft.com/office/drawing/2014/main" id="{BEF5352D-7BC2-47D7-B52A-7190F2D6B660}"/>
+                <a16:creationId xmlns:a16="http://schemas.microsoft.com/office/drawing/2014/main" id="{2245BB31-6A0E-4E7A-B5D5-0A23717FDB4A}"/>
               </a:ext>
             </a:extLst>
           </p:cNvPr>
@@ -6819,7 +6824,7 @@
           <p:cNvPr id="3" name="">
             <a:extLst xmlns:a="http://schemas.openxmlformats.org/drawingml/2006/main">
               <a:ext uri="{FF2B5EF4-FFF2-40B4-BE49-F238E27FC236}">
-                <a16:creationId xmlns:a16="http://schemas.microsoft.com/office/drawing/2014/main" id="{7A5B1322-EED7-4812-8BCC-D7D0747C8F17}"/>
+                <a16:creationId xmlns:a16="http://schemas.microsoft.com/office/drawing/2014/main" id="{4A2CE053-B236-4FF9-9EB1-C9327EDDFD33}"/>
               </a:ext>
             </a:extLst>
           </p:cNvPr>
@@ -6876,7 +6881,7 @@
           <p:cNvPr id="4" name="">
             <a:extLst xmlns:a="http://schemas.openxmlformats.org/drawingml/2006/main">
               <a:ext uri="{FF2B5EF4-FFF2-40B4-BE49-F238E27FC236}">
-                <a16:creationId xmlns:a16="http://schemas.microsoft.com/office/drawing/2014/main" id="{05994885-E739-47A6-BAD9-3BF5486BE5EE}"/>
+                <a16:creationId xmlns:a16="http://schemas.microsoft.com/office/drawing/2014/main" id="{3674CE58-2CA9-4E3E-85DF-8A59B80FCB9E}"/>
               </a:ext>
             </a:extLst>
           </p:cNvPr>
@@ -6931,7 +6936,7 @@
     </p:spTree>
     <p:extLst>
       <p:ext uri="{BB962C8B-B14F-4D97-AF65-F5344CB8AC3E}">
-        <p14:creationId xmlns:p14="http://schemas.microsoft.com/office/powerpoint/2010/main" val="1370585606"/>
+        <p14:creationId xmlns:p14="http://schemas.microsoft.com/office/powerpoint/2010/main" val="1983249247"/>
       </p:ext>
     </p:extLst>
   </p:cSld>
@@ -6962,7 +6967,7 @@
           <p:cNvPr id="13" name="">
             <a:extLst xmlns:a="http://schemas.openxmlformats.org/drawingml/2006/main">
               <a:ext uri="{FF2B5EF4-FFF2-40B4-BE49-F238E27FC236}">
-                <a16:creationId xmlns:a16="http://schemas.microsoft.com/office/drawing/2014/main" id="{F1ABBB92-6F14-4F34-B67F-E15DE3DD3EEB}"/>
+                <a16:creationId xmlns:a16="http://schemas.microsoft.com/office/drawing/2014/main" id="{32C61579-A40A-4E25-8B14-A8D8F0D57093}"/>
               </a:ext>
             </a:extLst>
           </p:cNvPr>
@@ -7019,7 +7024,7 @@
           <p:cNvPr id="2" name="">
             <a:extLst xmlns:a="http://schemas.openxmlformats.org/drawingml/2006/main">
               <a:ext uri="{FF2B5EF4-FFF2-40B4-BE49-F238E27FC236}">
-                <a16:creationId xmlns:a16="http://schemas.microsoft.com/office/drawing/2014/main" id="{BFA28507-F2CD-4603-B05B-C669FD14F332}"/>
+                <a16:creationId xmlns:a16="http://schemas.microsoft.com/office/drawing/2014/main" id="{D1EE0D65-081D-4CB8-803D-C8E204B126A1}"/>
               </a:ext>
             </a:extLst>
           </p:cNvPr>
@@ -7076,7 +7081,7 @@
           <p:cNvPr id="3" name="">
             <a:extLst xmlns:a="http://schemas.openxmlformats.org/drawingml/2006/main">
               <a:ext uri="{FF2B5EF4-FFF2-40B4-BE49-F238E27FC236}">
-                <a16:creationId xmlns:a16="http://schemas.microsoft.com/office/drawing/2014/main" id="{3311C0F6-2315-4B65-8104-642814FC3E41}"/>
+                <a16:creationId xmlns:a16="http://schemas.microsoft.com/office/drawing/2014/main" id="{7443D1F8-A507-448E-B72D-A3131FED41A4}"/>
               </a:ext>
             </a:extLst>
           </p:cNvPr>
@@ -7133,7 +7138,7 @@
           <p:cNvPr id="4" name="">
             <a:extLst xmlns:a="http://schemas.openxmlformats.org/drawingml/2006/main">
               <a:ext uri="{FF2B5EF4-FFF2-40B4-BE49-F238E27FC236}">
-                <a16:creationId xmlns:a16="http://schemas.microsoft.com/office/drawing/2014/main" id="{6AF7427C-96E6-42BD-A454-342593120709}"/>
+                <a16:creationId xmlns:a16="http://schemas.microsoft.com/office/drawing/2014/main" id="{71CC6CB2-C13F-4A4C-A710-FC9F8A66F77E}"/>
               </a:ext>
             </a:extLst>
           </p:cNvPr>
@@ -7190,7 +7195,7 @@
           <p:cNvPr id="5" name="">
             <a:extLst xmlns:a="http://schemas.openxmlformats.org/drawingml/2006/main">
               <a:ext uri="{FF2B5EF4-FFF2-40B4-BE49-F238E27FC236}">
-                <a16:creationId xmlns:a16="http://schemas.microsoft.com/office/drawing/2014/main" id="{2C3BDEC9-126A-4049-A4D6-AC1919965C3F}"/>
+                <a16:creationId xmlns:a16="http://schemas.microsoft.com/office/drawing/2014/main" id="{DFA66B08-4B36-4777-A17B-F6B0435D76E5}"/>
               </a:ext>
             </a:extLst>
           </p:cNvPr>
@@ -7247,7 +7252,7 @@
           <p:cNvPr id="6" name="">
             <a:extLst xmlns:a="http://schemas.openxmlformats.org/drawingml/2006/main">
               <a:ext uri="{FF2B5EF4-FFF2-40B4-BE49-F238E27FC236}">
-                <a16:creationId xmlns:a16="http://schemas.microsoft.com/office/drawing/2014/main" id="{B13751B3-644B-4B3F-A808-23E7B25928AE}"/>
+                <a16:creationId xmlns:a16="http://schemas.microsoft.com/office/drawing/2014/main" id="{54130756-47B0-44B5-BE86-7BF58B6880CF}"/>
               </a:ext>
             </a:extLst>
           </p:cNvPr>
@@ -7304,7 +7309,7 @@
           <p:cNvPr id="7" name="">
             <a:extLst xmlns:a="http://schemas.openxmlformats.org/drawingml/2006/main">
               <a:ext uri="{FF2B5EF4-FFF2-40B4-BE49-F238E27FC236}">
-                <a16:creationId xmlns:a16="http://schemas.microsoft.com/office/drawing/2014/main" id="{EDDD3E07-4803-49EE-8F23-CA3BBCF813C7}"/>
+                <a16:creationId xmlns:a16="http://schemas.microsoft.com/office/drawing/2014/main" id="{DE600BD3-A3A2-4F38-90E4-6A5A42AD7C93}"/>
               </a:ext>
             </a:extLst>
           </p:cNvPr>
@@ -7361,7 +7366,7 @@
           <p:cNvPr id="8" name="">
             <a:extLst xmlns:a="http://schemas.openxmlformats.org/drawingml/2006/main">
               <a:ext uri="{FF2B5EF4-FFF2-40B4-BE49-F238E27FC236}">
-                <a16:creationId xmlns:a16="http://schemas.microsoft.com/office/drawing/2014/main" id="{C9768FE6-972B-43A1-853B-BFCB456E3DF6}"/>
+                <a16:creationId xmlns:a16="http://schemas.microsoft.com/office/drawing/2014/main" id="{7115D6AD-2BFE-4CBA-B3B7-4B02CDD203A9}"/>
               </a:ext>
             </a:extLst>
           </p:cNvPr>
@@ -7418,7 +7423,7 @@
           <p:cNvPr id="9" name="">
             <a:extLst xmlns:a="http://schemas.openxmlformats.org/drawingml/2006/main">
               <a:ext uri="{FF2B5EF4-FFF2-40B4-BE49-F238E27FC236}">
-                <a16:creationId xmlns:a16="http://schemas.microsoft.com/office/drawing/2014/main" id="{572B29D0-8020-4DE1-9CB9-DC2A40BB1BE5}"/>
+                <a16:creationId xmlns:a16="http://schemas.microsoft.com/office/drawing/2014/main" id="{BFBF867B-281A-4116-B0D3-D9E8CC3D88DF}"/>
               </a:ext>
             </a:extLst>
           </p:cNvPr>
@@ -7475,7 +7480,7 @@
           <p:cNvPr id="10" name="">
             <a:extLst xmlns:a="http://schemas.openxmlformats.org/drawingml/2006/main">
               <a:ext uri="{FF2B5EF4-FFF2-40B4-BE49-F238E27FC236}">
-                <a16:creationId xmlns:a16="http://schemas.microsoft.com/office/drawing/2014/main" id="{3707D953-0308-475D-8A94-3A9F78C5D33E}"/>
+                <a16:creationId xmlns:a16="http://schemas.microsoft.com/office/drawing/2014/main" id="{F886F968-8E40-4AB5-946D-E2D244162C7A}"/>
               </a:ext>
             </a:extLst>
           </p:cNvPr>
@@ -7532,7 +7537,7 @@
           <p:cNvPr id="11" name="">
             <a:extLst xmlns:a="http://schemas.openxmlformats.org/drawingml/2006/main">
               <a:ext uri="{FF2B5EF4-FFF2-40B4-BE49-F238E27FC236}">
-                <a16:creationId xmlns:a16="http://schemas.microsoft.com/office/drawing/2014/main" id="{EC1E8A4D-322E-491D-8580-95BF09677A36}"/>
+                <a16:creationId xmlns:a16="http://schemas.microsoft.com/office/drawing/2014/main" id="{35385B37-9318-4AC1-AC6E-EA81A40BFA7D}"/>
               </a:ext>
             </a:extLst>
           </p:cNvPr>
@@ -7589,7 +7594,7 @@
           <p:cNvPr id="12" name="">
             <a:extLst xmlns:a="http://schemas.openxmlformats.org/drawingml/2006/main">
               <a:ext uri="{FF2B5EF4-FFF2-40B4-BE49-F238E27FC236}">
-                <a16:creationId xmlns:a16="http://schemas.microsoft.com/office/drawing/2014/main" id="{3CF4F008-FA76-4C60-A252-21B409ECA1C0}"/>
+                <a16:creationId xmlns:a16="http://schemas.microsoft.com/office/drawing/2014/main" id="{D1E6F8A3-7B99-4015-A397-23C2E5FC81FB}"/>
               </a:ext>
             </a:extLst>
           </p:cNvPr>
@@ -7644,7 +7649,7 @@
     </p:spTree>
     <p:extLst>
       <p:ext uri="{BB962C8B-B14F-4D97-AF65-F5344CB8AC3E}">
-        <p14:creationId xmlns:p14="http://schemas.microsoft.com/office/powerpoint/2010/main" val="170078020"/>
+        <p14:creationId xmlns:p14="http://schemas.microsoft.com/office/powerpoint/2010/main" val="1217272039"/>
       </p:ext>
     </p:extLst>
   </p:cSld>
@@ -7675,7 +7680,7 @@
           <p:cNvPr id="14" name="">
             <a:extLst xmlns:a="http://schemas.openxmlformats.org/drawingml/2006/main">
               <a:ext uri="{FF2B5EF4-FFF2-40B4-BE49-F238E27FC236}">
-                <a16:creationId xmlns:a16="http://schemas.microsoft.com/office/drawing/2014/main" id="{B3BE240C-951A-476C-99C3-F40BF27F764D}"/>
+                <a16:creationId xmlns:a16="http://schemas.microsoft.com/office/drawing/2014/main" id="{B935ABA5-EED9-4C1D-BC6D-D157629710A3}"/>
               </a:ext>
             </a:extLst>
           </p:cNvPr>
@@ -7732,7 +7737,7 @@
           <p:cNvPr id="2" name="">
             <a:extLst xmlns:a="http://schemas.openxmlformats.org/drawingml/2006/main">
               <a:ext uri="{FF2B5EF4-FFF2-40B4-BE49-F238E27FC236}">
-                <a16:creationId xmlns:a16="http://schemas.microsoft.com/office/drawing/2014/main" id="{91DB3DC1-35DA-4F67-8FA6-113CD240164D}"/>
+                <a16:creationId xmlns:a16="http://schemas.microsoft.com/office/drawing/2014/main" id="{F4468F7E-AD0E-495D-B8D8-776B6C58F099}"/>
               </a:ext>
             </a:extLst>
           </p:cNvPr>
@@ -7789,7 +7794,7 @@
           <p:cNvPr id="3" name="">
             <a:extLst xmlns:a="http://schemas.openxmlformats.org/drawingml/2006/main">
               <a:ext uri="{FF2B5EF4-FFF2-40B4-BE49-F238E27FC236}">
-                <a16:creationId xmlns:a16="http://schemas.microsoft.com/office/drawing/2014/main" id="{B830685C-8486-47F6-814B-75A59AC144C4}"/>
+                <a16:creationId xmlns:a16="http://schemas.microsoft.com/office/drawing/2014/main" id="{5532FE02-1277-4E46-8ADA-7BAE856337DF}"/>
               </a:ext>
             </a:extLst>
           </p:cNvPr>
@@ -7846,7 +7851,7 @@
           <p:cNvPr id="4" name="">
             <a:extLst xmlns:a="http://schemas.openxmlformats.org/drawingml/2006/main">
               <a:ext uri="{FF2B5EF4-FFF2-40B4-BE49-F238E27FC236}">
-                <a16:creationId xmlns:a16="http://schemas.microsoft.com/office/drawing/2014/main" id="{630377CB-1BA4-4369-A8A9-C99D3114AEDB}"/>
+                <a16:creationId xmlns:a16="http://schemas.microsoft.com/office/drawing/2014/main" id="{9C7063AE-5B84-45DB-85BF-BD1DE309331D}"/>
               </a:ext>
             </a:extLst>
           </p:cNvPr>
@@ -7903,7 +7908,7 @@
           <p:cNvPr id="5" name="">
             <a:extLst xmlns:a="http://schemas.openxmlformats.org/drawingml/2006/main">
               <a:ext uri="{FF2B5EF4-FFF2-40B4-BE49-F238E27FC236}">
-                <a16:creationId xmlns:a16="http://schemas.microsoft.com/office/drawing/2014/main" id="{9BF71CEF-A5CA-4BE4-8EB3-2A5CB5FC122B}"/>
+                <a16:creationId xmlns:a16="http://schemas.microsoft.com/office/drawing/2014/main" id="{87A3315A-DC75-4FF3-92F7-2297E0B7C5C3}"/>
               </a:ext>
             </a:extLst>
           </p:cNvPr>
@@ -7960,7 +7965,7 @@
           <p:cNvPr id="6" name="">
             <a:extLst xmlns:a="http://schemas.openxmlformats.org/drawingml/2006/main">
               <a:ext uri="{FF2B5EF4-FFF2-40B4-BE49-F238E27FC236}">
-                <a16:creationId xmlns:a16="http://schemas.microsoft.com/office/drawing/2014/main" id="{326EFBF8-C0A7-4C1B-9871-89A4CBA73D57}"/>
+                <a16:creationId xmlns:a16="http://schemas.microsoft.com/office/drawing/2014/main" id="{421377B2-E4EF-4ED7-9BDD-D201EB28583F}"/>
               </a:ext>
             </a:extLst>
           </p:cNvPr>
@@ -8017,7 +8022,7 @@
           <p:cNvPr id="7" name="">
             <a:extLst xmlns:a="http://schemas.openxmlformats.org/drawingml/2006/main">
               <a:ext uri="{FF2B5EF4-FFF2-40B4-BE49-F238E27FC236}">
-                <a16:creationId xmlns:a16="http://schemas.microsoft.com/office/drawing/2014/main" id="{3C86EA36-CBBD-44DF-8FF9-704CC8C40E09}"/>
+                <a16:creationId xmlns:a16="http://schemas.microsoft.com/office/drawing/2014/main" id="{BA5A58D0-0DFA-4484-8611-23C4A10059F0}"/>
               </a:ext>
             </a:extLst>
           </p:cNvPr>
@@ -8074,7 +8079,7 @@
           <p:cNvPr id="8" name="">
             <a:extLst xmlns:a="http://schemas.openxmlformats.org/drawingml/2006/main">
               <a:ext uri="{FF2B5EF4-FFF2-40B4-BE49-F238E27FC236}">
-                <a16:creationId xmlns:a16="http://schemas.microsoft.com/office/drawing/2014/main" id="{DAE96E15-170F-49CA-A030-B78C3F218330}"/>
+                <a16:creationId xmlns:a16="http://schemas.microsoft.com/office/drawing/2014/main" id="{522566C5-0397-4238-86A7-C6F3346778D2}"/>
               </a:ext>
             </a:extLst>
           </p:cNvPr>
@@ -8131,7 +8136,7 @@
           <p:cNvPr id="9" name="">
             <a:extLst xmlns:a="http://schemas.openxmlformats.org/drawingml/2006/main">
               <a:ext uri="{FF2B5EF4-FFF2-40B4-BE49-F238E27FC236}">
-                <a16:creationId xmlns:a16="http://schemas.microsoft.com/office/drawing/2014/main" id="{51D20C19-2425-4D3B-8FC2-094517AAC6E4}"/>
+                <a16:creationId xmlns:a16="http://schemas.microsoft.com/office/drawing/2014/main" id="{81099397-3674-4CB3-A9B2-BCB8E1F9AE12}"/>
               </a:ext>
             </a:extLst>
           </p:cNvPr>
@@ -8188,7 +8193,7 @@
           <p:cNvPr id="10" name="">
             <a:extLst xmlns:a="http://schemas.openxmlformats.org/drawingml/2006/main">
               <a:ext uri="{FF2B5EF4-FFF2-40B4-BE49-F238E27FC236}">
-                <a16:creationId xmlns:a16="http://schemas.microsoft.com/office/drawing/2014/main" id="{38E617D7-01A1-4409-86D6-4C6752AA0954}"/>
+                <a16:creationId xmlns:a16="http://schemas.microsoft.com/office/drawing/2014/main" id="{CF7BD66D-014C-4DC7-AAF4-864CC2AE0EBC}"/>
               </a:ext>
             </a:extLst>
           </p:cNvPr>
@@ -8245,7 +8250,7 @@
           <p:cNvPr id="11" name="">
             <a:extLst xmlns:a="http://schemas.openxmlformats.org/drawingml/2006/main">
               <a:ext uri="{FF2B5EF4-FFF2-40B4-BE49-F238E27FC236}">
-                <a16:creationId xmlns:a16="http://schemas.microsoft.com/office/drawing/2014/main" id="{81C90AA7-77C1-46BB-96F0-E258C9E02C33}"/>
+                <a16:creationId xmlns:a16="http://schemas.microsoft.com/office/drawing/2014/main" id="{A06138D9-B679-4746-ACC5-78B2E28CA16E}"/>
               </a:ext>
             </a:extLst>
           </p:cNvPr>
@@ -8302,7 +8307,7 @@
           <p:cNvPr id="12" name="">
             <a:extLst xmlns:a="http://schemas.openxmlformats.org/drawingml/2006/main">
               <a:ext uri="{FF2B5EF4-FFF2-40B4-BE49-F238E27FC236}">
-                <a16:creationId xmlns:a16="http://schemas.microsoft.com/office/drawing/2014/main" id="{D7FEF235-BBF0-4171-8FE2-71D737097ADF}"/>
+                <a16:creationId xmlns:a16="http://schemas.microsoft.com/office/drawing/2014/main" id="{A3A09B8C-67CD-4717-A8F2-2B6680907E6B}"/>
               </a:ext>
             </a:extLst>
           </p:cNvPr>
@@ -8359,7 +8364,7 @@
           <p:cNvPr id="13" name="">
             <a:extLst xmlns:a="http://schemas.openxmlformats.org/drawingml/2006/main">
               <a:ext uri="{FF2B5EF4-FFF2-40B4-BE49-F238E27FC236}">
-                <a16:creationId xmlns:a16="http://schemas.microsoft.com/office/drawing/2014/main" id="{220A047A-D94A-4C55-88AB-F54EA811B8BE}"/>
+                <a16:creationId xmlns:a16="http://schemas.microsoft.com/office/drawing/2014/main" id="{2B30FC58-8E58-4FE4-824D-0D38C0EADD26}"/>
               </a:ext>
             </a:extLst>
           </p:cNvPr>
@@ -8414,7 +8419,7 @@
     </p:spTree>
     <p:extLst>
       <p:ext uri="{BB962C8B-B14F-4D97-AF65-F5344CB8AC3E}">
-        <p14:creationId xmlns:p14="http://schemas.microsoft.com/office/powerpoint/2010/main" val="479440299"/>
+        <p14:creationId xmlns:p14="http://schemas.microsoft.com/office/powerpoint/2010/main" val="1735217956"/>
       </p:ext>
     </p:extLst>
   </p:cSld>
@@ -8445,7 +8450,7 @@
           <p:cNvPr id="8" name="">
             <a:extLst xmlns:a="http://schemas.openxmlformats.org/drawingml/2006/main">
               <a:ext uri="{FF2B5EF4-FFF2-40B4-BE49-F238E27FC236}">
-                <a16:creationId xmlns:a16="http://schemas.microsoft.com/office/drawing/2014/main" id="{AFAEEF6A-2A73-41B8-ABC8-6A41F3FCCA4B}"/>
+                <a16:creationId xmlns:a16="http://schemas.microsoft.com/office/drawing/2014/main" id="{62BA3558-EE24-4143-9D87-203E0A3CAF06}"/>
               </a:ext>
             </a:extLst>
           </p:cNvPr>
@@ -8502,7 +8507,7 @@
           <p:cNvPr id="2" name="">
             <a:extLst xmlns:a="http://schemas.openxmlformats.org/drawingml/2006/main">
               <a:ext uri="{FF2B5EF4-FFF2-40B4-BE49-F238E27FC236}">
-                <a16:creationId xmlns:a16="http://schemas.microsoft.com/office/drawing/2014/main" id="{7C28F2C3-911D-420C-806A-8734904B39E7}"/>
+                <a16:creationId xmlns:a16="http://schemas.microsoft.com/office/drawing/2014/main" id="{E6F1EDA6-BF62-487F-9907-47505AEF62A9}"/>
               </a:ext>
             </a:extLst>
           </p:cNvPr>
@@ -8559,7 +8564,7 @@
           <p:cNvPr id="3" name="">
             <a:extLst xmlns:a="http://schemas.openxmlformats.org/drawingml/2006/main">
               <a:ext uri="{FF2B5EF4-FFF2-40B4-BE49-F238E27FC236}">
-                <a16:creationId xmlns:a16="http://schemas.microsoft.com/office/drawing/2014/main" id="{CC04412F-56A3-4E7E-87D4-E4ABB61F8DF6}"/>
+                <a16:creationId xmlns:a16="http://schemas.microsoft.com/office/drawing/2014/main" id="{5470237F-A7EB-46C0-A28E-FB12AA1A4C19}"/>
               </a:ext>
             </a:extLst>
           </p:cNvPr>
@@ -8672,7 +8677,7 @@
           <p:cNvPr id="4" name="">
             <a:extLst xmlns:a="http://schemas.openxmlformats.org/drawingml/2006/main">
               <a:ext uri="{FF2B5EF4-FFF2-40B4-BE49-F238E27FC236}">
-                <a16:creationId xmlns:a16="http://schemas.microsoft.com/office/drawing/2014/main" id="{F2DD80DD-4ED9-4F94-93F1-2F6079A3F70A}"/>
+                <a16:creationId xmlns:a16="http://schemas.microsoft.com/office/drawing/2014/main" id="{179F7E26-F453-4884-BF80-14575EEF3F64}"/>
               </a:ext>
             </a:extLst>
           </p:cNvPr>
@@ -8729,7 +8734,7 @@
           <p:cNvPr id="5" name="">
             <a:extLst xmlns:a="http://schemas.openxmlformats.org/drawingml/2006/main">
               <a:ext uri="{FF2B5EF4-FFF2-40B4-BE49-F238E27FC236}">
-                <a16:creationId xmlns:a16="http://schemas.microsoft.com/office/drawing/2014/main" id="{A68E98F0-E143-46D0-B9FF-0451061FD0F7}"/>
+                <a16:creationId xmlns:a16="http://schemas.microsoft.com/office/drawing/2014/main" id="{8898033E-AC53-44CC-9AFB-321C0D7EC6CA}"/>
               </a:ext>
             </a:extLst>
           </p:cNvPr>
@@ -8842,7 +8847,7 @@
           <p:cNvPr id="6" name="">
             <a:extLst xmlns:a="http://schemas.openxmlformats.org/drawingml/2006/main">
               <a:ext uri="{FF2B5EF4-FFF2-40B4-BE49-F238E27FC236}">
-                <a16:creationId xmlns:a16="http://schemas.microsoft.com/office/drawing/2014/main" id="{A762CE98-FA2F-4A5A-A0D6-9253100E429B}"/>
+                <a16:creationId xmlns:a16="http://schemas.microsoft.com/office/drawing/2014/main" id="{2EE2EEEC-8562-4E02-8D97-041EFBB31273}"/>
               </a:ext>
             </a:extLst>
           </p:cNvPr>
@@ -8899,7 +8904,7 @@
           <p:cNvPr id="7" name="">
             <a:extLst xmlns:a="http://schemas.openxmlformats.org/drawingml/2006/main">
               <a:ext uri="{FF2B5EF4-FFF2-40B4-BE49-F238E27FC236}">
-                <a16:creationId xmlns:a16="http://schemas.microsoft.com/office/drawing/2014/main" id="{318BB09E-360A-477F-971D-D3327A8214EE}"/>
+                <a16:creationId xmlns:a16="http://schemas.microsoft.com/office/drawing/2014/main" id="{FC0D78A9-F404-4507-81CC-1A6C15B323E1}"/>
               </a:ext>
             </a:extLst>
           </p:cNvPr>
@@ -8954,7 +8959,7 @@
     </p:spTree>
     <p:extLst>
       <p:ext uri="{BB962C8B-B14F-4D97-AF65-F5344CB8AC3E}">
-        <p14:creationId xmlns:p14="http://schemas.microsoft.com/office/powerpoint/2010/main" val="1290052136"/>
+        <p14:creationId xmlns:p14="http://schemas.microsoft.com/office/powerpoint/2010/main" val="477332241"/>
       </p:ext>
     </p:extLst>
   </p:cSld>
@@ -8985,7 +8990,7 @@
           <p:cNvPr id="5" name="">
             <a:extLst xmlns:a="http://schemas.openxmlformats.org/drawingml/2006/main">
               <a:ext uri="{FF2B5EF4-FFF2-40B4-BE49-F238E27FC236}">
-                <a16:creationId xmlns:a16="http://schemas.microsoft.com/office/drawing/2014/main" id="{7A4B6D1A-6655-4953-9806-9AFF9090D3FC}"/>
+                <a16:creationId xmlns:a16="http://schemas.microsoft.com/office/drawing/2014/main" id="{FAA76444-30EC-4D7C-8CCB-9D7CB02D4B97}"/>
               </a:ext>
             </a:extLst>
           </p:cNvPr>
@@ -9042,7 +9047,7 @@
           <p:cNvPr id="2" name="">
             <a:extLst xmlns:a="http://schemas.openxmlformats.org/drawingml/2006/main">
               <a:ext uri="{FF2B5EF4-FFF2-40B4-BE49-F238E27FC236}">
-                <a16:creationId xmlns:a16="http://schemas.microsoft.com/office/drawing/2014/main" id="{4E7A8CBF-FA00-4A0D-8ECA-09472D31F25A}"/>
+                <a16:creationId xmlns:a16="http://schemas.microsoft.com/office/drawing/2014/main" id="{6B5212F6-FA6C-4CC8-A311-16ECF38C8AB3}"/>
               </a:ext>
             </a:extLst>
           </p:cNvPr>
@@ -9122,7 +9127,7 @@
           <p:cNvPr id="3" name="">
             <a:extLst xmlns:a="http://schemas.openxmlformats.org/drawingml/2006/main">
               <a:ext uri="{FF2B5EF4-FFF2-40B4-BE49-F238E27FC236}">
-                <a16:creationId xmlns:a16="http://schemas.microsoft.com/office/drawing/2014/main" id="{F9B5D1F8-F423-4A46-A051-1BD061E5C6CC}"/>
+                <a16:creationId xmlns:a16="http://schemas.microsoft.com/office/drawing/2014/main" id="{DBE3AB91-DFCA-4B51-ACD7-F44D2BDB5325}"/>
               </a:ext>
             </a:extLst>
           </p:cNvPr>
@@ -9179,7 +9184,7 @@
           <p:cNvPr id="4" name="">
             <a:extLst xmlns:a="http://schemas.openxmlformats.org/drawingml/2006/main">
               <a:ext uri="{FF2B5EF4-FFF2-40B4-BE49-F238E27FC236}">
-                <a16:creationId xmlns:a16="http://schemas.microsoft.com/office/drawing/2014/main" id="{E0C62FB3-2DD7-48C6-AEAB-0FF8CD7FCFDD}"/>
+                <a16:creationId xmlns:a16="http://schemas.microsoft.com/office/drawing/2014/main" id="{27AD5E45-EB16-43FF-B019-7C418F50FD8C}"/>
               </a:ext>
             </a:extLst>
           </p:cNvPr>
@@ -9234,7 +9239,7 @@
     </p:spTree>
     <p:extLst>
       <p:ext uri="{BB962C8B-B14F-4D97-AF65-F5344CB8AC3E}">
-        <p14:creationId xmlns:p14="http://schemas.microsoft.com/office/powerpoint/2010/main" val="2059242068"/>
+        <p14:creationId xmlns:p14="http://schemas.microsoft.com/office/powerpoint/2010/main" val="993519743"/>
       </p:ext>
     </p:extLst>
   </p:cSld>
@@ -9265,7 +9270,7 @@
           <p:cNvPr id="8" name="">
             <a:extLst xmlns:a="http://schemas.openxmlformats.org/drawingml/2006/main">
               <a:ext uri="{FF2B5EF4-FFF2-40B4-BE49-F238E27FC236}">
-                <a16:creationId xmlns:a16="http://schemas.microsoft.com/office/drawing/2014/main" id="{02FD45AC-C894-4642-90ED-F42C62F35F44}"/>
+                <a16:creationId xmlns:a16="http://schemas.microsoft.com/office/drawing/2014/main" id="{6755A47D-B588-4E75-88E2-734A9B69B044}"/>
               </a:ext>
             </a:extLst>
           </p:cNvPr>
@@ -9322,7 +9327,7 @@
           <p:cNvPr id="2" name="">
             <a:extLst xmlns:a="http://schemas.openxmlformats.org/drawingml/2006/main">
               <a:ext uri="{FF2B5EF4-FFF2-40B4-BE49-F238E27FC236}">
-                <a16:creationId xmlns:a16="http://schemas.microsoft.com/office/drawing/2014/main" id="{53E69388-C25B-4A5A-B6F5-C6C5BA3F6A71}"/>
+                <a16:creationId xmlns:a16="http://schemas.microsoft.com/office/drawing/2014/main" id="{9789AA7F-C59A-4A4C-A92D-2F505A0DAC7E}"/>
               </a:ext>
             </a:extLst>
           </p:cNvPr>
@@ -9379,7 +9384,7 @@
           <p:cNvPr id="3" name="">
             <a:extLst xmlns:a="http://schemas.openxmlformats.org/drawingml/2006/main">
               <a:ext uri="{FF2B5EF4-FFF2-40B4-BE49-F238E27FC236}">
-                <a16:creationId xmlns:a16="http://schemas.microsoft.com/office/drawing/2014/main" id="{3587D7C1-3D55-411F-8E0E-AA54CA48F6C5}"/>
+                <a16:creationId xmlns:a16="http://schemas.microsoft.com/office/drawing/2014/main" id="{BBA39AFB-56B8-4388-8474-303B86CD3EEB}"/>
               </a:ext>
             </a:extLst>
           </p:cNvPr>
@@ -9505,7 +9510,7 @@
           <p:cNvPr id="4" name="">
             <a:extLst xmlns:a="http://schemas.openxmlformats.org/drawingml/2006/main">
               <a:ext uri="{FF2B5EF4-FFF2-40B4-BE49-F238E27FC236}">
-                <a16:creationId xmlns:a16="http://schemas.microsoft.com/office/drawing/2014/main" id="{EDB0B99C-D79E-47C3-B231-1A6BB963111F}"/>
+                <a16:creationId xmlns:a16="http://schemas.microsoft.com/office/drawing/2014/main" id="{E15C97AA-CCEE-41EA-8B80-17BDCC9D3A0D}"/>
               </a:ext>
             </a:extLst>
           </p:cNvPr>
@@ -9562,7 +9567,7 @@
           <p:cNvPr id="5" name="">
             <a:extLst xmlns:a="http://schemas.openxmlformats.org/drawingml/2006/main">
               <a:ext uri="{FF2B5EF4-FFF2-40B4-BE49-F238E27FC236}">
-                <a16:creationId xmlns:a16="http://schemas.microsoft.com/office/drawing/2014/main" id="{85034A45-9719-4E08-8EFD-EA4442AAC7A3}"/>
+                <a16:creationId xmlns:a16="http://schemas.microsoft.com/office/drawing/2014/main" id="{01F5741D-24BF-4D82-8150-2B40EB88E308}"/>
               </a:ext>
             </a:extLst>
           </p:cNvPr>
@@ -9711,7 +9716,7 @@
           <p:cNvPr id="6" name="">
             <a:extLst xmlns:a="http://schemas.openxmlformats.org/drawingml/2006/main">
               <a:ext uri="{FF2B5EF4-FFF2-40B4-BE49-F238E27FC236}">
-                <a16:creationId xmlns:a16="http://schemas.microsoft.com/office/drawing/2014/main" id="{BB1FDF1A-C350-4D23-B678-E171360E6E72}"/>
+                <a16:creationId xmlns:a16="http://schemas.microsoft.com/office/drawing/2014/main" id="{4EAD27F4-C7D6-40D5-939D-8809AD624C30}"/>
               </a:ext>
             </a:extLst>
           </p:cNvPr>
@@ -9768,7 +9773,7 @@
           <p:cNvPr id="7" name="">
             <a:extLst xmlns:a="http://schemas.openxmlformats.org/drawingml/2006/main">
               <a:ext uri="{FF2B5EF4-FFF2-40B4-BE49-F238E27FC236}">
-                <a16:creationId xmlns:a16="http://schemas.microsoft.com/office/drawing/2014/main" id="{2B7FEDF2-2B87-4E63-8176-49D51EF01B18}"/>
+                <a16:creationId xmlns:a16="http://schemas.microsoft.com/office/drawing/2014/main" id="{90E2E595-56FB-494C-A776-06FAA79E0C8E}"/>
               </a:ext>
             </a:extLst>
           </p:cNvPr>
@@ -9823,7 +9828,7 @@
     </p:spTree>
     <p:extLst>
       <p:ext uri="{BB962C8B-B14F-4D97-AF65-F5344CB8AC3E}">
-        <p14:creationId xmlns:p14="http://schemas.microsoft.com/office/powerpoint/2010/main" val="1894052492"/>
+        <p14:creationId xmlns:p14="http://schemas.microsoft.com/office/powerpoint/2010/main" val="1266439895"/>
       </p:ext>
     </p:extLst>
   </p:cSld>
@@ -9851,10 +9856,10 @@
       </p:grpSpPr>
       <p:sp>
         <p:nvSpPr>
-          <p:cNvPr id="8" name="">
+          <p:cNvPr id="11" name="">
             <a:extLst xmlns:a="http://schemas.openxmlformats.org/drawingml/2006/main">
               <a:ext uri="{FF2B5EF4-FFF2-40B4-BE49-F238E27FC236}">
-                <a16:creationId xmlns:a16="http://schemas.microsoft.com/office/drawing/2014/main" id="{49AA7963-6485-44F8-BBE3-BC024814C539}"/>
+                <a16:creationId xmlns:a16="http://schemas.microsoft.com/office/drawing/2014/main" id="{45DE3EA8-DF84-4F37-BC44-DC15CF68B8FF}"/>
               </a:ext>
             </a:extLst>
           </p:cNvPr>
@@ -9911,7 +9916,7 @@
           <p:cNvPr id="2" name="">
             <a:extLst xmlns:a="http://schemas.openxmlformats.org/drawingml/2006/main">
               <a:ext uri="{FF2B5EF4-FFF2-40B4-BE49-F238E27FC236}">
-                <a16:creationId xmlns:a16="http://schemas.microsoft.com/office/drawing/2014/main" id="{5CE57702-5772-4EE1-84DA-6E2B71A74E64}"/>
+                <a16:creationId xmlns:a16="http://schemas.microsoft.com/office/drawing/2014/main" id="{6074A5C6-3D4C-4CD4-A9EB-D0F5C1971DB7}"/>
               </a:ext>
             </a:extLst>
           </p:cNvPr>
@@ -9968,7 +9973,7 @@
           <p:cNvPr id="3" name="">
             <a:extLst xmlns:a="http://schemas.openxmlformats.org/drawingml/2006/main">
               <a:ext uri="{FF2B5EF4-FFF2-40B4-BE49-F238E27FC236}">
-                <a16:creationId xmlns:a16="http://schemas.microsoft.com/office/drawing/2014/main" id="{FFED4D3F-A254-4DCD-86AE-3230776273E0}"/>
+                <a16:creationId xmlns:a16="http://schemas.microsoft.com/office/drawing/2014/main" id="{A6383242-94B0-42B5-B453-4EBB7FE5708A}"/>
               </a:ext>
             </a:extLst>
           </p:cNvPr>
@@ -10053,7 +10058,7 @@
           <p:cNvPr id="4" name="">
             <a:extLst xmlns:a="http://schemas.openxmlformats.org/drawingml/2006/main">
               <a:ext uri="{FF2B5EF4-FFF2-40B4-BE49-F238E27FC236}">
-                <a16:creationId xmlns:a16="http://schemas.microsoft.com/office/drawing/2014/main" id="{290401CC-F970-48CC-AF6C-7A970E6B0FF1}"/>
+                <a16:creationId xmlns:a16="http://schemas.microsoft.com/office/drawing/2014/main" id="{E5486AFC-0888-4A86-9F94-45DA83C9C4A7}"/>
               </a:ext>
             </a:extLst>
           </p:cNvPr>
@@ -10110,7 +10115,7 @@
           <p:cNvPr id="5" name="">
             <a:extLst xmlns:a="http://schemas.openxmlformats.org/drawingml/2006/main">
               <a:ext uri="{FF2B5EF4-FFF2-40B4-BE49-F238E27FC236}">
-                <a16:creationId xmlns:a16="http://schemas.microsoft.com/office/drawing/2014/main" id="{8349F0F5-3EDA-4AE0-A058-F25BCA019FB2}"/>
+                <a16:creationId xmlns:a16="http://schemas.microsoft.com/office/drawing/2014/main" id="{9AEF0CFB-8CB9-4DF9-81A1-467F63477AAE}"/>
               </a:ext>
             </a:extLst>
           </p:cNvPr>
@@ -10241,12 +10246,173 @@
           </a:p>
         </p:txBody>
       </p:sp>
-      <p:sp>
-        <p:nvSpPr>
-          <p:cNvPr id="6" name="">
+      <p:pic>
+        <p:nvPicPr>
+          <p:cNvPr id="16" name=""/>
+          <p:cNvPicPr>
+            <a:picLocks xmlns:a="http://schemas.openxmlformats.org/drawingml/2006/main" noChangeAspect="1"/>
+          </p:cNvPicPr>
+          <p:nvPr/>
+        </p:nvPicPr>
+        <p:blipFill>
+          <a:blip xmlns:r="http://schemas.openxmlformats.org/officeDocument/2006/relationships" xmlns:a="http://schemas.openxmlformats.org/drawingml/2006/main" r:embed="R1beb9c107dda4f8a"/>
+          <a:stretch xmlns:a="http://schemas.openxmlformats.org/drawingml/2006/main"/>
+        </p:blipFill>
+        <p:spPr>
+          <a:xfrm xmlns:a="http://schemas.openxmlformats.org/drawingml/2006/main">
+            <a:off x="609600" y="3695700"/>
+            <a:ext cx="2133600" cy="2133600"/>
+          </a:xfrm>
+          <a:prstGeom xmlns:a="http://schemas.openxmlformats.org/drawingml/2006/main" prst="rect">
+            <a:avLst/>
+          </a:prstGeom>
+        </p:spPr>
+      </p:pic>
+      <p:sp>
+        <p:nvSpPr>
+          <p:cNvPr id="7" name="">
             <a:extLst xmlns:a="http://schemas.openxmlformats.org/drawingml/2006/main">
               <a:ext uri="{FF2B5EF4-FFF2-40B4-BE49-F238E27FC236}">
-                <a16:creationId xmlns:a16="http://schemas.microsoft.com/office/drawing/2014/main" id="{A8087032-A0B9-4293-AD2D-D49F83A3C20B}"/>
+                <a16:creationId xmlns:a16="http://schemas.microsoft.com/office/drawing/2014/main" id="{B1051AD5-D2AC-484A-8A6A-67FF0D30FBB5}"/>
+              </a:ext>
+            </a:extLst>
+          </p:cNvPr>
+          <p:cNvSpPr>
+            <a:spLocks xmlns:a="http://schemas.openxmlformats.org/drawingml/2006/main" noGrp="1"/>
+          </p:cNvSpPr>
+          <p:nvPr/>
+        </p:nvSpPr>
+        <p:spPr>
+          <a:xfrm xmlns:a="http://schemas.openxmlformats.org/drawingml/2006/main">
+            <a:off x="2952750" y="3905250"/>
+            <a:ext cx="3429000" cy="438150"/>
+          </a:xfrm>
+          <a:prstGeom xmlns:a="http://schemas.openxmlformats.org/drawingml/2006/main" prst="rect">
+            <a:avLst/>
+          </a:prstGeom>
+          <a:noFill xmlns:a="http://schemas.openxmlformats.org/drawingml/2006/main"/>
+          <a:ln xmlns:a="http://schemas.openxmlformats.org/drawingml/2006/main" w="0">
+            <a:noFill/>
+          </a:ln>
+        </p:spPr>
+        <p:txBody>
+          <a:bodyPr xmlns:a="http://schemas.openxmlformats.org/drawingml/2006/main" anchor="t">
+            <a:noAutofit/>
+          </a:bodyPr>
+          <a:lstStyle xmlns:a="http://schemas.openxmlformats.org/drawingml/2006/main"/>
+          <a:p xmlns:a="http://schemas.openxmlformats.org/drawingml/2006/main">
+            <a:pPr>
+              <a:defRPr sz="2100" b="1">
+                <a:solidFill>
+                  <a:srgbClr val="FFD21E"/>
+                </a:solidFill>
+                <a:latin typeface="Arial"/>
+                <a:ea typeface="Arial"/>
+                <a:cs typeface="Arial"/>
+              </a:defRPr>
+            </a:pPr>
+            <a:r>
+              <a:rPr sz="2100" b="1">
+                <a:solidFill>
+                  <a:srgbClr val="FFD21E"/>
+                </a:solidFill>
+                <a:latin typeface="Arial"/>
+                <a:ea typeface="Arial"/>
+                <a:cs typeface="Arial"/>
+              </a:rPr>
+              <a:t>Code + Colab notebook</a:t>
+            </a:r>
+          </a:p>
+        </p:txBody>
+      </p:sp>
+      <p:sp>
+        <p:nvSpPr>
+          <p:cNvPr id="8" name="">
+            <a:extLst xmlns:a="http://schemas.openxmlformats.org/drawingml/2006/main">
+              <a:ext uri="{FF2B5EF4-FFF2-40B4-BE49-F238E27FC236}">
+                <a16:creationId xmlns:a16="http://schemas.microsoft.com/office/drawing/2014/main" id="{8CBF2EE7-78B5-4E70-B548-0C461CEFEEC4}"/>
+              </a:ext>
+            </a:extLst>
+          </p:cNvPr>
+          <p:cNvSpPr>
+            <a:spLocks xmlns:a="http://schemas.openxmlformats.org/drawingml/2006/main" noGrp="1"/>
+          </p:cNvSpPr>
+          <p:nvPr/>
+        </p:nvSpPr>
+        <p:spPr>
+          <a:xfrm xmlns:a="http://schemas.openxmlformats.org/drawingml/2006/main">
+            <a:off x="2952750" y="4381500"/>
+            <a:ext cx="3429000" cy="876300"/>
+          </a:xfrm>
+          <a:prstGeom xmlns:a="http://schemas.openxmlformats.org/drawingml/2006/main" prst="rect">
+            <a:avLst/>
+          </a:prstGeom>
+          <a:noFill xmlns:a="http://schemas.openxmlformats.org/drawingml/2006/main"/>
+          <a:ln xmlns:a="http://schemas.openxmlformats.org/drawingml/2006/main" w="0">
+            <a:noFill/>
+          </a:ln>
+        </p:spPr>
+        <p:txBody>
+          <a:bodyPr xmlns:a="http://schemas.openxmlformats.org/drawingml/2006/main" anchor="t">
+            <a:noAutofit/>
+          </a:bodyPr>
+          <a:lstStyle xmlns:a="http://schemas.openxmlformats.org/drawingml/2006/main"/>
+          <a:p xmlns:a="http://schemas.openxmlformats.org/drawingml/2006/main">
+            <a:pPr>
+              <a:defRPr sz="1950" b="0">
+                <a:solidFill>
+                  <a:srgbClr val="FFF9ED"/>
+                </a:solidFill>
+                <a:latin typeface="Arial"/>
+                <a:ea typeface="Arial"/>
+                <a:cs typeface="Arial"/>
+              </a:defRPr>
+            </a:pPr>
+            <a:r>
+              <a:rPr sz="1950" b="0">
+                <a:solidFill>
+                  <a:srgbClr val="FFF9ED"/>
+                </a:solidFill>
+                <a:latin typeface="Arial"/>
+                <a:ea typeface="Arial"/>
+                <a:cs typeface="Arial"/>
+                <a:hlinkClick xmlns:r="http://schemas.openxmlformats.org/officeDocument/2006/relationships" r:id="R344e7ed45103495b"/>
+              </a:rPr>
+              <a:t>github.com/jemsbhai/</a:t>
+            </a:r>
+          </a:p>
+          <a:p xmlns:a="http://schemas.openxmlformats.org/drawingml/2006/main">
+            <a:pPr>
+              <a:defRPr sz="1950" b="0">
+                <a:solidFill>
+                  <a:srgbClr val="FFF9ED"/>
+                </a:solidFill>
+                <a:latin typeface="Arial"/>
+                <a:ea typeface="Arial"/>
+                <a:cs typeface="Arial"/>
+              </a:defRPr>
+            </a:pPr>
+            <a:r>
+              <a:rPr sz="1950" b="0">
+                <a:solidFill>
+                  <a:srgbClr val="FFF9ED"/>
+                </a:solidFill>
+                <a:latin typeface="Arial"/>
+                <a:ea typeface="Arial"/>
+                <a:cs typeface="Arial"/>
+                <a:hlinkClick xmlns:r="http://schemas.openxmlformats.org/officeDocument/2006/relationships" r:id="R0d6807360466431a"/>
+              </a:rPr>
+              <a:t>bringing-the-heat</a:t>
+            </a:r>
+          </a:p>
+        </p:txBody>
+      </p:sp>
+      <p:sp>
+        <p:nvSpPr>
+          <p:cNvPr id="9" name="">
+            <a:extLst xmlns:a="http://schemas.openxmlformats.org/drawingml/2006/main">
+              <a:ext uri="{FF2B5EF4-FFF2-40B4-BE49-F238E27FC236}">
+                <a16:creationId xmlns:a16="http://schemas.microsoft.com/office/drawing/2014/main" id="{3E099102-CB9F-47CD-8712-4843A99E4462}"/>
               </a:ext>
             </a:extLst>
           </p:cNvPr>
@@ -10300,10 +10466,10 @@
       </p:sp>
       <p:sp>
         <p:nvSpPr>
-          <p:cNvPr id="7" name="">
+          <p:cNvPr id="10" name="">
             <a:extLst xmlns:a="http://schemas.openxmlformats.org/drawingml/2006/main">
               <a:ext uri="{FF2B5EF4-FFF2-40B4-BE49-F238E27FC236}">
-                <a16:creationId xmlns:a16="http://schemas.microsoft.com/office/drawing/2014/main" id="{B772F941-B96F-4DDE-B740-4992B43DC5E7}"/>
+                <a16:creationId xmlns:a16="http://schemas.microsoft.com/office/drawing/2014/main" id="{85804219-9D98-44D6-A97A-667554253E03}"/>
               </a:ext>
             </a:extLst>
           </p:cNvPr>
@@ -10358,7 +10524,7 @@
     </p:spTree>
     <p:extLst>
       <p:ext uri="{BB962C8B-B14F-4D97-AF65-F5344CB8AC3E}">
-        <p14:creationId xmlns:p14="http://schemas.microsoft.com/office/powerpoint/2010/main" val="557012094"/>
+        <p14:creationId xmlns:p14="http://schemas.microsoft.com/office/powerpoint/2010/main" val="1255998979"/>
       </p:ext>
     </p:extLst>
   </p:cSld>
@@ -10389,7 +10555,7 @@
           <p:cNvPr id="5" name="">
             <a:extLst xmlns:a="http://schemas.openxmlformats.org/drawingml/2006/main">
               <a:ext uri="{FF2B5EF4-FFF2-40B4-BE49-F238E27FC236}">
-                <a16:creationId xmlns:a16="http://schemas.microsoft.com/office/drawing/2014/main" id="{94CD3C4B-813C-44D1-B484-8CD9E0461520}"/>
+                <a16:creationId xmlns:a16="http://schemas.microsoft.com/office/drawing/2014/main" id="{896D701B-B8FA-4F51-B468-FAF6936390AA}"/>
               </a:ext>
             </a:extLst>
           </p:cNvPr>
@@ -10839,7 +11005,7 @@
           <p:cNvPr id="3" name="">
             <a:extLst xmlns:a="http://schemas.openxmlformats.org/drawingml/2006/main">
               <a:ext uri="{FF2B5EF4-FFF2-40B4-BE49-F238E27FC236}">
-                <a16:creationId xmlns:a16="http://schemas.microsoft.com/office/drawing/2014/main" id="{2A5E0108-8D5D-4869-BE48-FAECD7001182}"/>
+                <a16:creationId xmlns:a16="http://schemas.microsoft.com/office/drawing/2014/main" id="{CB1E894F-2C7A-409A-BABB-12B425353BC6}"/>
               </a:ext>
             </a:extLst>
           </p:cNvPr>
@@ -10896,7 +11062,7 @@
           <p:cNvPr id="4" name="">
             <a:extLst xmlns:a="http://schemas.openxmlformats.org/drawingml/2006/main">
               <a:ext uri="{FF2B5EF4-FFF2-40B4-BE49-F238E27FC236}">
-                <a16:creationId xmlns:a16="http://schemas.microsoft.com/office/drawing/2014/main" id="{2A46CA6F-AAB8-412B-897A-8AF21A063F5B}"/>
+                <a16:creationId xmlns:a16="http://schemas.microsoft.com/office/drawing/2014/main" id="{969E1E1E-214A-48E9-BC4B-5D00B7B39B3C}"/>
               </a:ext>
             </a:extLst>
           </p:cNvPr>
@@ -10951,7 +11117,7 @@
     </p:spTree>
     <p:extLst>
       <p:ext uri="{BB962C8B-B14F-4D97-AF65-F5344CB8AC3E}">
-        <p14:creationId xmlns:p14="http://schemas.microsoft.com/office/powerpoint/2010/main" val="1169798559"/>
+        <p14:creationId xmlns:p14="http://schemas.microsoft.com/office/powerpoint/2010/main" val="562289827"/>
       </p:ext>
     </p:extLst>
   </p:cSld>
@@ -10982,7 +11148,7 @@
           <p:cNvPr id="5" name="">
             <a:extLst xmlns:a="http://schemas.openxmlformats.org/drawingml/2006/main">
               <a:ext uri="{FF2B5EF4-FFF2-40B4-BE49-F238E27FC236}">
-                <a16:creationId xmlns:a16="http://schemas.microsoft.com/office/drawing/2014/main" id="{2077A799-B34F-4264-90C3-D15A8CEA0B74}"/>
+                <a16:creationId xmlns:a16="http://schemas.microsoft.com/office/drawing/2014/main" id="{1F80F923-AAB6-40A1-B7FD-26FA7A505497}"/>
               </a:ext>
             </a:extLst>
           </p:cNvPr>
@@ -11432,7 +11598,7 @@
           <p:cNvPr id="3" name="">
             <a:extLst xmlns:a="http://schemas.openxmlformats.org/drawingml/2006/main">
               <a:ext uri="{FF2B5EF4-FFF2-40B4-BE49-F238E27FC236}">
-                <a16:creationId xmlns:a16="http://schemas.microsoft.com/office/drawing/2014/main" id="{728DB0B1-7BDF-424C-9A81-FDFD610FB3E6}"/>
+                <a16:creationId xmlns:a16="http://schemas.microsoft.com/office/drawing/2014/main" id="{034C4BE8-E658-4734-9E2D-17A9B579BD1C}"/>
               </a:ext>
             </a:extLst>
           </p:cNvPr>
@@ -11489,7 +11655,7 @@
           <p:cNvPr id="4" name="">
             <a:extLst xmlns:a="http://schemas.openxmlformats.org/drawingml/2006/main">
               <a:ext uri="{FF2B5EF4-FFF2-40B4-BE49-F238E27FC236}">
-                <a16:creationId xmlns:a16="http://schemas.microsoft.com/office/drawing/2014/main" id="{C3E8B830-9F01-42D9-AE20-13AAD8189CBA}"/>
+                <a16:creationId xmlns:a16="http://schemas.microsoft.com/office/drawing/2014/main" id="{9492C988-8461-40D1-A77B-BD3F1C3E4CC1}"/>
               </a:ext>
             </a:extLst>
           </p:cNvPr>
@@ -11544,7 +11710,7 @@
     </p:spTree>
     <p:extLst>
       <p:ext uri="{BB962C8B-B14F-4D97-AF65-F5344CB8AC3E}">
-        <p14:creationId xmlns:p14="http://schemas.microsoft.com/office/powerpoint/2010/main" val="1328966132"/>
+        <p14:creationId xmlns:p14="http://schemas.microsoft.com/office/powerpoint/2010/main" val="965759910"/>
       </p:ext>
     </p:extLst>
   </p:cSld>
@@ -11575,7 +11741,7 @@
           <p:cNvPr id="14" name="">
             <a:extLst xmlns:a="http://schemas.openxmlformats.org/drawingml/2006/main">
               <a:ext uri="{FF2B5EF4-FFF2-40B4-BE49-F238E27FC236}">
-                <a16:creationId xmlns:a16="http://schemas.microsoft.com/office/drawing/2014/main" id="{4E2BC6ED-B5C1-47DF-9D23-D0F61D940F80}"/>
+                <a16:creationId xmlns:a16="http://schemas.microsoft.com/office/drawing/2014/main" id="{A199BCC6-BC5C-46C0-B511-766B852AEE28}"/>
               </a:ext>
             </a:extLst>
           </p:cNvPr>
@@ -11632,7 +11798,7 @@
           <p:cNvPr id="2" name="">
             <a:extLst xmlns:a="http://schemas.openxmlformats.org/drawingml/2006/main">
               <a:ext uri="{FF2B5EF4-FFF2-40B4-BE49-F238E27FC236}">
-                <a16:creationId xmlns:a16="http://schemas.microsoft.com/office/drawing/2014/main" id="{ED3FBC4A-0641-45F8-8F1F-880074E76414}"/>
+                <a16:creationId xmlns:a16="http://schemas.microsoft.com/office/drawing/2014/main" id="{ED100F87-CB25-4420-A440-98A734727FFB}"/>
               </a:ext>
             </a:extLst>
           </p:cNvPr>
@@ -11689,7 +11855,7 @@
           <p:cNvPr id="3" name="">
             <a:extLst xmlns:a="http://schemas.openxmlformats.org/drawingml/2006/main">
               <a:ext uri="{FF2B5EF4-FFF2-40B4-BE49-F238E27FC236}">
-                <a16:creationId xmlns:a16="http://schemas.microsoft.com/office/drawing/2014/main" id="{4540DF54-5EA4-402A-823D-4917DA6CCBFC}"/>
+                <a16:creationId xmlns:a16="http://schemas.microsoft.com/office/drawing/2014/main" id="{B06AD713-1D58-48DB-A570-63CC35CB09EE}"/>
               </a:ext>
             </a:extLst>
           </p:cNvPr>
@@ -11746,7 +11912,7 @@
           <p:cNvPr id="4" name="">
             <a:extLst xmlns:a="http://schemas.openxmlformats.org/drawingml/2006/main">
               <a:ext uri="{FF2B5EF4-FFF2-40B4-BE49-F238E27FC236}">
-                <a16:creationId xmlns:a16="http://schemas.microsoft.com/office/drawing/2014/main" id="{AF87EE93-2C8F-4A58-A8BF-0913320A0238}"/>
+                <a16:creationId xmlns:a16="http://schemas.microsoft.com/office/drawing/2014/main" id="{3E78B03D-B2C0-46E6-9A26-CF8E31559C3B}"/>
               </a:ext>
             </a:extLst>
           </p:cNvPr>
@@ -11803,7 +11969,7 @@
           <p:cNvPr id="5" name="">
             <a:extLst xmlns:a="http://schemas.openxmlformats.org/drawingml/2006/main">
               <a:ext uri="{FF2B5EF4-FFF2-40B4-BE49-F238E27FC236}">
-                <a16:creationId xmlns:a16="http://schemas.microsoft.com/office/drawing/2014/main" id="{F954B928-0A21-4DD9-8FF7-0DB5F94FFC5E}"/>
+                <a16:creationId xmlns:a16="http://schemas.microsoft.com/office/drawing/2014/main" id="{E5BA86BD-1F3C-45E2-B1FE-EAE7D4607336}"/>
               </a:ext>
             </a:extLst>
           </p:cNvPr>
@@ -11860,7 +12026,7 @@
           <p:cNvPr id="6" name="">
             <a:extLst xmlns:a="http://schemas.openxmlformats.org/drawingml/2006/main">
               <a:ext uri="{FF2B5EF4-FFF2-40B4-BE49-F238E27FC236}">
-                <a16:creationId xmlns:a16="http://schemas.microsoft.com/office/drawing/2014/main" id="{64F00471-FF89-4F33-9F56-B36B0C952A83}"/>
+                <a16:creationId xmlns:a16="http://schemas.microsoft.com/office/drawing/2014/main" id="{3B3134FD-4F8D-4537-ABE6-83BF184EBE9C}"/>
               </a:ext>
             </a:extLst>
           </p:cNvPr>
@@ -11917,7 +12083,7 @@
           <p:cNvPr id="7" name="">
             <a:extLst xmlns:a="http://schemas.openxmlformats.org/drawingml/2006/main">
               <a:ext uri="{FF2B5EF4-FFF2-40B4-BE49-F238E27FC236}">
-                <a16:creationId xmlns:a16="http://schemas.microsoft.com/office/drawing/2014/main" id="{2F92D06D-58DB-4852-81DF-D4EB6D04ED4E}"/>
+                <a16:creationId xmlns:a16="http://schemas.microsoft.com/office/drawing/2014/main" id="{C527EDE3-15E1-4450-BB8C-37D1C3C7287D}"/>
               </a:ext>
             </a:extLst>
           </p:cNvPr>
@@ -11974,7 +12140,7 @@
           <p:cNvPr id="8" name="">
             <a:extLst xmlns:a="http://schemas.openxmlformats.org/drawingml/2006/main">
               <a:ext uri="{FF2B5EF4-FFF2-40B4-BE49-F238E27FC236}">
-                <a16:creationId xmlns:a16="http://schemas.microsoft.com/office/drawing/2014/main" id="{B9425641-6AAF-4B92-8361-FE7268DF9AF2}"/>
+                <a16:creationId xmlns:a16="http://schemas.microsoft.com/office/drawing/2014/main" id="{EDF6807E-85A5-4759-A9A9-78D997755C57}"/>
               </a:ext>
             </a:extLst>
           </p:cNvPr>
@@ -12031,7 +12197,7 @@
           <p:cNvPr id="9" name="">
             <a:extLst xmlns:a="http://schemas.openxmlformats.org/drawingml/2006/main">
               <a:ext uri="{FF2B5EF4-FFF2-40B4-BE49-F238E27FC236}">
-                <a16:creationId xmlns:a16="http://schemas.microsoft.com/office/drawing/2014/main" id="{EDF20C90-07CC-47A8-A3CE-FF8525CE1B7E}"/>
+                <a16:creationId xmlns:a16="http://schemas.microsoft.com/office/drawing/2014/main" id="{7B60428F-9292-47FC-920F-2D8BCCE7456D}"/>
               </a:ext>
             </a:extLst>
           </p:cNvPr>
@@ -12088,7 +12254,7 @@
           <p:cNvPr id="10" name="">
             <a:extLst xmlns:a="http://schemas.openxmlformats.org/drawingml/2006/main">
               <a:ext uri="{FF2B5EF4-FFF2-40B4-BE49-F238E27FC236}">
-                <a16:creationId xmlns:a16="http://schemas.microsoft.com/office/drawing/2014/main" id="{CD0BE3A4-E731-4836-ACF2-DEB9E5A52C12}"/>
+                <a16:creationId xmlns:a16="http://schemas.microsoft.com/office/drawing/2014/main" id="{5467FEB3-82AE-40AB-89F4-5A1261A586BA}"/>
               </a:ext>
             </a:extLst>
           </p:cNvPr>
@@ -12145,7 +12311,7 @@
           <p:cNvPr id="11" name="">
             <a:extLst xmlns:a="http://schemas.openxmlformats.org/drawingml/2006/main">
               <a:ext uri="{FF2B5EF4-FFF2-40B4-BE49-F238E27FC236}">
-                <a16:creationId xmlns:a16="http://schemas.microsoft.com/office/drawing/2014/main" id="{DA93EF89-C8F5-494A-806F-031D8CF1ECBA}"/>
+                <a16:creationId xmlns:a16="http://schemas.microsoft.com/office/drawing/2014/main" id="{AAB98149-CA7C-47A7-B3DC-ADD785D3A852}"/>
               </a:ext>
             </a:extLst>
           </p:cNvPr>
@@ -12202,7 +12368,7 @@
           <p:cNvPr id="12" name="">
             <a:extLst xmlns:a="http://schemas.openxmlformats.org/drawingml/2006/main">
               <a:ext uri="{FF2B5EF4-FFF2-40B4-BE49-F238E27FC236}">
-                <a16:creationId xmlns:a16="http://schemas.microsoft.com/office/drawing/2014/main" id="{27A09AFF-D454-4505-91BB-030CA2486976}"/>
+                <a16:creationId xmlns:a16="http://schemas.microsoft.com/office/drawing/2014/main" id="{8FBC1672-6DD1-425F-9EE8-845BDBB81059}"/>
               </a:ext>
             </a:extLst>
           </p:cNvPr>
@@ -12259,7 +12425,7 @@
           <p:cNvPr id="13" name="">
             <a:extLst xmlns:a="http://schemas.openxmlformats.org/drawingml/2006/main">
               <a:ext uri="{FF2B5EF4-FFF2-40B4-BE49-F238E27FC236}">
-                <a16:creationId xmlns:a16="http://schemas.microsoft.com/office/drawing/2014/main" id="{6A720029-FC50-4828-A845-A54FE2EAF0F5}"/>
+                <a16:creationId xmlns:a16="http://schemas.microsoft.com/office/drawing/2014/main" id="{3259BB61-DA67-4BB1-88D3-6D3AA5B21668}"/>
               </a:ext>
             </a:extLst>
           </p:cNvPr>
@@ -12314,7 +12480,7 @@
     </p:spTree>
     <p:extLst>
       <p:ext uri="{BB962C8B-B14F-4D97-AF65-F5344CB8AC3E}">
-        <p14:creationId xmlns:p14="http://schemas.microsoft.com/office/powerpoint/2010/main" val="2072266721"/>
+        <p14:creationId xmlns:p14="http://schemas.microsoft.com/office/powerpoint/2010/main" val="1296269226"/>
       </p:ext>
     </p:extLst>
   </p:cSld>
@@ -12345,7 +12511,7 @@
           <p:cNvPr id="8" name="">
             <a:extLst xmlns:a="http://schemas.openxmlformats.org/drawingml/2006/main">
               <a:ext uri="{FF2B5EF4-FFF2-40B4-BE49-F238E27FC236}">
-                <a16:creationId xmlns:a16="http://schemas.microsoft.com/office/drawing/2014/main" id="{3F6A5009-6522-4922-9DD1-91F467CC5FFF}"/>
+                <a16:creationId xmlns:a16="http://schemas.microsoft.com/office/drawing/2014/main" id="{19C2CE38-043B-4A7A-9A65-BB77E0E45235}"/>
               </a:ext>
             </a:extLst>
           </p:cNvPr>
@@ -12402,7 +12568,7 @@
           <p:cNvPr id="2" name="">
             <a:extLst xmlns:a="http://schemas.openxmlformats.org/drawingml/2006/main">
               <a:ext uri="{FF2B5EF4-FFF2-40B4-BE49-F238E27FC236}">
-                <a16:creationId xmlns:a16="http://schemas.microsoft.com/office/drawing/2014/main" id="{5A0FE10F-AFFE-415A-B942-61157AE1D65A}"/>
+                <a16:creationId xmlns:a16="http://schemas.microsoft.com/office/drawing/2014/main" id="{A4144565-28F5-4E03-AAEA-FAA36EA14C6D}"/>
               </a:ext>
             </a:extLst>
           </p:cNvPr>
@@ -12459,7 +12625,7 @@
           <p:cNvPr id="3" name="">
             <a:extLst xmlns:a="http://schemas.openxmlformats.org/drawingml/2006/main">
               <a:ext uri="{FF2B5EF4-FFF2-40B4-BE49-F238E27FC236}">
-                <a16:creationId xmlns:a16="http://schemas.microsoft.com/office/drawing/2014/main" id="{4E7914F2-42AF-42B4-9501-2ABD695FE8B8}"/>
+                <a16:creationId xmlns:a16="http://schemas.microsoft.com/office/drawing/2014/main" id="{5836553A-7F38-4DAC-A366-D7E05A792749}"/>
               </a:ext>
             </a:extLst>
           </p:cNvPr>
@@ -12622,7 +12788,7 @@
           <p:nvPr/>
         </p:nvPicPr>
         <p:blipFill>
-          <a:blip xmlns:r="http://schemas.openxmlformats.org/officeDocument/2006/relationships" xmlns:a="http://schemas.openxmlformats.org/drawingml/2006/main" r:embed="R7375e9fd16c7428f"/>
+          <a:blip xmlns:r="http://schemas.openxmlformats.org/officeDocument/2006/relationships" xmlns:a="http://schemas.openxmlformats.org/drawingml/2006/main" r:embed="Radb973316b054055"/>
           <a:stretch xmlns:a="http://schemas.openxmlformats.org/drawingml/2006/main"/>
         </p:blipFill>
         <p:spPr>
@@ -12640,7 +12806,7 @@
           <p:cNvPr id="5" name="">
             <a:extLst xmlns:a="http://schemas.openxmlformats.org/drawingml/2006/main">
               <a:ext uri="{FF2B5EF4-FFF2-40B4-BE49-F238E27FC236}">
-                <a16:creationId xmlns:a16="http://schemas.microsoft.com/office/drawing/2014/main" id="{372CA88F-3706-4807-8C8E-1972084BE018}"/>
+                <a16:creationId xmlns:a16="http://schemas.microsoft.com/office/drawing/2014/main" id="{144ADB6A-5700-4E60-941E-5480D27BD8B0}"/>
               </a:ext>
             </a:extLst>
           </p:cNvPr>
@@ -12720,7 +12886,7 @@
           <p:cNvPr id="6" name="">
             <a:extLst xmlns:a="http://schemas.openxmlformats.org/drawingml/2006/main">
               <a:ext uri="{FF2B5EF4-FFF2-40B4-BE49-F238E27FC236}">
-                <a16:creationId xmlns:a16="http://schemas.microsoft.com/office/drawing/2014/main" id="{3D6B616A-99D6-462F-99A1-43A487C95CCC}"/>
+                <a16:creationId xmlns:a16="http://schemas.microsoft.com/office/drawing/2014/main" id="{CE37E72B-375D-494C-8216-94223381542C}"/>
               </a:ext>
             </a:extLst>
           </p:cNvPr>
@@ -12777,7 +12943,7 @@
           <p:cNvPr id="7" name="">
             <a:extLst xmlns:a="http://schemas.openxmlformats.org/drawingml/2006/main">
               <a:ext uri="{FF2B5EF4-FFF2-40B4-BE49-F238E27FC236}">
-                <a16:creationId xmlns:a16="http://schemas.microsoft.com/office/drawing/2014/main" id="{A2713E4B-8A3B-4EEB-8027-551191BF66A0}"/>
+                <a16:creationId xmlns:a16="http://schemas.microsoft.com/office/drawing/2014/main" id="{BF88D7B7-3213-4CD7-956A-DE84CD7DF636}"/>
               </a:ext>
             </a:extLst>
           </p:cNvPr>
@@ -12832,7 +12998,7 @@
     </p:spTree>
     <p:extLst>
       <p:ext uri="{BB962C8B-B14F-4D97-AF65-F5344CB8AC3E}">
-        <p14:creationId xmlns:p14="http://schemas.microsoft.com/office/powerpoint/2010/main" val="358101444"/>
+        <p14:creationId xmlns:p14="http://schemas.microsoft.com/office/powerpoint/2010/main" val="1669682754"/>
       </p:ext>
     </p:extLst>
   </p:cSld>
@@ -12863,7 +13029,7 @@
           <p:cNvPr id="5" name="">
             <a:extLst xmlns:a="http://schemas.openxmlformats.org/drawingml/2006/main">
               <a:ext uri="{FF2B5EF4-FFF2-40B4-BE49-F238E27FC236}">
-                <a16:creationId xmlns:a16="http://schemas.microsoft.com/office/drawing/2014/main" id="{0E58C380-3205-499C-9DF2-9165A1E1B1D0}"/>
+                <a16:creationId xmlns:a16="http://schemas.microsoft.com/office/drawing/2014/main" id="{CE00CBB1-CB21-4567-89C0-FD0542C2B81E}"/>
               </a:ext>
             </a:extLst>
           </p:cNvPr>
@@ -13313,7 +13479,7 @@
           <p:cNvPr id="3" name="">
             <a:extLst xmlns:a="http://schemas.openxmlformats.org/drawingml/2006/main">
               <a:ext uri="{FF2B5EF4-FFF2-40B4-BE49-F238E27FC236}">
-                <a16:creationId xmlns:a16="http://schemas.microsoft.com/office/drawing/2014/main" id="{059A7D5C-EC95-41E0-8BF7-92B9F65FA9EE}"/>
+                <a16:creationId xmlns:a16="http://schemas.microsoft.com/office/drawing/2014/main" id="{15D99004-C8BE-40C7-926A-DED914290486}"/>
               </a:ext>
             </a:extLst>
           </p:cNvPr>
@@ -13370,7 +13536,7 @@
           <p:cNvPr id="4" name="">
             <a:extLst xmlns:a="http://schemas.openxmlformats.org/drawingml/2006/main">
               <a:ext uri="{FF2B5EF4-FFF2-40B4-BE49-F238E27FC236}">
-                <a16:creationId xmlns:a16="http://schemas.microsoft.com/office/drawing/2014/main" id="{309C4385-E7BB-4AA4-A9D3-A45994A57289}"/>
+                <a16:creationId xmlns:a16="http://schemas.microsoft.com/office/drawing/2014/main" id="{BAE60BA8-7116-46B0-9BD3-0810F70A55C3}"/>
               </a:ext>
             </a:extLst>
           </p:cNvPr>
@@ -13425,7 +13591,7 @@
     </p:spTree>
     <p:extLst>
       <p:ext uri="{BB962C8B-B14F-4D97-AF65-F5344CB8AC3E}">
-        <p14:creationId xmlns:p14="http://schemas.microsoft.com/office/powerpoint/2010/main" val="1534942941"/>
+        <p14:creationId xmlns:p14="http://schemas.microsoft.com/office/powerpoint/2010/main" val="517143150"/>
       </p:ext>
     </p:extLst>
   </p:cSld>
@@ -13456,7 +13622,7 @@
           <p:cNvPr id="8" name="">
             <a:extLst xmlns:a="http://schemas.openxmlformats.org/drawingml/2006/main">
               <a:ext uri="{FF2B5EF4-FFF2-40B4-BE49-F238E27FC236}">
-                <a16:creationId xmlns:a16="http://schemas.microsoft.com/office/drawing/2014/main" id="{7EFED915-76A6-4062-8213-EA1C368C92F9}"/>
+                <a16:creationId xmlns:a16="http://schemas.microsoft.com/office/drawing/2014/main" id="{0D656C30-A14C-4686-9C1D-D62FB708D28D}"/>
               </a:ext>
             </a:extLst>
           </p:cNvPr>
@@ -13513,7 +13679,7 @@
           <p:cNvPr id="2" name="">
             <a:extLst xmlns:a="http://schemas.openxmlformats.org/drawingml/2006/main">
               <a:ext uri="{FF2B5EF4-FFF2-40B4-BE49-F238E27FC236}">
-                <a16:creationId xmlns:a16="http://schemas.microsoft.com/office/drawing/2014/main" id="{5DE24D21-A896-4BA4-B968-6E28DE58C339}"/>
+                <a16:creationId xmlns:a16="http://schemas.microsoft.com/office/drawing/2014/main" id="{3CF45DB8-5B7E-40D5-B9D9-D0D62768EAF1}"/>
               </a:ext>
             </a:extLst>
           </p:cNvPr>
@@ -13570,7 +13736,7 @@
           <p:cNvPr id="3" name="">
             <a:extLst xmlns:a="http://schemas.openxmlformats.org/drawingml/2006/main">
               <a:ext uri="{FF2B5EF4-FFF2-40B4-BE49-F238E27FC236}">
-                <a16:creationId xmlns:a16="http://schemas.microsoft.com/office/drawing/2014/main" id="{0A72BD13-B186-4CFB-B0AF-1DC28762B87F}"/>
+                <a16:creationId xmlns:a16="http://schemas.microsoft.com/office/drawing/2014/main" id="{5885F977-683E-421B-9197-3BB5204F7AA4}"/>
               </a:ext>
             </a:extLst>
           </p:cNvPr>
@@ -13678,7 +13844,7 @@
           <p:cNvPr id="4" name="">
             <a:extLst xmlns:a="http://schemas.openxmlformats.org/drawingml/2006/main">
               <a:ext uri="{FF2B5EF4-FFF2-40B4-BE49-F238E27FC236}">
-                <a16:creationId xmlns:a16="http://schemas.microsoft.com/office/drawing/2014/main" id="{2AEB82ED-F5BE-433B-BA92-1B38640FF21D}"/>
+                <a16:creationId xmlns:a16="http://schemas.microsoft.com/office/drawing/2014/main" id="{6BEE1284-10D0-44BA-85F9-4166319B28A4}"/>
               </a:ext>
             </a:extLst>
           </p:cNvPr>
@@ -13735,7 +13901,7 @@
           <p:cNvPr id="5" name="">
             <a:extLst xmlns:a="http://schemas.openxmlformats.org/drawingml/2006/main">
               <a:ext uri="{FF2B5EF4-FFF2-40B4-BE49-F238E27FC236}">
-                <a16:creationId xmlns:a16="http://schemas.microsoft.com/office/drawing/2014/main" id="{B043D3DA-4203-4B07-A331-8579AF8084EF}"/>
+                <a16:creationId xmlns:a16="http://schemas.microsoft.com/office/drawing/2014/main" id="{B8982003-B14F-44D2-8D2E-2B36E743A852}"/>
               </a:ext>
             </a:extLst>
           </p:cNvPr>
@@ -13861,7 +14027,7 @@
           <p:cNvPr id="6" name="">
             <a:extLst xmlns:a="http://schemas.openxmlformats.org/drawingml/2006/main">
               <a:ext uri="{FF2B5EF4-FFF2-40B4-BE49-F238E27FC236}">
-                <a16:creationId xmlns:a16="http://schemas.microsoft.com/office/drawing/2014/main" id="{77C0395F-B3EA-4936-BC13-0AA102DD9AF4}"/>
+                <a16:creationId xmlns:a16="http://schemas.microsoft.com/office/drawing/2014/main" id="{AEB72BCB-2C1B-484D-8D77-124BABD2B02A}"/>
               </a:ext>
             </a:extLst>
           </p:cNvPr>
@@ -13918,7 +14084,7 @@
           <p:cNvPr id="7" name="">
             <a:extLst xmlns:a="http://schemas.openxmlformats.org/drawingml/2006/main">
               <a:ext uri="{FF2B5EF4-FFF2-40B4-BE49-F238E27FC236}">
-                <a16:creationId xmlns:a16="http://schemas.microsoft.com/office/drawing/2014/main" id="{6688806A-68EC-4F4C-A90A-172B13B91B5F}"/>
+                <a16:creationId xmlns:a16="http://schemas.microsoft.com/office/drawing/2014/main" id="{1F1A680A-D372-49E7-A5CC-7CD9F929913A}"/>
               </a:ext>
             </a:extLst>
           </p:cNvPr>
@@ -13973,7 +14139,7 @@
     </p:spTree>
     <p:extLst>
       <p:ext uri="{BB962C8B-B14F-4D97-AF65-F5344CB8AC3E}">
-        <p14:creationId xmlns:p14="http://schemas.microsoft.com/office/powerpoint/2010/main" val="310169528"/>
+        <p14:creationId xmlns:p14="http://schemas.microsoft.com/office/powerpoint/2010/main" val="510957766"/>
       </p:ext>
     </p:extLst>
   </p:cSld>
@@ -14004,7 +14170,7 @@
           <p:cNvPr id="7" name="">
             <a:extLst xmlns:a="http://schemas.openxmlformats.org/drawingml/2006/main">
               <a:ext uri="{FF2B5EF4-FFF2-40B4-BE49-F238E27FC236}">
-                <a16:creationId xmlns:a16="http://schemas.microsoft.com/office/drawing/2014/main" id="{7C74A20A-36A8-448E-9380-62135367E130}"/>
+                <a16:creationId xmlns:a16="http://schemas.microsoft.com/office/drawing/2014/main" id="{5BDCEB6B-AC27-4201-9236-B84246A814A3}"/>
               </a:ext>
             </a:extLst>
           </p:cNvPr>
@@ -14061,7 +14227,7 @@
           <p:cNvPr id="2" name="">
             <a:extLst xmlns:a="http://schemas.openxmlformats.org/drawingml/2006/main">
               <a:ext uri="{FF2B5EF4-FFF2-40B4-BE49-F238E27FC236}">
-                <a16:creationId xmlns:a16="http://schemas.microsoft.com/office/drawing/2014/main" id="{D4FAEAA0-0900-4A16-B11A-5AE1188A315D}"/>
+                <a16:creationId xmlns:a16="http://schemas.microsoft.com/office/drawing/2014/main" id="{EA4B95A5-0011-49F1-86CF-EE289E15C04A}"/>
               </a:ext>
             </a:extLst>
           </p:cNvPr>
@@ -14284,7 +14450,7 @@
           <p:cNvPr id="3" name="">
             <a:extLst xmlns:a="http://schemas.openxmlformats.org/drawingml/2006/main">
               <a:ext uri="{FF2B5EF4-FFF2-40B4-BE49-F238E27FC236}">
-                <a16:creationId xmlns:a16="http://schemas.microsoft.com/office/drawing/2014/main" id="{CA712BA2-1A61-445C-B2B4-C12D5645DFF7}"/>
+                <a16:creationId xmlns:a16="http://schemas.microsoft.com/office/drawing/2014/main" id="{E5E3C801-C419-40AF-80B0-188E33A7C727}"/>
               </a:ext>
             </a:extLst>
           </p:cNvPr>
@@ -14341,7 +14507,7 @@
           <p:cNvPr id="4" name="">
             <a:extLst xmlns:a="http://schemas.openxmlformats.org/drawingml/2006/main">
               <a:ext uri="{FF2B5EF4-FFF2-40B4-BE49-F238E27FC236}">
-                <a16:creationId xmlns:a16="http://schemas.microsoft.com/office/drawing/2014/main" id="{5AA46B24-48BB-4799-8422-2F0F8C87A1F7}"/>
+                <a16:creationId xmlns:a16="http://schemas.microsoft.com/office/drawing/2014/main" id="{E5E4D1A8-679A-4250-8955-143B659B736A}"/>
               </a:ext>
             </a:extLst>
           </p:cNvPr>
@@ -14490,7 +14656,7 @@
           <p:cNvPr id="5" name="">
             <a:extLst xmlns:a="http://schemas.openxmlformats.org/drawingml/2006/main">
               <a:ext uri="{FF2B5EF4-FFF2-40B4-BE49-F238E27FC236}">
-                <a16:creationId xmlns:a16="http://schemas.microsoft.com/office/drawing/2014/main" id="{1A202B39-5F33-4F76-B9DC-4528D4050180}"/>
+                <a16:creationId xmlns:a16="http://schemas.microsoft.com/office/drawing/2014/main" id="{0C4D8A3A-DB29-481C-AE2E-5761A0C9F74B}"/>
               </a:ext>
             </a:extLst>
           </p:cNvPr>
@@ -14547,7 +14713,7 @@
           <p:cNvPr id="6" name="">
             <a:extLst xmlns:a="http://schemas.openxmlformats.org/drawingml/2006/main">
               <a:ext uri="{FF2B5EF4-FFF2-40B4-BE49-F238E27FC236}">
-                <a16:creationId xmlns:a16="http://schemas.microsoft.com/office/drawing/2014/main" id="{DD37AE62-8A69-419C-9AEB-B70E83452924}"/>
+                <a16:creationId xmlns:a16="http://schemas.microsoft.com/office/drawing/2014/main" id="{6D9C40AF-EF97-474F-BA34-16B193A911BE}"/>
               </a:ext>
             </a:extLst>
           </p:cNvPr>
@@ -14602,7 +14768,7 @@
     </p:spTree>
     <p:extLst>
       <p:ext uri="{BB962C8B-B14F-4D97-AF65-F5344CB8AC3E}">
-        <p14:creationId xmlns:p14="http://schemas.microsoft.com/office/powerpoint/2010/main" val="1640993360"/>
+        <p14:creationId xmlns:p14="http://schemas.microsoft.com/office/powerpoint/2010/main" val="591862343"/>
       </p:ext>
     </p:extLst>
   </p:cSld>
@@ -14633,7 +14799,7 @@
           <p:cNvPr id="9" name="">
             <a:extLst xmlns:a="http://schemas.openxmlformats.org/drawingml/2006/main">
               <a:ext uri="{FF2B5EF4-FFF2-40B4-BE49-F238E27FC236}">
-                <a16:creationId xmlns:a16="http://schemas.microsoft.com/office/drawing/2014/main" id="{9B7AFB59-4314-45D9-BE53-24041F57BE7D}"/>
+                <a16:creationId xmlns:a16="http://schemas.microsoft.com/office/drawing/2014/main" id="{C7F35863-37A9-4AFE-9506-6BC84FF6CE0A}"/>
               </a:ext>
             </a:extLst>
           </p:cNvPr>
@@ -14690,7 +14856,7 @@
           <p:cNvPr id="2" name="">
             <a:extLst xmlns:a="http://schemas.openxmlformats.org/drawingml/2006/main">
               <a:ext uri="{FF2B5EF4-FFF2-40B4-BE49-F238E27FC236}">
-                <a16:creationId xmlns:a16="http://schemas.microsoft.com/office/drawing/2014/main" id="{571014D8-BA25-4F36-B178-2CB7C38426D7}"/>
+                <a16:creationId xmlns:a16="http://schemas.microsoft.com/office/drawing/2014/main" id="{F6871F79-42BF-48BC-BDBD-E8FA6E3B48B3}"/>
               </a:ext>
             </a:extLst>
           </p:cNvPr>
@@ -14747,7 +14913,7 @@
           <p:cNvPr id="3" name="">
             <a:extLst xmlns:a="http://schemas.openxmlformats.org/drawingml/2006/main">
               <a:ext uri="{FF2B5EF4-FFF2-40B4-BE49-F238E27FC236}">
-                <a16:creationId xmlns:a16="http://schemas.microsoft.com/office/drawing/2014/main" id="{166F5CDC-BA58-44E8-8CEE-A0A4218181D2}"/>
+                <a16:creationId xmlns:a16="http://schemas.microsoft.com/office/drawing/2014/main" id="{D8116BD7-D49A-4CB2-94DF-DAC8541D387F}"/>
               </a:ext>
             </a:extLst>
           </p:cNvPr>
@@ -14804,7 +14970,7 @@
           <p:cNvPr id="4" name="">
             <a:extLst xmlns:a="http://schemas.openxmlformats.org/drawingml/2006/main">
               <a:ext uri="{FF2B5EF4-FFF2-40B4-BE49-F238E27FC236}">
-                <a16:creationId xmlns:a16="http://schemas.microsoft.com/office/drawing/2014/main" id="{ACBDDB66-5EA4-49FF-ACD9-8A02770C24ED}"/>
+                <a16:creationId xmlns:a16="http://schemas.microsoft.com/office/drawing/2014/main" id="{5201FCA2-2792-4707-ABAB-F67120EAFFFF}"/>
               </a:ext>
             </a:extLst>
           </p:cNvPr>
@@ -14884,7 +15050,7 @@
           <p:cNvPr id="5" name="">
             <a:extLst xmlns:a="http://schemas.openxmlformats.org/drawingml/2006/main">
               <a:ext uri="{FF2B5EF4-FFF2-40B4-BE49-F238E27FC236}">
-                <a16:creationId xmlns:a16="http://schemas.microsoft.com/office/drawing/2014/main" id="{55647B18-47F1-48F9-ADC2-A135734899A0}"/>
+                <a16:creationId xmlns:a16="http://schemas.microsoft.com/office/drawing/2014/main" id="{1B2F1B1A-919C-4724-BD8D-696163B451A5}"/>
               </a:ext>
             </a:extLst>
           </p:cNvPr>
@@ -14941,7 +15107,7 @@
           <p:cNvPr id="6" name="">
             <a:extLst xmlns:a="http://schemas.openxmlformats.org/drawingml/2006/main">
               <a:ext uri="{FF2B5EF4-FFF2-40B4-BE49-F238E27FC236}">
-                <a16:creationId xmlns:a16="http://schemas.microsoft.com/office/drawing/2014/main" id="{752795F9-A866-4C5B-A067-BFEBEE0438CD}"/>
+                <a16:creationId xmlns:a16="http://schemas.microsoft.com/office/drawing/2014/main" id="{B321171F-EF76-4D89-8C5F-23B6EBA8B940}"/>
               </a:ext>
             </a:extLst>
           </p:cNvPr>
@@ -15021,7 +15187,7 @@
           <p:cNvPr id="7" name="">
             <a:extLst xmlns:a="http://schemas.openxmlformats.org/drawingml/2006/main">
               <a:ext uri="{FF2B5EF4-FFF2-40B4-BE49-F238E27FC236}">
-                <a16:creationId xmlns:a16="http://schemas.microsoft.com/office/drawing/2014/main" id="{EC63A544-0B66-42C9-B0D2-D77D3F80F807}"/>
+                <a16:creationId xmlns:a16="http://schemas.microsoft.com/office/drawing/2014/main" id="{652FFBD2-BBF2-461C-BA51-2B1A5289CC4E}"/>
               </a:ext>
             </a:extLst>
           </p:cNvPr>
@@ -15078,7 +15244,7 @@
           <p:cNvPr id="8" name="">
             <a:extLst xmlns:a="http://schemas.openxmlformats.org/drawingml/2006/main">
               <a:ext uri="{FF2B5EF4-FFF2-40B4-BE49-F238E27FC236}">
-                <a16:creationId xmlns:a16="http://schemas.microsoft.com/office/drawing/2014/main" id="{2BB029B0-932C-4C76-8847-D35B46A6ECC5}"/>
+                <a16:creationId xmlns:a16="http://schemas.microsoft.com/office/drawing/2014/main" id="{09130F7B-45F9-4D5C-A0ED-C19718E16552}"/>
               </a:ext>
             </a:extLst>
           </p:cNvPr>
@@ -15133,7 +15299,7 @@
     </p:spTree>
     <p:extLst>
       <p:ext uri="{BB962C8B-B14F-4D97-AF65-F5344CB8AC3E}">
-        <p14:creationId xmlns:p14="http://schemas.microsoft.com/office/powerpoint/2010/main" val="1437015115"/>
+        <p14:creationId xmlns:p14="http://schemas.microsoft.com/office/powerpoint/2010/main" val="2087553409"/>
       </p:ext>
     </p:extLst>
   </p:cSld>
@@ -15164,7 +15330,7 @@
           <p:cNvPr id="7" name="">
             <a:extLst xmlns:a="http://schemas.openxmlformats.org/drawingml/2006/main">
               <a:ext uri="{FF2B5EF4-FFF2-40B4-BE49-F238E27FC236}">
-                <a16:creationId xmlns:a16="http://schemas.microsoft.com/office/drawing/2014/main" id="{7D8BD7FA-C711-4FF4-BA10-252B8881CEF7}"/>
+                <a16:creationId xmlns:a16="http://schemas.microsoft.com/office/drawing/2014/main" id="{48940B8E-0A73-4CF0-BBB6-AAD06CA84730}"/>
               </a:ext>
             </a:extLst>
           </p:cNvPr>
@@ -15221,7 +15387,7 @@
           <p:cNvPr id="2" name="">
             <a:extLst xmlns:a="http://schemas.openxmlformats.org/drawingml/2006/main">
               <a:ext uri="{FF2B5EF4-FFF2-40B4-BE49-F238E27FC236}">
-                <a16:creationId xmlns:a16="http://schemas.microsoft.com/office/drawing/2014/main" id="{79E3BD45-29DC-475B-B9B5-47CC958E99BD}"/>
+                <a16:creationId xmlns:a16="http://schemas.microsoft.com/office/drawing/2014/main" id="{7059E1F7-F45E-43A0-874F-A3A152B3BED7}"/>
               </a:ext>
             </a:extLst>
           </p:cNvPr>
@@ -15485,7 +15651,7 @@
           <p:cNvPr id="3" name="">
             <a:extLst xmlns:a="http://schemas.openxmlformats.org/drawingml/2006/main">
               <a:ext uri="{FF2B5EF4-FFF2-40B4-BE49-F238E27FC236}">
-                <a16:creationId xmlns:a16="http://schemas.microsoft.com/office/drawing/2014/main" id="{F44A3FB3-5CF8-4C7A-8525-0DCC42E1538E}"/>
+                <a16:creationId xmlns:a16="http://schemas.microsoft.com/office/drawing/2014/main" id="{E74FED1C-70C9-4D1D-A8D4-8138AF9C1F73}"/>
               </a:ext>
             </a:extLst>
           </p:cNvPr>
@@ -15542,7 +15708,7 @@
           <p:cNvPr id="4" name="">
             <a:extLst xmlns:a="http://schemas.openxmlformats.org/drawingml/2006/main">
               <a:ext uri="{FF2B5EF4-FFF2-40B4-BE49-F238E27FC236}">
-                <a16:creationId xmlns:a16="http://schemas.microsoft.com/office/drawing/2014/main" id="{823454E1-AC6E-4A12-96A4-838C7473FEFD}"/>
+                <a16:creationId xmlns:a16="http://schemas.microsoft.com/office/drawing/2014/main" id="{6F72C1F7-C391-4221-8265-360CCCAED81A}"/>
               </a:ext>
             </a:extLst>
           </p:cNvPr>
@@ -15701,7 +15867,7 @@
           <p:cNvPr id="5" name="">
             <a:extLst xmlns:a="http://schemas.openxmlformats.org/drawingml/2006/main">
               <a:ext uri="{FF2B5EF4-FFF2-40B4-BE49-F238E27FC236}">
-                <a16:creationId xmlns:a16="http://schemas.microsoft.com/office/drawing/2014/main" id="{F1C96BAD-B729-4F18-9D4E-A43C6E3C091F}"/>
+                <a16:creationId xmlns:a16="http://schemas.microsoft.com/office/drawing/2014/main" id="{7A35B67B-B224-4B5B-8B01-60231FDC99D7}"/>
               </a:ext>
             </a:extLst>
           </p:cNvPr>
@@ -15758,7 +15924,7 @@
           <p:cNvPr id="6" name="">
             <a:extLst xmlns:a="http://schemas.openxmlformats.org/drawingml/2006/main">
               <a:ext uri="{FF2B5EF4-FFF2-40B4-BE49-F238E27FC236}">
-                <a16:creationId xmlns:a16="http://schemas.microsoft.com/office/drawing/2014/main" id="{763F522E-3037-4724-9734-74F75BE74D91}"/>
+                <a16:creationId xmlns:a16="http://schemas.microsoft.com/office/drawing/2014/main" id="{72EBB0E5-08D2-44C1-8646-099439CA4E0D}"/>
               </a:ext>
             </a:extLst>
           </p:cNvPr>
@@ -15813,7 +15979,7 @@
     </p:spTree>
     <p:extLst>
       <p:ext uri="{BB962C8B-B14F-4D97-AF65-F5344CB8AC3E}">
-        <p14:creationId xmlns:p14="http://schemas.microsoft.com/office/powerpoint/2010/main" val="399320903"/>
+        <p14:creationId xmlns:p14="http://schemas.microsoft.com/office/powerpoint/2010/main" val="333591449"/>
       </p:ext>
     </p:extLst>
   </p:cSld>
@@ -15844,7 +16010,7 @@
           <p:cNvPr id="7" name="">
             <a:extLst xmlns:a="http://schemas.openxmlformats.org/drawingml/2006/main">
               <a:ext uri="{FF2B5EF4-FFF2-40B4-BE49-F238E27FC236}">
-                <a16:creationId xmlns:a16="http://schemas.microsoft.com/office/drawing/2014/main" id="{B43B9227-1F39-493F-8095-EF061CF26154}"/>
+                <a16:creationId xmlns:a16="http://schemas.microsoft.com/office/drawing/2014/main" id="{C78A36E7-D43C-4495-90A8-64C03D481B95}"/>
               </a:ext>
             </a:extLst>
           </p:cNvPr>
@@ -15901,7 +16067,7 @@
           <p:cNvPr id="2" name="">
             <a:extLst xmlns:a="http://schemas.openxmlformats.org/drawingml/2006/main">
               <a:ext uri="{FF2B5EF4-FFF2-40B4-BE49-F238E27FC236}">
-                <a16:creationId xmlns:a16="http://schemas.microsoft.com/office/drawing/2014/main" id="{3DD80831-CC20-4AC4-9BF0-2331D3ACC68E}"/>
+                <a16:creationId xmlns:a16="http://schemas.microsoft.com/office/drawing/2014/main" id="{68CF6212-248F-4944-B2BA-C42B893ECA66}"/>
               </a:ext>
             </a:extLst>
           </p:cNvPr>
@@ -16147,7 +16313,7 @@
           <p:cNvPr id="3" name="">
             <a:extLst xmlns:a="http://schemas.openxmlformats.org/drawingml/2006/main">
               <a:ext uri="{FF2B5EF4-FFF2-40B4-BE49-F238E27FC236}">
-                <a16:creationId xmlns:a16="http://schemas.microsoft.com/office/drawing/2014/main" id="{63C78E03-5625-46FB-8A8E-7F2268040CDA}"/>
+                <a16:creationId xmlns:a16="http://schemas.microsoft.com/office/drawing/2014/main" id="{EBE71DBB-1C6E-4F2C-9CB4-6824ABCD236E}"/>
               </a:ext>
             </a:extLst>
           </p:cNvPr>
@@ -16204,7 +16370,7 @@
           <p:cNvPr id="4" name="">
             <a:extLst xmlns:a="http://schemas.openxmlformats.org/drawingml/2006/main">
               <a:ext uri="{FF2B5EF4-FFF2-40B4-BE49-F238E27FC236}">
-                <a16:creationId xmlns:a16="http://schemas.microsoft.com/office/drawing/2014/main" id="{12B5202B-DA23-4E1C-BDCE-F59816188108}"/>
+                <a16:creationId xmlns:a16="http://schemas.microsoft.com/office/drawing/2014/main" id="{9B209211-2550-4D63-ABB4-9ED8DE0E9421}"/>
               </a:ext>
             </a:extLst>
           </p:cNvPr>
@@ -16363,7 +16529,7 @@
           <p:cNvPr id="5" name="">
             <a:extLst xmlns:a="http://schemas.openxmlformats.org/drawingml/2006/main">
               <a:ext uri="{FF2B5EF4-FFF2-40B4-BE49-F238E27FC236}">
-                <a16:creationId xmlns:a16="http://schemas.microsoft.com/office/drawing/2014/main" id="{964CF8F5-A9DF-4C0D-929F-83672627199D}"/>
+                <a16:creationId xmlns:a16="http://schemas.microsoft.com/office/drawing/2014/main" id="{997F80B1-B918-419F-957E-FC498C104CCC}"/>
               </a:ext>
             </a:extLst>
           </p:cNvPr>
@@ -16420,7 +16586,7 @@
           <p:cNvPr id="6" name="">
             <a:extLst xmlns:a="http://schemas.openxmlformats.org/drawingml/2006/main">
               <a:ext uri="{FF2B5EF4-FFF2-40B4-BE49-F238E27FC236}">
-                <a16:creationId xmlns:a16="http://schemas.microsoft.com/office/drawing/2014/main" id="{89C6C2C1-4BDD-4D41-8B7E-FE7A483D348B}"/>
+                <a16:creationId xmlns:a16="http://schemas.microsoft.com/office/drawing/2014/main" id="{09556ACD-5420-40A1-9485-31CB591118A7}"/>
               </a:ext>
             </a:extLst>
           </p:cNvPr>
@@ -16475,7 +16641,7 @@
     </p:spTree>
     <p:extLst>
       <p:ext uri="{BB962C8B-B14F-4D97-AF65-F5344CB8AC3E}">
-        <p14:creationId xmlns:p14="http://schemas.microsoft.com/office/powerpoint/2010/main" val="1474640682"/>
+        <p14:creationId xmlns:p14="http://schemas.microsoft.com/office/powerpoint/2010/main" val="439576555"/>
       </p:ext>
     </p:extLst>
   </p:cSld>

</xml_diff>

<commit_message>
Clarify affiliation and write public guides for attendees
</commit_message>
<xml_diff>
--- a/output/Bringing-the-Heat.pptx
+++ b/output/Bringing-the-Heat.pptx
@@ -2,34 +2,34 @@
 <file path=ppt/presentation.xml><?xml version="1.0" encoding="utf-8"?>
 <p:presentation xmlns:p="http://schemas.openxmlformats.org/presentationml/2006/main">
   <p:sldMasterIdLst>
-    <p:sldMasterId xmlns:r="http://schemas.openxmlformats.org/officeDocument/2006/relationships" id="2147483648" r:id="R6b020836dd244439"/>
+    <p:sldMasterId xmlns:r="http://schemas.openxmlformats.org/officeDocument/2006/relationships" id="2147483648" r:id="Rcf1b4518bfa64416"/>
   </p:sldMasterIdLst>
   <p:notesMasterIdLst>
-    <p:notesMasterId xmlns:r="http://schemas.openxmlformats.org/officeDocument/2006/relationships" r:id="R1b69ab9fc1794b92"/>
+    <p:notesMasterId xmlns:r="http://schemas.openxmlformats.org/officeDocument/2006/relationships" r:id="R745b8f67a8314c9c"/>
   </p:notesMasterIdLst>
   <p:sldIdLst>
-    <p:sldId xmlns:r="http://schemas.openxmlformats.org/officeDocument/2006/relationships" id="256" r:id="R1b86b7a3836041f9"/>
-    <p:sldId xmlns:r="http://schemas.openxmlformats.org/officeDocument/2006/relationships" id="257" r:id="Rb21cd10ffa9242c0"/>
-    <p:sldId xmlns:r="http://schemas.openxmlformats.org/officeDocument/2006/relationships" id="258" r:id="R75f68fd207744013"/>
-    <p:sldId xmlns:r="http://schemas.openxmlformats.org/officeDocument/2006/relationships" id="259" r:id="Rbd805e7879d742c6"/>
-    <p:sldId xmlns:r="http://schemas.openxmlformats.org/officeDocument/2006/relationships" id="260" r:id="Ref26c4ffa00d43a3"/>
-    <p:sldId xmlns:r="http://schemas.openxmlformats.org/officeDocument/2006/relationships" id="261" r:id="Rc7553532f68344e3"/>
-    <p:sldId xmlns:r="http://schemas.openxmlformats.org/officeDocument/2006/relationships" id="262" r:id="R0e5e43e9273e4e5e"/>
-    <p:sldId xmlns:r="http://schemas.openxmlformats.org/officeDocument/2006/relationships" id="263" r:id="Rf05c071d5ad643f7"/>
-    <p:sldId xmlns:r="http://schemas.openxmlformats.org/officeDocument/2006/relationships" id="264" r:id="Rc3916ea88e8a4dea"/>
-    <p:sldId xmlns:r="http://schemas.openxmlformats.org/officeDocument/2006/relationships" id="265" r:id="R70161f5ce0e3401e"/>
-    <p:sldId xmlns:r="http://schemas.openxmlformats.org/officeDocument/2006/relationships" id="266" r:id="R96b74216fdde4c50"/>
-    <p:sldId xmlns:r="http://schemas.openxmlformats.org/officeDocument/2006/relationships" id="267" r:id="R6a389ec511614f02"/>
-    <p:sldId xmlns:r="http://schemas.openxmlformats.org/officeDocument/2006/relationships" id="268" r:id="R5aaae1a02f2941cd"/>
-    <p:sldId xmlns:r="http://schemas.openxmlformats.org/officeDocument/2006/relationships" id="269" r:id="R8426eddb02014483"/>
-    <p:sldId xmlns:r="http://schemas.openxmlformats.org/officeDocument/2006/relationships" id="270" r:id="R4da9463ebd324b2c"/>
-    <p:sldId xmlns:r="http://schemas.openxmlformats.org/officeDocument/2006/relationships" id="271" r:id="R6aad3997d07b42b8"/>
-    <p:sldId xmlns:r="http://schemas.openxmlformats.org/officeDocument/2006/relationships" id="272" r:id="R3423d6f1c8f344ea"/>
-    <p:sldId xmlns:r="http://schemas.openxmlformats.org/officeDocument/2006/relationships" id="273" r:id="Recb1d6320f9b4a7f"/>
-    <p:sldId xmlns:r="http://schemas.openxmlformats.org/officeDocument/2006/relationships" id="274" r:id="R1c568befc70b4783"/>
-    <p:sldId xmlns:r="http://schemas.openxmlformats.org/officeDocument/2006/relationships" id="275" r:id="R18f6093793794bc2"/>
-    <p:sldId xmlns:r="http://schemas.openxmlformats.org/officeDocument/2006/relationships" id="276" r:id="Rc3ccc9bdf42a4824"/>
-    <p:sldId xmlns:r="http://schemas.openxmlformats.org/officeDocument/2006/relationships" id="277" r:id="R42f07726f0cd4a76"/>
+    <p:sldId xmlns:r="http://schemas.openxmlformats.org/officeDocument/2006/relationships" id="256" r:id="R384e593739054ba5"/>
+    <p:sldId xmlns:r="http://schemas.openxmlformats.org/officeDocument/2006/relationships" id="257" r:id="R88e5f8d36ff14a1c"/>
+    <p:sldId xmlns:r="http://schemas.openxmlformats.org/officeDocument/2006/relationships" id="258" r:id="R5adebf30f39d4284"/>
+    <p:sldId xmlns:r="http://schemas.openxmlformats.org/officeDocument/2006/relationships" id="259" r:id="R38d8d0d51d374568"/>
+    <p:sldId xmlns:r="http://schemas.openxmlformats.org/officeDocument/2006/relationships" id="260" r:id="R5c724f54a72a4eac"/>
+    <p:sldId xmlns:r="http://schemas.openxmlformats.org/officeDocument/2006/relationships" id="261" r:id="R6a99dd3bc78548c4"/>
+    <p:sldId xmlns:r="http://schemas.openxmlformats.org/officeDocument/2006/relationships" id="262" r:id="R4ab4b637b73843ad"/>
+    <p:sldId xmlns:r="http://schemas.openxmlformats.org/officeDocument/2006/relationships" id="263" r:id="Rf61deeef391d4a42"/>
+    <p:sldId xmlns:r="http://schemas.openxmlformats.org/officeDocument/2006/relationships" id="264" r:id="R4d589d760f0b4bf8"/>
+    <p:sldId xmlns:r="http://schemas.openxmlformats.org/officeDocument/2006/relationships" id="265" r:id="R188856fd25e14ce1"/>
+    <p:sldId xmlns:r="http://schemas.openxmlformats.org/officeDocument/2006/relationships" id="266" r:id="R57cb3796b80d43f3"/>
+    <p:sldId xmlns:r="http://schemas.openxmlformats.org/officeDocument/2006/relationships" id="267" r:id="R8ca3c3a6dcf44537"/>
+    <p:sldId xmlns:r="http://schemas.openxmlformats.org/officeDocument/2006/relationships" id="268" r:id="R8a036a9d7e174c03"/>
+    <p:sldId xmlns:r="http://schemas.openxmlformats.org/officeDocument/2006/relationships" id="269" r:id="R939e0e7bf1c6405b"/>
+    <p:sldId xmlns:r="http://schemas.openxmlformats.org/officeDocument/2006/relationships" id="270" r:id="R0c2acfd7c86e40c3"/>
+    <p:sldId xmlns:r="http://schemas.openxmlformats.org/officeDocument/2006/relationships" id="271" r:id="Race9797d37ff4f27"/>
+    <p:sldId xmlns:r="http://schemas.openxmlformats.org/officeDocument/2006/relationships" id="272" r:id="Rcaff61a17a7e49ee"/>
+    <p:sldId xmlns:r="http://schemas.openxmlformats.org/officeDocument/2006/relationships" id="273" r:id="R782a38538e8f4392"/>
+    <p:sldId xmlns:r="http://schemas.openxmlformats.org/officeDocument/2006/relationships" id="274" r:id="R705c4540cb3541b4"/>
+    <p:sldId xmlns:r="http://schemas.openxmlformats.org/officeDocument/2006/relationships" id="275" r:id="Rcaedeff8f89f408d"/>
+    <p:sldId xmlns:r="http://schemas.openxmlformats.org/officeDocument/2006/relationships" id="276" r:id="R8b81ea9127194e4c"/>
+    <p:sldId xmlns:r="http://schemas.openxmlformats.org/officeDocument/2006/relationships" id="277" r:id="R67909a9c36ed4c30"/>
   </p:sldIdLst>
   <p:sldSz cx="12192000" cy="6858000"/>
   <p:notesSz cx="6858000" cy="9144000"/>
@@ -473,7 +473,7 @@
           </a:p>
           <a:p xmlns:a="http://schemas.openxmlformats.org/drawingml/2006/main">
             <a:r>
-              <a:t>OPEN (45 seconds). Ask for a quick show of hands: who has downloaded a model from the Hub, and who has had to support one after deployment? Pause briefly. Say: Today we will follow one model through a repeatable workflow. You will see the code, the evidence that could block a release, and the choices that change when the target hardware changes. Introduce yourself with the supplied bio: Muntaser Syed, Lead GenAI Engineer at Insight Global, formerly NVIDIA. Venue: Miami Dade College. Do not add employer performance claims.</a:t>
+              <a:t>OPEN (45 seconds). Ask for a quick show of hands: who has downloaded a model from the Hub, and who has had to support one after deployment? Pause briefly. Say: Today we will follow one model through a repeatable workflow. You will see the code, the evidence that could block a release, and the choices that change when the target hardware changes. Introduce yourself with the supplied bio: Muntaser Syed, Lead GenAI Engineer at Insight Global, formerly NVIDIA. Academic affiliation: Florida Institute of Technology. Venue: Miami Dade College. Do not add employer performance claims.</a:t>
             </a:r>
           </a:p>
           <a:p xmlns:a="http://schemas.openxmlformats.org/drawingml/2006/main">
@@ -2906,7 +2906,7 @@
   </p:cSld>
   <p:clrMap bg1="lt1" tx1="dk1" bg2="lt2" tx2="dk2" accent1="accent1" accent2="accent2" accent3="accent3" accent4="accent4" accent5="accent5" accent6="accent6" hlink="hlink" folHlink="folHlink"/>
   <p:sldLayoutIdLst>
-    <p:sldLayoutId xmlns:r="http://schemas.openxmlformats.org/officeDocument/2006/relationships" id="2147483649" r:id="R325dce84982743b7"/>
+    <p:sldLayoutId xmlns:r="http://schemas.openxmlformats.org/officeDocument/2006/relationships" id="2147483649" r:id="R39467804f5ac4b2a"/>
   </p:sldLayoutIdLst>
   <p:txStyles>
     <p:titleStyle>
@@ -4881,7 +4881,7 @@
           <p:cNvPr id="6" name="">
             <a:extLst xmlns:a="http://schemas.openxmlformats.org/drawingml/2006/main">
               <a:ext uri="{FF2B5EF4-FFF2-40B4-BE49-F238E27FC236}">
-                <a16:creationId xmlns:a16="http://schemas.microsoft.com/office/drawing/2014/main" id="{D766DA2E-5D57-4430-B7D6-02392A1617C6}"/>
+                <a16:creationId xmlns:a16="http://schemas.microsoft.com/office/drawing/2014/main" id="{12F4F9B5-25C7-4AA5-A8B8-546B2B88C9DE}"/>
               </a:ext>
             </a:extLst>
           </p:cNvPr>
@@ -4938,7 +4938,7 @@
           <p:cNvPr id="2" name="">
             <a:extLst xmlns:a="http://schemas.openxmlformats.org/drawingml/2006/main">
               <a:ext uri="{FF2B5EF4-FFF2-40B4-BE49-F238E27FC236}">
-                <a16:creationId xmlns:a16="http://schemas.microsoft.com/office/drawing/2014/main" id="{81D6DEFC-FC3D-4F12-BE44-3F5C2676CA77}"/>
+                <a16:creationId xmlns:a16="http://schemas.microsoft.com/office/drawing/2014/main" id="{D87D321C-0ABF-4226-BA01-858D371E8072}"/>
               </a:ext>
             </a:extLst>
           </p:cNvPr>
@@ -5018,7 +5018,7 @@
           <p:cNvPr id="3" name="">
             <a:extLst xmlns:a="http://schemas.openxmlformats.org/drawingml/2006/main">
               <a:ext uri="{FF2B5EF4-FFF2-40B4-BE49-F238E27FC236}">
-                <a16:creationId xmlns:a16="http://schemas.microsoft.com/office/drawing/2014/main" id="{774037EE-A498-4896-834D-D20150D080F8}"/>
+                <a16:creationId xmlns:a16="http://schemas.microsoft.com/office/drawing/2014/main" id="{62ACC2E9-150F-4450-B85A-34422B7E9963}"/>
               </a:ext>
             </a:extLst>
           </p:cNvPr>
@@ -5075,7 +5075,7 @@
           <p:cNvPr id="4" name="">
             <a:extLst xmlns:a="http://schemas.openxmlformats.org/drawingml/2006/main">
               <a:ext uri="{FF2B5EF4-FFF2-40B4-BE49-F238E27FC236}">
-                <a16:creationId xmlns:a16="http://schemas.microsoft.com/office/drawing/2014/main" id="{D1C6371E-A8B6-47EC-B9AF-96CF3176D196}"/>
+                <a16:creationId xmlns:a16="http://schemas.microsoft.com/office/drawing/2014/main" id="{950500BC-F083-4FA3-ACD5-373C6808719F}"/>
               </a:ext>
             </a:extLst>
           </p:cNvPr>
@@ -5121,7 +5121,7 @@
                 <a:latin typeface="Arial"/>
                 <a:ea typeface="Arial"/>
                 <a:cs typeface="Arial"/>
-                <a:hlinkClick xmlns:r="http://schemas.openxmlformats.org/officeDocument/2006/relationships" r:id="R3fa139aab6994aee"/>
+                <a:hlinkClick xmlns:r="http://schemas.openxmlformats.org/officeDocument/2006/relationships" r:id="R361e2293c1e84e2d"/>
               </a:rPr>
               <a:t>muntasersyed.com</a:t>
             </a:r>
@@ -5137,7 +5137,7 @@
           <p:nvPr/>
         </p:nvPicPr>
         <p:blipFill>
-          <a:blip xmlns:r="http://schemas.openxmlformats.org/officeDocument/2006/relationships" xmlns:a="http://schemas.openxmlformats.org/drawingml/2006/main" r:embed="R4bf11aa95507453b"/>
+          <a:blip xmlns:r="http://schemas.openxmlformats.org/officeDocument/2006/relationships" xmlns:a="http://schemas.openxmlformats.org/drawingml/2006/main" r:embed="Rcce03ebf7dce4e17"/>
           <a:stretch xmlns:a="http://schemas.openxmlformats.org/drawingml/2006/main"/>
         </p:blipFill>
         <p:spPr>
@@ -5153,7 +5153,7 @@
     </p:spTree>
     <p:extLst>
       <p:ext uri="{BB962C8B-B14F-4D97-AF65-F5344CB8AC3E}">
-        <p14:creationId xmlns:p14="http://schemas.microsoft.com/office/powerpoint/2010/main" val="451615084"/>
+        <p14:creationId xmlns:p14="http://schemas.microsoft.com/office/powerpoint/2010/main" val="482395534"/>
       </p:ext>
     </p:extLst>
   </p:cSld>
@@ -5184,7 +5184,7 @@
           <p:cNvPr id="8" name="">
             <a:extLst xmlns:a="http://schemas.openxmlformats.org/drawingml/2006/main">
               <a:ext uri="{FF2B5EF4-FFF2-40B4-BE49-F238E27FC236}">
-                <a16:creationId xmlns:a16="http://schemas.microsoft.com/office/drawing/2014/main" id="{53AA6694-C9DA-4101-AC94-4C9A3AEBADCA}"/>
+                <a16:creationId xmlns:a16="http://schemas.microsoft.com/office/drawing/2014/main" id="{EC34D8F3-F627-4110-B3BC-5446A83A5B17}"/>
               </a:ext>
             </a:extLst>
           </p:cNvPr>
@@ -5248,7 +5248,7 @@
         </p:xfrm>
         <a:graphic xmlns:a="http://schemas.openxmlformats.org/drawingml/2006/main">
           <a:graphicData uri="http://schemas.openxmlformats.org/drawingml/2006/chart">
-            <c:chart xmlns:r="http://schemas.openxmlformats.org/officeDocument/2006/relationships" xmlns:c="http://schemas.openxmlformats.org/drawingml/2006/chart" r:id="R7a571b4aca604aa4"/>
+            <c:chart xmlns:r="http://schemas.openxmlformats.org/officeDocument/2006/relationships" xmlns:c="http://schemas.openxmlformats.org/drawingml/2006/chart" r:id="R6c78d2e90dcc48a7"/>
           </a:graphicData>
         </a:graphic>
       </p:graphicFrame>
@@ -5264,7 +5264,7 @@
         </p:xfrm>
         <a:graphic xmlns:a="http://schemas.openxmlformats.org/drawingml/2006/main">
           <a:graphicData uri="http://schemas.openxmlformats.org/drawingml/2006/chart">
-            <c:chart xmlns:r="http://schemas.openxmlformats.org/officeDocument/2006/relationships" xmlns:c="http://schemas.openxmlformats.org/drawingml/2006/chart" r:id="R0b019b6a3e7844da"/>
+            <c:chart xmlns:r="http://schemas.openxmlformats.org/officeDocument/2006/relationships" xmlns:c="http://schemas.openxmlformats.org/drawingml/2006/chart" r:id="Reddab4723db64538"/>
           </a:graphicData>
         </a:graphic>
       </p:graphicFrame>
@@ -5273,7 +5273,7 @@
           <p:cNvPr id="4" name="">
             <a:extLst xmlns:a="http://schemas.openxmlformats.org/drawingml/2006/main">
               <a:ext uri="{FF2B5EF4-FFF2-40B4-BE49-F238E27FC236}">
-                <a16:creationId xmlns:a16="http://schemas.microsoft.com/office/drawing/2014/main" id="{352803CA-D899-47D6-A60C-742A0D8D454E}"/>
+                <a16:creationId xmlns:a16="http://schemas.microsoft.com/office/drawing/2014/main" id="{04021314-9F5B-45CE-B9AB-5B90854D7938}"/>
               </a:ext>
             </a:extLst>
           </p:cNvPr>
@@ -5330,7 +5330,7 @@
           <p:cNvPr id="5" name="">
             <a:extLst xmlns:a="http://schemas.openxmlformats.org/drawingml/2006/main">
               <a:ext uri="{FF2B5EF4-FFF2-40B4-BE49-F238E27FC236}">
-                <a16:creationId xmlns:a16="http://schemas.microsoft.com/office/drawing/2014/main" id="{2828EBA6-71E9-411F-9F31-102320FC5381}"/>
+                <a16:creationId xmlns:a16="http://schemas.microsoft.com/office/drawing/2014/main" id="{302835BA-5D92-4DBA-A694-1942E789B6B2}"/>
               </a:ext>
             </a:extLst>
           </p:cNvPr>
@@ -5387,7 +5387,7 @@
           <p:cNvPr id="6" name="">
             <a:extLst xmlns:a="http://schemas.openxmlformats.org/drawingml/2006/main">
               <a:ext uri="{FF2B5EF4-FFF2-40B4-BE49-F238E27FC236}">
-                <a16:creationId xmlns:a16="http://schemas.microsoft.com/office/drawing/2014/main" id="{5A6C7D28-FE6B-44F4-9F1B-725EC2D6D063}"/>
+                <a16:creationId xmlns:a16="http://schemas.microsoft.com/office/drawing/2014/main" id="{A4E08B5D-A241-4997-BA28-5EFB5828C8B3}"/>
               </a:ext>
             </a:extLst>
           </p:cNvPr>
@@ -5444,7 +5444,7 @@
           <p:cNvPr id="7" name="">
             <a:extLst xmlns:a="http://schemas.openxmlformats.org/drawingml/2006/main">
               <a:ext uri="{FF2B5EF4-FFF2-40B4-BE49-F238E27FC236}">
-                <a16:creationId xmlns:a16="http://schemas.microsoft.com/office/drawing/2014/main" id="{A5EFE6E1-ACDF-4BE2-9C28-42B0BD3F656F}"/>
+                <a16:creationId xmlns:a16="http://schemas.microsoft.com/office/drawing/2014/main" id="{58E79ED4-E44F-4CAA-A29D-E25A3B9A19FB}"/>
               </a:ext>
             </a:extLst>
           </p:cNvPr>
@@ -5499,7 +5499,7 @@
     </p:spTree>
     <p:extLst>
       <p:ext uri="{BB962C8B-B14F-4D97-AF65-F5344CB8AC3E}">
-        <p14:creationId xmlns:p14="http://schemas.microsoft.com/office/powerpoint/2010/main" val="1531922950"/>
+        <p14:creationId xmlns:p14="http://schemas.microsoft.com/office/powerpoint/2010/main" val="1350659352"/>
       </p:ext>
     </p:extLst>
   </p:cSld>
@@ -5530,7 +5530,7 @@
           <p:cNvPr id="17" name="">
             <a:extLst xmlns:a="http://schemas.openxmlformats.org/drawingml/2006/main">
               <a:ext uri="{FF2B5EF4-FFF2-40B4-BE49-F238E27FC236}">
-                <a16:creationId xmlns:a16="http://schemas.microsoft.com/office/drawing/2014/main" id="{76F1F5BE-8688-42AD-B3C2-5FD77170FDFF}"/>
+                <a16:creationId xmlns:a16="http://schemas.microsoft.com/office/drawing/2014/main" id="{CBC4FBA3-6A7E-4327-A0A8-35B432C1873A}"/>
               </a:ext>
             </a:extLst>
           </p:cNvPr>
@@ -5587,7 +5587,7 @@
           <p:cNvPr id="2" name="lock">
             <a:extLst xmlns:a="http://schemas.openxmlformats.org/drawingml/2006/main">
               <a:ext uri="{FF2B5EF4-FFF2-40B4-BE49-F238E27FC236}">
-                <a16:creationId xmlns:a16="http://schemas.microsoft.com/office/drawing/2014/main" id="{75E6E07A-EF57-40C6-BD8D-6E117F1A4484}"/>
+                <a16:creationId xmlns:a16="http://schemas.microsoft.com/office/drawing/2014/main" id="{D8F7A8C9-C7A7-4CD6-BC08-4A325B2FC131}"/>
               </a:ext>
             </a:extLst>
           </p:cNvPr>
@@ -5671,7 +5671,7 @@
           <p:cNvPr id="3" name="evaluate">
             <a:extLst xmlns:a="http://schemas.openxmlformats.org/drawingml/2006/main">
               <a:ext uri="{FF2B5EF4-FFF2-40B4-BE49-F238E27FC236}">
-                <a16:creationId xmlns:a16="http://schemas.microsoft.com/office/drawing/2014/main" id="{7315C7C2-C80B-476A-9058-8DC51F84B08D}"/>
+                <a16:creationId xmlns:a16="http://schemas.microsoft.com/office/drawing/2014/main" id="{C55A6BCE-8719-4818-97B5-679535CCCECC}"/>
               </a:ext>
             </a:extLst>
           </p:cNvPr>
@@ -5755,7 +5755,7 @@
           <p:cNvPr id="4" name="decide">
             <a:extLst xmlns:a="http://schemas.openxmlformats.org/drawingml/2006/main">
               <a:ext uri="{FF2B5EF4-FFF2-40B4-BE49-F238E27FC236}">
-                <a16:creationId xmlns:a16="http://schemas.microsoft.com/office/drawing/2014/main" id="{55EC4333-3FBF-4C48-89DB-70BF64223D86}"/>
+                <a16:creationId xmlns:a16="http://schemas.microsoft.com/office/drawing/2014/main" id="{115AAD1B-A821-488E-B619-C1FF0004C3CF}"/>
               </a:ext>
             </a:extLst>
           </p:cNvPr>
@@ -5839,7 +5839,7 @@
           <p:cNvPr id="5" name="promote">
             <a:extLst xmlns:a="http://schemas.openxmlformats.org/drawingml/2006/main">
               <a:ext uri="{FF2B5EF4-FFF2-40B4-BE49-F238E27FC236}">
-                <a16:creationId xmlns:a16="http://schemas.microsoft.com/office/drawing/2014/main" id="{1BA77E83-EF79-4421-B451-0A3D6D341596}"/>
+                <a16:creationId xmlns:a16="http://schemas.microsoft.com/office/drawing/2014/main" id="{8B82A5B9-3129-4EDC-ACE6-B840432BF366}"/>
               </a:ext>
             </a:extLst>
           </p:cNvPr>
@@ -5900,7 +5900,7 @@
           <p:cNvPr id="6" name="block">
             <a:extLst xmlns:a="http://schemas.openxmlformats.org/drawingml/2006/main">
               <a:ext uri="{FF2B5EF4-FFF2-40B4-BE49-F238E27FC236}">
-                <a16:creationId xmlns:a16="http://schemas.microsoft.com/office/drawing/2014/main" id="{1EBD4F85-9F3C-41BC-B8F4-2DE72A07CAA0}"/>
+                <a16:creationId xmlns:a16="http://schemas.microsoft.com/office/drawing/2014/main" id="{317EEC5B-31DA-4D6E-B7D6-D15CAEDDCEFD}"/>
               </a:ext>
             </a:extLst>
           </p:cNvPr>
@@ -6065,7 +6065,7 @@
           <p:cNvPr id="11" name="">
             <a:extLst xmlns:a="http://schemas.openxmlformats.org/drawingml/2006/main">
               <a:ext uri="{FF2B5EF4-FFF2-40B4-BE49-F238E27FC236}">
-                <a16:creationId xmlns:a16="http://schemas.microsoft.com/office/drawing/2014/main" id="{723844A9-738D-46A9-AD6C-E91286A397ED}"/>
+                <a16:creationId xmlns:a16="http://schemas.microsoft.com/office/drawing/2014/main" id="{4F26FA6C-EC57-4A3E-A194-AD3FE8FC8B96}"/>
               </a:ext>
             </a:extLst>
           </p:cNvPr>
@@ -6122,7 +6122,7 @@
           <p:cNvPr id="12" name="">
             <a:extLst xmlns:a="http://schemas.openxmlformats.org/drawingml/2006/main">
               <a:ext uri="{FF2B5EF4-FFF2-40B4-BE49-F238E27FC236}">
-                <a16:creationId xmlns:a16="http://schemas.microsoft.com/office/drawing/2014/main" id="{536017C3-C8E5-4700-AC83-9D7A8E95FE59}"/>
+                <a16:creationId xmlns:a16="http://schemas.microsoft.com/office/drawing/2014/main" id="{0DD6E49F-F383-4ADB-A7CF-21403F72292A}"/>
               </a:ext>
             </a:extLst>
           </p:cNvPr>
@@ -6179,7 +6179,7 @@
           <p:cNvPr id="13" name="">
             <a:extLst xmlns:a="http://schemas.openxmlformats.org/drawingml/2006/main">
               <a:ext uri="{FF2B5EF4-FFF2-40B4-BE49-F238E27FC236}">
-                <a16:creationId xmlns:a16="http://schemas.microsoft.com/office/drawing/2014/main" id="{724ECEAF-1BD7-46B0-BCEA-483B3B2FD862}"/>
+                <a16:creationId xmlns:a16="http://schemas.microsoft.com/office/drawing/2014/main" id="{3E2D7C56-3514-4D46-89BF-AF2581986296}"/>
               </a:ext>
             </a:extLst>
           </p:cNvPr>
@@ -6236,7 +6236,7 @@
           <p:cNvPr id="14" name="">
             <a:extLst xmlns:a="http://schemas.openxmlformats.org/drawingml/2006/main">
               <a:ext uri="{FF2B5EF4-FFF2-40B4-BE49-F238E27FC236}">
-                <a16:creationId xmlns:a16="http://schemas.microsoft.com/office/drawing/2014/main" id="{32169FA2-EAAC-4A28-95F1-AA30BCF9EA7A}"/>
+                <a16:creationId xmlns:a16="http://schemas.microsoft.com/office/drawing/2014/main" id="{0C16F456-11D5-4664-81D1-6F6023FA7631}"/>
               </a:ext>
             </a:extLst>
           </p:cNvPr>
@@ -6293,7 +6293,7 @@
           <p:cNvPr id="15" name="">
             <a:extLst xmlns:a="http://schemas.openxmlformats.org/drawingml/2006/main">
               <a:ext uri="{FF2B5EF4-FFF2-40B4-BE49-F238E27FC236}">
-                <a16:creationId xmlns:a16="http://schemas.microsoft.com/office/drawing/2014/main" id="{B0B00EF1-55A7-4BD8-8F51-1E1D7C60C720}"/>
+                <a16:creationId xmlns:a16="http://schemas.microsoft.com/office/drawing/2014/main" id="{1DB39F7F-C182-4AD4-B254-6703F62A40BB}"/>
               </a:ext>
             </a:extLst>
           </p:cNvPr>
@@ -6350,7 +6350,7 @@
           <p:cNvPr id="16" name="">
             <a:extLst xmlns:a="http://schemas.openxmlformats.org/drawingml/2006/main">
               <a:ext uri="{FF2B5EF4-FFF2-40B4-BE49-F238E27FC236}">
-                <a16:creationId xmlns:a16="http://schemas.microsoft.com/office/drawing/2014/main" id="{F6D96334-B2A3-4B2F-AB00-68CA41EEB755}"/>
+                <a16:creationId xmlns:a16="http://schemas.microsoft.com/office/drawing/2014/main" id="{C523B8D5-DBFD-4686-9255-99346EEE94B6}"/>
               </a:ext>
             </a:extLst>
           </p:cNvPr>
@@ -6405,7 +6405,7 @@
     </p:spTree>
     <p:extLst>
       <p:ext uri="{BB962C8B-B14F-4D97-AF65-F5344CB8AC3E}">
-        <p14:creationId xmlns:p14="http://schemas.microsoft.com/office/powerpoint/2010/main" val="620667415"/>
+        <p14:creationId xmlns:p14="http://schemas.microsoft.com/office/powerpoint/2010/main" val="382711537"/>
       </p:ext>
     </p:extLst>
   </p:cSld>
@@ -6436,7 +6436,7 @@
           <p:cNvPr id="17" name="">
             <a:extLst xmlns:a="http://schemas.openxmlformats.org/drawingml/2006/main">
               <a:ext uri="{FF2B5EF4-FFF2-40B4-BE49-F238E27FC236}">
-                <a16:creationId xmlns:a16="http://schemas.microsoft.com/office/drawing/2014/main" id="{372D0BE9-C424-45A2-95E7-C97E9B2A9F35}"/>
+                <a16:creationId xmlns:a16="http://schemas.microsoft.com/office/drawing/2014/main" id="{E1754379-308A-4FF3-B57E-C358E5432E59}"/>
               </a:ext>
             </a:extLst>
           </p:cNvPr>
@@ -6493,7 +6493,7 @@
           <p:cNvPr id="2" name="base">
             <a:extLst xmlns:a="http://schemas.openxmlformats.org/drawingml/2006/main">
               <a:ext uri="{FF2B5EF4-FFF2-40B4-BE49-F238E27FC236}">
-                <a16:creationId xmlns:a16="http://schemas.microsoft.com/office/drawing/2014/main" id="{0C346267-2370-4180-8159-51C9F5FC1489}"/>
+                <a16:creationId xmlns:a16="http://schemas.microsoft.com/office/drawing/2014/main" id="{9B5BF3F5-A2BC-4972-8306-3F36029AF5F6}"/>
               </a:ext>
             </a:extLst>
           </p:cNvPr>
@@ -6577,7 +6577,7 @@
           <p:cNvPr id="3" name="adapter">
             <a:extLst xmlns:a="http://schemas.openxmlformats.org/drawingml/2006/main">
               <a:ext uri="{FF2B5EF4-FFF2-40B4-BE49-F238E27FC236}">
-                <a16:creationId xmlns:a16="http://schemas.microsoft.com/office/drawing/2014/main" id="{B26EFFAD-D08C-49B7-9896-98B30C996F12}"/>
+                <a16:creationId xmlns:a16="http://schemas.microsoft.com/office/drawing/2014/main" id="{DC2B1738-CAFA-438D-ADEA-6E8B15B04CEB}"/>
               </a:ext>
             </a:extLst>
           </p:cNvPr>
@@ -6661,7 +6661,7 @@
           <p:cNvPr id="4" name="merge">
             <a:extLst xmlns:a="http://schemas.openxmlformats.org/drawingml/2006/main">
               <a:ext uri="{FF2B5EF4-FFF2-40B4-BE49-F238E27FC236}">
-                <a16:creationId xmlns:a16="http://schemas.microsoft.com/office/drawing/2014/main" id="{BD29B7BC-2F59-49A5-AFC9-D5901897341E}"/>
+                <a16:creationId xmlns:a16="http://schemas.microsoft.com/office/drawing/2014/main" id="{D536D032-FB00-4C3C-B5F1-144A21E7D104}"/>
               </a:ext>
             </a:extLst>
           </p:cNvPr>
@@ -6722,7 +6722,7 @@
           <p:cNvPr id="5" name="export">
             <a:extLst xmlns:a="http://schemas.openxmlformats.org/drawingml/2006/main">
               <a:ext uri="{FF2B5EF4-FFF2-40B4-BE49-F238E27FC236}">
-                <a16:creationId xmlns:a16="http://schemas.microsoft.com/office/drawing/2014/main" id="{4A202165-382E-48FA-BF9C-53AAACDA307C}"/>
+                <a16:creationId xmlns:a16="http://schemas.microsoft.com/office/drawing/2014/main" id="{DFBA1A4F-8DA3-49FC-A4BC-615535AD4C92}"/>
               </a:ext>
             </a:extLst>
           </p:cNvPr>
@@ -6806,7 +6806,7 @@
           <p:cNvPr id="6" name="quantize">
             <a:extLst xmlns:a="http://schemas.openxmlformats.org/drawingml/2006/main">
               <a:ext uri="{FF2B5EF4-FFF2-40B4-BE49-F238E27FC236}">
-                <a16:creationId xmlns:a16="http://schemas.microsoft.com/office/drawing/2014/main" id="{2DEAD661-044C-4CB8-845D-DE8342974595}"/>
+                <a16:creationId xmlns:a16="http://schemas.microsoft.com/office/drawing/2014/main" id="{82B44C91-6095-4354-AE83-119B394DDD68}"/>
               </a:ext>
             </a:extLst>
           </p:cNvPr>
@@ -6994,7 +6994,7 @@
           <p:cNvPr id="11" name="">
             <a:extLst xmlns:a="http://schemas.openxmlformats.org/drawingml/2006/main">
               <a:ext uri="{FF2B5EF4-FFF2-40B4-BE49-F238E27FC236}">
-                <a16:creationId xmlns:a16="http://schemas.microsoft.com/office/drawing/2014/main" id="{C804B152-F109-48C6-B8B3-7D18BBED0495}"/>
+                <a16:creationId xmlns:a16="http://schemas.microsoft.com/office/drawing/2014/main" id="{3558D334-E6E9-40F5-BBBA-F1219B48179D}"/>
               </a:ext>
             </a:extLst>
           </p:cNvPr>
@@ -7051,7 +7051,7 @@
           <p:cNvPr id="12" name="">
             <a:extLst xmlns:a="http://schemas.openxmlformats.org/drawingml/2006/main">
               <a:ext uri="{FF2B5EF4-FFF2-40B4-BE49-F238E27FC236}">
-                <a16:creationId xmlns:a16="http://schemas.microsoft.com/office/drawing/2014/main" id="{9C4A6266-D85E-4AC3-A4DE-EF8D57DC2288}"/>
+                <a16:creationId xmlns:a16="http://schemas.microsoft.com/office/drawing/2014/main" id="{4B285C96-1302-4529-AD4E-4330CE498027}"/>
               </a:ext>
             </a:extLst>
           </p:cNvPr>
@@ -7108,7 +7108,7 @@
           <p:cNvPr id="13" name="">
             <a:extLst xmlns:a="http://schemas.openxmlformats.org/drawingml/2006/main">
               <a:ext uri="{FF2B5EF4-FFF2-40B4-BE49-F238E27FC236}">
-                <a16:creationId xmlns:a16="http://schemas.microsoft.com/office/drawing/2014/main" id="{7AB6E627-51F2-4300-B301-E9DD11309394}"/>
+                <a16:creationId xmlns:a16="http://schemas.microsoft.com/office/drawing/2014/main" id="{49D61AD6-22B1-4C59-A62A-19B2E312B5BB}"/>
               </a:ext>
             </a:extLst>
           </p:cNvPr>
@@ -7188,7 +7188,7 @@
           <p:cNvPr id="14" name="">
             <a:extLst xmlns:a="http://schemas.openxmlformats.org/drawingml/2006/main">
               <a:ext uri="{FF2B5EF4-FFF2-40B4-BE49-F238E27FC236}">
-                <a16:creationId xmlns:a16="http://schemas.microsoft.com/office/drawing/2014/main" id="{F3FCF5B3-FE94-4EB6-8FD7-6059F9ACC103}"/>
+                <a16:creationId xmlns:a16="http://schemas.microsoft.com/office/drawing/2014/main" id="{C51BF848-986B-4A5F-B9A7-84972BE57CE5}"/>
               </a:ext>
             </a:extLst>
           </p:cNvPr>
@@ -7245,7 +7245,7 @@
           <p:cNvPr id="15" name="">
             <a:extLst xmlns:a="http://schemas.openxmlformats.org/drawingml/2006/main">
               <a:ext uri="{FF2B5EF4-FFF2-40B4-BE49-F238E27FC236}">
-                <a16:creationId xmlns:a16="http://schemas.microsoft.com/office/drawing/2014/main" id="{07718E56-F6E3-4E02-A6B9-A7688FDADC0A}"/>
+                <a16:creationId xmlns:a16="http://schemas.microsoft.com/office/drawing/2014/main" id="{5B7AFD9C-79AC-4048-8706-653E6A2E414C}"/>
               </a:ext>
             </a:extLst>
           </p:cNvPr>
@@ -7302,7 +7302,7 @@
           <p:cNvPr id="16" name="">
             <a:extLst xmlns:a="http://schemas.openxmlformats.org/drawingml/2006/main">
               <a:ext uri="{FF2B5EF4-FFF2-40B4-BE49-F238E27FC236}">
-                <a16:creationId xmlns:a16="http://schemas.microsoft.com/office/drawing/2014/main" id="{1321DF7B-6984-455B-8B6C-2673C10E2A70}"/>
+                <a16:creationId xmlns:a16="http://schemas.microsoft.com/office/drawing/2014/main" id="{F25EB545-EA20-4531-A47A-BA4CCE54F464}"/>
               </a:ext>
             </a:extLst>
           </p:cNvPr>
@@ -7357,7 +7357,7 @@
     </p:spTree>
     <p:extLst>
       <p:ext uri="{BB962C8B-B14F-4D97-AF65-F5344CB8AC3E}">
-        <p14:creationId xmlns:p14="http://schemas.microsoft.com/office/powerpoint/2010/main" val="850931865"/>
+        <p14:creationId xmlns:p14="http://schemas.microsoft.com/office/powerpoint/2010/main" val="2077243770"/>
       </p:ext>
     </p:extLst>
   </p:cSld>
@@ -7388,7 +7388,7 @@
           <p:cNvPr id="9" name="">
             <a:extLst xmlns:a="http://schemas.openxmlformats.org/drawingml/2006/main">
               <a:ext uri="{FF2B5EF4-FFF2-40B4-BE49-F238E27FC236}">
-                <a16:creationId xmlns:a16="http://schemas.microsoft.com/office/drawing/2014/main" id="{326A7B01-C7A7-4748-9D34-145403505813}"/>
+                <a16:creationId xmlns:a16="http://schemas.microsoft.com/office/drawing/2014/main" id="{10925936-DFAB-4B2C-A246-EC04D6D405CF}"/>
               </a:ext>
             </a:extLst>
           </p:cNvPr>
@@ -7445,7 +7445,7 @@
           <p:cNvPr id="2" name="">
             <a:extLst xmlns:a="http://schemas.openxmlformats.org/drawingml/2006/main">
               <a:ext uri="{FF2B5EF4-FFF2-40B4-BE49-F238E27FC236}">
-                <a16:creationId xmlns:a16="http://schemas.microsoft.com/office/drawing/2014/main" id="{3866EA6D-1341-44C0-869B-9EB747217434}"/>
+                <a16:creationId xmlns:a16="http://schemas.microsoft.com/office/drawing/2014/main" id="{CC2483D1-119D-482A-9A17-5720DC0F0F13}"/>
               </a:ext>
             </a:extLst>
           </p:cNvPr>
@@ -7509,7 +7509,7 @@
         </p:xfrm>
         <a:graphic xmlns:a="http://schemas.openxmlformats.org/drawingml/2006/main">
           <a:graphicData uri="http://schemas.openxmlformats.org/drawingml/2006/chart">
-            <c:chart xmlns:r="http://schemas.openxmlformats.org/officeDocument/2006/relationships" xmlns:c="http://schemas.openxmlformats.org/drawingml/2006/chart" r:id="Rcfde943aa7d3442b"/>
+            <c:chart xmlns:r="http://schemas.openxmlformats.org/officeDocument/2006/relationships" xmlns:c="http://schemas.openxmlformats.org/drawingml/2006/chart" r:id="Rb8faf01f7a4c4d43"/>
           </a:graphicData>
         </a:graphic>
       </p:graphicFrame>
@@ -7525,7 +7525,7 @@
         </p:xfrm>
         <a:graphic xmlns:a="http://schemas.openxmlformats.org/drawingml/2006/main">
           <a:graphicData uri="http://schemas.openxmlformats.org/drawingml/2006/chart">
-            <c:chart xmlns:r="http://schemas.openxmlformats.org/officeDocument/2006/relationships" xmlns:c="http://schemas.openxmlformats.org/drawingml/2006/chart" r:id="Rca809445d89d4989"/>
+            <c:chart xmlns:r="http://schemas.openxmlformats.org/officeDocument/2006/relationships" xmlns:c="http://schemas.openxmlformats.org/drawingml/2006/chart" r:id="R0135673e2e704a5b"/>
           </a:graphicData>
         </a:graphic>
       </p:graphicFrame>
@@ -7541,7 +7541,7 @@
         </p:xfrm>
         <a:graphic xmlns:a="http://schemas.openxmlformats.org/drawingml/2006/main">
           <a:graphicData uri="http://schemas.openxmlformats.org/drawingml/2006/chart">
-            <c:chart xmlns:r="http://schemas.openxmlformats.org/officeDocument/2006/relationships" xmlns:c="http://schemas.openxmlformats.org/drawingml/2006/chart" r:id="R8cec0c88df9b416b"/>
+            <c:chart xmlns:r="http://schemas.openxmlformats.org/officeDocument/2006/relationships" xmlns:c="http://schemas.openxmlformats.org/drawingml/2006/chart" r:id="Rd388d58b53ce486a"/>
           </a:graphicData>
         </a:graphic>
       </p:graphicFrame>
@@ -7550,7 +7550,7 @@
           <p:cNvPr id="6" name="">
             <a:extLst xmlns:a="http://schemas.openxmlformats.org/drawingml/2006/main">
               <a:ext uri="{FF2B5EF4-FFF2-40B4-BE49-F238E27FC236}">
-                <a16:creationId xmlns:a16="http://schemas.microsoft.com/office/drawing/2014/main" id="{DD6127FD-8CC6-4E99-806F-8ED8C669659A}"/>
+                <a16:creationId xmlns:a16="http://schemas.microsoft.com/office/drawing/2014/main" id="{838B66B7-8A8A-4111-BBEB-A262A94C1DA7}"/>
               </a:ext>
             </a:extLst>
           </p:cNvPr>
@@ -7630,7 +7630,7 @@
           <p:cNvPr id="7" name="">
             <a:extLst xmlns:a="http://schemas.openxmlformats.org/drawingml/2006/main">
               <a:ext uri="{FF2B5EF4-FFF2-40B4-BE49-F238E27FC236}">
-                <a16:creationId xmlns:a16="http://schemas.microsoft.com/office/drawing/2014/main" id="{7A1EBDD5-0B5A-4072-8EA5-CA20B054A2F7}"/>
+                <a16:creationId xmlns:a16="http://schemas.microsoft.com/office/drawing/2014/main" id="{FB4FDF31-AF4C-4EBA-ADC8-9EE09C6D7732}"/>
               </a:ext>
             </a:extLst>
           </p:cNvPr>
@@ -7687,7 +7687,7 @@
           <p:cNvPr id="8" name="">
             <a:extLst xmlns:a="http://schemas.openxmlformats.org/drawingml/2006/main">
               <a:ext uri="{FF2B5EF4-FFF2-40B4-BE49-F238E27FC236}">
-                <a16:creationId xmlns:a16="http://schemas.microsoft.com/office/drawing/2014/main" id="{151CA11C-90B4-49E7-951B-AF3EC2837524}"/>
+                <a16:creationId xmlns:a16="http://schemas.microsoft.com/office/drawing/2014/main" id="{143B1E12-4A79-4C43-9FD6-F83518F413DD}"/>
               </a:ext>
             </a:extLst>
           </p:cNvPr>
@@ -7742,7 +7742,7 @@
     </p:spTree>
     <p:extLst>
       <p:ext uri="{BB962C8B-B14F-4D97-AF65-F5344CB8AC3E}">
-        <p14:creationId xmlns:p14="http://schemas.microsoft.com/office/powerpoint/2010/main" val="1228761534"/>
+        <p14:creationId xmlns:p14="http://schemas.microsoft.com/office/powerpoint/2010/main" val="639805078"/>
       </p:ext>
     </p:extLst>
   </p:cSld>
@@ -7773,7 +7773,7 @@
           <p:cNvPr id="21" name="">
             <a:extLst xmlns:a="http://schemas.openxmlformats.org/drawingml/2006/main">
               <a:ext uri="{FF2B5EF4-FFF2-40B4-BE49-F238E27FC236}">
-                <a16:creationId xmlns:a16="http://schemas.microsoft.com/office/drawing/2014/main" id="{A64C4B2C-E377-4AD0-AB35-7674FD9B81AB}"/>
+                <a16:creationId xmlns:a16="http://schemas.microsoft.com/office/drawing/2014/main" id="{A96E63B2-ABAB-4110-BE61-D44030EAEBB8}"/>
               </a:ext>
             </a:extLst>
           </p:cNvPr>
@@ -7830,7 +7830,7 @@
           <p:cNvPr id="2" name="target">
             <a:extLst xmlns:a="http://schemas.openxmlformats.org/drawingml/2006/main">
               <a:ext uri="{FF2B5EF4-FFF2-40B4-BE49-F238E27FC236}">
-                <a16:creationId xmlns:a16="http://schemas.microsoft.com/office/drawing/2014/main" id="{21EEF31D-E94C-4D83-8C89-339400BD9DA7}"/>
+                <a16:creationId xmlns:a16="http://schemas.microsoft.com/office/drawing/2014/main" id="{D780976E-0BB7-485A-95D5-829E53985C28}"/>
               </a:ext>
             </a:extLst>
           </p:cNvPr>
@@ -7914,7 +7914,7 @@
           <p:cNvPr id="3" name="cpu">
             <a:extLst xmlns:a="http://schemas.openxmlformats.org/drawingml/2006/main">
               <a:ext uri="{FF2B5EF4-FFF2-40B4-BE49-F238E27FC236}">
-                <a16:creationId xmlns:a16="http://schemas.microsoft.com/office/drawing/2014/main" id="{179EE59B-6643-4177-ACCA-384D2E3CC459}"/>
+                <a16:creationId xmlns:a16="http://schemas.microsoft.com/office/drawing/2014/main" id="{45FEDD7A-6CEC-4A6F-B0A1-9E930F2D7DCD}"/>
               </a:ext>
             </a:extLst>
           </p:cNvPr>
@@ -7975,7 +7975,7 @@
           <p:cNvPr id="4" name="browser">
             <a:extLst xmlns:a="http://schemas.openxmlformats.org/drawingml/2006/main">
               <a:ext uri="{FF2B5EF4-FFF2-40B4-BE49-F238E27FC236}">
-                <a16:creationId xmlns:a16="http://schemas.microsoft.com/office/drawing/2014/main" id="{156546E4-8E39-43D9-93AD-A206C6EDFDCB}"/>
+                <a16:creationId xmlns:a16="http://schemas.microsoft.com/office/drawing/2014/main" id="{B3655934-BF1C-4A87-ABDF-70389640C48B}"/>
               </a:ext>
             </a:extLst>
           </p:cNvPr>
@@ -8036,7 +8036,7 @@
           <p:cNvPr id="5" name="gpu">
             <a:extLst xmlns:a="http://schemas.openxmlformats.org/drawingml/2006/main">
               <a:ext uri="{FF2B5EF4-FFF2-40B4-BE49-F238E27FC236}">
-                <a16:creationId xmlns:a16="http://schemas.microsoft.com/office/drawing/2014/main" id="{5ADD8B76-3769-4E89-A73E-62349CD1CE4D}"/>
+                <a16:creationId xmlns:a16="http://schemas.microsoft.com/office/drawing/2014/main" id="{6788C43B-CFB1-4325-B960-075C55A97CA2}"/>
               </a:ext>
             </a:extLst>
           </p:cNvPr>
@@ -8097,7 +8097,7 @@
           <p:cNvPr id="6" name="managed">
             <a:extLst xmlns:a="http://schemas.openxmlformats.org/drawingml/2006/main">
               <a:ext uri="{FF2B5EF4-FFF2-40B4-BE49-F238E27FC236}">
-                <a16:creationId xmlns:a16="http://schemas.microsoft.com/office/drawing/2014/main" id="{1E3C496D-B192-4682-B19C-4686168E4D13}"/>
+                <a16:creationId xmlns:a16="http://schemas.microsoft.com/office/drawing/2014/main" id="{56A6D403-B5F4-4A69-AD6A-D4A03E953EEA}"/>
               </a:ext>
             </a:extLst>
           </p:cNvPr>
@@ -8266,7 +8266,7 @@
           <p:cNvPr id="11" name="">
             <a:extLst xmlns:a="http://schemas.openxmlformats.org/drawingml/2006/main">
               <a:ext uri="{FF2B5EF4-FFF2-40B4-BE49-F238E27FC236}">
-                <a16:creationId xmlns:a16="http://schemas.microsoft.com/office/drawing/2014/main" id="{00B61EFA-D266-4062-9AA1-AADB72170D71}"/>
+                <a16:creationId xmlns:a16="http://schemas.microsoft.com/office/drawing/2014/main" id="{27EB3B58-0F45-4F2E-A4E1-1E364DF96478}"/>
               </a:ext>
             </a:extLst>
           </p:cNvPr>
@@ -8323,7 +8323,7 @@
           <p:cNvPr id="12" name="">
             <a:extLst xmlns:a="http://schemas.openxmlformats.org/drawingml/2006/main">
               <a:ext uri="{FF2B5EF4-FFF2-40B4-BE49-F238E27FC236}">
-                <a16:creationId xmlns:a16="http://schemas.microsoft.com/office/drawing/2014/main" id="{59ECDF63-ABDE-4D37-BAE7-50F0A5B30645}"/>
+                <a16:creationId xmlns:a16="http://schemas.microsoft.com/office/drawing/2014/main" id="{2C459A62-1BE9-4602-8E23-178C875DFC97}"/>
               </a:ext>
             </a:extLst>
           </p:cNvPr>
@@ -8380,7 +8380,7 @@
           <p:cNvPr id="13" name="">
             <a:extLst xmlns:a="http://schemas.openxmlformats.org/drawingml/2006/main">
               <a:ext uri="{FF2B5EF4-FFF2-40B4-BE49-F238E27FC236}">
-                <a16:creationId xmlns:a16="http://schemas.microsoft.com/office/drawing/2014/main" id="{00EF348E-3173-49C9-A7BB-59FC684D778D}"/>
+                <a16:creationId xmlns:a16="http://schemas.microsoft.com/office/drawing/2014/main" id="{1AA68181-FA0A-4E7F-ACCD-287EF845E124}"/>
               </a:ext>
             </a:extLst>
           </p:cNvPr>
@@ -8437,7 +8437,7 @@
           <p:cNvPr id="14" name="">
             <a:extLst xmlns:a="http://schemas.openxmlformats.org/drawingml/2006/main">
               <a:ext uri="{FF2B5EF4-FFF2-40B4-BE49-F238E27FC236}">
-                <a16:creationId xmlns:a16="http://schemas.microsoft.com/office/drawing/2014/main" id="{AC2898D8-0DF0-46FC-980A-AAE06CF2BD6F}"/>
+                <a16:creationId xmlns:a16="http://schemas.microsoft.com/office/drawing/2014/main" id="{58BD5485-C5EC-498B-9E0C-F35A52C7BBF1}"/>
               </a:ext>
             </a:extLst>
           </p:cNvPr>
@@ -8494,7 +8494,7 @@
           <p:cNvPr id="15" name="">
             <a:extLst xmlns:a="http://schemas.openxmlformats.org/drawingml/2006/main">
               <a:ext uri="{FF2B5EF4-FFF2-40B4-BE49-F238E27FC236}">
-                <a16:creationId xmlns:a16="http://schemas.microsoft.com/office/drawing/2014/main" id="{6858CB02-C6E2-4E3A-9400-460C0F6735E1}"/>
+                <a16:creationId xmlns:a16="http://schemas.microsoft.com/office/drawing/2014/main" id="{19D93D51-F424-4F07-AACD-C8CE369FA458}"/>
               </a:ext>
             </a:extLst>
           </p:cNvPr>
@@ -8551,7 +8551,7 @@
           <p:cNvPr id="16" name="">
             <a:extLst xmlns:a="http://schemas.openxmlformats.org/drawingml/2006/main">
               <a:ext uri="{FF2B5EF4-FFF2-40B4-BE49-F238E27FC236}">
-                <a16:creationId xmlns:a16="http://schemas.microsoft.com/office/drawing/2014/main" id="{982886C3-3598-42E8-B624-59688A092480}"/>
+                <a16:creationId xmlns:a16="http://schemas.microsoft.com/office/drawing/2014/main" id="{F019307F-0CD9-4E5E-B8DC-B4CD7A2CA93A}"/>
               </a:ext>
             </a:extLst>
           </p:cNvPr>
@@ -8608,7 +8608,7 @@
           <p:cNvPr id="17" name="">
             <a:extLst xmlns:a="http://schemas.openxmlformats.org/drawingml/2006/main">
               <a:ext uri="{FF2B5EF4-FFF2-40B4-BE49-F238E27FC236}">
-                <a16:creationId xmlns:a16="http://schemas.microsoft.com/office/drawing/2014/main" id="{47EE4751-1BB9-41BF-8D4B-E5AC45A46A1B}"/>
+                <a16:creationId xmlns:a16="http://schemas.microsoft.com/office/drawing/2014/main" id="{C4F0E53B-1341-4BF5-854B-84DC7AB0BB3F}"/>
               </a:ext>
             </a:extLst>
           </p:cNvPr>
@@ -8665,7 +8665,7 @@
           <p:cNvPr id="18" name="">
             <a:extLst xmlns:a="http://schemas.openxmlformats.org/drawingml/2006/main">
               <a:ext uri="{FF2B5EF4-FFF2-40B4-BE49-F238E27FC236}">
-                <a16:creationId xmlns:a16="http://schemas.microsoft.com/office/drawing/2014/main" id="{5ABE7015-7A1C-4606-B6BE-E267D3F81232}"/>
+                <a16:creationId xmlns:a16="http://schemas.microsoft.com/office/drawing/2014/main" id="{2F8F02C7-9B12-4176-B2DF-8F4F7EEE5B6B}"/>
               </a:ext>
             </a:extLst>
           </p:cNvPr>
@@ -8722,7 +8722,7 @@
           <p:cNvPr id="19" name="">
             <a:extLst xmlns:a="http://schemas.openxmlformats.org/drawingml/2006/main">
               <a:ext uri="{FF2B5EF4-FFF2-40B4-BE49-F238E27FC236}">
-                <a16:creationId xmlns:a16="http://schemas.microsoft.com/office/drawing/2014/main" id="{05AAC695-417E-4333-A1BA-19DD708BF20A}"/>
+                <a16:creationId xmlns:a16="http://schemas.microsoft.com/office/drawing/2014/main" id="{ED0F1EB2-AA4B-48E3-B0D8-AA2675B72139}"/>
               </a:ext>
             </a:extLst>
           </p:cNvPr>
@@ -8779,7 +8779,7 @@
           <p:cNvPr id="20" name="">
             <a:extLst xmlns:a="http://schemas.openxmlformats.org/drawingml/2006/main">
               <a:ext uri="{FF2B5EF4-FFF2-40B4-BE49-F238E27FC236}">
-                <a16:creationId xmlns:a16="http://schemas.microsoft.com/office/drawing/2014/main" id="{529E4F80-64F0-443A-901B-ECCE03116673}"/>
+                <a16:creationId xmlns:a16="http://schemas.microsoft.com/office/drawing/2014/main" id="{26996FF2-4803-45A7-BF08-D51442B590A3}"/>
               </a:ext>
             </a:extLst>
           </p:cNvPr>
@@ -8834,7 +8834,7 @@
     </p:spTree>
     <p:extLst>
       <p:ext uri="{BB962C8B-B14F-4D97-AF65-F5344CB8AC3E}">
-        <p14:creationId xmlns:p14="http://schemas.microsoft.com/office/powerpoint/2010/main" val="989823874"/>
+        <p14:creationId xmlns:p14="http://schemas.microsoft.com/office/powerpoint/2010/main" val="383712406"/>
       </p:ext>
     </p:extLst>
   </p:cSld>
@@ -8865,7 +8865,7 @@
           <p:cNvPr id="13" name="">
             <a:extLst xmlns:a="http://schemas.openxmlformats.org/drawingml/2006/main">
               <a:ext uri="{FF2B5EF4-FFF2-40B4-BE49-F238E27FC236}">
-                <a16:creationId xmlns:a16="http://schemas.microsoft.com/office/drawing/2014/main" id="{E9090A91-2382-4BC1-BBCE-803CA340CEB1}"/>
+                <a16:creationId xmlns:a16="http://schemas.microsoft.com/office/drawing/2014/main" id="{A74DD39E-F1F4-433B-BAF5-3FB5E6812DD7}"/>
               </a:ext>
             </a:extLst>
           </p:cNvPr>
@@ -8922,7 +8922,7 @@
           <p:cNvPr id="2" name="">
             <a:extLst xmlns:a="http://schemas.openxmlformats.org/drawingml/2006/main">
               <a:ext uri="{FF2B5EF4-FFF2-40B4-BE49-F238E27FC236}">
-                <a16:creationId xmlns:a16="http://schemas.microsoft.com/office/drawing/2014/main" id="{DC1F49EC-60FA-4045-A3B2-8D3E6E04B6D9}"/>
+                <a16:creationId xmlns:a16="http://schemas.microsoft.com/office/drawing/2014/main" id="{7B8C14B7-7A73-4717-A700-0FF8E391A20F}"/>
               </a:ext>
             </a:extLst>
           </p:cNvPr>
@@ -8979,7 +8979,7 @@
           <p:cNvPr id="3" name="">
             <a:extLst xmlns:a="http://schemas.openxmlformats.org/drawingml/2006/main">
               <a:ext uri="{FF2B5EF4-FFF2-40B4-BE49-F238E27FC236}">
-                <a16:creationId xmlns:a16="http://schemas.microsoft.com/office/drawing/2014/main" id="{5A8FCFBC-666D-4C26-8EF1-CA8FFE49B03D}"/>
+                <a16:creationId xmlns:a16="http://schemas.microsoft.com/office/drawing/2014/main" id="{2AE095B1-4806-4914-80AB-0BC70C46611F}"/>
               </a:ext>
             </a:extLst>
           </p:cNvPr>
@@ -9036,7 +9036,7 @@
           <p:cNvPr id="4" name="">
             <a:extLst xmlns:a="http://schemas.openxmlformats.org/drawingml/2006/main">
               <a:ext uri="{FF2B5EF4-FFF2-40B4-BE49-F238E27FC236}">
-                <a16:creationId xmlns:a16="http://schemas.microsoft.com/office/drawing/2014/main" id="{7D8A3754-5ADB-45BB-A032-05F36781F251}"/>
+                <a16:creationId xmlns:a16="http://schemas.microsoft.com/office/drawing/2014/main" id="{43547CF1-047E-46CD-8765-E542D300DD79}"/>
               </a:ext>
             </a:extLst>
           </p:cNvPr>
@@ -9093,7 +9093,7 @@
           <p:cNvPr id="5" name="">
             <a:extLst xmlns:a="http://schemas.openxmlformats.org/drawingml/2006/main">
               <a:ext uri="{FF2B5EF4-FFF2-40B4-BE49-F238E27FC236}">
-                <a16:creationId xmlns:a16="http://schemas.microsoft.com/office/drawing/2014/main" id="{A8EC3E72-5B60-4049-AFA6-CFE6AACE7D53}"/>
+                <a16:creationId xmlns:a16="http://schemas.microsoft.com/office/drawing/2014/main" id="{70BCB1B9-4BDE-41C5-85C7-ABA973AEE9F7}"/>
               </a:ext>
             </a:extLst>
           </p:cNvPr>
@@ -9150,7 +9150,7 @@
           <p:cNvPr id="6" name="">
             <a:extLst xmlns:a="http://schemas.openxmlformats.org/drawingml/2006/main">
               <a:ext uri="{FF2B5EF4-FFF2-40B4-BE49-F238E27FC236}">
-                <a16:creationId xmlns:a16="http://schemas.microsoft.com/office/drawing/2014/main" id="{5B9B5E75-186F-4397-82BD-8ADAEC134DDC}"/>
+                <a16:creationId xmlns:a16="http://schemas.microsoft.com/office/drawing/2014/main" id="{BAFD5DDA-4BF6-42A9-BB03-8A071413BC9D}"/>
               </a:ext>
             </a:extLst>
           </p:cNvPr>
@@ -9207,7 +9207,7 @@
           <p:cNvPr id="7" name="">
             <a:extLst xmlns:a="http://schemas.openxmlformats.org/drawingml/2006/main">
               <a:ext uri="{FF2B5EF4-FFF2-40B4-BE49-F238E27FC236}">
-                <a16:creationId xmlns:a16="http://schemas.microsoft.com/office/drawing/2014/main" id="{84ADDF78-4A3C-4387-BE7B-2DA55E37DAB8}"/>
+                <a16:creationId xmlns:a16="http://schemas.microsoft.com/office/drawing/2014/main" id="{D2119F97-8D30-488E-95E0-20D8C2968E52}"/>
               </a:ext>
             </a:extLst>
           </p:cNvPr>
@@ -9264,7 +9264,7 @@
           <p:cNvPr id="8" name="">
             <a:extLst xmlns:a="http://schemas.openxmlformats.org/drawingml/2006/main">
               <a:ext uri="{FF2B5EF4-FFF2-40B4-BE49-F238E27FC236}">
-                <a16:creationId xmlns:a16="http://schemas.microsoft.com/office/drawing/2014/main" id="{93B87375-27D0-4113-850A-410A08585B42}"/>
+                <a16:creationId xmlns:a16="http://schemas.microsoft.com/office/drawing/2014/main" id="{F56DFA5A-0E49-4301-9968-054CCD174DAF}"/>
               </a:ext>
             </a:extLst>
           </p:cNvPr>
@@ -9321,7 +9321,7 @@
           <p:cNvPr id="9" name="">
             <a:extLst xmlns:a="http://schemas.openxmlformats.org/drawingml/2006/main">
               <a:ext uri="{FF2B5EF4-FFF2-40B4-BE49-F238E27FC236}">
-                <a16:creationId xmlns:a16="http://schemas.microsoft.com/office/drawing/2014/main" id="{D11E5E3B-733E-4F4B-B012-BD84706AC89B}"/>
+                <a16:creationId xmlns:a16="http://schemas.microsoft.com/office/drawing/2014/main" id="{FF1C6113-4032-45F5-AD08-9A124A01C08C}"/>
               </a:ext>
             </a:extLst>
           </p:cNvPr>
@@ -9378,7 +9378,7 @@
           <p:cNvPr id="10" name="">
             <a:extLst xmlns:a="http://schemas.openxmlformats.org/drawingml/2006/main">
               <a:ext uri="{FF2B5EF4-FFF2-40B4-BE49-F238E27FC236}">
-                <a16:creationId xmlns:a16="http://schemas.microsoft.com/office/drawing/2014/main" id="{8FB97651-BCE6-454E-BCAE-EE511FB1FC94}"/>
+                <a16:creationId xmlns:a16="http://schemas.microsoft.com/office/drawing/2014/main" id="{DA4CE577-9EA8-4758-B8A5-DE2B6C3ACB96}"/>
               </a:ext>
             </a:extLst>
           </p:cNvPr>
@@ -9435,7 +9435,7 @@
           <p:cNvPr id="11" name="">
             <a:extLst xmlns:a="http://schemas.openxmlformats.org/drawingml/2006/main">
               <a:ext uri="{FF2B5EF4-FFF2-40B4-BE49-F238E27FC236}">
-                <a16:creationId xmlns:a16="http://schemas.microsoft.com/office/drawing/2014/main" id="{FAFA6203-9418-4DEB-9B2C-C07623B0D4D7}"/>
+                <a16:creationId xmlns:a16="http://schemas.microsoft.com/office/drawing/2014/main" id="{18E3135B-1D7E-46A6-9E36-87E729BDA252}"/>
               </a:ext>
             </a:extLst>
           </p:cNvPr>
@@ -9492,7 +9492,7 @@
           <p:cNvPr id="12" name="">
             <a:extLst xmlns:a="http://schemas.openxmlformats.org/drawingml/2006/main">
               <a:ext uri="{FF2B5EF4-FFF2-40B4-BE49-F238E27FC236}">
-                <a16:creationId xmlns:a16="http://schemas.microsoft.com/office/drawing/2014/main" id="{30B0CBFB-2A4E-4AA5-A05F-4A3D37918722}"/>
+                <a16:creationId xmlns:a16="http://schemas.microsoft.com/office/drawing/2014/main" id="{F2E0221F-A1A2-492C-AE70-48BA1959DCDC}"/>
               </a:ext>
             </a:extLst>
           </p:cNvPr>
@@ -9547,7 +9547,7 @@
     </p:spTree>
     <p:extLst>
       <p:ext uri="{BB962C8B-B14F-4D97-AF65-F5344CB8AC3E}">
-        <p14:creationId xmlns:p14="http://schemas.microsoft.com/office/powerpoint/2010/main" val="1786216498"/>
+        <p14:creationId xmlns:p14="http://schemas.microsoft.com/office/powerpoint/2010/main" val="807031041"/>
       </p:ext>
     </p:extLst>
   </p:cSld>
@@ -9578,7 +9578,7 @@
           <p:cNvPr id="14" name="">
             <a:extLst xmlns:a="http://schemas.openxmlformats.org/drawingml/2006/main">
               <a:ext uri="{FF2B5EF4-FFF2-40B4-BE49-F238E27FC236}">
-                <a16:creationId xmlns:a16="http://schemas.microsoft.com/office/drawing/2014/main" id="{EBA2D7EA-A745-45A6-9C96-57F6027A3BA5}"/>
+                <a16:creationId xmlns:a16="http://schemas.microsoft.com/office/drawing/2014/main" id="{7F398FEA-DF9A-45B8-AEBA-4324EE19C9D5}"/>
               </a:ext>
             </a:extLst>
           </p:cNvPr>
@@ -9635,7 +9635,7 @@
           <p:cNvPr id="2" name="">
             <a:extLst xmlns:a="http://schemas.openxmlformats.org/drawingml/2006/main">
               <a:ext uri="{FF2B5EF4-FFF2-40B4-BE49-F238E27FC236}">
-                <a16:creationId xmlns:a16="http://schemas.microsoft.com/office/drawing/2014/main" id="{C49813C8-9914-456B-A027-969789D3BA84}"/>
+                <a16:creationId xmlns:a16="http://schemas.microsoft.com/office/drawing/2014/main" id="{8AAE8D5F-72B6-4364-825E-A8E5AC092928}"/>
               </a:ext>
             </a:extLst>
           </p:cNvPr>
@@ -9692,7 +9692,7 @@
           <p:cNvPr id="3" name="">
             <a:extLst xmlns:a="http://schemas.openxmlformats.org/drawingml/2006/main">
               <a:ext uri="{FF2B5EF4-FFF2-40B4-BE49-F238E27FC236}">
-                <a16:creationId xmlns:a16="http://schemas.microsoft.com/office/drawing/2014/main" id="{A71B6C12-3289-461F-B32A-145614E7186B}"/>
+                <a16:creationId xmlns:a16="http://schemas.microsoft.com/office/drawing/2014/main" id="{76E47259-CA34-499D-BC04-B3D280E0A600}"/>
               </a:ext>
             </a:extLst>
           </p:cNvPr>
@@ -9749,7 +9749,7 @@
           <p:cNvPr id="4" name="">
             <a:extLst xmlns:a="http://schemas.openxmlformats.org/drawingml/2006/main">
               <a:ext uri="{FF2B5EF4-FFF2-40B4-BE49-F238E27FC236}">
-                <a16:creationId xmlns:a16="http://schemas.microsoft.com/office/drawing/2014/main" id="{27EAE9C7-CFC7-4E80-82C6-5CBA2E22DAD9}"/>
+                <a16:creationId xmlns:a16="http://schemas.microsoft.com/office/drawing/2014/main" id="{A0C01105-DC2F-4A73-B19B-BFE490153C51}"/>
               </a:ext>
             </a:extLst>
           </p:cNvPr>
@@ -9806,7 +9806,7 @@
           <p:cNvPr id="5" name="">
             <a:extLst xmlns:a="http://schemas.openxmlformats.org/drawingml/2006/main">
               <a:ext uri="{FF2B5EF4-FFF2-40B4-BE49-F238E27FC236}">
-                <a16:creationId xmlns:a16="http://schemas.microsoft.com/office/drawing/2014/main" id="{FAE3BBC6-AAF3-42AB-95F0-F30A0E6580D3}"/>
+                <a16:creationId xmlns:a16="http://schemas.microsoft.com/office/drawing/2014/main" id="{40C2F7EE-98C0-4598-9FA9-F6795C169164}"/>
               </a:ext>
             </a:extLst>
           </p:cNvPr>
@@ -9863,7 +9863,7 @@
           <p:cNvPr id="6" name="">
             <a:extLst xmlns:a="http://schemas.openxmlformats.org/drawingml/2006/main">
               <a:ext uri="{FF2B5EF4-FFF2-40B4-BE49-F238E27FC236}">
-                <a16:creationId xmlns:a16="http://schemas.microsoft.com/office/drawing/2014/main" id="{33400118-C4DF-466F-809B-4CEE76B8FF68}"/>
+                <a16:creationId xmlns:a16="http://schemas.microsoft.com/office/drawing/2014/main" id="{6CFF8AE4-65B0-416B-979D-28D27214CD11}"/>
               </a:ext>
             </a:extLst>
           </p:cNvPr>
@@ -9920,7 +9920,7 @@
           <p:cNvPr id="7" name="">
             <a:extLst xmlns:a="http://schemas.openxmlformats.org/drawingml/2006/main">
               <a:ext uri="{FF2B5EF4-FFF2-40B4-BE49-F238E27FC236}">
-                <a16:creationId xmlns:a16="http://schemas.microsoft.com/office/drawing/2014/main" id="{2A8D302A-56AA-4577-A060-7AADD05659ED}"/>
+                <a16:creationId xmlns:a16="http://schemas.microsoft.com/office/drawing/2014/main" id="{4F23ECAF-2E67-44EF-BB95-50D454B855AD}"/>
               </a:ext>
             </a:extLst>
           </p:cNvPr>
@@ -9977,7 +9977,7 @@
           <p:cNvPr id="8" name="">
             <a:extLst xmlns:a="http://schemas.openxmlformats.org/drawingml/2006/main">
               <a:ext uri="{FF2B5EF4-FFF2-40B4-BE49-F238E27FC236}">
-                <a16:creationId xmlns:a16="http://schemas.microsoft.com/office/drawing/2014/main" id="{47784A49-97F8-4E20-9ABA-C25043A83BDC}"/>
+                <a16:creationId xmlns:a16="http://schemas.microsoft.com/office/drawing/2014/main" id="{42F90680-E853-4457-A1D4-0059CDD91223}"/>
               </a:ext>
             </a:extLst>
           </p:cNvPr>
@@ -10034,7 +10034,7 @@
           <p:cNvPr id="9" name="">
             <a:extLst xmlns:a="http://schemas.openxmlformats.org/drawingml/2006/main">
               <a:ext uri="{FF2B5EF4-FFF2-40B4-BE49-F238E27FC236}">
-                <a16:creationId xmlns:a16="http://schemas.microsoft.com/office/drawing/2014/main" id="{85BF9FD9-8528-42A4-A499-6B90380297E1}"/>
+                <a16:creationId xmlns:a16="http://schemas.microsoft.com/office/drawing/2014/main" id="{FE88348F-8AE7-41A5-B1F6-ACEC808501A7}"/>
               </a:ext>
             </a:extLst>
           </p:cNvPr>
@@ -10091,7 +10091,7 @@
           <p:cNvPr id="10" name="">
             <a:extLst xmlns:a="http://schemas.openxmlformats.org/drawingml/2006/main">
               <a:ext uri="{FF2B5EF4-FFF2-40B4-BE49-F238E27FC236}">
-                <a16:creationId xmlns:a16="http://schemas.microsoft.com/office/drawing/2014/main" id="{9B2EC5E8-35AD-42C3-988F-C0BC5F4C3FEA}"/>
+                <a16:creationId xmlns:a16="http://schemas.microsoft.com/office/drawing/2014/main" id="{8BED16DC-0DB7-40C0-AD7E-2F54789F348E}"/>
               </a:ext>
             </a:extLst>
           </p:cNvPr>
@@ -10148,7 +10148,7 @@
           <p:cNvPr id="11" name="">
             <a:extLst xmlns:a="http://schemas.openxmlformats.org/drawingml/2006/main">
               <a:ext uri="{FF2B5EF4-FFF2-40B4-BE49-F238E27FC236}">
-                <a16:creationId xmlns:a16="http://schemas.microsoft.com/office/drawing/2014/main" id="{C4C7BF91-281E-4FB6-8C6A-31E9A039F78F}"/>
+                <a16:creationId xmlns:a16="http://schemas.microsoft.com/office/drawing/2014/main" id="{962EFF26-16F1-449B-88A2-0F9D585DD67E}"/>
               </a:ext>
             </a:extLst>
           </p:cNvPr>
@@ -10205,7 +10205,7 @@
           <p:cNvPr id="12" name="">
             <a:extLst xmlns:a="http://schemas.openxmlformats.org/drawingml/2006/main">
               <a:ext uri="{FF2B5EF4-FFF2-40B4-BE49-F238E27FC236}">
-                <a16:creationId xmlns:a16="http://schemas.microsoft.com/office/drawing/2014/main" id="{05185CC5-214D-4689-9470-5AA55F2FA696}"/>
+                <a16:creationId xmlns:a16="http://schemas.microsoft.com/office/drawing/2014/main" id="{B65D3B89-2178-4D03-9866-2F6CC55990A5}"/>
               </a:ext>
             </a:extLst>
           </p:cNvPr>
@@ -10262,7 +10262,7 @@
           <p:cNvPr id="13" name="">
             <a:extLst xmlns:a="http://schemas.openxmlformats.org/drawingml/2006/main">
               <a:ext uri="{FF2B5EF4-FFF2-40B4-BE49-F238E27FC236}">
-                <a16:creationId xmlns:a16="http://schemas.microsoft.com/office/drawing/2014/main" id="{E09BB2FB-898B-4036-B701-85F88A920D85}"/>
+                <a16:creationId xmlns:a16="http://schemas.microsoft.com/office/drawing/2014/main" id="{F3DC5ED1-1BB0-428E-BE71-2143F6A06280}"/>
               </a:ext>
             </a:extLst>
           </p:cNvPr>
@@ -10317,7 +10317,7 @@
     </p:spTree>
     <p:extLst>
       <p:ext uri="{BB962C8B-B14F-4D97-AF65-F5344CB8AC3E}">
-        <p14:creationId xmlns:p14="http://schemas.microsoft.com/office/powerpoint/2010/main" val="912319801"/>
+        <p14:creationId xmlns:p14="http://schemas.microsoft.com/office/powerpoint/2010/main" val="457529360"/>
       </p:ext>
     </p:extLst>
   </p:cSld>
@@ -10348,7 +10348,7 @@
           <p:cNvPr id="8" name="">
             <a:extLst xmlns:a="http://schemas.openxmlformats.org/drawingml/2006/main">
               <a:ext uri="{FF2B5EF4-FFF2-40B4-BE49-F238E27FC236}">
-                <a16:creationId xmlns:a16="http://schemas.microsoft.com/office/drawing/2014/main" id="{E7D19E94-143E-4076-AB76-57AF218660AD}"/>
+                <a16:creationId xmlns:a16="http://schemas.microsoft.com/office/drawing/2014/main" id="{FFEA558A-A003-4E38-A25F-B5B878D34125}"/>
               </a:ext>
             </a:extLst>
           </p:cNvPr>
@@ -10405,7 +10405,7 @@
           <p:cNvPr id="2" name="">
             <a:extLst xmlns:a="http://schemas.openxmlformats.org/drawingml/2006/main">
               <a:ext uri="{FF2B5EF4-FFF2-40B4-BE49-F238E27FC236}">
-                <a16:creationId xmlns:a16="http://schemas.microsoft.com/office/drawing/2014/main" id="{34458BB5-09A8-4857-B7C4-3DC8DAF3234C}"/>
+                <a16:creationId xmlns:a16="http://schemas.microsoft.com/office/drawing/2014/main" id="{41BB6B40-A5AC-42F6-8205-9CF9978DD3FE}"/>
               </a:ext>
             </a:extLst>
           </p:cNvPr>
@@ -10462,7 +10462,7 @@
           <p:cNvPr id="3" name="">
             <a:extLst xmlns:a="http://schemas.openxmlformats.org/drawingml/2006/main">
               <a:ext uri="{FF2B5EF4-FFF2-40B4-BE49-F238E27FC236}">
-                <a16:creationId xmlns:a16="http://schemas.microsoft.com/office/drawing/2014/main" id="{D3FDA98D-AD25-48DD-B8ED-B478138AEC75}"/>
+                <a16:creationId xmlns:a16="http://schemas.microsoft.com/office/drawing/2014/main" id="{63AD1539-45AD-45FF-A64F-665C193EBE62}"/>
               </a:ext>
             </a:extLst>
           </p:cNvPr>
@@ -10575,7 +10575,7 @@
           <p:cNvPr id="4" name="">
             <a:extLst xmlns:a="http://schemas.openxmlformats.org/drawingml/2006/main">
               <a:ext uri="{FF2B5EF4-FFF2-40B4-BE49-F238E27FC236}">
-                <a16:creationId xmlns:a16="http://schemas.microsoft.com/office/drawing/2014/main" id="{5E42012B-CCCC-4804-9F66-93B9E13568FB}"/>
+                <a16:creationId xmlns:a16="http://schemas.microsoft.com/office/drawing/2014/main" id="{D0ECA3CC-433B-4CE7-9611-25CD608F3476}"/>
               </a:ext>
             </a:extLst>
           </p:cNvPr>
@@ -10632,7 +10632,7 @@
           <p:cNvPr id="5" name="">
             <a:extLst xmlns:a="http://schemas.openxmlformats.org/drawingml/2006/main">
               <a:ext uri="{FF2B5EF4-FFF2-40B4-BE49-F238E27FC236}">
-                <a16:creationId xmlns:a16="http://schemas.microsoft.com/office/drawing/2014/main" id="{AA723B19-8E4B-4CE0-8B82-E94155BBDD50}"/>
+                <a16:creationId xmlns:a16="http://schemas.microsoft.com/office/drawing/2014/main" id="{26830001-84DC-4256-ACC4-3CC4E3DCF72E}"/>
               </a:ext>
             </a:extLst>
           </p:cNvPr>
@@ -10745,7 +10745,7 @@
           <p:cNvPr id="6" name="">
             <a:extLst xmlns:a="http://schemas.openxmlformats.org/drawingml/2006/main">
               <a:ext uri="{FF2B5EF4-FFF2-40B4-BE49-F238E27FC236}">
-                <a16:creationId xmlns:a16="http://schemas.microsoft.com/office/drawing/2014/main" id="{367EDCD4-883B-4F35-8B8E-0CE9886DB581}"/>
+                <a16:creationId xmlns:a16="http://schemas.microsoft.com/office/drawing/2014/main" id="{DCFF0996-333B-47AF-A330-D4B19986DFA4}"/>
               </a:ext>
             </a:extLst>
           </p:cNvPr>
@@ -10802,7 +10802,7 @@
           <p:cNvPr id="7" name="">
             <a:extLst xmlns:a="http://schemas.openxmlformats.org/drawingml/2006/main">
               <a:ext uri="{FF2B5EF4-FFF2-40B4-BE49-F238E27FC236}">
-                <a16:creationId xmlns:a16="http://schemas.microsoft.com/office/drawing/2014/main" id="{1D1E3E4E-E9F4-4DFC-A119-42F4A337CB7B}"/>
+                <a16:creationId xmlns:a16="http://schemas.microsoft.com/office/drawing/2014/main" id="{40A87637-7169-4BAC-B984-38E70B8A4854}"/>
               </a:ext>
             </a:extLst>
           </p:cNvPr>
@@ -10857,7 +10857,7 @@
     </p:spTree>
     <p:extLst>
       <p:ext uri="{BB962C8B-B14F-4D97-AF65-F5344CB8AC3E}">
-        <p14:creationId xmlns:p14="http://schemas.microsoft.com/office/powerpoint/2010/main" val="307533881"/>
+        <p14:creationId xmlns:p14="http://schemas.microsoft.com/office/powerpoint/2010/main" val="1481653667"/>
       </p:ext>
     </p:extLst>
   </p:cSld>
@@ -10888,7 +10888,7 @@
           <p:cNvPr id="5" name="">
             <a:extLst xmlns:a="http://schemas.openxmlformats.org/drawingml/2006/main">
               <a:ext uri="{FF2B5EF4-FFF2-40B4-BE49-F238E27FC236}">
-                <a16:creationId xmlns:a16="http://schemas.microsoft.com/office/drawing/2014/main" id="{EA92B7CF-564A-4C8C-9B64-453D898F989A}"/>
+                <a16:creationId xmlns:a16="http://schemas.microsoft.com/office/drawing/2014/main" id="{36B28246-2C46-44B3-906A-5085C3D68110}"/>
               </a:ext>
             </a:extLst>
           </p:cNvPr>
@@ -10945,7 +10945,7 @@
           <p:cNvPr id="2" name="">
             <a:extLst xmlns:a="http://schemas.openxmlformats.org/drawingml/2006/main">
               <a:ext uri="{FF2B5EF4-FFF2-40B4-BE49-F238E27FC236}">
-                <a16:creationId xmlns:a16="http://schemas.microsoft.com/office/drawing/2014/main" id="{709A3FC9-EE59-421D-A968-9CC645FB6940}"/>
+                <a16:creationId xmlns:a16="http://schemas.microsoft.com/office/drawing/2014/main" id="{53FE863A-3382-43AC-8E1E-42934AC3459D}"/>
               </a:ext>
             </a:extLst>
           </p:cNvPr>
@@ -11025,7 +11025,7 @@
           <p:cNvPr id="3" name="">
             <a:extLst xmlns:a="http://schemas.openxmlformats.org/drawingml/2006/main">
               <a:ext uri="{FF2B5EF4-FFF2-40B4-BE49-F238E27FC236}">
-                <a16:creationId xmlns:a16="http://schemas.microsoft.com/office/drawing/2014/main" id="{95C68754-ACC5-4D7F-8B5A-26720BA20024}"/>
+                <a16:creationId xmlns:a16="http://schemas.microsoft.com/office/drawing/2014/main" id="{F9B6A671-671E-4F29-BA77-4BE837A68811}"/>
               </a:ext>
             </a:extLst>
           </p:cNvPr>
@@ -11082,7 +11082,7 @@
           <p:cNvPr id="4" name="">
             <a:extLst xmlns:a="http://schemas.openxmlformats.org/drawingml/2006/main">
               <a:ext uri="{FF2B5EF4-FFF2-40B4-BE49-F238E27FC236}">
-                <a16:creationId xmlns:a16="http://schemas.microsoft.com/office/drawing/2014/main" id="{7FC30439-EB61-49FF-8DE7-273172B4ABC7}"/>
+                <a16:creationId xmlns:a16="http://schemas.microsoft.com/office/drawing/2014/main" id="{7C029624-CD1C-4E8D-926E-AB992C616247}"/>
               </a:ext>
             </a:extLst>
           </p:cNvPr>
@@ -11137,7 +11137,7 @@
     </p:spTree>
     <p:extLst>
       <p:ext uri="{BB962C8B-B14F-4D97-AF65-F5344CB8AC3E}">
-        <p14:creationId xmlns:p14="http://schemas.microsoft.com/office/powerpoint/2010/main" val="1778946715"/>
+        <p14:creationId xmlns:p14="http://schemas.microsoft.com/office/powerpoint/2010/main" val="1077618693"/>
       </p:ext>
     </p:extLst>
   </p:cSld>
@@ -11168,7 +11168,7 @@
           <p:cNvPr id="8" name="">
             <a:extLst xmlns:a="http://schemas.openxmlformats.org/drawingml/2006/main">
               <a:ext uri="{FF2B5EF4-FFF2-40B4-BE49-F238E27FC236}">
-                <a16:creationId xmlns:a16="http://schemas.microsoft.com/office/drawing/2014/main" id="{CEB123EA-AFB3-487D-AA70-AA29674812A7}"/>
+                <a16:creationId xmlns:a16="http://schemas.microsoft.com/office/drawing/2014/main" id="{5DD9BAA0-4BA6-4BC8-9A5E-FB7F53189C8C}"/>
               </a:ext>
             </a:extLst>
           </p:cNvPr>
@@ -11225,7 +11225,7 @@
           <p:cNvPr id="2" name="">
             <a:extLst xmlns:a="http://schemas.openxmlformats.org/drawingml/2006/main">
               <a:ext uri="{FF2B5EF4-FFF2-40B4-BE49-F238E27FC236}">
-                <a16:creationId xmlns:a16="http://schemas.microsoft.com/office/drawing/2014/main" id="{0F746DCC-C7AE-4E08-B144-4C4BF82648D5}"/>
+                <a16:creationId xmlns:a16="http://schemas.microsoft.com/office/drawing/2014/main" id="{42AEF57E-392C-49FD-8E30-6DECCCDFD8CF}"/>
               </a:ext>
             </a:extLst>
           </p:cNvPr>
@@ -11282,7 +11282,7 @@
           <p:cNvPr id="3" name="">
             <a:extLst xmlns:a="http://schemas.openxmlformats.org/drawingml/2006/main">
               <a:ext uri="{FF2B5EF4-FFF2-40B4-BE49-F238E27FC236}">
-                <a16:creationId xmlns:a16="http://schemas.microsoft.com/office/drawing/2014/main" id="{C1F94A5D-11B0-4143-A81C-B11D18AE94F9}"/>
+                <a16:creationId xmlns:a16="http://schemas.microsoft.com/office/drawing/2014/main" id="{C99E0DDE-1514-4404-822F-A725D1FBC395}"/>
               </a:ext>
             </a:extLst>
           </p:cNvPr>
@@ -11408,7 +11408,7 @@
           <p:cNvPr id="4" name="">
             <a:extLst xmlns:a="http://schemas.openxmlformats.org/drawingml/2006/main">
               <a:ext uri="{FF2B5EF4-FFF2-40B4-BE49-F238E27FC236}">
-                <a16:creationId xmlns:a16="http://schemas.microsoft.com/office/drawing/2014/main" id="{D910BFB6-35D6-4DD5-A74F-689CDBEFC6CA}"/>
+                <a16:creationId xmlns:a16="http://schemas.microsoft.com/office/drawing/2014/main" id="{1188F522-32A9-4474-B55D-4419312BB292}"/>
               </a:ext>
             </a:extLst>
           </p:cNvPr>
@@ -11465,7 +11465,7 @@
           <p:cNvPr id="5" name="">
             <a:extLst xmlns:a="http://schemas.openxmlformats.org/drawingml/2006/main">
               <a:ext uri="{FF2B5EF4-FFF2-40B4-BE49-F238E27FC236}">
-                <a16:creationId xmlns:a16="http://schemas.microsoft.com/office/drawing/2014/main" id="{E30CE951-0623-4896-A5C2-6E55F1CEF383}"/>
+                <a16:creationId xmlns:a16="http://schemas.microsoft.com/office/drawing/2014/main" id="{BD50F709-6FDF-4B84-A975-ACD447DA5498}"/>
               </a:ext>
             </a:extLst>
           </p:cNvPr>
@@ -11614,7 +11614,7 @@
           <p:cNvPr id="6" name="">
             <a:extLst xmlns:a="http://schemas.openxmlformats.org/drawingml/2006/main">
               <a:ext uri="{FF2B5EF4-FFF2-40B4-BE49-F238E27FC236}">
-                <a16:creationId xmlns:a16="http://schemas.microsoft.com/office/drawing/2014/main" id="{D6FB70E7-7B85-47D2-8C43-3929F440A6BF}"/>
+                <a16:creationId xmlns:a16="http://schemas.microsoft.com/office/drawing/2014/main" id="{E10E584B-B80A-43A4-B27E-782586603226}"/>
               </a:ext>
             </a:extLst>
           </p:cNvPr>
@@ -11671,7 +11671,7 @@
           <p:cNvPr id="7" name="">
             <a:extLst xmlns:a="http://schemas.openxmlformats.org/drawingml/2006/main">
               <a:ext uri="{FF2B5EF4-FFF2-40B4-BE49-F238E27FC236}">
-                <a16:creationId xmlns:a16="http://schemas.microsoft.com/office/drawing/2014/main" id="{0D7A7845-8B5B-45D5-B003-B85EC63AF02F}"/>
+                <a16:creationId xmlns:a16="http://schemas.microsoft.com/office/drawing/2014/main" id="{64A01313-716D-49CC-9B62-C03395FCAA65}"/>
               </a:ext>
             </a:extLst>
           </p:cNvPr>
@@ -11726,7 +11726,7 @@
     </p:spTree>
     <p:extLst>
       <p:ext uri="{BB962C8B-B14F-4D97-AF65-F5344CB8AC3E}">
-        <p14:creationId xmlns:p14="http://schemas.microsoft.com/office/powerpoint/2010/main" val="11283441"/>
+        <p14:creationId xmlns:p14="http://schemas.microsoft.com/office/powerpoint/2010/main" val="1592217996"/>
       </p:ext>
     </p:extLst>
   </p:cSld>
@@ -11757,7 +11757,7 @@
           <p:cNvPr id="11" name="">
             <a:extLst xmlns:a="http://schemas.openxmlformats.org/drawingml/2006/main">
               <a:ext uri="{FF2B5EF4-FFF2-40B4-BE49-F238E27FC236}">
-                <a16:creationId xmlns:a16="http://schemas.microsoft.com/office/drawing/2014/main" id="{6317EEBD-1E5F-468D-8117-B82819915346}"/>
+                <a16:creationId xmlns:a16="http://schemas.microsoft.com/office/drawing/2014/main" id="{4C8BCA32-258F-420F-A2E6-EFF9E2BA8058}"/>
               </a:ext>
             </a:extLst>
           </p:cNvPr>
@@ -11814,7 +11814,7 @@
           <p:cNvPr id="2" name="">
             <a:extLst xmlns:a="http://schemas.openxmlformats.org/drawingml/2006/main">
               <a:ext uri="{FF2B5EF4-FFF2-40B4-BE49-F238E27FC236}">
-                <a16:creationId xmlns:a16="http://schemas.microsoft.com/office/drawing/2014/main" id="{D46C9D84-D4F5-4EE5-91F0-3926DA318ED3}"/>
+                <a16:creationId xmlns:a16="http://schemas.microsoft.com/office/drawing/2014/main" id="{5F0533F7-4DCF-4103-A5B2-1DE6CD58736E}"/>
               </a:ext>
             </a:extLst>
           </p:cNvPr>
@@ -11871,7 +11871,7 @@
           <p:cNvPr id="3" name="">
             <a:extLst xmlns:a="http://schemas.openxmlformats.org/drawingml/2006/main">
               <a:ext uri="{FF2B5EF4-FFF2-40B4-BE49-F238E27FC236}">
-                <a16:creationId xmlns:a16="http://schemas.microsoft.com/office/drawing/2014/main" id="{8D21C182-02A9-4DAD-BBC7-5510924D5C97}"/>
+                <a16:creationId xmlns:a16="http://schemas.microsoft.com/office/drawing/2014/main" id="{4515A0A0-FEC1-42A1-8D00-2F93D19A1CB2}"/>
               </a:ext>
             </a:extLst>
           </p:cNvPr>
@@ -11956,7 +11956,7 @@
           <p:cNvPr id="4" name="">
             <a:extLst xmlns:a="http://schemas.openxmlformats.org/drawingml/2006/main">
               <a:ext uri="{FF2B5EF4-FFF2-40B4-BE49-F238E27FC236}">
-                <a16:creationId xmlns:a16="http://schemas.microsoft.com/office/drawing/2014/main" id="{27624A0D-E323-4B60-8433-31F6A320DF19}"/>
+                <a16:creationId xmlns:a16="http://schemas.microsoft.com/office/drawing/2014/main" id="{FE0EA541-6E53-4205-A443-47789F2631FD}"/>
               </a:ext>
             </a:extLst>
           </p:cNvPr>
@@ -12013,7 +12013,7 @@
           <p:cNvPr id="5" name="">
             <a:extLst xmlns:a="http://schemas.openxmlformats.org/drawingml/2006/main">
               <a:ext uri="{FF2B5EF4-FFF2-40B4-BE49-F238E27FC236}">
-                <a16:creationId xmlns:a16="http://schemas.microsoft.com/office/drawing/2014/main" id="{12A34D76-A16A-47AD-8ABC-57402687D98D}"/>
+                <a16:creationId xmlns:a16="http://schemas.microsoft.com/office/drawing/2014/main" id="{D85DD6D8-16AE-4965-9746-533BB59499C0}"/>
               </a:ext>
             </a:extLst>
           </p:cNvPr>
@@ -12153,7 +12153,7 @@
           <p:nvPr/>
         </p:nvPicPr>
         <p:blipFill>
-          <a:blip xmlns:r="http://schemas.openxmlformats.org/officeDocument/2006/relationships" xmlns:a="http://schemas.openxmlformats.org/drawingml/2006/main" r:embed="R815ee80f6b1f4e61"/>
+          <a:blip xmlns:r="http://schemas.openxmlformats.org/officeDocument/2006/relationships" xmlns:a="http://schemas.openxmlformats.org/drawingml/2006/main" r:embed="R774c3ea6132d4fbf"/>
           <a:stretch xmlns:a="http://schemas.openxmlformats.org/drawingml/2006/main"/>
         </p:blipFill>
         <p:spPr>
@@ -12171,7 +12171,7 @@
           <p:cNvPr id="7" name="">
             <a:extLst xmlns:a="http://schemas.openxmlformats.org/drawingml/2006/main">
               <a:ext uri="{FF2B5EF4-FFF2-40B4-BE49-F238E27FC236}">
-                <a16:creationId xmlns:a16="http://schemas.microsoft.com/office/drawing/2014/main" id="{7F8B848B-BBD2-4E44-9C39-D250E7EB86F2}"/>
+                <a16:creationId xmlns:a16="http://schemas.microsoft.com/office/drawing/2014/main" id="{9BCBE805-DB67-4E89-B093-4AA695BAF2A6}"/>
               </a:ext>
             </a:extLst>
           </p:cNvPr>
@@ -12228,7 +12228,7 @@
           <p:cNvPr id="8" name="">
             <a:extLst xmlns:a="http://schemas.openxmlformats.org/drawingml/2006/main">
               <a:ext uri="{FF2B5EF4-FFF2-40B4-BE49-F238E27FC236}">
-                <a16:creationId xmlns:a16="http://schemas.microsoft.com/office/drawing/2014/main" id="{1D4C51B3-CEB9-4D26-BDFE-538B3CE63668}"/>
+                <a16:creationId xmlns:a16="http://schemas.microsoft.com/office/drawing/2014/main" id="{FAC8D248-868B-4F6B-8A66-CF4138EB2082}"/>
               </a:ext>
             </a:extLst>
           </p:cNvPr>
@@ -12274,7 +12274,7 @@
                 <a:latin typeface="Arial"/>
                 <a:ea typeface="Arial"/>
                 <a:cs typeface="Arial"/>
-                <a:hlinkClick xmlns:r="http://schemas.openxmlformats.org/officeDocument/2006/relationships" r:id="R83fa31619b1a431d"/>
+                <a:hlinkClick xmlns:r="http://schemas.openxmlformats.org/officeDocument/2006/relationships" r:id="Rc3ad082fbc8340dd"/>
               </a:rPr>
               <a:t>github.com/jemsbhai/</a:t>
             </a:r>
@@ -12298,7 +12298,7 @@
                 <a:latin typeface="Arial"/>
                 <a:ea typeface="Arial"/>
                 <a:cs typeface="Arial"/>
-                <a:hlinkClick xmlns:r="http://schemas.openxmlformats.org/officeDocument/2006/relationships" r:id="R03a63f6708a74b50"/>
+                <a:hlinkClick xmlns:r="http://schemas.openxmlformats.org/officeDocument/2006/relationships" r:id="R0c55f6e4ad6d48fd"/>
               </a:rPr>
               <a:t>bringing-the-heat</a:t>
             </a:r>
@@ -12310,7 +12310,7 @@
           <p:cNvPr id="9" name="">
             <a:extLst xmlns:a="http://schemas.openxmlformats.org/drawingml/2006/main">
               <a:ext uri="{FF2B5EF4-FFF2-40B4-BE49-F238E27FC236}">
-                <a16:creationId xmlns:a16="http://schemas.microsoft.com/office/drawing/2014/main" id="{7A27A85B-CDEB-4A0E-8FBA-9A6363519474}"/>
+                <a16:creationId xmlns:a16="http://schemas.microsoft.com/office/drawing/2014/main" id="{C2AB183F-03E3-4E00-80EF-EE835BA13195}"/>
               </a:ext>
             </a:extLst>
           </p:cNvPr>
@@ -12367,7 +12367,7 @@
           <p:cNvPr id="10" name="">
             <a:extLst xmlns:a="http://schemas.openxmlformats.org/drawingml/2006/main">
               <a:ext uri="{FF2B5EF4-FFF2-40B4-BE49-F238E27FC236}">
-                <a16:creationId xmlns:a16="http://schemas.microsoft.com/office/drawing/2014/main" id="{E6A8072F-FA6F-45A6-8A79-46134E567B95}"/>
+                <a16:creationId xmlns:a16="http://schemas.microsoft.com/office/drawing/2014/main" id="{3F5A3069-018F-40A0-B4F2-E4E5CAEF17A3}"/>
               </a:ext>
             </a:extLst>
           </p:cNvPr>
@@ -12422,7 +12422,7 @@
     </p:spTree>
     <p:extLst>
       <p:ext uri="{BB962C8B-B14F-4D97-AF65-F5344CB8AC3E}">
-        <p14:creationId xmlns:p14="http://schemas.microsoft.com/office/powerpoint/2010/main" val="1501342977"/>
+        <p14:creationId xmlns:p14="http://schemas.microsoft.com/office/powerpoint/2010/main" val="1866915047"/>
       </p:ext>
     </p:extLst>
   </p:cSld>
@@ -12453,7 +12453,7 @@
           <p:cNvPr id="5" name="">
             <a:extLst xmlns:a="http://schemas.openxmlformats.org/drawingml/2006/main">
               <a:ext uri="{FF2B5EF4-FFF2-40B4-BE49-F238E27FC236}">
-                <a16:creationId xmlns:a16="http://schemas.microsoft.com/office/drawing/2014/main" id="{E3B800AB-196C-471A-9658-BFA7C8689589}"/>
+                <a16:creationId xmlns:a16="http://schemas.microsoft.com/office/drawing/2014/main" id="{4316BD9E-F4EB-462C-9D52-3C9B279A9065}"/>
               </a:ext>
             </a:extLst>
           </p:cNvPr>
@@ -12903,7 +12903,7 @@
           <p:cNvPr id="3" name="">
             <a:extLst xmlns:a="http://schemas.openxmlformats.org/drawingml/2006/main">
               <a:ext uri="{FF2B5EF4-FFF2-40B4-BE49-F238E27FC236}">
-                <a16:creationId xmlns:a16="http://schemas.microsoft.com/office/drawing/2014/main" id="{5D04431F-87C3-4A1A-AF2E-D177ECB5D4E2}"/>
+                <a16:creationId xmlns:a16="http://schemas.microsoft.com/office/drawing/2014/main" id="{522FE74E-9945-4AC8-803C-51427E9A834C}"/>
               </a:ext>
             </a:extLst>
           </p:cNvPr>
@@ -12960,7 +12960,7 @@
           <p:cNvPr id="4" name="">
             <a:extLst xmlns:a="http://schemas.openxmlformats.org/drawingml/2006/main">
               <a:ext uri="{FF2B5EF4-FFF2-40B4-BE49-F238E27FC236}">
-                <a16:creationId xmlns:a16="http://schemas.microsoft.com/office/drawing/2014/main" id="{179C5CB5-0786-4C7C-A74C-F47172A93F5C}"/>
+                <a16:creationId xmlns:a16="http://schemas.microsoft.com/office/drawing/2014/main" id="{6BFE60A2-4FCA-4F0B-AD45-63D28A312D29}"/>
               </a:ext>
             </a:extLst>
           </p:cNvPr>
@@ -13015,7 +13015,7 @@
     </p:spTree>
     <p:extLst>
       <p:ext uri="{BB962C8B-B14F-4D97-AF65-F5344CB8AC3E}">
-        <p14:creationId xmlns:p14="http://schemas.microsoft.com/office/powerpoint/2010/main" val="1142441564"/>
+        <p14:creationId xmlns:p14="http://schemas.microsoft.com/office/powerpoint/2010/main" val="898081878"/>
       </p:ext>
     </p:extLst>
   </p:cSld>
@@ -13046,7 +13046,7 @@
           <p:cNvPr id="5" name="">
             <a:extLst xmlns:a="http://schemas.openxmlformats.org/drawingml/2006/main">
               <a:ext uri="{FF2B5EF4-FFF2-40B4-BE49-F238E27FC236}">
-                <a16:creationId xmlns:a16="http://schemas.microsoft.com/office/drawing/2014/main" id="{54445548-7898-4855-87FF-D660237EFA00}"/>
+                <a16:creationId xmlns:a16="http://schemas.microsoft.com/office/drawing/2014/main" id="{D4F5A473-D0A0-4855-8CE7-4221EC875F01}"/>
               </a:ext>
             </a:extLst>
           </p:cNvPr>
@@ -13496,7 +13496,7 @@
           <p:cNvPr id="3" name="">
             <a:extLst xmlns:a="http://schemas.openxmlformats.org/drawingml/2006/main">
               <a:ext uri="{FF2B5EF4-FFF2-40B4-BE49-F238E27FC236}">
-                <a16:creationId xmlns:a16="http://schemas.microsoft.com/office/drawing/2014/main" id="{C404341A-2C4A-4FEF-9E12-B18540B33BFD}"/>
+                <a16:creationId xmlns:a16="http://schemas.microsoft.com/office/drawing/2014/main" id="{B3FDB99A-E604-4173-9AC1-CC3D290DB865}"/>
               </a:ext>
             </a:extLst>
           </p:cNvPr>
@@ -13553,7 +13553,7 @@
           <p:cNvPr id="4" name="">
             <a:extLst xmlns:a="http://schemas.openxmlformats.org/drawingml/2006/main">
               <a:ext uri="{FF2B5EF4-FFF2-40B4-BE49-F238E27FC236}">
-                <a16:creationId xmlns:a16="http://schemas.microsoft.com/office/drawing/2014/main" id="{7422ADEC-915C-4F2E-8C20-B5BD2C951C3A}"/>
+                <a16:creationId xmlns:a16="http://schemas.microsoft.com/office/drawing/2014/main" id="{9509B36A-A3ED-4097-9C45-B8115E963B51}"/>
               </a:ext>
             </a:extLst>
           </p:cNvPr>
@@ -13608,7 +13608,7 @@
     </p:spTree>
     <p:extLst>
       <p:ext uri="{BB962C8B-B14F-4D97-AF65-F5344CB8AC3E}">
-        <p14:creationId xmlns:p14="http://schemas.microsoft.com/office/powerpoint/2010/main" val="613288384"/>
+        <p14:creationId xmlns:p14="http://schemas.microsoft.com/office/powerpoint/2010/main" val="536532968"/>
       </p:ext>
     </p:extLst>
   </p:cSld>
@@ -13639,7 +13639,7 @@
           <p:cNvPr id="14" name="">
             <a:extLst xmlns:a="http://schemas.openxmlformats.org/drawingml/2006/main">
               <a:ext uri="{FF2B5EF4-FFF2-40B4-BE49-F238E27FC236}">
-                <a16:creationId xmlns:a16="http://schemas.microsoft.com/office/drawing/2014/main" id="{10BF508C-B205-45DA-AF7E-C693F989C889}"/>
+                <a16:creationId xmlns:a16="http://schemas.microsoft.com/office/drawing/2014/main" id="{1D74A58E-9701-4BD9-9D80-51EE65182F52}"/>
               </a:ext>
             </a:extLst>
           </p:cNvPr>
@@ -13696,7 +13696,7 @@
           <p:cNvPr id="2" name="">
             <a:extLst xmlns:a="http://schemas.openxmlformats.org/drawingml/2006/main">
               <a:ext uri="{FF2B5EF4-FFF2-40B4-BE49-F238E27FC236}">
-                <a16:creationId xmlns:a16="http://schemas.microsoft.com/office/drawing/2014/main" id="{06E96627-FABE-4E3A-9940-23764F4E6CA9}"/>
+                <a16:creationId xmlns:a16="http://schemas.microsoft.com/office/drawing/2014/main" id="{CCB96DA0-69CC-4F5A-B13F-773D75D9CAE1}"/>
               </a:ext>
             </a:extLst>
           </p:cNvPr>
@@ -13753,7 +13753,7 @@
           <p:cNvPr id="3" name="">
             <a:extLst xmlns:a="http://schemas.openxmlformats.org/drawingml/2006/main">
               <a:ext uri="{FF2B5EF4-FFF2-40B4-BE49-F238E27FC236}">
-                <a16:creationId xmlns:a16="http://schemas.microsoft.com/office/drawing/2014/main" id="{95656F46-8AF0-4C58-B70E-D740889598B7}"/>
+                <a16:creationId xmlns:a16="http://schemas.microsoft.com/office/drawing/2014/main" id="{1110E398-DC19-4F12-BA16-FEEE8993F85D}"/>
               </a:ext>
             </a:extLst>
           </p:cNvPr>
@@ -13810,7 +13810,7 @@
           <p:cNvPr id="4" name="">
             <a:extLst xmlns:a="http://schemas.openxmlformats.org/drawingml/2006/main">
               <a:ext uri="{FF2B5EF4-FFF2-40B4-BE49-F238E27FC236}">
-                <a16:creationId xmlns:a16="http://schemas.microsoft.com/office/drawing/2014/main" id="{99E94F49-99F2-4B41-B160-1AD2CA492D0A}"/>
+                <a16:creationId xmlns:a16="http://schemas.microsoft.com/office/drawing/2014/main" id="{33C42D51-071D-4A50-A055-30AE44036461}"/>
               </a:ext>
             </a:extLst>
           </p:cNvPr>
@@ -13867,7 +13867,7 @@
           <p:cNvPr id="5" name="">
             <a:extLst xmlns:a="http://schemas.openxmlformats.org/drawingml/2006/main">
               <a:ext uri="{FF2B5EF4-FFF2-40B4-BE49-F238E27FC236}">
-                <a16:creationId xmlns:a16="http://schemas.microsoft.com/office/drawing/2014/main" id="{E7666EDC-4E67-42B2-B208-62DC27C50758}"/>
+                <a16:creationId xmlns:a16="http://schemas.microsoft.com/office/drawing/2014/main" id="{C41C8C6A-F8BE-475F-BB1C-B3A3B185785F}"/>
               </a:ext>
             </a:extLst>
           </p:cNvPr>
@@ -13924,7 +13924,7 @@
           <p:cNvPr id="6" name="">
             <a:extLst xmlns:a="http://schemas.openxmlformats.org/drawingml/2006/main">
               <a:ext uri="{FF2B5EF4-FFF2-40B4-BE49-F238E27FC236}">
-                <a16:creationId xmlns:a16="http://schemas.microsoft.com/office/drawing/2014/main" id="{3388C9DB-81EB-47A4-9B82-1748728B4F3F}"/>
+                <a16:creationId xmlns:a16="http://schemas.microsoft.com/office/drawing/2014/main" id="{ACDC1B89-1624-4937-A77C-1A7C2B39AAA5}"/>
               </a:ext>
             </a:extLst>
           </p:cNvPr>
@@ -13981,7 +13981,7 @@
           <p:cNvPr id="7" name="">
             <a:extLst xmlns:a="http://schemas.openxmlformats.org/drawingml/2006/main">
               <a:ext uri="{FF2B5EF4-FFF2-40B4-BE49-F238E27FC236}">
-                <a16:creationId xmlns:a16="http://schemas.microsoft.com/office/drawing/2014/main" id="{20868F1A-AF0C-4E8E-AFFA-3625E252F922}"/>
+                <a16:creationId xmlns:a16="http://schemas.microsoft.com/office/drawing/2014/main" id="{8FB1E8BA-5DA9-4190-935D-42BF3F93C756}"/>
               </a:ext>
             </a:extLst>
           </p:cNvPr>
@@ -14038,7 +14038,7 @@
           <p:cNvPr id="8" name="">
             <a:extLst xmlns:a="http://schemas.openxmlformats.org/drawingml/2006/main">
               <a:ext uri="{FF2B5EF4-FFF2-40B4-BE49-F238E27FC236}">
-                <a16:creationId xmlns:a16="http://schemas.microsoft.com/office/drawing/2014/main" id="{4974F09B-7771-43EC-953E-D3112AC3CF4C}"/>
+                <a16:creationId xmlns:a16="http://schemas.microsoft.com/office/drawing/2014/main" id="{25DA6179-A1B3-4E5D-A7C0-520F147BA49C}"/>
               </a:ext>
             </a:extLst>
           </p:cNvPr>
@@ -14095,7 +14095,7 @@
           <p:cNvPr id="9" name="">
             <a:extLst xmlns:a="http://schemas.openxmlformats.org/drawingml/2006/main">
               <a:ext uri="{FF2B5EF4-FFF2-40B4-BE49-F238E27FC236}">
-                <a16:creationId xmlns:a16="http://schemas.microsoft.com/office/drawing/2014/main" id="{33003BB1-FFA6-4AC7-A2CC-26F8E91DD87A}"/>
+                <a16:creationId xmlns:a16="http://schemas.microsoft.com/office/drawing/2014/main" id="{282702AC-B928-4D72-B67E-7D8D3A33045A}"/>
               </a:ext>
             </a:extLst>
           </p:cNvPr>
@@ -14152,7 +14152,7 @@
           <p:cNvPr id="10" name="">
             <a:extLst xmlns:a="http://schemas.openxmlformats.org/drawingml/2006/main">
               <a:ext uri="{FF2B5EF4-FFF2-40B4-BE49-F238E27FC236}">
-                <a16:creationId xmlns:a16="http://schemas.microsoft.com/office/drawing/2014/main" id="{84008222-181F-42C3-9FCD-BD5FC227777A}"/>
+                <a16:creationId xmlns:a16="http://schemas.microsoft.com/office/drawing/2014/main" id="{7E622683-D673-4AD5-90E4-3CD694D70934}"/>
               </a:ext>
             </a:extLst>
           </p:cNvPr>
@@ -14209,7 +14209,7 @@
           <p:cNvPr id="11" name="">
             <a:extLst xmlns:a="http://schemas.openxmlformats.org/drawingml/2006/main">
               <a:ext uri="{FF2B5EF4-FFF2-40B4-BE49-F238E27FC236}">
-                <a16:creationId xmlns:a16="http://schemas.microsoft.com/office/drawing/2014/main" id="{91D2DE7F-309C-4754-90A3-AA293BC8DA6D}"/>
+                <a16:creationId xmlns:a16="http://schemas.microsoft.com/office/drawing/2014/main" id="{DD3A7933-15A1-46FA-A589-FB9FCE2D6F09}"/>
               </a:ext>
             </a:extLst>
           </p:cNvPr>
@@ -14266,7 +14266,7 @@
           <p:cNvPr id="12" name="">
             <a:extLst xmlns:a="http://schemas.openxmlformats.org/drawingml/2006/main">
               <a:ext uri="{FF2B5EF4-FFF2-40B4-BE49-F238E27FC236}">
-                <a16:creationId xmlns:a16="http://schemas.microsoft.com/office/drawing/2014/main" id="{40A382B5-E54D-4768-B657-0345603FE1BF}"/>
+                <a16:creationId xmlns:a16="http://schemas.microsoft.com/office/drawing/2014/main" id="{073907F9-750C-41B9-B01E-C33F20DF033A}"/>
               </a:ext>
             </a:extLst>
           </p:cNvPr>
@@ -14323,7 +14323,7 @@
           <p:cNvPr id="13" name="">
             <a:extLst xmlns:a="http://schemas.openxmlformats.org/drawingml/2006/main">
               <a:ext uri="{FF2B5EF4-FFF2-40B4-BE49-F238E27FC236}">
-                <a16:creationId xmlns:a16="http://schemas.microsoft.com/office/drawing/2014/main" id="{429B3502-1BFC-4543-9F89-F4AD89082E2B}"/>
+                <a16:creationId xmlns:a16="http://schemas.microsoft.com/office/drawing/2014/main" id="{5FA8CB20-FCEB-4687-B353-F7F7A7294E56}"/>
               </a:ext>
             </a:extLst>
           </p:cNvPr>
@@ -14378,7 +14378,7 @@
     </p:spTree>
     <p:extLst>
       <p:ext uri="{BB962C8B-B14F-4D97-AF65-F5344CB8AC3E}">
-        <p14:creationId xmlns:p14="http://schemas.microsoft.com/office/powerpoint/2010/main" val="1402463589"/>
+        <p14:creationId xmlns:p14="http://schemas.microsoft.com/office/powerpoint/2010/main" val="1538480354"/>
       </p:ext>
     </p:extLst>
   </p:cSld>
@@ -14409,7 +14409,7 @@
           <p:cNvPr id="8" name="">
             <a:extLst xmlns:a="http://schemas.openxmlformats.org/drawingml/2006/main">
               <a:ext uri="{FF2B5EF4-FFF2-40B4-BE49-F238E27FC236}">
-                <a16:creationId xmlns:a16="http://schemas.microsoft.com/office/drawing/2014/main" id="{FAB707DE-9C32-488D-B961-D06551F675FC}"/>
+                <a16:creationId xmlns:a16="http://schemas.microsoft.com/office/drawing/2014/main" id="{6BA0615B-A4ED-4ACD-9B06-6E9C3A2596B7}"/>
               </a:ext>
             </a:extLst>
           </p:cNvPr>
@@ -14466,7 +14466,7 @@
           <p:cNvPr id="2" name="">
             <a:extLst xmlns:a="http://schemas.openxmlformats.org/drawingml/2006/main">
               <a:ext uri="{FF2B5EF4-FFF2-40B4-BE49-F238E27FC236}">
-                <a16:creationId xmlns:a16="http://schemas.microsoft.com/office/drawing/2014/main" id="{46772632-8054-4BD3-9938-D51195BA14C8}"/>
+                <a16:creationId xmlns:a16="http://schemas.microsoft.com/office/drawing/2014/main" id="{48014E82-99E7-439A-BBA8-7CB3B3964BAA}"/>
               </a:ext>
             </a:extLst>
           </p:cNvPr>
@@ -14523,7 +14523,7 @@
           <p:cNvPr id="3" name="">
             <a:extLst xmlns:a="http://schemas.openxmlformats.org/drawingml/2006/main">
               <a:ext uri="{FF2B5EF4-FFF2-40B4-BE49-F238E27FC236}">
-                <a16:creationId xmlns:a16="http://schemas.microsoft.com/office/drawing/2014/main" id="{8331C925-6BBF-479C-9ECD-8C0FC74666CB}"/>
+                <a16:creationId xmlns:a16="http://schemas.microsoft.com/office/drawing/2014/main" id="{BB312AE8-BC65-499E-8C18-59A5FD0D64C8}"/>
               </a:ext>
             </a:extLst>
           </p:cNvPr>
@@ -14686,7 +14686,7 @@
           <p:nvPr/>
         </p:nvPicPr>
         <p:blipFill>
-          <a:blip xmlns:r="http://schemas.openxmlformats.org/officeDocument/2006/relationships" xmlns:a="http://schemas.openxmlformats.org/drawingml/2006/main" r:embed="Rfb264aa17c414064"/>
+          <a:blip xmlns:r="http://schemas.openxmlformats.org/officeDocument/2006/relationships" xmlns:a="http://schemas.openxmlformats.org/drawingml/2006/main" r:embed="Rcd5315627072470a"/>
           <a:stretch xmlns:a="http://schemas.openxmlformats.org/drawingml/2006/main"/>
         </p:blipFill>
         <p:spPr>
@@ -14704,7 +14704,7 @@
           <p:cNvPr id="5" name="">
             <a:extLst xmlns:a="http://schemas.openxmlformats.org/drawingml/2006/main">
               <a:ext uri="{FF2B5EF4-FFF2-40B4-BE49-F238E27FC236}">
-                <a16:creationId xmlns:a16="http://schemas.microsoft.com/office/drawing/2014/main" id="{570615AD-43E7-4F45-9732-FCDF8D73B0F8}"/>
+                <a16:creationId xmlns:a16="http://schemas.microsoft.com/office/drawing/2014/main" id="{E3EC653C-64C0-435A-ABF2-7EDD46F8E135}"/>
               </a:ext>
             </a:extLst>
           </p:cNvPr>
@@ -14784,7 +14784,7 @@
           <p:cNvPr id="6" name="">
             <a:extLst xmlns:a="http://schemas.openxmlformats.org/drawingml/2006/main">
               <a:ext uri="{FF2B5EF4-FFF2-40B4-BE49-F238E27FC236}">
-                <a16:creationId xmlns:a16="http://schemas.microsoft.com/office/drawing/2014/main" id="{7308C2E9-1CEE-45DA-97BD-AB09FAB74135}"/>
+                <a16:creationId xmlns:a16="http://schemas.microsoft.com/office/drawing/2014/main" id="{2D481E8E-3D7C-4155-8A88-25C8A959F86D}"/>
               </a:ext>
             </a:extLst>
           </p:cNvPr>
@@ -14841,7 +14841,7 @@
           <p:cNvPr id="7" name="">
             <a:extLst xmlns:a="http://schemas.openxmlformats.org/drawingml/2006/main">
               <a:ext uri="{FF2B5EF4-FFF2-40B4-BE49-F238E27FC236}">
-                <a16:creationId xmlns:a16="http://schemas.microsoft.com/office/drawing/2014/main" id="{0046A031-80A9-4426-B3D3-A4FAFF594FB3}"/>
+                <a16:creationId xmlns:a16="http://schemas.microsoft.com/office/drawing/2014/main" id="{967C6370-85C6-45FB-B15B-D2ECF7357C12}"/>
               </a:ext>
             </a:extLst>
           </p:cNvPr>
@@ -14896,7 +14896,7 @@
     </p:spTree>
     <p:extLst>
       <p:ext uri="{BB962C8B-B14F-4D97-AF65-F5344CB8AC3E}">
-        <p14:creationId xmlns:p14="http://schemas.microsoft.com/office/powerpoint/2010/main" val="322910369"/>
+        <p14:creationId xmlns:p14="http://schemas.microsoft.com/office/powerpoint/2010/main" val="1844302139"/>
       </p:ext>
     </p:extLst>
   </p:cSld>
@@ -14927,7 +14927,7 @@
           <p:cNvPr id="23" name="">
             <a:extLst xmlns:a="http://schemas.openxmlformats.org/drawingml/2006/main">
               <a:ext uri="{FF2B5EF4-FFF2-40B4-BE49-F238E27FC236}">
-                <a16:creationId xmlns:a16="http://schemas.microsoft.com/office/drawing/2014/main" id="{961996E8-337A-4E9F-BBDC-731D88959D3C}"/>
+                <a16:creationId xmlns:a16="http://schemas.microsoft.com/office/drawing/2014/main" id="{D0D6C85F-8FD6-45CD-B06A-C714118A3F86}"/>
               </a:ext>
             </a:extLst>
           </p:cNvPr>
@@ -14984,7 +14984,7 @@
           <p:cNvPr id="2" name="stage0">
             <a:extLst xmlns:a="http://schemas.openxmlformats.org/drawingml/2006/main">
               <a:ext uri="{FF2B5EF4-FFF2-40B4-BE49-F238E27FC236}">
-                <a16:creationId xmlns:a16="http://schemas.microsoft.com/office/drawing/2014/main" id="{701676FE-C074-4325-9AC1-00E266D9ACE0}"/>
+                <a16:creationId xmlns:a16="http://schemas.microsoft.com/office/drawing/2014/main" id="{B3916571-761F-4619-A1C0-38A086AB104A}"/>
               </a:ext>
             </a:extLst>
           </p:cNvPr>
@@ -15068,7 +15068,7 @@
           <p:cNvPr id="3" name="artifact0">
             <a:extLst xmlns:a="http://schemas.openxmlformats.org/drawingml/2006/main">
               <a:ext uri="{FF2B5EF4-FFF2-40B4-BE49-F238E27FC236}">
-                <a16:creationId xmlns:a16="http://schemas.microsoft.com/office/drawing/2014/main" id="{23F30A69-1F1E-48CF-A972-470FC0C6D5BB}"/>
+                <a16:creationId xmlns:a16="http://schemas.microsoft.com/office/drawing/2014/main" id="{73A8FD5F-EEF6-4AB9-8ACE-7453FB88151D}"/>
               </a:ext>
             </a:extLst>
           </p:cNvPr>
@@ -15152,7 +15152,7 @@
           <p:cNvPr id="4" name="stage1">
             <a:extLst xmlns:a="http://schemas.openxmlformats.org/drawingml/2006/main">
               <a:ext uri="{FF2B5EF4-FFF2-40B4-BE49-F238E27FC236}">
-                <a16:creationId xmlns:a16="http://schemas.microsoft.com/office/drawing/2014/main" id="{080B4B99-FFCA-40C9-94BA-775EAA514543}"/>
+                <a16:creationId xmlns:a16="http://schemas.microsoft.com/office/drawing/2014/main" id="{F8433B06-604C-4311-B364-CA9613E5F51B}"/>
               </a:ext>
             </a:extLst>
           </p:cNvPr>
@@ -15236,7 +15236,7 @@
           <p:cNvPr id="5" name="artifact1">
             <a:extLst xmlns:a="http://schemas.openxmlformats.org/drawingml/2006/main">
               <a:ext uri="{FF2B5EF4-FFF2-40B4-BE49-F238E27FC236}">
-                <a16:creationId xmlns:a16="http://schemas.microsoft.com/office/drawing/2014/main" id="{914F3D39-6153-42CE-B605-A9C614C8960C}"/>
+                <a16:creationId xmlns:a16="http://schemas.microsoft.com/office/drawing/2014/main" id="{5A9DD13F-D4D2-449E-A4EF-22958EDA15B0}"/>
               </a:ext>
             </a:extLst>
           </p:cNvPr>
@@ -15320,7 +15320,7 @@
           <p:cNvPr id="6" name="stage2">
             <a:extLst xmlns:a="http://schemas.openxmlformats.org/drawingml/2006/main">
               <a:ext uri="{FF2B5EF4-FFF2-40B4-BE49-F238E27FC236}">
-                <a16:creationId xmlns:a16="http://schemas.microsoft.com/office/drawing/2014/main" id="{9A50231B-20AA-4269-960A-976D1F1C3346}"/>
+                <a16:creationId xmlns:a16="http://schemas.microsoft.com/office/drawing/2014/main" id="{6B48F8D3-742A-4526-BDAE-C643084AF42A}"/>
               </a:ext>
             </a:extLst>
           </p:cNvPr>
@@ -15404,7 +15404,7 @@
           <p:cNvPr id="7" name="artifact2">
             <a:extLst xmlns:a="http://schemas.openxmlformats.org/drawingml/2006/main">
               <a:ext uri="{FF2B5EF4-FFF2-40B4-BE49-F238E27FC236}">
-                <a16:creationId xmlns:a16="http://schemas.microsoft.com/office/drawing/2014/main" id="{EFDFC272-E0F2-4467-A388-EA71B3780F64}"/>
+                <a16:creationId xmlns:a16="http://schemas.microsoft.com/office/drawing/2014/main" id="{8E4BA879-D4D5-4284-99CE-0840768D44B7}"/>
               </a:ext>
             </a:extLst>
           </p:cNvPr>
@@ -15488,7 +15488,7 @@
           <p:cNvPr id="8" name="stage3">
             <a:extLst xmlns:a="http://schemas.openxmlformats.org/drawingml/2006/main">
               <a:ext uri="{FF2B5EF4-FFF2-40B4-BE49-F238E27FC236}">
-                <a16:creationId xmlns:a16="http://schemas.microsoft.com/office/drawing/2014/main" id="{C07873E1-0C69-465D-90AD-B2F9E3A15931}"/>
+                <a16:creationId xmlns:a16="http://schemas.microsoft.com/office/drawing/2014/main" id="{9134CA3E-3FA1-4AB7-B876-A29C2441D879}"/>
               </a:ext>
             </a:extLst>
           </p:cNvPr>
@@ -15572,7 +15572,7 @@
           <p:cNvPr id="9" name="artifact3">
             <a:extLst xmlns:a="http://schemas.openxmlformats.org/drawingml/2006/main">
               <a:ext uri="{FF2B5EF4-FFF2-40B4-BE49-F238E27FC236}">
-                <a16:creationId xmlns:a16="http://schemas.microsoft.com/office/drawing/2014/main" id="{CFBFCCB1-ED9F-4E9F-A8B9-EAF5B50465CC}"/>
+                <a16:creationId xmlns:a16="http://schemas.microsoft.com/office/drawing/2014/main" id="{4FDEDA53-4D76-4290-A74F-CB84804D9D9C}"/>
               </a:ext>
             </a:extLst>
           </p:cNvPr>
@@ -15831,7 +15831,7 @@
           <p:cNvPr id="17" name="">
             <a:extLst xmlns:a="http://schemas.openxmlformats.org/drawingml/2006/main">
               <a:ext uri="{FF2B5EF4-FFF2-40B4-BE49-F238E27FC236}">
-                <a16:creationId xmlns:a16="http://schemas.microsoft.com/office/drawing/2014/main" id="{E9B7922E-CE68-4841-BDDC-205B194696B0}"/>
+                <a16:creationId xmlns:a16="http://schemas.microsoft.com/office/drawing/2014/main" id="{8BBAFF97-7EF7-4400-A7B6-2AD806AB25F5}"/>
               </a:ext>
             </a:extLst>
           </p:cNvPr>
@@ -15913,7 +15913,7 @@
           <p:cNvPr id="18" name="">
             <a:extLst xmlns:a="http://schemas.openxmlformats.org/drawingml/2006/main">
               <a:ext uri="{FF2B5EF4-FFF2-40B4-BE49-F238E27FC236}">
-                <a16:creationId xmlns:a16="http://schemas.microsoft.com/office/drawing/2014/main" id="{0A052700-9F99-48B0-BACB-2230B427C673}"/>
+                <a16:creationId xmlns:a16="http://schemas.microsoft.com/office/drawing/2014/main" id="{77742DB7-4794-4EB9-8D2F-92381DA2E5F7}"/>
               </a:ext>
             </a:extLst>
           </p:cNvPr>
@@ -15995,7 +15995,7 @@
           <p:cNvPr id="19" name="">
             <a:extLst xmlns:a="http://schemas.openxmlformats.org/drawingml/2006/main">
               <a:ext uri="{FF2B5EF4-FFF2-40B4-BE49-F238E27FC236}">
-                <a16:creationId xmlns:a16="http://schemas.microsoft.com/office/drawing/2014/main" id="{4DCC0D54-94D7-4D31-BCF4-83F9D9A3E06E}"/>
+                <a16:creationId xmlns:a16="http://schemas.microsoft.com/office/drawing/2014/main" id="{278CA42A-3883-4E5F-B922-AEB1F4C72DA0}"/>
               </a:ext>
             </a:extLst>
           </p:cNvPr>
@@ -16077,7 +16077,7 @@
           <p:cNvPr id="20" name="">
             <a:extLst xmlns:a="http://schemas.openxmlformats.org/drawingml/2006/main">
               <a:ext uri="{FF2B5EF4-FFF2-40B4-BE49-F238E27FC236}">
-                <a16:creationId xmlns:a16="http://schemas.microsoft.com/office/drawing/2014/main" id="{A762B787-45C1-4F3A-9D39-9F448FBCA335}"/>
+                <a16:creationId xmlns:a16="http://schemas.microsoft.com/office/drawing/2014/main" id="{513955EE-4EB3-4665-AD2F-8B9B10665B52}"/>
               </a:ext>
             </a:extLst>
           </p:cNvPr>
@@ -16159,7 +16159,7 @@
           <p:cNvPr id="21" name="">
             <a:extLst xmlns:a="http://schemas.openxmlformats.org/drawingml/2006/main">
               <a:ext uri="{FF2B5EF4-FFF2-40B4-BE49-F238E27FC236}">
-                <a16:creationId xmlns:a16="http://schemas.microsoft.com/office/drawing/2014/main" id="{00640DEB-62A4-43E4-BF3F-1EED3BF8D48E}"/>
+                <a16:creationId xmlns:a16="http://schemas.microsoft.com/office/drawing/2014/main" id="{41C6038B-FA40-4777-AEDA-B4433660106D}"/>
               </a:ext>
             </a:extLst>
           </p:cNvPr>
@@ -16216,7 +16216,7 @@
           <p:cNvPr id="22" name="">
             <a:extLst xmlns:a="http://schemas.openxmlformats.org/drawingml/2006/main">
               <a:ext uri="{FF2B5EF4-FFF2-40B4-BE49-F238E27FC236}">
-                <a16:creationId xmlns:a16="http://schemas.microsoft.com/office/drawing/2014/main" id="{CD2B0B0C-4669-42C7-8071-6B8B9FB8DCD8}"/>
+                <a16:creationId xmlns:a16="http://schemas.microsoft.com/office/drawing/2014/main" id="{B7514B3B-C9EB-4D77-AE38-73E1AA01521A}"/>
               </a:ext>
             </a:extLst>
           </p:cNvPr>
@@ -16271,7 +16271,7 @@
     </p:spTree>
     <p:extLst>
       <p:ext uri="{BB962C8B-B14F-4D97-AF65-F5344CB8AC3E}">
-        <p14:creationId xmlns:p14="http://schemas.microsoft.com/office/powerpoint/2010/main" val="40124560"/>
+        <p14:creationId xmlns:p14="http://schemas.microsoft.com/office/powerpoint/2010/main" val="1520994479"/>
       </p:ext>
     </p:extLst>
   </p:cSld>
@@ -16302,7 +16302,7 @@
           <p:cNvPr id="8" name="">
             <a:extLst xmlns:a="http://schemas.openxmlformats.org/drawingml/2006/main">
               <a:ext uri="{FF2B5EF4-FFF2-40B4-BE49-F238E27FC236}">
-                <a16:creationId xmlns:a16="http://schemas.microsoft.com/office/drawing/2014/main" id="{9C891CE3-6743-4FD8-B1A8-2B3D3713F663}"/>
+                <a16:creationId xmlns:a16="http://schemas.microsoft.com/office/drawing/2014/main" id="{22672AD3-FD46-4CFE-BE5F-05AB9C3CA89E}"/>
               </a:ext>
             </a:extLst>
           </p:cNvPr>
@@ -16359,7 +16359,7 @@
           <p:cNvPr id="2" name="">
             <a:extLst xmlns:a="http://schemas.openxmlformats.org/drawingml/2006/main">
               <a:ext uri="{FF2B5EF4-FFF2-40B4-BE49-F238E27FC236}">
-                <a16:creationId xmlns:a16="http://schemas.microsoft.com/office/drawing/2014/main" id="{C9C79F10-089C-4CA6-A956-9528A8A152EE}"/>
+                <a16:creationId xmlns:a16="http://schemas.microsoft.com/office/drawing/2014/main" id="{B27E0960-66C3-4D42-BB66-19D3553FBA5A}"/>
               </a:ext>
             </a:extLst>
           </p:cNvPr>
@@ -16416,7 +16416,7 @@
           <p:cNvPr id="3" name="">
             <a:extLst xmlns:a="http://schemas.openxmlformats.org/drawingml/2006/main">
               <a:ext uri="{FF2B5EF4-FFF2-40B4-BE49-F238E27FC236}">
-                <a16:creationId xmlns:a16="http://schemas.microsoft.com/office/drawing/2014/main" id="{B226828F-B816-494A-96D0-C720B845E499}"/>
+                <a16:creationId xmlns:a16="http://schemas.microsoft.com/office/drawing/2014/main" id="{3FD2737B-A73C-4D9D-91C0-8DA467345BBE}"/>
               </a:ext>
             </a:extLst>
           </p:cNvPr>
@@ -16524,7 +16524,7 @@
           <p:cNvPr id="4" name="">
             <a:extLst xmlns:a="http://schemas.openxmlformats.org/drawingml/2006/main">
               <a:ext uri="{FF2B5EF4-FFF2-40B4-BE49-F238E27FC236}">
-                <a16:creationId xmlns:a16="http://schemas.microsoft.com/office/drawing/2014/main" id="{45E13556-1F12-45BD-A620-0653878B0488}"/>
+                <a16:creationId xmlns:a16="http://schemas.microsoft.com/office/drawing/2014/main" id="{8B0EB1FD-3FC7-4895-80FD-3120A5BF5196}"/>
               </a:ext>
             </a:extLst>
           </p:cNvPr>
@@ -16581,7 +16581,7 @@
           <p:cNvPr id="5" name="">
             <a:extLst xmlns:a="http://schemas.openxmlformats.org/drawingml/2006/main">
               <a:ext uri="{FF2B5EF4-FFF2-40B4-BE49-F238E27FC236}">
-                <a16:creationId xmlns:a16="http://schemas.microsoft.com/office/drawing/2014/main" id="{788451F5-1733-4C45-8E97-8A0523BF5250}"/>
+                <a16:creationId xmlns:a16="http://schemas.microsoft.com/office/drawing/2014/main" id="{17CFCF63-73FB-4F1C-B51A-0954CDBB1380}"/>
               </a:ext>
             </a:extLst>
           </p:cNvPr>
@@ -16707,7 +16707,7 @@
           <p:cNvPr id="6" name="">
             <a:extLst xmlns:a="http://schemas.openxmlformats.org/drawingml/2006/main">
               <a:ext uri="{FF2B5EF4-FFF2-40B4-BE49-F238E27FC236}">
-                <a16:creationId xmlns:a16="http://schemas.microsoft.com/office/drawing/2014/main" id="{8533BB34-F48B-4830-9397-F19D58133A75}"/>
+                <a16:creationId xmlns:a16="http://schemas.microsoft.com/office/drawing/2014/main" id="{4E96E37F-1718-44F6-8967-55EA5CAD5AA0}"/>
               </a:ext>
             </a:extLst>
           </p:cNvPr>
@@ -16764,7 +16764,7 @@
           <p:cNvPr id="7" name="">
             <a:extLst xmlns:a="http://schemas.openxmlformats.org/drawingml/2006/main">
               <a:ext uri="{FF2B5EF4-FFF2-40B4-BE49-F238E27FC236}">
-                <a16:creationId xmlns:a16="http://schemas.microsoft.com/office/drawing/2014/main" id="{79B4C31E-EEDA-43E7-8C4A-B7310EEE68DE}"/>
+                <a16:creationId xmlns:a16="http://schemas.microsoft.com/office/drawing/2014/main" id="{EBF37DE8-C5D6-4D5F-ABBE-966B2AED2D90}"/>
               </a:ext>
             </a:extLst>
           </p:cNvPr>
@@ -16819,7 +16819,7 @@
     </p:spTree>
     <p:extLst>
       <p:ext uri="{BB962C8B-B14F-4D97-AF65-F5344CB8AC3E}">
-        <p14:creationId xmlns:p14="http://schemas.microsoft.com/office/powerpoint/2010/main" val="1403953797"/>
+        <p14:creationId xmlns:p14="http://schemas.microsoft.com/office/powerpoint/2010/main" val="1864206511"/>
       </p:ext>
     </p:extLst>
   </p:cSld>
@@ -16850,7 +16850,7 @@
           <p:cNvPr id="15" name="">
             <a:extLst xmlns:a="http://schemas.openxmlformats.org/drawingml/2006/main">
               <a:ext uri="{FF2B5EF4-FFF2-40B4-BE49-F238E27FC236}">
-                <a16:creationId xmlns:a16="http://schemas.microsoft.com/office/drawing/2014/main" id="{06509473-3C4F-49C7-9687-BF4955F604AB}"/>
+                <a16:creationId xmlns:a16="http://schemas.microsoft.com/office/drawing/2014/main" id="{2660C4AD-8F10-4E57-94A0-07F8A0144477}"/>
               </a:ext>
             </a:extLst>
           </p:cNvPr>
@@ -16907,7 +16907,7 @@
           <p:cNvPr id="2" name="dataset">
             <a:extLst xmlns:a="http://schemas.openxmlformats.org/drawingml/2006/main">
               <a:ext uri="{FF2B5EF4-FFF2-40B4-BE49-F238E27FC236}">
-                <a16:creationId xmlns:a16="http://schemas.microsoft.com/office/drawing/2014/main" id="{50FFEA48-6277-4B44-9335-BAFEE027A7A8}"/>
+                <a16:creationId xmlns:a16="http://schemas.microsoft.com/office/drawing/2014/main" id="{6DFE240C-91AE-4E48-99B5-0C922EBE4E31}"/>
               </a:ext>
             </a:extLst>
           </p:cNvPr>
@@ -16991,7 +16991,7 @@
           <p:cNvPr id="3" name="train">
             <a:extLst xmlns:a="http://schemas.openxmlformats.org/drawingml/2006/main">
               <a:ext uri="{FF2B5EF4-FFF2-40B4-BE49-F238E27FC236}">
-                <a16:creationId xmlns:a16="http://schemas.microsoft.com/office/drawing/2014/main" id="{23075D3B-EB5A-402B-9ED6-A0CD3799B5C9}"/>
+                <a16:creationId xmlns:a16="http://schemas.microsoft.com/office/drawing/2014/main" id="{26BB828C-6FBF-4AEE-B7AA-5FF1A7EDD15C}"/>
               </a:ext>
             </a:extLst>
           </p:cNvPr>
@@ -17052,7 +17052,7 @@
           <p:cNvPr id="4" name="validation">
             <a:extLst xmlns:a="http://schemas.openxmlformats.org/drawingml/2006/main">
               <a:ext uri="{FF2B5EF4-FFF2-40B4-BE49-F238E27FC236}">
-                <a16:creationId xmlns:a16="http://schemas.microsoft.com/office/drawing/2014/main" id="{D48851D2-C4E7-46E4-90FA-A6FF1088F6ED}"/>
+                <a16:creationId xmlns:a16="http://schemas.microsoft.com/office/drawing/2014/main" id="{54D8128F-CCE0-4360-974F-80748E141D3F}"/>
               </a:ext>
             </a:extLst>
           </p:cNvPr>
@@ -17113,7 +17113,7 @@
           <p:cNvPr id="5" name="test">
             <a:extLst xmlns:a="http://schemas.openxmlformats.org/drawingml/2006/main">
               <a:ext uri="{FF2B5EF4-FFF2-40B4-BE49-F238E27FC236}">
-                <a16:creationId xmlns:a16="http://schemas.microsoft.com/office/drawing/2014/main" id="{82663A11-F7C2-4BA6-9A7B-B1000E796FF8}"/>
+                <a16:creationId xmlns:a16="http://schemas.microsoft.com/office/drawing/2014/main" id="{DDEBE6FD-8CD7-4205-A333-8F7606A9B6BC}"/>
               </a:ext>
             </a:extLst>
           </p:cNvPr>
@@ -17255,7 +17255,7 @@
           <p:cNvPr id="9" name="">
             <a:extLst xmlns:a="http://schemas.openxmlformats.org/drawingml/2006/main">
               <a:ext uri="{FF2B5EF4-FFF2-40B4-BE49-F238E27FC236}">
-                <a16:creationId xmlns:a16="http://schemas.microsoft.com/office/drawing/2014/main" id="{F75EAF24-5E0F-4D2E-B94C-22DDEDC769CA}"/>
+                <a16:creationId xmlns:a16="http://schemas.microsoft.com/office/drawing/2014/main" id="{D385C96F-E105-40EF-B1D4-9F88888E7F00}"/>
               </a:ext>
             </a:extLst>
           </p:cNvPr>
@@ -17312,7 +17312,7 @@
           <p:cNvPr id="10" name="">
             <a:extLst xmlns:a="http://schemas.openxmlformats.org/drawingml/2006/main">
               <a:ext uri="{FF2B5EF4-FFF2-40B4-BE49-F238E27FC236}">
-                <a16:creationId xmlns:a16="http://schemas.microsoft.com/office/drawing/2014/main" id="{36F00AF5-0D5F-4AB7-AB23-886ADDFE66F3}"/>
+                <a16:creationId xmlns:a16="http://schemas.microsoft.com/office/drawing/2014/main" id="{4A4DC2A9-C6AC-4309-8B23-57333421367A}"/>
               </a:ext>
             </a:extLst>
           </p:cNvPr>
@@ -17369,7 +17369,7 @@
           <p:cNvPr id="11" name="">
             <a:extLst xmlns:a="http://schemas.openxmlformats.org/drawingml/2006/main">
               <a:ext uri="{FF2B5EF4-FFF2-40B4-BE49-F238E27FC236}">
-                <a16:creationId xmlns:a16="http://schemas.microsoft.com/office/drawing/2014/main" id="{F6711EC7-B711-421D-AB48-CF584AAF8B06}"/>
+                <a16:creationId xmlns:a16="http://schemas.microsoft.com/office/drawing/2014/main" id="{687BB0E3-146B-43ED-ACD7-036C372130EA}"/>
               </a:ext>
             </a:extLst>
           </p:cNvPr>
@@ -17426,7 +17426,7 @@
           <p:cNvPr id="12" name="">
             <a:extLst xmlns:a="http://schemas.openxmlformats.org/drawingml/2006/main">
               <a:ext uri="{FF2B5EF4-FFF2-40B4-BE49-F238E27FC236}">
-                <a16:creationId xmlns:a16="http://schemas.microsoft.com/office/drawing/2014/main" id="{F5857637-B9E0-49C2-BEE7-B2D5504B7109}"/>
+                <a16:creationId xmlns:a16="http://schemas.microsoft.com/office/drawing/2014/main" id="{AC30F131-B0E8-40EB-93E1-01FF5D55E206}"/>
               </a:ext>
             </a:extLst>
           </p:cNvPr>
@@ -17483,7 +17483,7 @@
           <p:cNvPr id="13" name="">
             <a:extLst xmlns:a="http://schemas.openxmlformats.org/drawingml/2006/main">
               <a:ext uri="{FF2B5EF4-FFF2-40B4-BE49-F238E27FC236}">
-                <a16:creationId xmlns:a16="http://schemas.microsoft.com/office/drawing/2014/main" id="{A4D0595D-2802-44FB-976A-E6A912B52652}"/>
+                <a16:creationId xmlns:a16="http://schemas.microsoft.com/office/drawing/2014/main" id="{4988B58A-18AC-47EC-B74F-F5D0B233D138}"/>
               </a:ext>
             </a:extLst>
           </p:cNvPr>
@@ -17540,7 +17540,7 @@
           <p:cNvPr id="14" name="">
             <a:extLst xmlns:a="http://schemas.openxmlformats.org/drawingml/2006/main">
               <a:ext uri="{FF2B5EF4-FFF2-40B4-BE49-F238E27FC236}">
-                <a16:creationId xmlns:a16="http://schemas.microsoft.com/office/drawing/2014/main" id="{E019C77D-CFEA-4F82-9DC2-8E1DD31951D0}"/>
+                <a16:creationId xmlns:a16="http://schemas.microsoft.com/office/drawing/2014/main" id="{90178C6A-F027-46ED-B5E5-9CFD2867098D}"/>
               </a:ext>
             </a:extLst>
           </p:cNvPr>
@@ -17595,7 +17595,7 @@
     </p:spTree>
     <p:extLst>
       <p:ext uri="{BB962C8B-B14F-4D97-AF65-F5344CB8AC3E}">
-        <p14:creationId xmlns:p14="http://schemas.microsoft.com/office/powerpoint/2010/main" val="147064242"/>
+        <p14:creationId xmlns:p14="http://schemas.microsoft.com/office/powerpoint/2010/main" val="817157385"/>
       </p:ext>
     </p:extLst>
   </p:cSld>
@@ -17626,7 +17626,7 @@
           <p:cNvPr id="18" name="">
             <a:extLst xmlns:a="http://schemas.openxmlformats.org/drawingml/2006/main">
               <a:ext uri="{FF2B5EF4-FFF2-40B4-BE49-F238E27FC236}">
-                <a16:creationId xmlns:a16="http://schemas.microsoft.com/office/drawing/2014/main" id="{1C165723-672B-4137-B3E3-937C08B2CA13}"/>
+                <a16:creationId xmlns:a16="http://schemas.microsoft.com/office/drawing/2014/main" id="{BAB63CBF-C080-4514-BE81-6D8604709EAA}"/>
               </a:ext>
             </a:extLst>
           </p:cNvPr>
@@ -17683,7 +17683,7 @@
           <p:cNvPr id="2" name="input">
             <a:extLst xmlns:a="http://schemas.openxmlformats.org/drawingml/2006/main">
               <a:ext uri="{FF2B5EF4-FFF2-40B4-BE49-F238E27FC236}">
-                <a16:creationId xmlns:a16="http://schemas.microsoft.com/office/drawing/2014/main" id="{29C626D6-DF8E-4F54-BC83-3C07840B9628}"/>
+                <a16:creationId xmlns:a16="http://schemas.microsoft.com/office/drawing/2014/main" id="{9F6D67DB-7D93-4236-A054-C8CCEBB7E2EC}"/>
               </a:ext>
             </a:extLst>
           </p:cNvPr>
@@ -17744,7 +17744,7 @@
           <p:cNvPr id="3" name="frozen">
             <a:extLst xmlns:a="http://schemas.openxmlformats.org/drawingml/2006/main">
               <a:ext uri="{FF2B5EF4-FFF2-40B4-BE49-F238E27FC236}">
-                <a16:creationId xmlns:a16="http://schemas.microsoft.com/office/drawing/2014/main" id="{8F63683C-A603-4B24-AEA7-305E6B2769B0}"/>
+                <a16:creationId xmlns:a16="http://schemas.microsoft.com/office/drawing/2014/main" id="{7718EB48-0683-422C-91D6-CD9F985E3BB9}"/>
               </a:ext>
             </a:extLst>
           </p:cNvPr>
@@ -17828,7 +17828,7 @@
           <p:cNvPr id="4" name="A">
             <a:extLst xmlns:a="http://schemas.openxmlformats.org/drawingml/2006/main">
               <a:ext uri="{FF2B5EF4-FFF2-40B4-BE49-F238E27FC236}">
-                <a16:creationId xmlns:a16="http://schemas.microsoft.com/office/drawing/2014/main" id="{DD93D19F-AF2A-44B5-8705-153687C93B75}"/>
+                <a16:creationId xmlns:a16="http://schemas.microsoft.com/office/drawing/2014/main" id="{AC48071A-29A9-4529-B3A1-92E6A43DBD19}"/>
               </a:ext>
             </a:extLst>
           </p:cNvPr>
@@ -17912,7 +17912,7 @@
           <p:cNvPr id="5" name="B">
             <a:extLst xmlns:a="http://schemas.openxmlformats.org/drawingml/2006/main">
               <a:ext uri="{FF2B5EF4-FFF2-40B4-BE49-F238E27FC236}">
-                <a16:creationId xmlns:a16="http://schemas.microsoft.com/office/drawing/2014/main" id="{9009D43C-9593-441A-A0F2-18D39BC77A0B}"/>
+                <a16:creationId xmlns:a16="http://schemas.microsoft.com/office/drawing/2014/main" id="{DD50B75E-9BDF-45CE-8A66-C01DFCE5272B}"/>
               </a:ext>
             </a:extLst>
           </p:cNvPr>
@@ -17996,7 +17996,7 @@
           <p:cNvPr id="6" name="sum">
             <a:extLst xmlns:a="http://schemas.openxmlformats.org/drawingml/2006/main">
               <a:ext uri="{FF2B5EF4-FFF2-40B4-BE49-F238E27FC236}">
-                <a16:creationId xmlns:a16="http://schemas.microsoft.com/office/drawing/2014/main" id="{C0264BB9-201E-4809-B7F8-E89A2C481AAA}"/>
+                <a16:creationId xmlns:a16="http://schemas.microsoft.com/office/drawing/2014/main" id="{812732A2-2C75-4233-9F4A-CB0DA49A3005}"/>
               </a:ext>
             </a:extLst>
           </p:cNvPr>
@@ -18057,7 +18057,7 @@
           <p:cNvPr id="7" name="output">
             <a:extLst xmlns:a="http://schemas.openxmlformats.org/drawingml/2006/main">
               <a:ext uri="{FF2B5EF4-FFF2-40B4-BE49-F238E27FC236}">
-                <a16:creationId xmlns:a16="http://schemas.microsoft.com/office/drawing/2014/main" id="{AC65F093-9017-43E1-851D-CA8115F9463F}"/>
+                <a16:creationId xmlns:a16="http://schemas.microsoft.com/office/drawing/2014/main" id="{BCB4BC78-4866-4DEA-AFA0-3222DE08CFB6}"/>
               </a:ext>
             </a:extLst>
           </p:cNvPr>
@@ -18275,7 +18275,7 @@
           <p:cNvPr id="14" name="">
             <a:extLst xmlns:a="http://schemas.openxmlformats.org/drawingml/2006/main">
               <a:ext uri="{FF2B5EF4-FFF2-40B4-BE49-F238E27FC236}">
-                <a16:creationId xmlns:a16="http://schemas.microsoft.com/office/drawing/2014/main" id="{0AFC2A48-098C-4482-A366-8F40950E8131}"/>
+                <a16:creationId xmlns:a16="http://schemas.microsoft.com/office/drawing/2014/main" id="{C62226F4-20CD-427C-935A-BF212FCC066C}"/>
               </a:ext>
             </a:extLst>
           </p:cNvPr>
@@ -18332,7 +18332,7 @@
           <p:cNvPr id="15" name="">
             <a:extLst xmlns:a="http://schemas.openxmlformats.org/drawingml/2006/main">
               <a:ext uri="{FF2B5EF4-FFF2-40B4-BE49-F238E27FC236}">
-                <a16:creationId xmlns:a16="http://schemas.microsoft.com/office/drawing/2014/main" id="{973F854B-35CB-49D6-B1C1-086DBF72EAF7}"/>
+                <a16:creationId xmlns:a16="http://schemas.microsoft.com/office/drawing/2014/main" id="{E14916B0-CA29-4B18-A9C6-776977F7322C}"/>
               </a:ext>
             </a:extLst>
           </p:cNvPr>
@@ -18389,7 +18389,7 @@
           <p:cNvPr id="16" name="">
             <a:extLst xmlns:a="http://schemas.openxmlformats.org/drawingml/2006/main">
               <a:ext uri="{FF2B5EF4-FFF2-40B4-BE49-F238E27FC236}">
-                <a16:creationId xmlns:a16="http://schemas.microsoft.com/office/drawing/2014/main" id="{543486C6-5275-498E-9E80-356BECEF5604}"/>
+                <a16:creationId xmlns:a16="http://schemas.microsoft.com/office/drawing/2014/main" id="{951C1B14-9D8D-467F-A626-1C4C5EF1168B}"/>
               </a:ext>
             </a:extLst>
           </p:cNvPr>
@@ -18446,7 +18446,7 @@
           <p:cNvPr id="17" name="">
             <a:extLst xmlns:a="http://schemas.openxmlformats.org/drawingml/2006/main">
               <a:ext uri="{FF2B5EF4-FFF2-40B4-BE49-F238E27FC236}">
-                <a16:creationId xmlns:a16="http://schemas.microsoft.com/office/drawing/2014/main" id="{258199BB-8C20-4157-83C3-216EC9BEE98F}"/>
+                <a16:creationId xmlns:a16="http://schemas.microsoft.com/office/drawing/2014/main" id="{027BA9DB-6530-48F8-94BA-1CCC85FF14E6}"/>
               </a:ext>
             </a:extLst>
           </p:cNvPr>
@@ -18501,7 +18501,7 @@
     </p:spTree>
     <p:extLst>
       <p:ext uri="{BB962C8B-B14F-4D97-AF65-F5344CB8AC3E}">
-        <p14:creationId xmlns:p14="http://schemas.microsoft.com/office/powerpoint/2010/main" val="2008332120"/>
+        <p14:creationId xmlns:p14="http://schemas.microsoft.com/office/powerpoint/2010/main" val="1527854344"/>
       </p:ext>
     </p:extLst>
   </p:cSld>
@@ -18532,7 +18532,7 @@
           <p:cNvPr id="7" name="">
             <a:extLst xmlns:a="http://schemas.openxmlformats.org/drawingml/2006/main">
               <a:ext uri="{FF2B5EF4-FFF2-40B4-BE49-F238E27FC236}">
-                <a16:creationId xmlns:a16="http://schemas.microsoft.com/office/drawing/2014/main" id="{1A84E2B7-D8C6-4818-BBBA-C64C8080873E}"/>
+                <a16:creationId xmlns:a16="http://schemas.microsoft.com/office/drawing/2014/main" id="{49D9EE93-FBE3-4B65-8DB5-FA46515D8BDF}"/>
               </a:ext>
             </a:extLst>
           </p:cNvPr>
@@ -18589,7 +18589,7 @@
           <p:cNvPr id="2" name="">
             <a:extLst xmlns:a="http://schemas.openxmlformats.org/drawingml/2006/main">
               <a:ext uri="{FF2B5EF4-FFF2-40B4-BE49-F238E27FC236}">
-                <a16:creationId xmlns:a16="http://schemas.microsoft.com/office/drawing/2014/main" id="{58E283F0-25A7-4BA1-9092-60FBA13578D6}"/>
+                <a16:creationId xmlns:a16="http://schemas.microsoft.com/office/drawing/2014/main" id="{B44EEEAD-02A5-4134-A550-6C42FCBC1633}"/>
               </a:ext>
             </a:extLst>
           </p:cNvPr>
@@ -18853,7 +18853,7 @@
           <p:cNvPr id="3" name="">
             <a:extLst xmlns:a="http://schemas.openxmlformats.org/drawingml/2006/main">
               <a:ext uri="{FF2B5EF4-FFF2-40B4-BE49-F238E27FC236}">
-                <a16:creationId xmlns:a16="http://schemas.microsoft.com/office/drawing/2014/main" id="{1ED082B5-D998-4F94-BAC8-EAC1EDFD080E}"/>
+                <a16:creationId xmlns:a16="http://schemas.microsoft.com/office/drawing/2014/main" id="{F46686A6-AB6F-48B1-81A8-A17229CB53A6}"/>
               </a:ext>
             </a:extLst>
           </p:cNvPr>
@@ -18910,7 +18910,7 @@
           <p:cNvPr id="4" name="">
             <a:extLst xmlns:a="http://schemas.openxmlformats.org/drawingml/2006/main">
               <a:ext uri="{FF2B5EF4-FFF2-40B4-BE49-F238E27FC236}">
-                <a16:creationId xmlns:a16="http://schemas.microsoft.com/office/drawing/2014/main" id="{44D8E593-9004-46CB-BE3B-5546E8809354}"/>
+                <a16:creationId xmlns:a16="http://schemas.microsoft.com/office/drawing/2014/main" id="{10EE85B4-C4CD-4412-86CB-6548D96C401D}"/>
               </a:ext>
             </a:extLst>
           </p:cNvPr>
@@ -19069,7 +19069,7 @@
           <p:cNvPr id="5" name="">
             <a:extLst xmlns:a="http://schemas.openxmlformats.org/drawingml/2006/main">
               <a:ext uri="{FF2B5EF4-FFF2-40B4-BE49-F238E27FC236}">
-                <a16:creationId xmlns:a16="http://schemas.microsoft.com/office/drawing/2014/main" id="{474F27CC-CFCF-4065-962F-89D4B522F742}"/>
+                <a16:creationId xmlns:a16="http://schemas.microsoft.com/office/drawing/2014/main" id="{81CAD8D2-7261-4FE0-8FF7-A6D76294F517}"/>
               </a:ext>
             </a:extLst>
           </p:cNvPr>
@@ -19126,7 +19126,7 @@
           <p:cNvPr id="6" name="">
             <a:extLst xmlns:a="http://schemas.openxmlformats.org/drawingml/2006/main">
               <a:ext uri="{FF2B5EF4-FFF2-40B4-BE49-F238E27FC236}">
-                <a16:creationId xmlns:a16="http://schemas.microsoft.com/office/drawing/2014/main" id="{99988C18-CCC0-471C-AF59-3576E37AE211}"/>
+                <a16:creationId xmlns:a16="http://schemas.microsoft.com/office/drawing/2014/main" id="{B2B76755-8057-43A2-BBF1-81A8A100CA09}"/>
               </a:ext>
             </a:extLst>
           </p:cNvPr>
@@ -19181,7 +19181,7 @@
     </p:spTree>
     <p:extLst>
       <p:ext uri="{BB962C8B-B14F-4D97-AF65-F5344CB8AC3E}">
-        <p14:creationId xmlns:p14="http://schemas.microsoft.com/office/powerpoint/2010/main" val="723983016"/>
+        <p14:creationId xmlns:p14="http://schemas.microsoft.com/office/powerpoint/2010/main" val="1669278224"/>
       </p:ext>
     </p:extLst>
   </p:cSld>
@@ -19212,7 +19212,7 @@
           <p:cNvPr id="16" name="">
             <a:extLst xmlns:a="http://schemas.openxmlformats.org/drawingml/2006/main">
               <a:ext uri="{FF2B5EF4-FFF2-40B4-BE49-F238E27FC236}">
-                <a16:creationId xmlns:a16="http://schemas.microsoft.com/office/drawing/2014/main" id="{D8690233-90EC-4407-8693-04CC09E96436}"/>
+                <a16:creationId xmlns:a16="http://schemas.microsoft.com/office/drawing/2014/main" id="{10B9310D-716B-48AB-8754-40557C1C0E8C}"/>
               </a:ext>
             </a:extLst>
           </p:cNvPr>
@@ -19269,7 +19269,7 @@
           <p:cNvPr id="2" name="prepare">
             <a:extLst xmlns:a="http://schemas.openxmlformats.org/drawingml/2006/main">
               <a:ext uri="{FF2B5EF4-FFF2-40B4-BE49-F238E27FC236}">
-                <a16:creationId xmlns:a16="http://schemas.microsoft.com/office/drawing/2014/main" id="{24E43C92-EFA1-4513-A1B4-0E5C3DD4D43A}"/>
+                <a16:creationId xmlns:a16="http://schemas.microsoft.com/office/drawing/2014/main" id="{F353E1CB-DDB8-4078-93F4-F98934DF6353}"/>
               </a:ext>
             </a:extLst>
           </p:cNvPr>
@@ -19353,7 +19353,7 @@
           <p:cNvPr id="3" name="forward">
             <a:extLst xmlns:a="http://schemas.openxmlformats.org/drawingml/2006/main">
               <a:ext uri="{FF2B5EF4-FFF2-40B4-BE49-F238E27FC236}">
-                <a16:creationId xmlns:a16="http://schemas.microsoft.com/office/drawing/2014/main" id="{CFDE5E35-4F51-4307-A659-8489D23140FC}"/>
+                <a16:creationId xmlns:a16="http://schemas.microsoft.com/office/drawing/2014/main" id="{5F30B06A-55CF-4C30-B16A-531AB641EB38}"/>
               </a:ext>
             </a:extLst>
           </p:cNvPr>
@@ -19437,7 +19437,7 @@
           <p:cNvPr id="4" name="backward">
             <a:extLst xmlns:a="http://schemas.openxmlformats.org/drawingml/2006/main">
               <a:ext uri="{FF2B5EF4-FFF2-40B4-BE49-F238E27FC236}">
-                <a16:creationId xmlns:a16="http://schemas.microsoft.com/office/drawing/2014/main" id="{05B04839-2B49-4DA7-95F2-1D9377527F17}"/>
+                <a16:creationId xmlns:a16="http://schemas.microsoft.com/office/drawing/2014/main" id="{8BDED43D-8F75-447D-880B-8D169A13C65C}"/>
               </a:ext>
             </a:extLst>
           </p:cNvPr>
@@ -19521,7 +19521,7 @@
           <p:cNvPr id="5" name="update">
             <a:extLst xmlns:a="http://schemas.openxmlformats.org/drawingml/2006/main">
               <a:ext uri="{FF2B5EF4-FFF2-40B4-BE49-F238E27FC236}">
-                <a16:creationId xmlns:a16="http://schemas.microsoft.com/office/drawing/2014/main" id="{B84FF48F-0040-4888-A1CB-BC5D10269B32}"/>
+                <a16:creationId xmlns:a16="http://schemas.microsoft.com/office/drawing/2014/main" id="{CFCBA503-1501-4781-8DAD-0A5A3635EEA8}"/>
               </a:ext>
             </a:extLst>
           </p:cNvPr>
@@ -19605,7 +19605,7 @@
           <p:cNvPr id="6" name="single">
             <a:extLst xmlns:a="http://schemas.openxmlformats.org/drawingml/2006/main">
               <a:ext uri="{FF2B5EF4-FFF2-40B4-BE49-F238E27FC236}">
-                <a16:creationId xmlns:a16="http://schemas.microsoft.com/office/drawing/2014/main" id="{9422B22D-4CE5-4291-842A-964162F0CED0}"/>
+                <a16:creationId xmlns:a16="http://schemas.microsoft.com/office/drawing/2014/main" id="{029BB3D2-1F67-4EB9-BFEC-FE6408102BC1}"/>
               </a:ext>
             </a:extLst>
           </p:cNvPr>
@@ -19666,7 +19666,7 @@
           <p:cNvPr id="7" name="ddp">
             <a:extLst xmlns:a="http://schemas.openxmlformats.org/drawingml/2006/main">
               <a:ext uri="{FF2B5EF4-FFF2-40B4-BE49-F238E27FC236}">
-                <a16:creationId xmlns:a16="http://schemas.microsoft.com/office/drawing/2014/main" id="{91C9C7B1-0BE1-42AA-A03B-6BA2BBC4992C}"/>
+                <a16:creationId xmlns:a16="http://schemas.microsoft.com/office/drawing/2014/main" id="{E02F152C-4610-40DE-A7E0-74BFD7C200F9}"/>
               </a:ext>
             </a:extLst>
           </p:cNvPr>
@@ -19750,7 +19750,7 @@
           <p:cNvPr id="8" name="shard">
             <a:extLst xmlns:a="http://schemas.openxmlformats.org/drawingml/2006/main">
               <a:ext uri="{FF2B5EF4-FFF2-40B4-BE49-F238E27FC236}">
-                <a16:creationId xmlns:a16="http://schemas.microsoft.com/office/drawing/2014/main" id="{5EC1FD55-0D95-46F3-A46A-896DC6B904D7}"/>
+                <a16:creationId xmlns:a16="http://schemas.microsoft.com/office/drawing/2014/main" id="{100075A1-CE29-4318-A573-67CB4EE72558}"/>
               </a:ext>
             </a:extLst>
           </p:cNvPr>
@@ -19909,7 +19909,7 @@
           <p:cNvPr id="12" name="">
             <a:extLst xmlns:a="http://schemas.openxmlformats.org/drawingml/2006/main">
               <a:ext uri="{FF2B5EF4-FFF2-40B4-BE49-F238E27FC236}">
-                <a16:creationId xmlns:a16="http://schemas.microsoft.com/office/drawing/2014/main" id="{133D02C9-7DA0-4C1B-A6EF-3963AF6B475D}"/>
+                <a16:creationId xmlns:a16="http://schemas.microsoft.com/office/drawing/2014/main" id="{8EB5FFFE-432B-436F-A867-363BD220FEEC}"/>
               </a:ext>
             </a:extLst>
           </p:cNvPr>
@@ -19966,7 +19966,7 @@
           <p:cNvPr id="13" name="">
             <a:extLst xmlns:a="http://schemas.openxmlformats.org/drawingml/2006/main">
               <a:ext uri="{FF2B5EF4-FFF2-40B4-BE49-F238E27FC236}">
-                <a16:creationId xmlns:a16="http://schemas.microsoft.com/office/drawing/2014/main" id="{DE67C3C9-068B-4695-BE62-641C4EFFD15F}"/>
+                <a16:creationId xmlns:a16="http://schemas.microsoft.com/office/drawing/2014/main" id="{9988EE15-E45B-4CA9-8930-F6166FCEA8EF}"/>
               </a:ext>
             </a:extLst>
           </p:cNvPr>
@@ -20023,7 +20023,7 @@
           <p:cNvPr id="14" name="">
             <a:extLst xmlns:a="http://schemas.openxmlformats.org/drawingml/2006/main">
               <a:ext uri="{FF2B5EF4-FFF2-40B4-BE49-F238E27FC236}">
-                <a16:creationId xmlns:a16="http://schemas.microsoft.com/office/drawing/2014/main" id="{1FF8A7BB-C30F-4DD3-AED3-4C575999615A}"/>
+                <a16:creationId xmlns:a16="http://schemas.microsoft.com/office/drawing/2014/main" id="{0DE3829D-8EC8-4E4C-A225-C57A407680E5}"/>
               </a:ext>
             </a:extLst>
           </p:cNvPr>
@@ -20080,7 +20080,7 @@
           <p:cNvPr id="15" name="">
             <a:extLst xmlns:a="http://schemas.openxmlformats.org/drawingml/2006/main">
               <a:ext uri="{FF2B5EF4-FFF2-40B4-BE49-F238E27FC236}">
-                <a16:creationId xmlns:a16="http://schemas.microsoft.com/office/drawing/2014/main" id="{92F22E98-26DD-44B1-A2CA-0FB0DB2B093A}"/>
+                <a16:creationId xmlns:a16="http://schemas.microsoft.com/office/drawing/2014/main" id="{FBE0EBFC-4302-4A51-9176-6B631F142B36}"/>
               </a:ext>
             </a:extLst>
           </p:cNvPr>
@@ -20135,7 +20135,7 @@
     </p:spTree>
     <p:extLst>
       <p:ext uri="{BB962C8B-B14F-4D97-AF65-F5344CB8AC3E}">
-        <p14:creationId xmlns:p14="http://schemas.microsoft.com/office/powerpoint/2010/main" val="1940915805"/>
+        <p14:creationId xmlns:p14="http://schemas.microsoft.com/office/powerpoint/2010/main" val="1061401357"/>
       </p:ext>
     </p:extLst>
   </p:cSld>

</xml_diff>